<commit_message>
docs: finalize Team 07 presentation deck and assets (sanitized member details, no roles)
</commit_message>
<xml_diff>
--- a/Telephone_Bill_Management_System_Team07.pptx
+++ b/Telephone_Bill_Management_System_Team07.pptx
@@ -3428,7 +3428,7 @@
               <a:spcAft>
                 <a:spcPts val="200"/>
               </a:spcAft>
-              <a:defRPr sz="1400" b="1">
+              <a:defRPr sz="1500" b="1">
                 <a:solidFill>
                   <a:srgbClr val="06B6D4"/>
                 </a:solidFill>
@@ -3442,7 +3442,7 @@
           <a:p>
             <a:pPr>
               <a:spcAft>
-                <a:spcPts val="1400"/>
+                <a:spcPts val="1600"/>
               </a:spcAft>
               <a:defRPr sz="1000">
                 <a:solidFill>
@@ -3458,21 +3458,24 @@
           <a:p>
             <a:pPr>
               <a:spcAft>
+                <a:spcPts val="1200"/>
+              </a:spcAft>
+              <a:defRPr sz="1300" b="1">
+                <a:solidFill>
+                  <a:srgbClr val="FFFFFF"/>
+                </a:solidFill>
+                <a:latin typeface="Segoe UI"/>
+              </a:defRPr>
+            </a:pPr>
+            <a:r>
+              <a:t>Presented by:</a:t>
+            </a:r>
+          </a:p>
+          <a:p>
+            <a:pPr>
+              <a:spcAft>
                 <a:spcPts val="1000"/>
               </a:spcAft>
-              <a:defRPr sz="1100" b="1">
-                <a:solidFill>
-                  <a:srgbClr val="FFFFFF"/>
-                </a:solidFill>
-                <a:latin typeface="Segoe UI"/>
-              </a:defRPr>
-            </a:pPr>
-            <a:r>
-              <a:t>PRESENTED BY:</a:t>
-            </a:r>
-          </a:p>
-          <a:p>
-            <a:pPr>
               <a:defRPr sz="1200" b="1">
                 <a:solidFill>
                   <a:srgbClr val="E2E8F0"/>
@@ -3481,27 +3484,14 @@
               </a:defRPr>
             </a:pPr>
             <a:r>
-              <a:t>•  M. Akshitha</a:t>
-            </a:r>
-          </a:p>
-          <a:p>
-            <a:pPr>
-              <a:spcAft>
-                <a:spcPts val="800"/>
-              </a:spcAft>
-              <a:defRPr sz="1050">
-                <a:solidFill>
-                  <a:srgbClr val="06B6D4"/>
-                </a:solidFill>
-                <a:latin typeface="Consolas"/>
-              </a:defRPr>
-            </a:pPr>
-            <a:r>
-              <a:t>    Roll No: 24241-CS-033</a:t>
-            </a:r>
-          </a:p>
-          <a:p>
-            <a:pPr>
+              <a:t>•  M. Akshitha (24241-CS-033)</a:t>
+            </a:r>
+          </a:p>
+          <a:p>
+            <a:pPr>
+              <a:spcAft>
+                <a:spcPts val="1000"/>
+              </a:spcAft>
               <a:defRPr sz="1200" b="1">
                 <a:solidFill>
                   <a:srgbClr val="E2E8F0"/>
@@ -3510,27 +3500,14 @@
               </a:defRPr>
             </a:pPr>
             <a:r>
-              <a:t>•  G. Ashlesh</a:t>
-            </a:r>
-          </a:p>
-          <a:p>
-            <a:pPr>
-              <a:spcAft>
-                <a:spcPts val="800"/>
-              </a:spcAft>
-              <a:defRPr sz="1050">
-                <a:solidFill>
-                  <a:srgbClr val="06B6D4"/>
-                </a:solidFill>
-                <a:latin typeface="Consolas"/>
-              </a:defRPr>
-            </a:pPr>
-            <a:r>
-              <a:t>    Roll No: 24241-CS-034</a:t>
-            </a:r>
-          </a:p>
-          <a:p>
-            <a:pPr>
+              <a:t>•  G. Ashlesh (24241-CS-034)</a:t>
+            </a:r>
+          </a:p>
+          <a:p>
+            <a:pPr>
+              <a:spcAft>
+                <a:spcPts val="1000"/>
+              </a:spcAft>
               <a:defRPr sz="1200" b="1">
                 <a:solidFill>
                   <a:srgbClr val="E2E8F0"/>
@@ -3539,27 +3516,14 @@
               </a:defRPr>
             </a:pPr>
             <a:r>
-              <a:t>•  G. Bhargavi</a:t>
-            </a:r>
-          </a:p>
-          <a:p>
-            <a:pPr>
-              <a:spcAft>
-                <a:spcPts val="800"/>
-              </a:spcAft>
-              <a:defRPr sz="1050">
-                <a:solidFill>
-                  <a:srgbClr val="06B6D4"/>
-                </a:solidFill>
-                <a:latin typeface="Consolas"/>
-              </a:defRPr>
-            </a:pPr>
-            <a:r>
-              <a:t>    Roll No: 24241-CS-035</a:t>
-            </a:r>
-          </a:p>
-          <a:p>
-            <a:pPr>
+              <a:t>•  G. Bhargavi (24241-CS-035)</a:t>
+            </a:r>
+          </a:p>
+          <a:p>
+            <a:pPr>
+              <a:spcAft>
+                <a:spcPts val="1000"/>
+              </a:spcAft>
               <a:defRPr sz="1200" b="1">
                 <a:solidFill>
                   <a:srgbClr val="E2E8F0"/>
@@ -3568,27 +3532,14 @@
               </a:defRPr>
             </a:pPr>
             <a:r>
-              <a:t>•  E. Sakshi</a:t>
-            </a:r>
-          </a:p>
-          <a:p>
-            <a:pPr>
-              <a:spcAft>
-                <a:spcPts val="800"/>
-              </a:spcAft>
-              <a:defRPr sz="1050">
-                <a:solidFill>
-                  <a:srgbClr val="06B6D4"/>
-                </a:solidFill>
-                <a:latin typeface="Consolas"/>
-              </a:defRPr>
-            </a:pPr>
-            <a:r>
-              <a:t>    Roll No: 24241-CS-036</a:t>
-            </a:r>
-          </a:p>
-          <a:p>
-            <a:pPr>
+              <a:t>•  E. Sakshi (24241-CS-036)</a:t>
+            </a:r>
+          </a:p>
+          <a:p>
+            <a:pPr>
+              <a:spcAft>
+                <a:spcPts val="1000"/>
+              </a:spcAft>
               <a:defRPr sz="1200" b="1">
                 <a:solidFill>
                   <a:srgbClr val="E2E8F0"/>
@@ -3597,23 +3548,7 @@
               </a:defRPr>
             </a:pPr>
             <a:r>
-              <a:t>•  A. Varun</a:t>
-            </a:r>
-          </a:p>
-          <a:p>
-            <a:pPr>
-              <a:spcAft>
-                <a:spcPts val="800"/>
-              </a:spcAft>
-              <a:defRPr sz="1050">
-                <a:solidFill>
-                  <a:srgbClr val="06B6D4"/>
-                </a:solidFill>
-                <a:latin typeface="Consolas"/>
-              </a:defRPr>
-            </a:pPr>
-            <a:r>
-              <a:t>    Roll No: 24241-CS-037</a:t>
+              <a:t>•  A. Varun (24241-CS-037)</a:t>
             </a:r>
           </a:p>
         </p:txBody>
@@ -5281,7 +5216,7 @@
               </a:defRPr>
             </a:pPr>
             <a:r>
-              <a:t>Version-controlled with sanitized credentials and complete automated build scripts.</a:t>
+              <a:t>Version-controlled with sanitized configuration and complete automated build scripts.</a:t>
             </a:r>
           </a:p>
           <a:p>
@@ -5675,7 +5610,7 @@
               </a:defRPr>
             </a:pPr>
             <a:r>
-              <a:t>TEAM COLLABORATION</a:t>
+              <a:t>PROJECT MEMBERS</a:t>
             </a:r>
           </a:p>
           <a:p>
@@ -5691,7 +5626,7 @@
               </a:defRPr>
             </a:pPr>
             <a:r>
-              <a:t>Team 07 Individual Contributions</a:t>
+              <a:t>Team 07</a:t>
             </a:r>
           </a:p>
           <a:p>
@@ -5704,7 +5639,7 @@
               </a:defRPr>
             </a:pPr>
             <a:r>
-              <a:t>Equal distribution of responsibilities across architecture, development, database, QA, and cloud hosting</a:t>
+              <a:t>Department of Computer Science &amp; Engineering — Academic Major Project 2026</a:t>
             </a:r>
           </a:p>
         </p:txBody>
@@ -5718,7 +5653,7 @@
         <p:spPr>
           <a:xfrm>
             <a:off x="731520" y="1645920"/>
-            <a:ext cx="10698480" cy="804672"/>
+            <a:ext cx="10698480" cy="777240"/>
           </a:xfrm>
           <a:prstGeom prst="roundRect">
             <a:avLst/>
@@ -5756,14 +5691,69 @@
       </p:sp>
       <p:sp>
         <p:nvSpPr>
-          <p:cNvPr id="5" name="TextBox 4"/>
+          <p:cNvPr id="5" name="Oval 4"/>
+          <p:cNvSpPr/>
+          <p:nvPr/>
+        </p:nvSpPr>
+        <p:spPr>
+          <a:xfrm>
+            <a:off x="1005840" y="1783080"/>
+            <a:ext cx="502920" cy="502920"/>
+          </a:xfrm>
+          <a:prstGeom prst="ellipse">
+            <a:avLst/>
+          </a:prstGeom>
+          <a:solidFill>
+            <a:srgbClr val="1E293B"/>
+          </a:solidFill>
+          <a:ln>
+            <a:solidFill>
+              <a:srgbClr val="06B6D4"/>
+            </a:solidFill>
+          </a:ln>
+        </p:spPr>
+        <p:style>
+          <a:lnRef idx="1">
+            <a:schemeClr val="accent1"/>
+          </a:lnRef>
+          <a:fillRef idx="3">
+            <a:schemeClr val="accent1"/>
+          </a:fillRef>
+          <a:effectRef idx="2">
+            <a:schemeClr val="accent1"/>
+          </a:effectRef>
+          <a:fontRef idx="minor">
+            <a:schemeClr val="lt1"/>
+          </a:fontRef>
+        </p:style>
+        <p:txBody>
+          <a:bodyPr rtlCol="0" anchor="ctr"/>
+          <a:lstStyle/>
+          <a:p>
+            <a:pPr algn="ctr">
+              <a:defRPr sz="1300" b="1">
+                <a:solidFill>
+                  <a:srgbClr val="06B6D4"/>
+                </a:solidFill>
+                <a:latin typeface="Segoe UI"/>
+              </a:defRPr>
+            </a:pPr>
+            <a:r>
+              <a:t>1</a:t>
+            </a:r>
+          </a:p>
+        </p:txBody>
+      </p:sp>
+      <p:sp>
+        <p:nvSpPr>
+          <p:cNvPr id="6" name="TextBox 5"/>
           <p:cNvSpPr txBox="1"/>
           <p:nvPr/>
         </p:nvSpPr>
         <p:spPr>
           <a:xfrm>
-            <a:off x="914400" y="1755648"/>
-            <a:ext cx="2926080" cy="594360"/>
+            <a:off x="1691640" y="1755648"/>
+            <a:ext cx="4114800" cy="548640"/>
           </a:xfrm>
           <a:prstGeom prst="rect">
             <a:avLst/>
@@ -5777,7 +5767,7 @@
           <a:lstStyle/>
           <a:p>
             <a:pPr>
-              <a:defRPr sz="1250" b="1">
+              <a:defRPr sz="1600" b="1">
                 <a:solidFill>
                   <a:srgbClr val="FFFFFF"/>
                 </a:solidFill>
@@ -5792,6 +5782,61 @@
             <a:pPr>
               <a:defRPr sz="950">
                 <a:solidFill>
+                  <a:srgbClr val="94A3B8"/>
+                </a:solidFill>
+                <a:latin typeface="Segoe UI"/>
+              </a:defRPr>
+            </a:pPr>
+            <a:r>
+              <a:t>Computer Science &amp; Engineering</a:t>
+            </a:r>
+          </a:p>
+        </p:txBody>
+      </p:sp>
+      <p:sp>
+        <p:nvSpPr>
+          <p:cNvPr id="7" name="Rounded Rectangle 6"/>
+          <p:cNvSpPr/>
+          <p:nvPr/>
+        </p:nvSpPr>
+        <p:spPr>
+          <a:xfrm>
+            <a:off x="8961120" y="1828800"/>
+            <a:ext cx="2194560" cy="411480"/>
+          </a:xfrm>
+          <a:prstGeom prst="roundRect">
+            <a:avLst/>
+          </a:prstGeom>
+          <a:solidFill>
+            <a:srgbClr val="0F172A"/>
+          </a:solidFill>
+          <a:ln w="12700">
+            <a:solidFill>
+              <a:srgbClr val="06B6D4"/>
+            </a:solidFill>
+          </a:ln>
+        </p:spPr>
+        <p:style>
+          <a:lnRef idx="1">
+            <a:schemeClr val="accent1"/>
+          </a:lnRef>
+          <a:fillRef idx="3">
+            <a:schemeClr val="accent1"/>
+          </a:fillRef>
+          <a:effectRef idx="2">
+            <a:schemeClr val="accent1"/>
+          </a:effectRef>
+          <a:fontRef idx="minor">
+            <a:schemeClr val="lt1"/>
+          </a:fontRef>
+        </p:style>
+        <p:txBody>
+          <a:bodyPr rtlCol="0" anchor="ctr"/>
+          <a:lstStyle/>
+          <a:p>
+            <a:pPr algn="ctr">
+              <a:defRPr sz="1100" b="1">
+                <a:solidFill>
                   <a:srgbClr val="06B6D4"/>
                 </a:solidFill>
                 <a:latin typeface="Consolas"/>
@@ -5799,104 +5844,6 @@
             </a:pPr>
             <a:r>
               <a:t>Roll: 24241-CS-033</a:t>
-            </a:r>
-          </a:p>
-        </p:txBody>
-      </p:sp>
-      <p:sp>
-        <p:nvSpPr>
-          <p:cNvPr id="6" name="TextBox 5"/>
-          <p:cNvSpPr txBox="1"/>
-          <p:nvPr/>
-        </p:nvSpPr>
-        <p:spPr>
-          <a:xfrm>
-            <a:off x="3840480" y="1755648"/>
-            <a:ext cx="2377440" cy="594360"/>
-          </a:xfrm>
-          <a:prstGeom prst="rect">
-            <a:avLst/>
-          </a:prstGeom>
-          <a:noFill/>
-        </p:spPr>
-        <p:txBody>
-          <a:bodyPr wrap="square">
-            <a:spAutoFit/>
-          </a:bodyPr>
-          <a:lstStyle/>
-          <a:p>
-            <a:pPr>
-              <a:defRPr sz="850" b="1">
-                <a:solidFill>
-                  <a:srgbClr val="64748B"/>
-                </a:solidFill>
-                <a:latin typeface="Segoe UI"/>
-              </a:defRPr>
-            </a:pPr>
-            <a:r>
-              <a:t>ASSIGNED ROLE:</a:t>
-            </a:r>
-          </a:p>
-          <a:p>
-            <a:pPr>
-              <a:defRPr sz="1050" b="1">
-                <a:solidFill>
-                  <a:srgbClr val="F59E0B"/>
-                </a:solidFill>
-                <a:latin typeface="Segoe UI"/>
-              </a:defRPr>
-            </a:pPr>
-            <a:r>
-              <a:t>UI/UX &amp; JavaFX Controller Design</a:t>
-            </a:r>
-          </a:p>
-        </p:txBody>
-      </p:sp>
-      <p:sp>
-        <p:nvSpPr>
-          <p:cNvPr id="7" name="TextBox 6"/>
-          <p:cNvSpPr txBox="1"/>
-          <p:nvPr/>
-        </p:nvSpPr>
-        <p:spPr>
-          <a:xfrm>
-            <a:off x="6400800" y="1755648"/>
-            <a:ext cx="4846320" cy="594360"/>
-          </a:xfrm>
-          <a:prstGeom prst="rect">
-            <a:avLst/>
-          </a:prstGeom>
-          <a:noFill/>
-        </p:spPr>
-        <p:txBody>
-          <a:bodyPr wrap="square">
-            <a:spAutoFit/>
-          </a:bodyPr>
-          <a:lstStyle/>
-          <a:p>
-            <a:pPr>
-              <a:defRPr sz="850" b="1">
-                <a:solidFill>
-                  <a:srgbClr val="64748B"/>
-                </a:solidFill>
-                <a:latin typeface="Segoe UI"/>
-              </a:defRPr>
-            </a:pPr>
-            <a:r>
-              <a:t>KEY CONTRIBUTIONS:</a:t>
-            </a:r>
-          </a:p>
-          <a:p>
-            <a:pPr>
-              <a:defRPr sz="950">
-                <a:solidFill>
-                  <a:srgbClr val="E2E8F0"/>
-                </a:solidFill>
-                <a:latin typeface="Segoe UI"/>
-              </a:defRPr>
-            </a:pPr>
-            <a:r>
-              <a:t> • Designed declarative FXML screens for Dashboard, Subscribers, and Invoices.  • Implemented dark/light CSS skinning, transitions, and responsive controls.</a:t>
             </a:r>
           </a:p>
         </p:txBody>
@@ -5909,8 +5856,8 @@
         </p:nvSpPr>
         <p:spPr>
           <a:xfrm>
-            <a:off x="731520" y="2523744"/>
-            <a:ext cx="10698480" cy="804672"/>
+            <a:off x="731520" y="2532888"/>
+            <a:ext cx="10698480" cy="777240"/>
           </a:xfrm>
           <a:prstGeom prst="roundRect">
             <a:avLst/>
@@ -5948,14 +5895,69 @@
       </p:sp>
       <p:sp>
         <p:nvSpPr>
-          <p:cNvPr id="9" name="TextBox 8"/>
+          <p:cNvPr id="9" name="Oval 8"/>
+          <p:cNvSpPr/>
+          <p:nvPr/>
+        </p:nvSpPr>
+        <p:spPr>
+          <a:xfrm>
+            <a:off x="1005840" y="2670048"/>
+            <a:ext cx="502920" cy="502920"/>
+          </a:xfrm>
+          <a:prstGeom prst="ellipse">
+            <a:avLst/>
+          </a:prstGeom>
+          <a:solidFill>
+            <a:srgbClr val="1E293B"/>
+          </a:solidFill>
+          <a:ln>
+            <a:solidFill>
+              <a:srgbClr val="06B6D4"/>
+            </a:solidFill>
+          </a:ln>
+        </p:spPr>
+        <p:style>
+          <a:lnRef idx="1">
+            <a:schemeClr val="accent1"/>
+          </a:lnRef>
+          <a:fillRef idx="3">
+            <a:schemeClr val="accent1"/>
+          </a:fillRef>
+          <a:effectRef idx="2">
+            <a:schemeClr val="accent1"/>
+          </a:effectRef>
+          <a:fontRef idx="minor">
+            <a:schemeClr val="lt1"/>
+          </a:fontRef>
+        </p:style>
+        <p:txBody>
+          <a:bodyPr rtlCol="0" anchor="ctr"/>
+          <a:lstStyle/>
+          <a:p>
+            <a:pPr algn="ctr">
+              <a:defRPr sz="1300" b="1">
+                <a:solidFill>
+                  <a:srgbClr val="06B6D4"/>
+                </a:solidFill>
+                <a:latin typeface="Segoe UI"/>
+              </a:defRPr>
+            </a:pPr>
+            <a:r>
+              <a:t>2</a:t>
+            </a:r>
+          </a:p>
+        </p:txBody>
+      </p:sp>
+      <p:sp>
+        <p:nvSpPr>
+          <p:cNvPr id="10" name="TextBox 9"/>
           <p:cNvSpPr txBox="1"/>
           <p:nvPr/>
         </p:nvSpPr>
         <p:spPr>
           <a:xfrm>
-            <a:off x="914400" y="2633472"/>
-            <a:ext cx="2926080" cy="594360"/>
+            <a:off x="1691640" y="2642616"/>
+            <a:ext cx="4114800" cy="548640"/>
           </a:xfrm>
           <a:prstGeom prst="rect">
             <a:avLst/>
@@ -5969,7 +5971,7 @@
           <a:lstStyle/>
           <a:p>
             <a:pPr>
-              <a:defRPr sz="1250" b="1">
+              <a:defRPr sz="1600" b="1">
                 <a:solidFill>
                   <a:srgbClr val="FFFFFF"/>
                 </a:solidFill>
@@ -5984,6 +5986,61 @@
             <a:pPr>
               <a:defRPr sz="950">
                 <a:solidFill>
+                  <a:srgbClr val="94A3B8"/>
+                </a:solidFill>
+                <a:latin typeface="Segoe UI"/>
+              </a:defRPr>
+            </a:pPr>
+            <a:r>
+              <a:t>Computer Science &amp; Engineering</a:t>
+            </a:r>
+          </a:p>
+        </p:txBody>
+      </p:sp>
+      <p:sp>
+        <p:nvSpPr>
+          <p:cNvPr id="11" name="Rounded Rectangle 10"/>
+          <p:cNvSpPr/>
+          <p:nvPr/>
+        </p:nvSpPr>
+        <p:spPr>
+          <a:xfrm>
+            <a:off x="8961120" y="2715768"/>
+            <a:ext cx="2194560" cy="411480"/>
+          </a:xfrm>
+          <a:prstGeom prst="roundRect">
+            <a:avLst/>
+          </a:prstGeom>
+          <a:solidFill>
+            <a:srgbClr val="0F172A"/>
+          </a:solidFill>
+          <a:ln w="12700">
+            <a:solidFill>
+              <a:srgbClr val="06B6D4"/>
+            </a:solidFill>
+          </a:ln>
+        </p:spPr>
+        <p:style>
+          <a:lnRef idx="1">
+            <a:schemeClr val="accent1"/>
+          </a:lnRef>
+          <a:fillRef idx="3">
+            <a:schemeClr val="accent1"/>
+          </a:fillRef>
+          <a:effectRef idx="2">
+            <a:schemeClr val="accent1"/>
+          </a:effectRef>
+          <a:fontRef idx="minor">
+            <a:schemeClr val="lt1"/>
+          </a:fontRef>
+        </p:style>
+        <p:txBody>
+          <a:bodyPr rtlCol="0" anchor="ctr"/>
+          <a:lstStyle/>
+          <a:p>
+            <a:pPr algn="ctr">
+              <a:defRPr sz="1100" b="1">
+                <a:solidFill>
                   <a:srgbClr val="06B6D4"/>
                 </a:solidFill>
                 <a:latin typeface="Consolas"/>
@@ -5991,104 +6048,6 @@
             </a:pPr>
             <a:r>
               <a:t>Roll: 24241-CS-034</a:t>
-            </a:r>
-          </a:p>
-        </p:txBody>
-      </p:sp>
-      <p:sp>
-        <p:nvSpPr>
-          <p:cNvPr id="10" name="TextBox 9"/>
-          <p:cNvSpPr txBox="1"/>
-          <p:nvPr/>
-        </p:nvSpPr>
-        <p:spPr>
-          <a:xfrm>
-            <a:off x="3840480" y="2633472"/>
-            <a:ext cx="2377440" cy="594360"/>
-          </a:xfrm>
-          <a:prstGeom prst="rect">
-            <a:avLst/>
-          </a:prstGeom>
-          <a:noFill/>
-        </p:spPr>
-        <p:txBody>
-          <a:bodyPr wrap="square">
-            <a:spAutoFit/>
-          </a:bodyPr>
-          <a:lstStyle/>
-          <a:p>
-            <a:pPr>
-              <a:defRPr sz="850" b="1">
-                <a:solidFill>
-                  <a:srgbClr val="64748B"/>
-                </a:solidFill>
-                <a:latin typeface="Segoe UI"/>
-              </a:defRPr>
-            </a:pPr>
-            <a:r>
-              <a:t>ASSIGNED ROLE:</a:t>
-            </a:r>
-          </a:p>
-          <a:p>
-            <a:pPr>
-              <a:defRPr sz="1050" b="1">
-                <a:solidFill>
-                  <a:srgbClr val="F59E0B"/>
-                </a:solidFill>
-                <a:latin typeface="Segoe UI"/>
-              </a:defRPr>
-            </a:pPr>
-            <a:r>
-              <a:t>System Architecture &amp; Cloud Deployment</a:t>
-            </a:r>
-          </a:p>
-        </p:txBody>
-      </p:sp>
-      <p:sp>
-        <p:nvSpPr>
-          <p:cNvPr id="11" name="TextBox 10"/>
-          <p:cNvSpPr txBox="1"/>
-          <p:nvPr/>
-        </p:nvSpPr>
-        <p:spPr>
-          <a:xfrm>
-            <a:off x="6400800" y="2633472"/>
-            <a:ext cx="4846320" cy="594360"/>
-          </a:xfrm>
-          <a:prstGeom prst="rect">
-            <a:avLst/>
-          </a:prstGeom>
-          <a:noFill/>
-        </p:spPr>
-        <p:txBody>
-          <a:bodyPr wrap="square">
-            <a:spAutoFit/>
-          </a:bodyPr>
-          <a:lstStyle/>
-          <a:p>
-            <a:pPr>
-              <a:defRPr sz="850" b="1">
-                <a:solidFill>
-                  <a:srgbClr val="64748B"/>
-                </a:solidFill>
-                <a:latin typeface="Segoe UI"/>
-              </a:defRPr>
-            </a:pPr>
-            <a:r>
-              <a:t>KEY CONTRIBUTIONS:</a:t>
-            </a:r>
-          </a:p>
-          <a:p>
-            <a:pPr>
-              <a:defRPr sz="950">
-                <a:solidFill>
-                  <a:srgbClr val="E2E8F0"/>
-                </a:solidFill>
-                <a:latin typeface="Segoe UI"/>
-              </a:defRPr>
-            </a:pPr>
-            <a:r>
-              <a:t> • Architected overall MVC design pattern and module separation.  • Ported system to Vercel cloud web application with client-side data store.</a:t>
             </a:r>
           </a:p>
         </p:txBody>
@@ -6101,8 +6060,8 @@
         </p:nvSpPr>
         <p:spPr>
           <a:xfrm>
-            <a:off x="731520" y="3401568"/>
-            <a:ext cx="10698480" cy="804672"/>
+            <a:off x="731520" y="3419856"/>
+            <a:ext cx="10698480" cy="777240"/>
           </a:xfrm>
           <a:prstGeom prst="roundRect">
             <a:avLst/>
@@ -6140,14 +6099,69 @@
       </p:sp>
       <p:sp>
         <p:nvSpPr>
-          <p:cNvPr id="13" name="TextBox 12"/>
+          <p:cNvPr id="13" name="Oval 12"/>
+          <p:cNvSpPr/>
+          <p:nvPr/>
+        </p:nvSpPr>
+        <p:spPr>
+          <a:xfrm>
+            <a:off x="1005840" y="3557016"/>
+            <a:ext cx="502920" cy="502920"/>
+          </a:xfrm>
+          <a:prstGeom prst="ellipse">
+            <a:avLst/>
+          </a:prstGeom>
+          <a:solidFill>
+            <a:srgbClr val="1E293B"/>
+          </a:solidFill>
+          <a:ln>
+            <a:solidFill>
+              <a:srgbClr val="06B6D4"/>
+            </a:solidFill>
+          </a:ln>
+        </p:spPr>
+        <p:style>
+          <a:lnRef idx="1">
+            <a:schemeClr val="accent1"/>
+          </a:lnRef>
+          <a:fillRef idx="3">
+            <a:schemeClr val="accent1"/>
+          </a:fillRef>
+          <a:effectRef idx="2">
+            <a:schemeClr val="accent1"/>
+          </a:effectRef>
+          <a:fontRef idx="minor">
+            <a:schemeClr val="lt1"/>
+          </a:fontRef>
+        </p:style>
+        <p:txBody>
+          <a:bodyPr rtlCol="0" anchor="ctr"/>
+          <a:lstStyle/>
+          <a:p>
+            <a:pPr algn="ctr">
+              <a:defRPr sz="1300" b="1">
+                <a:solidFill>
+                  <a:srgbClr val="06B6D4"/>
+                </a:solidFill>
+                <a:latin typeface="Segoe UI"/>
+              </a:defRPr>
+            </a:pPr>
+            <a:r>
+              <a:t>3</a:t>
+            </a:r>
+          </a:p>
+        </p:txBody>
+      </p:sp>
+      <p:sp>
+        <p:nvSpPr>
+          <p:cNvPr id="14" name="TextBox 13"/>
           <p:cNvSpPr txBox="1"/>
           <p:nvPr/>
         </p:nvSpPr>
         <p:spPr>
           <a:xfrm>
-            <a:off x="914400" y="3511296"/>
-            <a:ext cx="2926080" cy="594360"/>
+            <a:off x="1691640" y="3529584"/>
+            <a:ext cx="4114800" cy="548640"/>
           </a:xfrm>
           <a:prstGeom prst="rect">
             <a:avLst/>
@@ -6161,7 +6175,7 @@
           <a:lstStyle/>
           <a:p>
             <a:pPr>
-              <a:defRPr sz="1250" b="1">
+              <a:defRPr sz="1600" b="1">
                 <a:solidFill>
                   <a:srgbClr val="FFFFFF"/>
                 </a:solidFill>
@@ -6176,6 +6190,61 @@
             <a:pPr>
               <a:defRPr sz="950">
                 <a:solidFill>
+                  <a:srgbClr val="94A3B8"/>
+                </a:solidFill>
+                <a:latin typeface="Segoe UI"/>
+              </a:defRPr>
+            </a:pPr>
+            <a:r>
+              <a:t>Computer Science &amp; Engineering</a:t>
+            </a:r>
+          </a:p>
+        </p:txBody>
+      </p:sp>
+      <p:sp>
+        <p:nvSpPr>
+          <p:cNvPr id="15" name="Rounded Rectangle 14"/>
+          <p:cNvSpPr/>
+          <p:nvPr/>
+        </p:nvSpPr>
+        <p:spPr>
+          <a:xfrm>
+            <a:off x="8961120" y="3602736"/>
+            <a:ext cx="2194560" cy="411480"/>
+          </a:xfrm>
+          <a:prstGeom prst="roundRect">
+            <a:avLst/>
+          </a:prstGeom>
+          <a:solidFill>
+            <a:srgbClr val="0F172A"/>
+          </a:solidFill>
+          <a:ln w="12700">
+            <a:solidFill>
+              <a:srgbClr val="06B6D4"/>
+            </a:solidFill>
+          </a:ln>
+        </p:spPr>
+        <p:style>
+          <a:lnRef idx="1">
+            <a:schemeClr val="accent1"/>
+          </a:lnRef>
+          <a:fillRef idx="3">
+            <a:schemeClr val="accent1"/>
+          </a:fillRef>
+          <a:effectRef idx="2">
+            <a:schemeClr val="accent1"/>
+          </a:effectRef>
+          <a:fontRef idx="minor">
+            <a:schemeClr val="lt1"/>
+          </a:fontRef>
+        </p:style>
+        <p:txBody>
+          <a:bodyPr rtlCol="0" anchor="ctr"/>
+          <a:lstStyle/>
+          <a:p>
+            <a:pPr algn="ctr">
+              <a:defRPr sz="1100" b="1">
+                <a:solidFill>
                   <a:srgbClr val="06B6D4"/>
                 </a:solidFill>
                 <a:latin typeface="Consolas"/>
@@ -6183,104 +6252,6 @@
             </a:pPr>
             <a:r>
               <a:t>Roll: 24241-CS-035</a:t>
-            </a:r>
-          </a:p>
-        </p:txBody>
-      </p:sp>
-      <p:sp>
-        <p:nvSpPr>
-          <p:cNvPr id="14" name="TextBox 13"/>
-          <p:cNvSpPr txBox="1"/>
-          <p:nvPr/>
-        </p:nvSpPr>
-        <p:spPr>
-          <a:xfrm>
-            <a:off x="3840480" y="3511296"/>
-            <a:ext cx="2377440" cy="594360"/>
-          </a:xfrm>
-          <a:prstGeom prst="rect">
-            <a:avLst/>
-          </a:prstGeom>
-          <a:noFill/>
-        </p:spPr>
-        <p:txBody>
-          <a:bodyPr wrap="square">
-            <a:spAutoFit/>
-          </a:bodyPr>
-          <a:lstStyle/>
-          <a:p>
-            <a:pPr>
-              <a:defRPr sz="850" b="1">
-                <a:solidFill>
-                  <a:srgbClr val="64748B"/>
-                </a:solidFill>
-                <a:latin typeface="Segoe UI"/>
-              </a:defRPr>
-            </a:pPr>
-            <a:r>
-              <a:t>ASSIGNED ROLE:</a:t>
-            </a:r>
-          </a:p>
-          <a:p>
-            <a:pPr>
-              <a:defRPr sz="1050" b="1">
-                <a:solidFill>
-                  <a:srgbClr val="F59E0B"/>
-                </a:solidFill>
-                <a:latin typeface="Segoe UI"/>
-              </a:defRPr>
-            </a:pPr>
-            <a:r>
-              <a:t>Core Billing Engine &amp; Rating Algorithms</a:t>
-            </a:r>
-          </a:p>
-        </p:txBody>
-      </p:sp>
-      <p:sp>
-        <p:nvSpPr>
-          <p:cNvPr id="15" name="TextBox 14"/>
-          <p:cNvSpPr txBox="1"/>
-          <p:nvPr/>
-        </p:nvSpPr>
-        <p:spPr>
-          <a:xfrm>
-            <a:off x="6400800" y="3511296"/>
-            <a:ext cx="4846320" cy="594360"/>
-          </a:xfrm>
-          <a:prstGeom prst="rect">
-            <a:avLst/>
-          </a:prstGeom>
-          <a:noFill/>
-        </p:spPr>
-        <p:txBody>
-          <a:bodyPr wrap="square">
-            <a:spAutoFit/>
-          </a:bodyPr>
-          <a:lstStyle/>
-          <a:p>
-            <a:pPr>
-              <a:defRPr sz="850" b="1">
-                <a:solidFill>
-                  <a:srgbClr val="64748B"/>
-                </a:solidFill>
-                <a:latin typeface="Segoe UI"/>
-              </a:defRPr>
-            </a:pPr>
-            <a:r>
-              <a:t>KEY CONTRIBUTIONS:</a:t>
-            </a:r>
-          </a:p>
-          <a:p>
-            <a:pPr>
-              <a:defRPr sz="950">
-                <a:solidFill>
-                  <a:srgbClr val="E2E8F0"/>
-                </a:solidFill>
-                <a:latin typeface="Segoe UI"/>
-              </a:defRPr>
-            </a:pPr>
-            <a:r>
-              <a:t> • Implemented BillingEngine calculation rules and 60-second pulse ceiling logic.  • Programmed free-minutes deduction priorities and statutory 18% GST computations.</a:t>
             </a:r>
           </a:p>
         </p:txBody>
@@ -6293,8 +6264,8 @@
         </p:nvSpPr>
         <p:spPr>
           <a:xfrm>
-            <a:off x="731520" y="4279392"/>
-            <a:ext cx="10698480" cy="804672"/>
+            <a:off x="731520" y="4306824"/>
+            <a:ext cx="10698480" cy="777240"/>
           </a:xfrm>
           <a:prstGeom prst="roundRect">
             <a:avLst/>
@@ -6332,14 +6303,69 @@
       </p:sp>
       <p:sp>
         <p:nvSpPr>
-          <p:cNvPr id="17" name="TextBox 16"/>
+          <p:cNvPr id="17" name="Oval 16"/>
+          <p:cNvSpPr/>
+          <p:nvPr/>
+        </p:nvSpPr>
+        <p:spPr>
+          <a:xfrm>
+            <a:off x="1005840" y="4443984"/>
+            <a:ext cx="502920" cy="502920"/>
+          </a:xfrm>
+          <a:prstGeom prst="ellipse">
+            <a:avLst/>
+          </a:prstGeom>
+          <a:solidFill>
+            <a:srgbClr val="1E293B"/>
+          </a:solidFill>
+          <a:ln>
+            <a:solidFill>
+              <a:srgbClr val="06B6D4"/>
+            </a:solidFill>
+          </a:ln>
+        </p:spPr>
+        <p:style>
+          <a:lnRef idx="1">
+            <a:schemeClr val="accent1"/>
+          </a:lnRef>
+          <a:fillRef idx="3">
+            <a:schemeClr val="accent1"/>
+          </a:fillRef>
+          <a:effectRef idx="2">
+            <a:schemeClr val="accent1"/>
+          </a:effectRef>
+          <a:fontRef idx="minor">
+            <a:schemeClr val="lt1"/>
+          </a:fontRef>
+        </p:style>
+        <p:txBody>
+          <a:bodyPr rtlCol="0" anchor="ctr"/>
+          <a:lstStyle/>
+          <a:p>
+            <a:pPr algn="ctr">
+              <a:defRPr sz="1300" b="1">
+                <a:solidFill>
+                  <a:srgbClr val="06B6D4"/>
+                </a:solidFill>
+                <a:latin typeface="Segoe UI"/>
+              </a:defRPr>
+            </a:pPr>
+            <a:r>
+              <a:t>4</a:t>
+            </a:r>
+          </a:p>
+        </p:txBody>
+      </p:sp>
+      <p:sp>
+        <p:nvSpPr>
+          <p:cNvPr id="18" name="TextBox 17"/>
           <p:cNvSpPr txBox="1"/>
           <p:nvPr/>
         </p:nvSpPr>
         <p:spPr>
           <a:xfrm>
-            <a:off x="914400" y="4389120"/>
-            <a:ext cx="2926080" cy="594360"/>
+            <a:off x="1691640" y="4416552"/>
+            <a:ext cx="4114800" cy="548640"/>
           </a:xfrm>
           <a:prstGeom prst="rect">
             <a:avLst/>
@@ -6353,7 +6379,7 @@
           <a:lstStyle/>
           <a:p>
             <a:pPr>
-              <a:defRPr sz="1250" b="1">
+              <a:defRPr sz="1600" b="1">
                 <a:solidFill>
                   <a:srgbClr val="FFFFFF"/>
                 </a:solidFill>
@@ -6368,6 +6394,61 @@
             <a:pPr>
               <a:defRPr sz="950">
                 <a:solidFill>
+                  <a:srgbClr val="94A3B8"/>
+                </a:solidFill>
+                <a:latin typeface="Segoe UI"/>
+              </a:defRPr>
+            </a:pPr>
+            <a:r>
+              <a:t>Computer Science &amp; Engineering</a:t>
+            </a:r>
+          </a:p>
+        </p:txBody>
+      </p:sp>
+      <p:sp>
+        <p:nvSpPr>
+          <p:cNvPr id="19" name="Rounded Rectangle 18"/>
+          <p:cNvSpPr/>
+          <p:nvPr/>
+        </p:nvSpPr>
+        <p:spPr>
+          <a:xfrm>
+            <a:off x="8961120" y="4489704"/>
+            <a:ext cx="2194560" cy="411480"/>
+          </a:xfrm>
+          <a:prstGeom prst="roundRect">
+            <a:avLst/>
+          </a:prstGeom>
+          <a:solidFill>
+            <a:srgbClr val="0F172A"/>
+          </a:solidFill>
+          <a:ln w="12700">
+            <a:solidFill>
+              <a:srgbClr val="06B6D4"/>
+            </a:solidFill>
+          </a:ln>
+        </p:spPr>
+        <p:style>
+          <a:lnRef idx="1">
+            <a:schemeClr val="accent1"/>
+          </a:lnRef>
+          <a:fillRef idx="3">
+            <a:schemeClr val="accent1"/>
+          </a:fillRef>
+          <a:effectRef idx="2">
+            <a:schemeClr val="accent1"/>
+          </a:effectRef>
+          <a:fontRef idx="minor">
+            <a:schemeClr val="lt1"/>
+          </a:fontRef>
+        </p:style>
+        <p:txBody>
+          <a:bodyPr rtlCol="0" anchor="ctr"/>
+          <a:lstStyle/>
+          <a:p>
+            <a:pPr algn="ctr">
+              <a:defRPr sz="1100" b="1">
+                <a:solidFill>
                   <a:srgbClr val="06B6D4"/>
                 </a:solidFill>
                 <a:latin typeface="Consolas"/>
@@ -6375,104 +6456,6 @@
             </a:pPr>
             <a:r>
               <a:t>Roll: 24241-CS-036</a:t>
-            </a:r>
-          </a:p>
-        </p:txBody>
-      </p:sp>
-      <p:sp>
-        <p:nvSpPr>
-          <p:cNvPr id="18" name="TextBox 17"/>
-          <p:cNvSpPr txBox="1"/>
-          <p:nvPr/>
-        </p:nvSpPr>
-        <p:spPr>
-          <a:xfrm>
-            <a:off x="3840480" y="4389120"/>
-            <a:ext cx="2377440" cy="594360"/>
-          </a:xfrm>
-          <a:prstGeom prst="rect">
-            <a:avLst/>
-          </a:prstGeom>
-          <a:noFill/>
-        </p:spPr>
-        <p:txBody>
-          <a:bodyPr wrap="square">
-            <a:spAutoFit/>
-          </a:bodyPr>
-          <a:lstStyle/>
-          <a:p>
-            <a:pPr>
-              <a:defRPr sz="850" b="1">
-                <a:solidFill>
-                  <a:srgbClr val="64748B"/>
-                </a:solidFill>
-                <a:latin typeface="Segoe UI"/>
-              </a:defRPr>
-            </a:pPr>
-            <a:r>
-              <a:t>ASSIGNED ROLE:</a:t>
-            </a:r>
-          </a:p>
-          <a:p>
-            <a:pPr>
-              <a:defRPr sz="1050" b="1">
-                <a:solidFill>
-                  <a:srgbClr val="F59E0B"/>
-                </a:solidFill>
-                <a:latin typeface="Segoe UI"/>
-              </a:defRPr>
-            </a:pPr>
-            <a:r>
-              <a:t>Database Design &amp; Data Access (DAO)</a:t>
-            </a:r>
-          </a:p>
-        </p:txBody>
-      </p:sp>
-      <p:sp>
-        <p:nvSpPr>
-          <p:cNvPr id="19" name="TextBox 18"/>
-          <p:cNvSpPr txBox="1"/>
-          <p:nvPr/>
-        </p:nvSpPr>
-        <p:spPr>
-          <a:xfrm>
-            <a:off x="6400800" y="4389120"/>
-            <a:ext cx="4846320" cy="594360"/>
-          </a:xfrm>
-          <a:prstGeom prst="rect">
-            <a:avLst/>
-          </a:prstGeom>
-          <a:noFill/>
-        </p:spPr>
-        <p:txBody>
-          <a:bodyPr wrap="square">
-            <a:spAutoFit/>
-          </a:bodyPr>
-          <a:lstStyle/>
-          <a:p>
-            <a:pPr>
-              <a:defRPr sz="850" b="1">
-                <a:solidFill>
-                  <a:srgbClr val="64748B"/>
-                </a:solidFill>
-                <a:latin typeface="Segoe UI"/>
-              </a:defRPr>
-            </a:pPr>
-            <a:r>
-              <a:t>KEY CONTRIBUTIONS:</a:t>
-            </a:r>
-          </a:p>
-          <a:p>
-            <a:pPr>
-              <a:defRPr sz="950">
-                <a:solidFill>
-                  <a:srgbClr val="E2E8F0"/>
-                </a:solidFill>
-                <a:latin typeface="Segoe UI"/>
-              </a:defRPr>
-            </a:pPr>
-            <a:r>
-              <a:t> • Engineered SQLite relational schema (schema.sql) with foreign keys and indexes.  • Implemented DatabaseManager and CRUD DAO classes for customers, bills, and calls.</a:t>
             </a:r>
           </a:p>
         </p:txBody>
@@ -6485,8 +6468,8 @@
         </p:nvSpPr>
         <p:spPr>
           <a:xfrm>
-            <a:off x="731520" y="5157216"/>
-            <a:ext cx="10698480" cy="804672"/>
+            <a:off x="731520" y="5193792"/>
+            <a:ext cx="10698480" cy="777240"/>
           </a:xfrm>
           <a:prstGeom prst="roundRect">
             <a:avLst/>
@@ -6524,14 +6507,69 @@
       </p:sp>
       <p:sp>
         <p:nvSpPr>
-          <p:cNvPr id="21" name="TextBox 20"/>
+          <p:cNvPr id="21" name="Oval 20"/>
+          <p:cNvSpPr/>
+          <p:nvPr/>
+        </p:nvSpPr>
+        <p:spPr>
+          <a:xfrm>
+            <a:off x="1005840" y="5330952"/>
+            <a:ext cx="502920" cy="502920"/>
+          </a:xfrm>
+          <a:prstGeom prst="ellipse">
+            <a:avLst/>
+          </a:prstGeom>
+          <a:solidFill>
+            <a:srgbClr val="1E293B"/>
+          </a:solidFill>
+          <a:ln>
+            <a:solidFill>
+              <a:srgbClr val="06B6D4"/>
+            </a:solidFill>
+          </a:ln>
+        </p:spPr>
+        <p:style>
+          <a:lnRef idx="1">
+            <a:schemeClr val="accent1"/>
+          </a:lnRef>
+          <a:fillRef idx="3">
+            <a:schemeClr val="accent1"/>
+          </a:fillRef>
+          <a:effectRef idx="2">
+            <a:schemeClr val="accent1"/>
+          </a:effectRef>
+          <a:fontRef idx="minor">
+            <a:schemeClr val="lt1"/>
+          </a:fontRef>
+        </p:style>
+        <p:txBody>
+          <a:bodyPr rtlCol="0" anchor="ctr"/>
+          <a:lstStyle/>
+          <a:p>
+            <a:pPr algn="ctr">
+              <a:defRPr sz="1300" b="1">
+                <a:solidFill>
+                  <a:srgbClr val="06B6D4"/>
+                </a:solidFill>
+                <a:latin typeface="Segoe UI"/>
+              </a:defRPr>
+            </a:pPr>
+            <a:r>
+              <a:t>5</a:t>
+            </a:r>
+          </a:p>
+        </p:txBody>
+      </p:sp>
+      <p:sp>
+        <p:nvSpPr>
+          <p:cNvPr id="22" name="TextBox 21"/>
           <p:cNvSpPr txBox="1"/>
           <p:nvPr/>
         </p:nvSpPr>
         <p:spPr>
           <a:xfrm>
-            <a:off x="914400" y="5266944"/>
-            <a:ext cx="2926080" cy="594360"/>
+            <a:off x="1691640" y="5303520"/>
+            <a:ext cx="4114800" cy="548640"/>
           </a:xfrm>
           <a:prstGeom prst="rect">
             <a:avLst/>
@@ -6545,7 +6583,7 @@
           <a:lstStyle/>
           <a:p>
             <a:pPr>
-              <a:defRPr sz="1250" b="1">
+              <a:defRPr sz="1600" b="1">
                 <a:solidFill>
                   <a:srgbClr val="FFFFFF"/>
                 </a:solidFill>
@@ -6560,6 +6598,61 @@
             <a:pPr>
               <a:defRPr sz="950">
                 <a:solidFill>
+                  <a:srgbClr val="94A3B8"/>
+                </a:solidFill>
+                <a:latin typeface="Segoe UI"/>
+              </a:defRPr>
+            </a:pPr>
+            <a:r>
+              <a:t>Computer Science &amp; Engineering</a:t>
+            </a:r>
+          </a:p>
+        </p:txBody>
+      </p:sp>
+      <p:sp>
+        <p:nvSpPr>
+          <p:cNvPr id="23" name="Rounded Rectangle 22"/>
+          <p:cNvSpPr/>
+          <p:nvPr/>
+        </p:nvSpPr>
+        <p:spPr>
+          <a:xfrm>
+            <a:off x="8961120" y="5376672"/>
+            <a:ext cx="2194560" cy="411480"/>
+          </a:xfrm>
+          <a:prstGeom prst="roundRect">
+            <a:avLst/>
+          </a:prstGeom>
+          <a:solidFill>
+            <a:srgbClr val="0F172A"/>
+          </a:solidFill>
+          <a:ln w="12700">
+            <a:solidFill>
+              <a:srgbClr val="06B6D4"/>
+            </a:solidFill>
+          </a:ln>
+        </p:spPr>
+        <p:style>
+          <a:lnRef idx="1">
+            <a:schemeClr val="accent1"/>
+          </a:lnRef>
+          <a:fillRef idx="3">
+            <a:schemeClr val="accent1"/>
+          </a:fillRef>
+          <a:effectRef idx="2">
+            <a:schemeClr val="accent1"/>
+          </a:effectRef>
+          <a:fontRef idx="minor">
+            <a:schemeClr val="lt1"/>
+          </a:fontRef>
+        </p:style>
+        <p:txBody>
+          <a:bodyPr rtlCol="0" anchor="ctr"/>
+          <a:lstStyle/>
+          <a:p>
+            <a:pPr algn="ctr">
+              <a:defRPr sz="1100" b="1">
+                <a:solidFill>
                   <a:srgbClr val="06B6D4"/>
                 </a:solidFill>
                 <a:latin typeface="Consolas"/>
@@ -6567,104 +6660,6 @@
             </a:pPr>
             <a:r>
               <a:t>Roll: 24241-CS-037</a:t>
-            </a:r>
-          </a:p>
-        </p:txBody>
-      </p:sp>
-      <p:sp>
-        <p:nvSpPr>
-          <p:cNvPr id="22" name="TextBox 21"/>
-          <p:cNvSpPr txBox="1"/>
-          <p:nvPr/>
-        </p:nvSpPr>
-        <p:spPr>
-          <a:xfrm>
-            <a:off x="3840480" y="5266944"/>
-            <a:ext cx="2377440" cy="594360"/>
-          </a:xfrm>
-          <a:prstGeom prst="rect">
-            <a:avLst/>
-          </a:prstGeom>
-          <a:noFill/>
-        </p:spPr>
-        <p:txBody>
-          <a:bodyPr wrap="square">
-            <a:spAutoFit/>
-          </a:bodyPr>
-          <a:lstStyle/>
-          <a:p>
-            <a:pPr>
-              <a:defRPr sz="850" b="1">
-                <a:solidFill>
-                  <a:srgbClr val="64748B"/>
-                </a:solidFill>
-                <a:latin typeface="Segoe UI"/>
-              </a:defRPr>
-            </a:pPr>
-            <a:r>
-              <a:t>ASSIGNED ROLE:</a:t>
-            </a:r>
-          </a:p>
-          <a:p>
-            <a:pPr>
-              <a:defRPr sz="1050" b="1">
-                <a:solidFill>
-                  <a:srgbClr val="F59E0B"/>
-                </a:solidFill>
-                <a:latin typeface="Segoe UI"/>
-              </a:defRPr>
-            </a:pPr>
-            <a:r>
-              <a:t>CDR Prefix Engine &amp; Quality Assurance</a:t>
-            </a:r>
-          </a:p>
-        </p:txBody>
-      </p:sp>
-      <p:sp>
-        <p:nvSpPr>
-          <p:cNvPr id="23" name="TextBox 22"/>
-          <p:cNvSpPr txBox="1"/>
-          <p:nvPr/>
-        </p:nvSpPr>
-        <p:spPr>
-          <a:xfrm>
-            <a:off x="6400800" y="5266944"/>
-            <a:ext cx="4846320" cy="594360"/>
-          </a:xfrm>
-          <a:prstGeom prst="rect">
-            <a:avLst/>
-          </a:prstGeom>
-          <a:noFill/>
-        </p:spPr>
-        <p:txBody>
-          <a:bodyPr wrap="square">
-            <a:spAutoFit/>
-          </a:bodyPr>
-          <a:lstStyle/>
-          <a:p>
-            <a:pPr>
-              <a:defRPr sz="850" b="1">
-                <a:solidFill>
-                  <a:srgbClr val="64748B"/>
-                </a:solidFill>
-                <a:latin typeface="Segoe UI"/>
-              </a:defRPr>
-            </a:pPr>
-            <a:r>
-              <a:t>KEY CONTRIBUTIONS:</a:t>
-            </a:r>
-          </a:p>
-          <a:p>
-            <a:pPr>
-              <a:defRPr sz="950">
-                <a:solidFill>
-                  <a:srgbClr val="E2E8F0"/>
-                </a:solidFill>
-                <a:latin typeface="Segoe UI"/>
-              </a:defRPr>
-            </a:pPr>
-            <a:r>
-              <a:t> • Developed CallService prefix auto-detection algorithms (ISD, STD, Local).  • Authored JUnit 5 automated unit test suite (10/10 passing test cases).</a:t>
             </a:r>
           </a:p>
         </p:txBody>

</xml_diff>

<commit_message>
docs: remove slide 13 to streamline presentation deck to 13 slides
</commit_message>
<xml_diff>
--- a/Telephone_Bill_Management_System_Team07.pptx
+++ b/Telephone_Bill_Management_System_Team07.pptx
@@ -18,7 +18,6 @@
     <p:sldId id="266" r:id="rId17"/>
     <p:sldId id="267" r:id="rId18"/>
     <p:sldId id="268" r:id="rId19"/>
-    <p:sldId id="269" r:id="rId20"/>
   </p:sldIdLst>
   <p:sldSz cx="12191695" cy="6858000" type="screen4x3"/>
   <p:notesSz cx="6858000" cy="9144000"/>
@@ -3584,7 +3583,7 @@
               </a:defRPr>
             </a:pPr>
             <a:r>
-              <a:t>APEX TELECOM — Major Project Presentation  |  Team 07  |  Slide 1 of 14</a:t>
+              <a:t>APEX TELECOM — Major Project Presentation  |  Team 07  |  Slide 1 of 13</a:t>
             </a:r>
           </a:p>
         </p:txBody>
@@ -4038,7 +4037,7 @@
               </a:defRPr>
             </a:pPr>
             <a:r>
-              <a:t>APEX TELECOM — Major Project Presentation  |  Team 07  |  Slide 10 of 14</a:t>
+              <a:t>APEX TELECOM — Major Project Presentation  |  Team 07  |  Slide 10 of 13</a:t>
             </a:r>
           </a:p>
         </p:txBody>
@@ -4745,7 +4744,7 @@
               </a:defRPr>
             </a:pPr>
             <a:r>
-              <a:t>APEX TELECOM — Major Project Presentation  |  Team 07  |  Slide 11 of 14</a:t>
+              <a:t>APEX TELECOM — Major Project Presentation  |  Team 07  |  Slide 11 of 13</a:t>
             </a:r>
           </a:p>
         </p:txBody>
@@ -5510,7 +5509,7 @@
               </a:defRPr>
             </a:pPr>
             <a:r>
-              <a:t>APEX TELECOM — Major Project Presentation  |  Team 07  |  Slide 12 of 14</a:t>
+              <a:t>APEX TELECOM — Major Project Presentation  |  Team 07  |  Slide 12 of 13</a:t>
             </a:r>
           </a:p>
         </p:txBody>
@@ -5610,1191 +5609,6 @@
               </a:defRPr>
             </a:pPr>
             <a:r>
-              <a:t>PROJECT MEMBERS</a:t>
-            </a:r>
-          </a:p>
-          <a:p>
-            <a:pPr>
-              <a:spcAft>
-                <a:spcPts val="200"/>
-              </a:spcAft>
-              <a:defRPr sz="2200" b="1">
-                <a:solidFill>
-                  <a:srgbClr val="FFFFFF"/>
-                </a:solidFill>
-                <a:latin typeface="Segoe UI"/>
-              </a:defRPr>
-            </a:pPr>
-            <a:r>
-              <a:t>Team 07</a:t>
-            </a:r>
-          </a:p>
-          <a:p>
-            <a:pPr>
-              <a:defRPr sz="1200">
-                <a:solidFill>
-                  <a:srgbClr val="94A3B8"/>
-                </a:solidFill>
-                <a:latin typeface="Segoe UI"/>
-              </a:defRPr>
-            </a:pPr>
-            <a:r>
-              <a:t>Department of Computer Science &amp; Engineering — Academic Major Project 2026</a:t>
-            </a:r>
-          </a:p>
-        </p:txBody>
-      </p:sp>
-      <p:sp>
-        <p:nvSpPr>
-          <p:cNvPr id="4" name="Rounded Rectangle 3"/>
-          <p:cNvSpPr/>
-          <p:nvPr/>
-        </p:nvSpPr>
-        <p:spPr>
-          <a:xfrm>
-            <a:off x="731520" y="1645920"/>
-            <a:ext cx="10698480" cy="777240"/>
-          </a:xfrm>
-          <a:prstGeom prst="roundRect">
-            <a:avLst/>
-          </a:prstGeom>
-          <a:solidFill>
-            <a:srgbClr val="131A2B"/>
-          </a:solidFill>
-          <a:ln w="15240">
-            <a:solidFill>
-              <a:srgbClr val="253352"/>
-            </a:solidFill>
-          </a:ln>
-        </p:spPr>
-        <p:style>
-          <a:lnRef idx="1">
-            <a:schemeClr val="accent1"/>
-          </a:lnRef>
-          <a:fillRef idx="3">
-            <a:schemeClr val="accent1"/>
-          </a:fillRef>
-          <a:effectRef idx="2">
-            <a:schemeClr val="accent1"/>
-          </a:effectRef>
-          <a:fontRef idx="minor">
-            <a:schemeClr val="lt1"/>
-          </a:fontRef>
-        </p:style>
-        <p:txBody>
-          <a:bodyPr rtlCol="0" anchor="ctr"/>
-          <a:lstStyle/>
-          <a:p>
-            <a:pPr algn="ctr"/>
-          </a:p>
-        </p:txBody>
-      </p:sp>
-      <p:sp>
-        <p:nvSpPr>
-          <p:cNvPr id="5" name="Oval 4"/>
-          <p:cNvSpPr/>
-          <p:nvPr/>
-        </p:nvSpPr>
-        <p:spPr>
-          <a:xfrm>
-            <a:off x="1005840" y="1783080"/>
-            <a:ext cx="502920" cy="502920"/>
-          </a:xfrm>
-          <a:prstGeom prst="ellipse">
-            <a:avLst/>
-          </a:prstGeom>
-          <a:solidFill>
-            <a:srgbClr val="1E293B"/>
-          </a:solidFill>
-          <a:ln>
-            <a:solidFill>
-              <a:srgbClr val="06B6D4"/>
-            </a:solidFill>
-          </a:ln>
-        </p:spPr>
-        <p:style>
-          <a:lnRef idx="1">
-            <a:schemeClr val="accent1"/>
-          </a:lnRef>
-          <a:fillRef idx="3">
-            <a:schemeClr val="accent1"/>
-          </a:fillRef>
-          <a:effectRef idx="2">
-            <a:schemeClr val="accent1"/>
-          </a:effectRef>
-          <a:fontRef idx="minor">
-            <a:schemeClr val="lt1"/>
-          </a:fontRef>
-        </p:style>
-        <p:txBody>
-          <a:bodyPr rtlCol="0" anchor="ctr"/>
-          <a:lstStyle/>
-          <a:p>
-            <a:pPr algn="ctr">
-              <a:defRPr sz="1300" b="1">
-                <a:solidFill>
-                  <a:srgbClr val="06B6D4"/>
-                </a:solidFill>
-                <a:latin typeface="Segoe UI"/>
-              </a:defRPr>
-            </a:pPr>
-            <a:r>
-              <a:t>1</a:t>
-            </a:r>
-          </a:p>
-        </p:txBody>
-      </p:sp>
-      <p:sp>
-        <p:nvSpPr>
-          <p:cNvPr id="6" name="TextBox 5"/>
-          <p:cNvSpPr txBox="1"/>
-          <p:nvPr/>
-        </p:nvSpPr>
-        <p:spPr>
-          <a:xfrm>
-            <a:off x="1691640" y="1755648"/>
-            <a:ext cx="4114800" cy="548640"/>
-          </a:xfrm>
-          <a:prstGeom prst="rect">
-            <a:avLst/>
-          </a:prstGeom>
-          <a:noFill/>
-        </p:spPr>
-        <p:txBody>
-          <a:bodyPr wrap="square">
-            <a:spAutoFit/>
-          </a:bodyPr>
-          <a:lstStyle/>
-          <a:p>
-            <a:pPr>
-              <a:defRPr sz="1600" b="1">
-                <a:solidFill>
-                  <a:srgbClr val="FFFFFF"/>
-                </a:solidFill>
-                <a:latin typeface="Segoe UI"/>
-              </a:defRPr>
-            </a:pPr>
-            <a:r>
-              <a:t>M. Akshitha</a:t>
-            </a:r>
-          </a:p>
-          <a:p>
-            <a:pPr>
-              <a:defRPr sz="950">
-                <a:solidFill>
-                  <a:srgbClr val="94A3B8"/>
-                </a:solidFill>
-                <a:latin typeface="Segoe UI"/>
-              </a:defRPr>
-            </a:pPr>
-            <a:r>
-              <a:t>Computer Science &amp; Engineering</a:t>
-            </a:r>
-          </a:p>
-        </p:txBody>
-      </p:sp>
-      <p:sp>
-        <p:nvSpPr>
-          <p:cNvPr id="7" name="Rounded Rectangle 6"/>
-          <p:cNvSpPr/>
-          <p:nvPr/>
-        </p:nvSpPr>
-        <p:spPr>
-          <a:xfrm>
-            <a:off x="8961120" y="1828800"/>
-            <a:ext cx="2194560" cy="411480"/>
-          </a:xfrm>
-          <a:prstGeom prst="roundRect">
-            <a:avLst/>
-          </a:prstGeom>
-          <a:solidFill>
-            <a:srgbClr val="0F172A"/>
-          </a:solidFill>
-          <a:ln w="12700">
-            <a:solidFill>
-              <a:srgbClr val="06B6D4"/>
-            </a:solidFill>
-          </a:ln>
-        </p:spPr>
-        <p:style>
-          <a:lnRef idx="1">
-            <a:schemeClr val="accent1"/>
-          </a:lnRef>
-          <a:fillRef idx="3">
-            <a:schemeClr val="accent1"/>
-          </a:fillRef>
-          <a:effectRef idx="2">
-            <a:schemeClr val="accent1"/>
-          </a:effectRef>
-          <a:fontRef idx="minor">
-            <a:schemeClr val="lt1"/>
-          </a:fontRef>
-        </p:style>
-        <p:txBody>
-          <a:bodyPr rtlCol="0" anchor="ctr"/>
-          <a:lstStyle/>
-          <a:p>
-            <a:pPr algn="ctr">
-              <a:defRPr sz="1100" b="1">
-                <a:solidFill>
-                  <a:srgbClr val="06B6D4"/>
-                </a:solidFill>
-                <a:latin typeface="Consolas"/>
-              </a:defRPr>
-            </a:pPr>
-            <a:r>
-              <a:t>Roll: 24241-CS-033</a:t>
-            </a:r>
-          </a:p>
-        </p:txBody>
-      </p:sp>
-      <p:sp>
-        <p:nvSpPr>
-          <p:cNvPr id="8" name="Rounded Rectangle 7"/>
-          <p:cNvSpPr/>
-          <p:nvPr/>
-        </p:nvSpPr>
-        <p:spPr>
-          <a:xfrm>
-            <a:off x="731520" y="2532888"/>
-            <a:ext cx="10698480" cy="777240"/>
-          </a:xfrm>
-          <a:prstGeom prst="roundRect">
-            <a:avLst/>
-          </a:prstGeom>
-          <a:solidFill>
-            <a:srgbClr val="131A2B"/>
-          </a:solidFill>
-          <a:ln w="15240">
-            <a:solidFill>
-              <a:srgbClr val="253352"/>
-            </a:solidFill>
-          </a:ln>
-        </p:spPr>
-        <p:style>
-          <a:lnRef idx="1">
-            <a:schemeClr val="accent1"/>
-          </a:lnRef>
-          <a:fillRef idx="3">
-            <a:schemeClr val="accent1"/>
-          </a:fillRef>
-          <a:effectRef idx="2">
-            <a:schemeClr val="accent1"/>
-          </a:effectRef>
-          <a:fontRef idx="minor">
-            <a:schemeClr val="lt1"/>
-          </a:fontRef>
-        </p:style>
-        <p:txBody>
-          <a:bodyPr rtlCol="0" anchor="ctr"/>
-          <a:lstStyle/>
-          <a:p>
-            <a:pPr algn="ctr"/>
-          </a:p>
-        </p:txBody>
-      </p:sp>
-      <p:sp>
-        <p:nvSpPr>
-          <p:cNvPr id="9" name="Oval 8"/>
-          <p:cNvSpPr/>
-          <p:nvPr/>
-        </p:nvSpPr>
-        <p:spPr>
-          <a:xfrm>
-            <a:off x="1005840" y="2670048"/>
-            <a:ext cx="502920" cy="502920"/>
-          </a:xfrm>
-          <a:prstGeom prst="ellipse">
-            <a:avLst/>
-          </a:prstGeom>
-          <a:solidFill>
-            <a:srgbClr val="1E293B"/>
-          </a:solidFill>
-          <a:ln>
-            <a:solidFill>
-              <a:srgbClr val="06B6D4"/>
-            </a:solidFill>
-          </a:ln>
-        </p:spPr>
-        <p:style>
-          <a:lnRef idx="1">
-            <a:schemeClr val="accent1"/>
-          </a:lnRef>
-          <a:fillRef idx="3">
-            <a:schemeClr val="accent1"/>
-          </a:fillRef>
-          <a:effectRef idx="2">
-            <a:schemeClr val="accent1"/>
-          </a:effectRef>
-          <a:fontRef idx="minor">
-            <a:schemeClr val="lt1"/>
-          </a:fontRef>
-        </p:style>
-        <p:txBody>
-          <a:bodyPr rtlCol="0" anchor="ctr"/>
-          <a:lstStyle/>
-          <a:p>
-            <a:pPr algn="ctr">
-              <a:defRPr sz="1300" b="1">
-                <a:solidFill>
-                  <a:srgbClr val="06B6D4"/>
-                </a:solidFill>
-                <a:latin typeface="Segoe UI"/>
-              </a:defRPr>
-            </a:pPr>
-            <a:r>
-              <a:t>2</a:t>
-            </a:r>
-          </a:p>
-        </p:txBody>
-      </p:sp>
-      <p:sp>
-        <p:nvSpPr>
-          <p:cNvPr id="10" name="TextBox 9"/>
-          <p:cNvSpPr txBox="1"/>
-          <p:nvPr/>
-        </p:nvSpPr>
-        <p:spPr>
-          <a:xfrm>
-            <a:off x="1691640" y="2642616"/>
-            <a:ext cx="4114800" cy="548640"/>
-          </a:xfrm>
-          <a:prstGeom prst="rect">
-            <a:avLst/>
-          </a:prstGeom>
-          <a:noFill/>
-        </p:spPr>
-        <p:txBody>
-          <a:bodyPr wrap="square">
-            <a:spAutoFit/>
-          </a:bodyPr>
-          <a:lstStyle/>
-          <a:p>
-            <a:pPr>
-              <a:defRPr sz="1600" b="1">
-                <a:solidFill>
-                  <a:srgbClr val="FFFFFF"/>
-                </a:solidFill>
-                <a:latin typeface="Segoe UI"/>
-              </a:defRPr>
-            </a:pPr>
-            <a:r>
-              <a:t>G. Ashlesh</a:t>
-            </a:r>
-          </a:p>
-          <a:p>
-            <a:pPr>
-              <a:defRPr sz="950">
-                <a:solidFill>
-                  <a:srgbClr val="94A3B8"/>
-                </a:solidFill>
-                <a:latin typeface="Segoe UI"/>
-              </a:defRPr>
-            </a:pPr>
-            <a:r>
-              <a:t>Computer Science &amp; Engineering</a:t>
-            </a:r>
-          </a:p>
-        </p:txBody>
-      </p:sp>
-      <p:sp>
-        <p:nvSpPr>
-          <p:cNvPr id="11" name="Rounded Rectangle 10"/>
-          <p:cNvSpPr/>
-          <p:nvPr/>
-        </p:nvSpPr>
-        <p:spPr>
-          <a:xfrm>
-            <a:off x="8961120" y="2715768"/>
-            <a:ext cx="2194560" cy="411480"/>
-          </a:xfrm>
-          <a:prstGeom prst="roundRect">
-            <a:avLst/>
-          </a:prstGeom>
-          <a:solidFill>
-            <a:srgbClr val="0F172A"/>
-          </a:solidFill>
-          <a:ln w="12700">
-            <a:solidFill>
-              <a:srgbClr val="06B6D4"/>
-            </a:solidFill>
-          </a:ln>
-        </p:spPr>
-        <p:style>
-          <a:lnRef idx="1">
-            <a:schemeClr val="accent1"/>
-          </a:lnRef>
-          <a:fillRef idx="3">
-            <a:schemeClr val="accent1"/>
-          </a:fillRef>
-          <a:effectRef idx="2">
-            <a:schemeClr val="accent1"/>
-          </a:effectRef>
-          <a:fontRef idx="minor">
-            <a:schemeClr val="lt1"/>
-          </a:fontRef>
-        </p:style>
-        <p:txBody>
-          <a:bodyPr rtlCol="0" anchor="ctr"/>
-          <a:lstStyle/>
-          <a:p>
-            <a:pPr algn="ctr">
-              <a:defRPr sz="1100" b="1">
-                <a:solidFill>
-                  <a:srgbClr val="06B6D4"/>
-                </a:solidFill>
-                <a:latin typeface="Consolas"/>
-              </a:defRPr>
-            </a:pPr>
-            <a:r>
-              <a:t>Roll: 24241-CS-034</a:t>
-            </a:r>
-          </a:p>
-        </p:txBody>
-      </p:sp>
-      <p:sp>
-        <p:nvSpPr>
-          <p:cNvPr id="12" name="Rounded Rectangle 11"/>
-          <p:cNvSpPr/>
-          <p:nvPr/>
-        </p:nvSpPr>
-        <p:spPr>
-          <a:xfrm>
-            <a:off x="731520" y="3419856"/>
-            <a:ext cx="10698480" cy="777240"/>
-          </a:xfrm>
-          <a:prstGeom prst="roundRect">
-            <a:avLst/>
-          </a:prstGeom>
-          <a:solidFill>
-            <a:srgbClr val="131A2B"/>
-          </a:solidFill>
-          <a:ln w="15240">
-            <a:solidFill>
-              <a:srgbClr val="253352"/>
-            </a:solidFill>
-          </a:ln>
-        </p:spPr>
-        <p:style>
-          <a:lnRef idx="1">
-            <a:schemeClr val="accent1"/>
-          </a:lnRef>
-          <a:fillRef idx="3">
-            <a:schemeClr val="accent1"/>
-          </a:fillRef>
-          <a:effectRef idx="2">
-            <a:schemeClr val="accent1"/>
-          </a:effectRef>
-          <a:fontRef idx="minor">
-            <a:schemeClr val="lt1"/>
-          </a:fontRef>
-        </p:style>
-        <p:txBody>
-          <a:bodyPr rtlCol="0" anchor="ctr"/>
-          <a:lstStyle/>
-          <a:p>
-            <a:pPr algn="ctr"/>
-          </a:p>
-        </p:txBody>
-      </p:sp>
-      <p:sp>
-        <p:nvSpPr>
-          <p:cNvPr id="13" name="Oval 12"/>
-          <p:cNvSpPr/>
-          <p:nvPr/>
-        </p:nvSpPr>
-        <p:spPr>
-          <a:xfrm>
-            <a:off x="1005840" y="3557016"/>
-            <a:ext cx="502920" cy="502920"/>
-          </a:xfrm>
-          <a:prstGeom prst="ellipse">
-            <a:avLst/>
-          </a:prstGeom>
-          <a:solidFill>
-            <a:srgbClr val="1E293B"/>
-          </a:solidFill>
-          <a:ln>
-            <a:solidFill>
-              <a:srgbClr val="06B6D4"/>
-            </a:solidFill>
-          </a:ln>
-        </p:spPr>
-        <p:style>
-          <a:lnRef idx="1">
-            <a:schemeClr val="accent1"/>
-          </a:lnRef>
-          <a:fillRef idx="3">
-            <a:schemeClr val="accent1"/>
-          </a:fillRef>
-          <a:effectRef idx="2">
-            <a:schemeClr val="accent1"/>
-          </a:effectRef>
-          <a:fontRef idx="minor">
-            <a:schemeClr val="lt1"/>
-          </a:fontRef>
-        </p:style>
-        <p:txBody>
-          <a:bodyPr rtlCol="0" anchor="ctr"/>
-          <a:lstStyle/>
-          <a:p>
-            <a:pPr algn="ctr">
-              <a:defRPr sz="1300" b="1">
-                <a:solidFill>
-                  <a:srgbClr val="06B6D4"/>
-                </a:solidFill>
-                <a:latin typeface="Segoe UI"/>
-              </a:defRPr>
-            </a:pPr>
-            <a:r>
-              <a:t>3</a:t>
-            </a:r>
-          </a:p>
-        </p:txBody>
-      </p:sp>
-      <p:sp>
-        <p:nvSpPr>
-          <p:cNvPr id="14" name="TextBox 13"/>
-          <p:cNvSpPr txBox="1"/>
-          <p:nvPr/>
-        </p:nvSpPr>
-        <p:spPr>
-          <a:xfrm>
-            <a:off x="1691640" y="3529584"/>
-            <a:ext cx="4114800" cy="548640"/>
-          </a:xfrm>
-          <a:prstGeom prst="rect">
-            <a:avLst/>
-          </a:prstGeom>
-          <a:noFill/>
-        </p:spPr>
-        <p:txBody>
-          <a:bodyPr wrap="square">
-            <a:spAutoFit/>
-          </a:bodyPr>
-          <a:lstStyle/>
-          <a:p>
-            <a:pPr>
-              <a:defRPr sz="1600" b="1">
-                <a:solidFill>
-                  <a:srgbClr val="FFFFFF"/>
-                </a:solidFill>
-                <a:latin typeface="Segoe UI"/>
-              </a:defRPr>
-            </a:pPr>
-            <a:r>
-              <a:t>G. Bhargavi</a:t>
-            </a:r>
-          </a:p>
-          <a:p>
-            <a:pPr>
-              <a:defRPr sz="950">
-                <a:solidFill>
-                  <a:srgbClr val="94A3B8"/>
-                </a:solidFill>
-                <a:latin typeface="Segoe UI"/>
-              </a:defRPr>
-            </a:pPr>
-            <a:r>
-              <a:t>Computer Science &amp; Engineering</a:t>
-            </a:r>
-          </a:p>
-        </p:txBody>
-      </p:sp>
-      <p:sp>
-        <p:nvSpPr>
-          <p:cNvPr id="15" name="Rounded Rectangle 14"/>
-          <p:cNvSpPr/>
-          <p:nvPr/>
-        </p:nvSpPr>
-        <p:spPr>
-          <a:xfrm>
-            <a:off x="8961120" y="3602736"/>
-            <a:ext cx="2194560" cy="411480"/>
-          </a:xfrm>
-          <a:prstGeom prst="roundRect">
-            <a:avLst/>
-          </a:prstGeom>
-          <a:solidFill>
-            <a:srgbClr val="0F172A"/>
-          </a:solidFill>
-          <a:ln w="12700">
-            <a:solidFill>
-              <a:srgbClr val="06B6D4"/>
-            </a:solidFill>
-          </a:ln>
-        </p:spPr>
-        <p:style>
-          <a:lnRef idx="1">
-            <a:schemeClr val="accent1"/>
-          </a:lnRef>
-          <a:fillRef idx="3">
-            <a:schemeClr val="accent1"/>
-          </a:fillRef>
-          <a:effectRef idx="2">
-            <a:schemeClr val="accent1"/>
-          </a:effectRef>
-          <a:fontRef idx="minor">
-            <a:schemeClr val="lt1"/>
-          </a:fontRef>
-        </p:style>
-        <p:txBody>
-          <a:bodyPr rtlCol="0" anchor="ctr"/>
-          <a:lstStyle/>
-          <a:p>
-            <a:pPr algn="ctr">
-              <a:defRPr sz="1100" b="1">
-                <a:solidFill>
-                  <a:srgbClr val="06B6D4"/>
-                </a:solidFill>
-                <a:latin typeface="Consolas"/>
-              </a:defRPr>
-            </a:pPr>
-            <a:r>
-              <a:t>Roll: 24241-CS-035</a:t>
-            </a:r>
-          </a:p>
-        </p:txBody>
-      </p:sp>
-      <p:sp>
-        <p:nvSpPr>
-          <p:cNvPr id="16" name="Rounded Rectangle 15"/>
-          <p:cNvSpPr/>
-          <p:nvPr/>
-        </p:nvSpPr>
-        <p:spPr>
-          <a:xfrm>
-            <a:off x="731520" y="4306824"/>
-            <a:ext cx="10698480" cy="777240"/>
-          </a:xfrm>
-          <a:prstGeom prst="roundRect">
-            <a:avLst/>
-          </a:prstGeom>
-          <a:solidFill>
-            <a:srgbClr val="131A2B"/>
-          </a:solidFill>
-          <a:ln w="15240">
-            <a:solidFill>
-              <a:srgbClr val="253352"/>
-            </a:solidFill>
-          </a:ln>
-        </p:spPr>
-        <p:style>
-          <a:lnRef idx="1">
-            <a:schemeClr val="accent1"/>
-          </a:lnRef>
-          <a:fillRef idx="3">
-            <a:schemeClr val="accent1"/>
-          </a:fillRef>
-          <a:effectRef idx="2">
-            <a:schemeClr val="accent1"/>
-          </a:effectRef>
-          <a:fontRef idx="minor">
-            <a:schemeClr val="lt1"/>
-          </a:fontRef>
-        </p:style>
-        <p:txBody>
-          <a:bodyPr rtlCol="0" anchor="ctr"/>
-          <a:lstStyle/>
-          <a:p>
-            <a:pPr algn="ctr"/>
-          </a:p>
-        </p:txBody>
-      </p:sp>
-      <p:sp>
-        <p:nvSpPr>
-          <p:cNvPr id="17" name="Oval 16"/>
-          <p:cNvSpPr/>
-          <p:nvPr/>
-        </p:nvSpPr>
-        <p:spPr>
-          <a:xfrm>
-            <a:off x="1005840" y="4443984"/>
-            <a:ext cx="502920" cy="502920"/>
-          </a:xfrm>
-          <a:prstGeom prst="ellipse">
-            <a:avLst/>
-          </a:prstGeom>
-          <a:solidFill>
-            <a:srgbClr val="1E293B"/>
-          </a:solidFill>
-          <a:ln>
-            <a:solidFill>
-              <a:srgbClr val="06B6D4"/>
-            </a:solidFill>
-          </a:ln>
-        </p:spPr>
-        <p:style>
-          <a:lnRef idx="1">
-            <a:schemeClr val="accent1"/>
-          </a:lnRef>
-          <a:fillRef idx="3">
-            <a:schemeClr val="accent1"/>
-          </a:fillRef>
-          <a:effectRef idx="2">
-            <a:schemeClr val="accent1"/>
-          </a:effectRef>
-          <a:fontRef idx="minor">
-            <a:schemeClr val="lt1"/>
-          </a:fontRef>
-        </p:style>
-        <p:txBody>
-          <a:bodyPr rtlCol="0" anchor="ctr"/>
-          <a:lstStyle/>
-          <a:p>
-            <a:pPr algn="ctr">
-              <a:defRPr sz="1300" b="1">
-                <a:solidFill>
-                  <a:srgbClr val="06B6D4"/>
-                </a:solidFill>
-                <a:latin typeface="Segoe UI"/>
-              </a:defRPr>
-            </a:pPr>
-            <a:r>
-              <a:t>4</a:t>
-            </a:r>
-          </a:p>
-        </p:txBody>
-      </p:sp>
-      <p:sp>
-        <p:nvSpPr>
-          <p:cNvPr id="18" name="TextBox 17"/>
-          <p:cNvSpPr txBox="1"/>
-          <p:nvPr/>
-        </p:nvSpPr>
-        <p:spPr>
-          <a:xfrm>
-            <a:off x="1691640" y="4416552"/>
-            <a:ext cx="4114800" cy="548640"/>
-          </a:xfrm>
-          <a:prstGeom prst="rect">
-            <a:avLst/>
-          </a:prstGeom>
-          <a:noFill/>
-        </p:spPr>
-        <p:txBody>
-          <a:bodyPr wrap="square">
-            <a:spAutoFit/>
-          </a:bodyPr>
-          <a:lstStyle/>
-          <a:p>
-            <a:pPr>
-              <a:defRPr sz="1600" b="1">
-                <a:solidFill>
-                  <a:srgbClr val="FFFFFF"/>
-                </a:solidFill>
-                <a:latin typeface="Segoe UI"/>
-              </a:defRPr>
-            </a:pPr>
-            <a:r>
-              <a:t>E. Sakshi</a:t>
-            </a:r>
-          </a:p>
-          <a:p>
-            <a:pPr>
-              <a:defRPr sz="950">
-                <a:solidFill>
-                  <a:srgbClr val="94A3B8"/>
-                </a:solidFill>
-                <a:latin typeface="Segoe UI"/>
-              </a:defRPr>
-            </a:pPr>
-            <a:r>
-              <a:t>Computer Science &amp; Engineering</a:t>
-            </a:r>
-          </a:p>
-        </p:txBody>
-      </p:sp>
-      <p:sp>
-        <p:nvSpPr>
-          <p:cNvPr id="19" name="Rounded Rectangle 18"/>
-          <p:cNvSpPr/>
-          <p:nvPr/>
-        </p:nvSpPr>
-        <p:spPr>
-          <a:xfrm>
-            <a:off x="8961120" y="4489704"/>
-            <a:ext cx="2194560" cy="411480"/>
-          </a:xfrm>
-          <a:prstGeom prst="roundRect">
-            <a:avLst/>
-          </a:prstGeom>
-          <a:solidFill>
-            <a:srgbClr val="0F172A"/>
-          </a:solidFill>
-          <a:ln w="12700">
-            <a:solidFill>
-              <a:srgbClr val="06B6D4"/>
-            </a:solidFill>
-          </a:ln>
-        </p:spPr>
-        <p:style>
-          <a:lnRef idx="1">
-            <a:schemeClr val="accent1"/>
-          </a:lnRef>
-          <a:fillRef idx="3">
-            <a:schemeClr val="accent1"/>
-          </a:fillRef>
-          <a:effectRef idx="2">
-            <a:schemeClr val="accent1"/>
-          </a:effectRef>
-          <a:fontRef idx="minor">
-            <a:schemeClr val="lt1"/>
-          </a:fontRef>
-        </p:style>
-        <p:txBody>
-          <a:bodyPr rtlCol="0" anchor="ctr"/>
-          <a:lstStyle/>
-          <a:p>
-            <a:pPr algn="ctr">
-              <a:defRPr sz="1100" b="1">
-                <a:solidFill>
-                  <a:srgbClr val="06B6D4"/>
-                </a:solidFill>
-                <a:latin typeface="Consolas"/>
-              </a:defRPr>
-            </a:pPr>
-            <a:r>
-              <a:t>Roll: 24241-CS-036</a:t>
-            </a:r>
-          </a:p>
-        </p:txBody>
-      </p:sp>
-      <p:sp>
-        <p:nvSpPr>
-          <p:cNvPr id="20" name="Rounded Rectangle 19"/>
-          <p:cNvSpPr/>
-          <p:nvPr/>
-        </p:nvSpPr>
-        <p:spPr>
-          <a:xfrm>
-            <a:off x="731520" y="5193792"/>
-            <a:ext cx="10698480" cy="777240"/>
-          </a:xfrm>
-          <a:prstGeom prst="roundRect">
-            <a:avLst/>
-          </a:prstGeom>
-          <a:solidFill>
-            <a:srgbClr val="131A2B"/>
-          </a:solidFill>
-          <a:ln w="15240">
-            <a:solidFill>
-              <a:srgbClr val="253352"/>
-            </a:solidFill>
-          </a:ln>
-        </p:spPr>
-        <p:style>
-          <a:lnRef idx="1">
-            <a:schemeClr val="accent1"/>
-          </a:lnRef>
-          <a:fillRef idx="3">
-            <a:schemeClr val="accent1"/>
-          </a:fillRef>
-          <a:effectRef idx="2">
-            <a:schemeClr val="accent1"/>
-          </a:effectRef>
-          <a:fontRef idx="minor">
-            <a:schemeClr val="lt1"/>
-          </a:fontRef>
-        </p:style>
-        <p:txBody>
-          <a:bodyPr rtlCol="0" anchor="ctr"/>
-          <a:lstStyle/>
-          <a:p>
-            <a:pPr algn="ctr"/>
-          </a:p>
-        </p:txBody>
-      </p:sp>
-      <p:sp>
-        <p:nvSpPr>
-          <p:cNvPr id="21" name="Oval 20"/>
-          <p:cNvSpPr/>
-          <p:nvPr/>
-        </p:nvSpPr>
-        <p:spPr>
-          <a:xfrm>
-            <a:off x="1005840" y="5330952"/>
-            <a:ext cx="502920" cy="502920"/>
-          </a:xfrm>
-          <a:prstGeom prst="ellipse">
-            <a:avLst/>
-          </a:prstGeom>
-          <a:solidFill>
-            <a:srgbClr val="1E293B"/>
-          </a:solidFill>
-          <a:ln>
-            <a:solidFill>
-              <a:srgbClr val="06B6D4"/>
-            </a:solidFill>
-          </a:ln>
-        </p:spPr>
-        <p:style>
-          <a:lnRef idx="1">
-            <a:schemeClr val="accent1"/>
-          </a:lnRef>
-          <a:fillRef idx="3">
-            <a:schemeClr val="accent1"/>
-          </a:fillRef>
-          <a:effectRef idx="2">
-            <a:schemeClr val="accent1"/>
-          </a:effectRef>
-          <a:fontRef idx="minor">
-            <a:schemeClr val="lt1"/>
-          </a:fontRef>
-        </p:style>
-        <p:txBody>
-          <a:bodyPr rtlCol="0" anchor="ctr"/>
-          <a:lstStyle/>
-          <a:p>
-            <a:pPr algn="ctr">
-              <a:defRPr sz="1300" b="1">
-                <a:solidFill>
-                  <a:srgbClr val="06B6D4"/>
-                </a:solidFill>
-                <a:latin typeface="Segoe UI"/>
-              </a:defRPr>
-            </a:pPr>
-            <a:r>
-              <a:t>5</a:t>
-            </a:r>
-          </a:p>
-        </p:txBody>
-      </p:sp>
-      <p:sp>
-        <p:nvSpPr>
-          <p:cNvPr id="22" name="TextBox 21"/>
-          <p:cNvSpPr txBox="1"/>
-          <p:nvPr/>
-        </p:nvSpPr>
-        <p:spPr>
-          <a:xfrm>
-            <a:off x="1691640" y="5303520"/>
-            <a:ext cx="4114800" cy="548640"/>
-          </a:xfrm>
-          <a:prstGeom prst="rect">
-            <a:avLst/>
-          </a:prstGeom>
-          <a:noFill/>
-        </p:spPr>
-        <p:txBody>
-          <a:bodyPr wrap="square">
-            <a:spAutoFit/>
-          </a:bodyPr>
-          <a:lstStyle/>
-          <a:p>
-            <a:pPr>
-              <a:defRPr sz="1600" b="1">
-                <a:solidFill>
-                  <a:srgbClr val="FFFFFF"/>
-                </a:solidFill>
-                <a:latin typeface="Segoe UI"/>
-              </a:defRPr>
-            </a:pPr>
-            <a:r>
-              <a:t>A. Varun</a:t>
-            </a:r>
-          </a:p>
-          <a:p>
-            <a:pPr>
-              <a:defRPr sz="950">
-                <a:solidFill>
-                  <a:srgbClr val="94A3B8"/>
-                </a:solidFill>
-                <a:latin typeface="Segoe UI"/>
-              </a:defRPr>
-            </a:pPr>
-            <a:r>
-              <a:t>Computer Science &amp; Engineering</a:t>
-            </a:r>
-          </a:p>
-        </p:txBody>
-      </p:sp>
-      <p:sp>
-        <p:nvSpPr>
-          <p:cNvPr id="23" name="Rounded Rectangle 22"/>
-          <p:cNvSpPr/>
-          <p:nvPr/>
-        </p:nvSpPr>
-        <p:spPr>
-          <a:xfrm>
-            <a:off x="8961120" y="5376672"/>
-            <a:ext cx="2194560" cy="411480"/>
-          </a:xfrm>
-          <a:prstGeom prst="roundRect">
-            <a:avLst/>
-          </a:prstGeom>
-          <a:solidFill>
-            <a:srgbClr val="0F172A"/>
-          </a:solidFill>
-          <a:ln w="12700">
-            <a:solidFill>
-              <a:srgbClr val="06B6D4"/>
-            </a:solidFill>
-          </a:ln>
-        </p:spPr>
-        <p:style>
-          <a:lnRef idx="1">
-            <a:schemeClr val="accent1"/>
-          </a:lnRef>
-          <a:fillRef idx="3">
-            <a:schemeClr val="accent1"/>
-          </a:fillRef>
-          <a:effectRef idx="2">
-            <a:schemeClr val="accent1"/>
-          </a:effectRef>
-          <a:fontRef idx="minor">
-            <a:schemeClr val="lt1"/>
-          </a:fontRef>
-        </p:style>
-        <p:txBody>
-          <a:bodyPr rtlCol="0" anchor="ctr"/>
-          <a:lstStyle/>
-          <a:p>
-            <a:pPr algn="ctr">
-              <a:defRPr sz="1100" b="1">
-                <a:solidFill>
-                  <a:srgbClr val="06B6D4"/>
-                </a:solidFill>
-                <a:latin typeface="Consolas"/>
-              </a:defRPr>
-            </a:pPr>
-            <a:r>
-              <a:t>Roll: 24241-CS-037</a:t>
-            </a:r>
-          </a:p>
-        </p:txBody>
-      </p:sp>
-      <p:sp>
-        <p:nvSpPr>
-          <p:cNvPr id="24" name="TextBox 23"/>
-          <p:cNvSpPr txBox="1"/>
-          <p:nvPr/>
-        </p:nvSpPr>
-        <p:spPr>
-          <a:xfrm>
-            <a:off x="731520" y="6309360"/>
-            <a:ext cx="10698480" cy="365760"/>
-          </a:xfrm>
-          <a:prstGeom prst="rect">
-            <a:avLst/>
-          </a:prstGeom>
-          <a:noFill/>
-        </p:spPr>
-        <p:txBody>
-          <a:bodyPr wrap="square" lIns="0" tIns="0" rIns="0" bIns="0">
-            <a:spAutoFit/>
-          </a:bodyPr>
-          <a:lstStyle/>
-          <a:p>
-            <a:pPr>
-              <a:defRPr sz="950">
-                <a:solidFill>
-                  <a:srgbClr val="64748B"/>
-                </a:solidFill>
-                <a:latin typeface="Segoe UI"/>
-              </a:defRPr>
-            </a:pPr>
-            <a:r>
-              <a:t>APEX TELECOM — Major Project Presentation  |  Team 07  |  Slide 13 of 14</a:t>
-            </a:r>
-          </a:p>
-        </p:txBody>
-      </p:sp>
-    </p:spTree>
-  </p:cSld>
-  <p:clrMapOvr>
-    <a:masterClrMapping/>
-  </p:clrMapOvr>
-</p:sld>
-</file>
-
-<file path=ppt/slides/slide14.xml><?xml version="1.0" encoding="utf-8"?>
-<p:sld xmlns:a="http://schemas.openxmlformats.org/drawingml/2006/main" xmlns:p="http://schemas.openxmlformats.org/presentationml/2006/main" xmlns:r="http://schemas.openxmlformats.org/officeDocument/2006/relationships">
-  <p:cSld>
-    <p:spTree>
-      <p:nvGrpSpPr>
-        <p:cNvPr id="1" name=""/>
-        <p:cNvGrpSpPr/>
-        <p:nvPr/>
-      </p:nvGrpSpPr>
-      <p:grpSpPr/>
-      <p:sp>
-        <p:nvSpPr>
-          <p:cNvPr id="2" name="Rectangle 1"/>
-          <p:cNvSpPr/>
-          <p:nvPr/>
-        </p:nvSpPr>
-        <p:spPr>
-          <a:xfrm>
-            <a:off x="0" y="0"/>
-            <a:ext cx="12191695" cy="6858000"/>
-          </a:xfrm>
-          <a:prstGeom prst="rect">
-            <a:avLst/>
-          </a:prstGeom>
-          <a:solidFill>
-            <a:srgbClr val="0B0F19"/>
-          </a:solidFill>
-          <a:ln>
-            <a:noFill/>
-          </a:ln>
-        </p:spPr>
-        <p:style>
-          <a:lnRef idx="1">
-            <a:schemeClr val="accent1"/>
-          </a:lnRef>
-          <a:fillRef idx="3">
-            <a:schemeClr val="accent1"/>
-          </a:fillRef>
-          <a:effectRef idx="2">
-            <a:schemeClr val="accent1"/>
-          </a:effectRef>
-          <a:fontRef idx="minor">
-            <a:schemeClr val="lt1"/>
-          </a:fontRef>
-        </p:style>
-        <p:txBody>
-          <a:bodyPr rtlCol="0" anchor="ctr"/>
-          <a:lstStyle/>
-          <a:p>
-            <a:pPr algn="ctr"/>
-          </a:p>
-        </p:txBody>
-      </p:sp>
-      <p:sp>
-        <p:nvSpPr>
-          <p:cNvPr id="3" name="TextBox 2"/>
-          <p:cNvSpPr txBox="1"/>
-          <p:nvPr/>
-        </p:nvSpPr>
-        <p:spPr>
-          <a:xfrm>
-            <a:off x="731520" y="457200"/>
-            <a:ext cx="10698480" cy="1005840"/>
-          </a:xfrm>
-          <a:prstGeom prst="rect">
-            <a:avLst/>
-          </a:prstGeom>
-          <a:noFill/>
-        </p:spPr>
-        <p:txBody>
-          <a:bodyPr wrap="square" lIns="0" tIns="0" rIns="0" bIns="0">
-            <a:spAutoFit/>
-          </a:bodyPr>
-          <a:lstStyle/>
-          <a:p>
-            <a:pPr>
-              <a:spcAft>
-                <a:spcPts val="200"/>
-              </a:spcAft>
-              <a:defRPr sz="1100" b="1">
-                <a:solidFill>
-                  <a:srgbClr val="06B6D4"/>
-                </a:solidFill>
-                <a:latin typeface="Segoe UI"/>
-              </a:defRPr>
-            </a:pPr>
-            <a:r>
               <a:t>CONCLUSION &amp; ROADMAP</a:t>
             </a:r>
           </a:p>
@@ -7273,7 +6087,7 @@
               </a:defRPr>
             </a:pPr>
             <a:r>
-              <a:t>APEX TELECOM — Major Project Presentation  |  Team 07  |  Slide 14 of 14</a:t>
+              <a:t>APEX TELECOM — Major Project Presentation  |  Team 07  |  Slide 13 of 13</a:t>
             </a:r>
           </a:p>
         </p:txBody>
@@ -7838,7 +6652,7 @@
               </a:defRPr>
             </a:pPr>
             <a:r>
-              <a:t>APEX TELECOM — Major Project Presentation  |  Team 07  |  Slide 2 of 14</a:t>
+              <a:t>APEX TELECOM — Major Project Presentation  |  Team 07  |  Slide 2 of 13</a:t>
             </a:r>
           </a:p>
         </p:txBody>
@@ -8803,7 +7617,7 @@
               </a:defRPr>
             </a:pPr>
             <a:r>
-              <a:t>APEX TELECOM — Major Project Presentation  |  Team 07  |  Slide 3 of 14</a:t>
+              <a:t>APEX TELECOM — Major Project Presentation  |  Team 07  |  Slide 3 of 13</a:t>
             </a:r>
           </a:p>
         </p:txBody>
@@ -9646,7 +8460,7 @@
               </a:defRPr>
             </a:pPr>
             <a:r>
-              <a:t>APEX TELECOM — Major Project Presentation  |  Team 07  |  Slide 4 of 14</a:t>
+              <a:t>APEX TELECOM — Major Project Presentation  |  Team 07  |  Slide 4 of 13</a:t>
             </a:r>
           </a:p>
         </p:txBody>
@@ -10100,7 +8914,7 @@
               </a:defRPr>
             </a:pPr>
             <a:r>
-              <a:t>APEX TELECOM — Major Project Presentation  |  Team 07  |  Slide 5 of 14</a:t>
+              <a:t>APEX TELECOM — Major Project Presentation  |  Team 07  |  Slide 5 of 13</a:t>
             </a:r>
           </a:p>
         </p:txBody>
@@ -10554,7 +9368,7 @@
               </a:defRPr>
             </a:pPr>
             <a:r>
-              <a:t>APEX TELECOM — Major Project Presentation  |  Team 07  |  Slide 6 of 14</a:t>
+              <a:t>APEX TELECOM — Major Project Presentation  |  Team 07  |  Slide 6 of 13</a:t>
             </a:r>
           </a:p>
         </p:txBody>
@@ -11008,7 +9822,7 @@
               </a:defRPr>
             </a:pPr>
             <a:r>
-              <a:t>APEX TELECOM — Major Project Presentation  |  Team 07  |  Slide 7 of 14</a:t>
+              <a:t>APEX TELECOM — Major Project Presentation  |  Team 07  |  Slide 7 of 13</a:t>
             </a:r>
           </a:p>
         </p:txBody>
@@ -11462,7 +10276,7 @@
               </a:defRPr>
             </a:pPr>
             <a:r>
-              <a:t>APEX TELECOM — Major Project Presentation  |  Team 07  |  Slide 8 of 14</a:t>
+              <a:t>APEX TELECOM — Major Project Presentation  |  Team 07  |  Slide 8 of 13</a:t>
             </a:r>
           </a:p>
         </p:txBody>
@@ -11916,7 +10730,7 @@
               </a:defRPr>
             </a:pPr>
             <a:r>
-              <a:t>APEX TELECOM — Major Project Presentation  |  Team 07  |  Slide 9 of 14</a:t>
+              <a:t>APEX TELECOM — Major Project Presentation  |  Team 07  |  Slide 9 of 13</a:t>
             </a:r>
           </a:p>
         </p:txBody>

</xml_diff>

<commit_message>
docs: style presentation deck with clean white theme and decent professional colors
</commit_message>
<xml_diff>
--- a/Telephone_Bill_Management_System_Team07.pptx
+++ b/Telephone_Bill_Management_System_Team07.pptx
@@ -3115,7 +3115,7 @@
             <a:avLst/>
           </a:prstGeom>
           <a:solidFill>
-            <a:srgbClr val="0B0F19"/>
+            <a:srgbClr val="FFFFFF"/>
           </a:solidFill>
           <a:ln>
             <a:noFill/>
@@ -3158,7 +3158,7 @@
             <a:avLst/>
           </a:prstGeom>
           <a:solidFill>
-            <a:srgbClr val="2563EB"/>
+            <a:srgbClr val="1D4ED8"/>
           </a:solidFill>
           <a:ln>
             <a:noFill/>
@@ -3195,17 +3195,17 @@
         <p:spPr>
           <a:xfrm>
             <a:off x="731520" y="731520"/>
-            <a:ext cx="2926080" cy="411480"/>
+            <a:ext cx="3108960" cy="411480"/>
           </a:xfrm>
           <a:prstGeom prst="roundRect">
             <a:avLst/>
           </a:prstGeom>
           <a:solidFill>
-            <a:srgbClr val="1E293B"/>
+            <a:srgbClr val="EFF6FF"/>
           </a:solidFill>
           <a:ln w="12700">
             <a:solidFill>
-              <a:srgbClr val="2563EB"/>
+              <a:srgbClr val="BFDBFE"/>
             </a:solidFill>
           </a:ln>
         </p:spPr>
@@ -3230,7 +3230,7 @@
             <a:pPr algn="ctr">
               <a:defRPr sz="1050" b="1">
                 <a:solidFill>
-                  <a:srgbClr val="06B6D4"/>
+                  <a:srgbClr val="1D4ED8"/>
                 </a:solidFill>
                 <a:latin typeface="Segoe UI"/>
               </a:defRPr>
@@ -3249,8 +3249,8 @@
         </p:nvSpPr>
         <p:spPr>
           <a:xfrm>
-            <a:off x="731520" y="1280160"/>
-            <a:ext cx="6858000" cy="2011680"/>
+            <a:off x="731520" y="1325880"/>
+            <a:ext cx="6766560" cy="2011680"/>
           </a:xfrm>
           <a:prstGeom prst="rect">
             <a:avLst/>
@@ -3265,11 +3265,11 @@
           <a:p>
             <a:pPr>
               <a:spcAft>
-                <a:spcPts val="800"/>
+                <a:spcPts val="1000"/>
               </a:spcAft>
               <a:defRPr sz="3600" b="1">
                 <a:solidFill>
-                  <a:srgbClr val="FFFFFF"/>
+                  <a:srgbClr val="0F172A"/>
                 </a:solidFill>
                 <a:latin typeface="Segoe UI"/>
               </a:defRPr>
@@ -3286,7 +3286,7 @@
             <a:pPr>
               <a:defRPr sz="1300">
                 <a:solidFill>
-                  <a:srgbClr val="94A3B8"/>
+                  <a:srgbClr val="475569"/>
                 </a:solidFill>
                 <a:latin typeface="Segoe UI"/>
               </a:defRPr>
@@ -3296,7 +3296,7 @@
             </a:r>
             <a:br/>
             <a:r>
-              <a:t>Developed in Java 21 (JavaFX + SQLite + OpenPDF) with Live Cloud Web Deployment</a:t>
+              <a:t>Engineered in Java 21 (JavaFX + SQLite + OpenPDF) with Live Cloud Web Deployment</a:t>
             </a:r>
           </a:p>
         </p:txBody>
@@ -3309,18 +3309,18 @@
         </p:nvSpPr>
         <p:spPr>
           <a:xfrm>
-            <a:off x="731520" y="3474720"/>
-            <a:ext cx="4389120" cy="457200"/>
+            <a:off x="731520" y="3566160"/>
+            <a:ext cx="4572000" cy="438912"/>
           </a:xfrm>
           <a:prstGeom prst="roundRect">
             <a:avLst/>
           </a:prstGeom>
           <a:solidFill>
-            <a:srgbClr val="064E3B"/>
+            <a:srgbClr val="ECFDF5"/>
           </a:solidFill>
           <a:ln>
             <a:solidFill>
-              <a:srgbClr val="10B981"/>
+              <a:srgbClr val="A7F3D0"/>
             </a:solidFill>
           </a:ln>
         </p:spPr>
@@ -3345,7 +3345,7 @@
             <a:pPr algn="ctr">
               <a:defRPr sz="1050" b="1">
                 <a:solidFill>
-                  <a:srgbClr val="A7F3D0"/>
+                  <a:srgbClr val="107A57"/>
                 </a:solidFill>
                 <a:latin typeface="Segoe UI"/>
               </a:defRPr>
@@ -3364,18 +3364,18 @@
         </p:nvSpPr>
         <p:spPr>
           <a:xfrm>
-            <a:off x="7772400" y="731520"/>
-            <a:ext cx="3657600" cy="5303520"/>
+            <a:off x="731520" y="4160520"/>
+            <a:ext cx="4572000" cy="438912"/>
           </a:xfrm>
           <a:prstGeom prst="roundRect">
             <a:avLst/>
           </a:prstGeom>
           <a:solidFill>
-            <a:srgbClr val="131A2B"/>
+            <a:srgbClr val="EFF6FF"/>
           </a:solidFill>
-          <a:ln w="15240">
+          <a:ln>
             <a:solidFill>
-              <a:srgbClr val="2563EB"/>
+              <a:srgbClr val="BFDBFE"/>
             </a:solidFill>
           </a:ln>
         </p:spPr>
@@ -3397,19 +3397,74 @@
           <a:bodyPr rtlCol="0" anchor="ctr"/>
           <a:lstStyle/>
           <a:p>
+            <a:pPr algn="ctr">
+              <a:defRPr sz="950" b="1">
+                <a:solidFill>
+                  <a:srgbClr val="1D4ED8"/>
+                </a:solidFill>
+                <a:latin typeface="Segoe UI"/>
+              </a:defRPr>
+            </a:pPr>
+            <a:r>
+              <a:t>📂 GitHub: github.com/ashlesh0805/TelephoneBillManagementSystem</a:t>
+            </a:r>
+          </a:p>
+        </p:txBody>
+      </p:sp>
+      <p:sp>
+        <p:nvSpPr>
+          <p:cNvPr id="8" name="Rounded Rectangle 7"/>
+          <p:cNvSpPr/>
+          <p:nvPr/>
+        </p:nvSpPr>
+        <p:spPr>
+          <a:xfrm>
+            <a:off x="7772400" y="731520"/>
+            <a:ext cx="3657600" cy="5212080"/>
+          </a:xfrm>
+          <a:prstGeom prst="roundRect">
+            <a:avLst/>
+          </a:prstGeom>
+          <a:solidFill>
+            <a:srgbClr val="F8FAFC"/>
+          </a:solidFill>
+          <a:ln w="15240">
+            <a:solidFill>
+              <a:srgbClr val="CBD5E1"/>
+            </a:solidFill>
+          </a:ln>
+        </p:spPr>
+        <p:style>
+          <a:lnRef idx="1">
+            <a:schemeClr val="accent1"/>
+          </a:lnRef>
+          <a:fillRef idx="3">
+            <a:schemeClr val="accent1"/>
+          </a:fillRef>
+          <a:effectRef idx="2">
+            <a:schemeClr val="accent1"/>
+          </a:effectRef>
+          <a:fontRef idx="minor">
+            <a:schemeClr val="lt1"/>
+          </a:fontRef>
+        </p:style>
+        <p:txBody>
+          <a:bodyPr rtlCol="0" anchor="ctr"/>
+          <a:lstStyle/>
+          <a:p>
             <a:pPr algn="ctr"/>
           </a:p>
         </p:txBody>
       </p:sp>
       <p:sp>
         <p:nvSpPr>
-          <p:cNvPr id="8" name="TextBox 7"/>
+          <p:cNvPr id="9" name="TextBox 8"/>
           <p:cNvSpPr txBox="1"/>
           <p:nvPr/>
         </p:nvSpPr>
         <p:spPr>
           <a:xfrm>
-            <a:off x="8046720" y="1005840"/>
+            <a:off x="8046720" y="960120"/>
             <a:ext cx="3108960" cy="4754880"/>
           </a:xfrm>
           <a:prstGeom prst="rect">
@@ -3427,9 +3482,9 @@
               <a:spcAft>
                 <a:spcPts val="200"/>
               </a:spcAft>
-              <a:defRPr sz="1500" b="1">
-                <a:solidFill>
-                  <a:srgbClr val="06B6D4"/>
+              <a:defRPr sz="1600" b="1">
+                <a:solidFill>
+                  <a:srgbClr val="1D4ED8"/>
                 </a:solidFill>
                 <a:latin typeface="Segoe UI"/>
               </a:defRPr>
@@ -3443,9 +3498,9 @@
               <a:spcAft>
                 <a:spcPts val="1600"/>
               </a:spcAft>
-              <a:defRPr sz="1000">
-                <a:solidFill>
-                  <a:srgbClr val="94A3B8"/>
+              <a:defRPr sz="1050">
+                <a:solidFill>
+                  <a:srgbClr val="64748B"/>
                 </a:solidFill>
                 <a:latin typeface="Segoe UI"/>
               </a:defRPr>
@@ -3459,9 +3514,9 @@
               <a:spcAft>
                 <a:spcPts val="1200"/>
               </a:spcAft>
-              <a:defRPr sz="1300" b="1">
-                <a:solidFill>
-                  <a:srgbClr val="FFFFFF"/>
+              <a:defRPr sz="1350" b="1">
+                <a:solidFill>
+                  <a:srgbClr val="0F172A"/>
                 </a:solidFill>
                 <a:latin typeface="Segoe UI"/>
               </a:defRPr>
@@ -3477,13 +3532,13 @@
               </a:spcAft>
               <a:defRPr sz="1200" b="1">
                 <a:solidFill>
-                  <a:srgbClr val="E2E8F0"/>
-                </a:solidFill>
-                <a:latin typeface="Segoe UI"/>
-              </a:defRPr>
-            </a:pPr>
-            <a:r>
-              <a:t>•  M. Akshitha (24241-CS-033)</a:t>
+                  <a:srgbClr val="334155"/>
+                </a:solidFill>
+                <a:latin typeface="Segoe UI"/>
+              </a:defRPr>
+            </a:pPr>
+            <a:r>
+              <a:t>•  M. Akshitha  (24241-CS-033)</a:t>
             </a:r>
           </a:p>
           <a:p>
@@ -3493,13 +3548,13 @@
               </a:spcAft>
               <a:defRPr sz="1200" b="1">
                 <a:solidFill>
-                  <a:srgbClr val="E2E8F0"/>
-                </a:solidFill>
-                <a:latin typeface="Segoe UI"/>
-              </a:defRPr>
-            </a:pPr>
-            <a:r>
-              <a:t>•  G. Ashlesh (24241-CS-034)</a:t>
+                  <a:srgbClr val="334155"/>
+                </a:solidFill>
+                <a:latin typeface="Segoe UI"/>
+              </a:defRPr>
+            </a:pPr>
+            <a:r>
+              <a:t>•  G. Ashlesh  (24241-CS-034)</a:t>
             </a:r>
           </a:p>
           <a:p>
@@ -3509,13 +3564,13 @@
               </a:spcAft>
               <a:defRPr sz="1200" b="1">
                 <a:solidFill>
-                  <a:srgbClr val="E2E8F0"/>
-                </a:solidFill>
-                <a:latin typeface="Segoe UI"/>
-              </a:defRPr>
-            </a:pPr>
-            <a:r>
-              <a:t>•  G. Bhargavi (24241-CS-035)</a:t>
+                  <a:srgbClr val="334155"/>
+                </a:solidFill>
+                <a:latin typeface="Segoe UI"/>
+              </a:defRPr>
+            </a:pPr>
+            <a:r>
+              <a:t>•  G. Bhargavi  (24241-CS-035)</a:t>
             </a:r>
           </a:p>
           <a:p>
@@ -3525,13 +3580,13 @@
               </a:spcAft>
               <a:defRPr sz="1200" b="1">
                 <a:solidFill>
-                  <a:srgbClr val="E2E8F0"/>
-                </a:solidFill>
-                <a:latin typeface="Segoe UI"/>
-              </a:defRPr>
-            </a:pPr>
-            <a:r>
-              <a:t>•  E. Sakshi (24241-CS-036)</a:t>
+                  <a:srgbClr val="334155"/>
+                </a:solidFill>
+                <a:latin typeface="Segoe UI"/>
+              </a:defRPr>
+            </a:pPr>
+            <a:r>
+              <a:t>•  E. Sakshi  (24241-CS-036)</a:t>
             </a:r>
           </a:p>
           <a:p>
@@ -3541,27 +3596,70 @@
               </a:spcAft>
               <a:defRPr sz="1200" b="1">
                 <a:solidFill>
-                  <a:srgbClr val="E2E8F0"/>
-                </a:solidFill>
-                <a:latin typeface="Segoe UI"/>
-              </a:defRPr>
-            </a:pPr>
-            <a:r>
-              <a:t>•  A. Varun (24241-CS-037)</a:t>
-            </a:r>
-          </a:p>
-        </p:txBody>
-      </p:sp>
-      <p:sp>
-        <p:nvSpPr>
-          <p:cNvPr id="9" name="TextBox 8"/>
+                  <a:srgbClr val="334155"/>
+                </a:solidFill>
+                <a:latin typeface="Segoe UI"/>
+              </a:defRPr>
+            </a:pPr>
+            <a:r>
+              <a:t>•  A. Varun  (24241-CS-037)</a:t>
+            </a:r>
+          </a:p>
+        </p:txBody>
+      </p:sp>
+      <p:sp>
+        <p:nvSpPr>
+          <p:cNvPr id="10" name="Rectangle 9"/>
+          <p:cNvSpPr/>
+          <p:nvPr/>
+        </p:nvSpPr>
+        <p:spPr>
+          <a:xfrm>
+            <a:off x="731520" y="6217920"/>
+            <a:ext cx="10728655" cy="13716"/>
+          </a:xfrm>
+          <a:prstGeom prst="rect">
+            <a:avLst/>
+          </a:prstGeom>
+          <a:solidFill>
+            <a:srgbClr val="E2E8F0"/>
+          </a:solidFill>
+          <a:ln>
+            <a:noFill/>
+          </a:ln>
+        </p:spPr>
+        <p:style>
+          <a:lnRef idx="1">
+            <a:schemeClr val="accent1"/>
+          </a:lnRef>
+          <a:fillRef idx="3">
+            <a:schemeClr val="accent1"/>
+          </a:fillRef>
+          <a:effectRef idx="2">
+            <a:schemeClr val="accent1"/>
+          </a:effectRef>
+          <a:fontRef idx="minor">
+            <a:schemeClr val="lt1"/>
+          </a:fontRef>
+        </p:style>
+        <p:txBody>
+          <a:bodyPr rtlCol="0" anchor="ctr"/>
+          <a:lstStyle/>
+          <a:p>
+            <a:pPr algn="ctr"/>
+          </a:p>
+        </p:txBody>
+      </p:sp>
+      <p:sp>
+        <p:nvSpPr>
+          <p:cNvPr id="11" name="TextBox 10"/>
           <p:cNvSpPr txBox="1"/>
           <p:nvPr/>
         </p:nvSpPr>
         <p:spPr>
           <a:xfrm>
             <a:off x="731520" y="6309360"/>
-            <a:ext cx="10698480" cy="365760"/>
+            <a:ext cx="10698480" cy="320040"/>
           </a:xfrm>
           <a:prstGeom prst="rect">
             <a:avLst/>
@@ -3621,7 +3719,7 @@
             <a:avLst/>
           </a:prstGeom>
           <a:solidFill>
-            <a:srgbClr val="0B0F19"/>
+            <a:srgbClr val="FFFFFF"/>
           </a:solidFill>
           <a:ln>
             <a:noFill/>
@@ -3657,8 +3755,8 @@
         </p:nvSpPr>
         <p:spPr>
           <a:xfrm>
-            <a:off x="731520" y="457200"/>
-            <a:ext cx="10698480" cy="1005840"/>
+            <a:off x="731520" y="411480"/>
+            <a:ext cx="10698480" cy="1051560"/>
           </a:xfrm>
           <a:prstGeom prst="rect">
             <a:avLst/>
@@ -3675,9 +3773,9 @@
               <a:spcAft>
                 <a:spcPts val="200"/>
               </a:spcAft>
-              <a:defRPr sz="1100" b="1">
-                <a:solidFill>
-                  <a:srgbClr val="06B6D4"/>
+              <a:defRPr sz="1050" b="1">
+                <a:solidFill>
+                  <a:srgbClr val="1D4ED8"/>
                 </a:solidFill>
                 <a:latin typeface="Segoe UI"/>
               </a:defRPr>
@@ -3693,7 +3791,7 @@
               </a:spcAft>
               <a:defRPr sz="2200" b="1">
                 <a:solidFill>
-                  <a:srgbClr val="FFFFFF"/>
+                  <a:srgbClr val="0F172A"/>
                 </a:solidFill>
                 <a:latin typeface="Segoe UI"/>
               </a:defRPr>
@@ -3704,9 +3802,9 @@
           </a:p>
           <a:p>
             <a:pPr>
-              <a:defRPr sz="1200">
-                <a:solidFill>
-                  <a:srgbClr val="94A3B8"/>
+              <a:defRPr sz="1150">
+                <a:solidFill>
+                  <a:srgbClr val="475569"/>
                 </a:solidFill>
                 <a:latin typeface="Segoe UI"/>
               </a:defRPr>
@@ -3732,11 +3830,11 @@
             <a:avLst/>
           </a:prstGeom>
           <a:solidFill>
-            <a:srgbClr val="131A2B"/>
+            <a:srgbClr val="F8FAFC"/>
           </a:solidFill>
           <a:ln w="15240">
             <a:solidFill>
-              <a:srgbClr val="253352"/>
+              <a:srgbClr val="E2E8F0"/>
             </a:solidFill>
           </a:ln>
         </p:spPr>
@@ -3785,9 +3883,9 @@
           <a:lstStyle/>
           <a:p>
             <a:pPr>
-              <a:defRPr sz="1250" b="1">
-                <a:solidFill>
-                  <a:srgbClr val="06B6D4"/>
+              <a:defRPr sz="1200" b="1">
+                <a:solidFill>
+                  <a:srgbClr val="1D4ED8"/>
                 </a:solidFill>
                 <a:latin typeface="Segoe UI"/>
               </a:defRPr>
@@ -3799,11 +3897,11 @@
           <a:p>
             <a:pPr>
               <a:spcAft>
-                <a:spcPts val="1000"/>
+                <a:spcPts val="900"/>
               </a:spcAft>
               <a:defRPr sz="1050">
                 <a:solidFill>
-                  <a:srgbClr val="94A3B8"/>
+                  <a:srgbClr val="475569"/>
                 </a:solidFill>
                 <a:latin typeface="Segoe UI"/>
               </a:defRPr>
@@ -3814,9 +3912,9 @@
           </a:p>
           <a:p>
             <a:pPr>
-              <a:defRPr sz="1250" b="1">
-                <a:solidFill>
-                  <a:srgbClr val="FFFFFF"/>
+              <a:defRPr sz="1200" b="1">
+                <a:solidFill>
+                  <a:srgbClr val="0F172A"/>
                 </a:solidFill>
                 <a:latin typeface="Segoe UI"/>
               </a:defRPr>
@@ -3828,11 +3926,11 @@
           <a:p>
             <a:pPr>
               <a:spcAft>
-                <a:spcPts val="1000"/>
+                <a:spcPts val="900"/>
               </a:spcAft>
               <a:defRPr sz="1050">
                 <a:solidFill>
-                  <a:srgbClr val="94A3B8"/>
+                  <a:srgbClr val="475569"/>
                 </a:solidFill>
                 <a:latin typeface="Segoe UI"/>
               </a:defRPr>
@@ -3843,9 +3941,9 @@
           </a:p>
           <a:p>
             <a:pPr>
-              <a:defRPr sz="1250" b="1">
-                <a:solidFill>
-                  <a:srgbClr val="FFFFFF"/>
+              <a:defRPr sz="1200" b="1">
+                <a:solidFill>
+                  <a:srgbClr val="0F172A"/>
                 </a:solidFill>
                 <a:latin typeface="Segoe UI"/>
               </a:defRPr>
@@ -3857,11 +3955,11 @@
           <a:p>
             <a:pPr>
               <a:spcAft>
-                <a:spcPts val="1000"/>
+                <a:spcPts val="900"/>
               </a:spcAft>
               <a:defRPr sz="1050">
                 <a:solidFill>
-                  <a:srgbClr val="94A3B8"/>
+                  <a:srgbClr val="475569"/>
                 </a:solidFill>
                 <a:latin typeface="Segoe UI"/>
               </a:defRPr>
@@ -3872,9 +3970,9 @@
           </a:p>
           <a:p>
             <a:pPr>
-              <a:defRPr sz="1250" b="1">
-                <a:solidFill>
-                  <a:srgbClr val="FFFFFF"/>
+              <a:defRPr sz="1200" b="1">
+                <a:solidFill>
+                  <a:srgbClr val="0F172A"/>
                 </a:solidFill>
                 <a:latin typeface="Segoe UI"/>
               </a:defRPr>
@@ -3886,11 +3984,11 @@
           <a:p>
             <a:pPr>
               <a:spcAft>
-                <a:spcPts val="1000"/>
+                <a:spcPts val="900"/>
               </a:spcAft>
               <a:defRPr sz="1050">
                 <a:solidFill>
-                  <a:srgbClr val="94A3B8"/>
+                  <a:srgbClr val="475569"/>
                 </a:solidFill>
                 <a:latin typeface="Segoe UI"/>
               </a:defRPr>
@@ -3916,11 +4014,11 @@
             <a:avLst/>
           </a:prstGeom>
           <a:solidFill>
-            <a:srgbClr val="131A2B"/>
+            <a:srgbClr val="FFFFFF"/>
           </a:solidFill>
           <a:ln w="15240">
             <a:solidFill>
-              <a:srgbClr val="2563EB"/>
+              <a:srgbClr val="CBD5E1"/>
             </a:solidFill>
           </a:ln>
         </p:spPr>
@@ -3993,9 +4091,9 @@
           <a:lstStyle/>
           <a:p>
             <a:pPr algn="ctr">
-              <a:defRPr sz="950">
-                <a:solidFill>
-                  <a:srgbClr val="06B6D4"/>
+              <a:defRPr sz="950" b="1">
+                <a:solidFill>
+                  <a:srgbClr val="64748B"/>
                 </a:solidFill>
                 <a:latin typeface="Segoe UI"/>
               </a:defRPr>
@@ -4008,14 +4106,57 @@
       </p:sp>
       <p:sp>
         <p:nvSpPr>
-          <p:cNvPr id="9" name="TextBox 8"/>
+          <p:cNvPr id="9" name="Rectangle 8"/>
+          <p:cNvSpPr/>
+          <p:nvPr/>
+        </p:nvSpPr>
+        <p:spPr>
+          <a:xfrm>
+            <a:off x="731520" y="6217920"/>
+            <a:ext cx="10728655" cy="13716"/>
+          </a:xfrm>
+          <a:prstGeom prst="rect">
+            <a:avLst/>
+          </a:prstGeom>
+          <a:solidFill>
+            <a:srgbClr val="E2E8F0"/>
+          </a:solidFill>
+          <a:ln>
+            <a:noFill/>
+          </a:ln>
+        </p:spPr>
+        <p:style>
+          <a:lnRef idx="1">
+            <a:schemeClr val="accent1"/>
+          </a:lnRef>
+          <a:fillRef idx="3">
+            <a:schemeClr val="accent1"/>
+          </a:fillRef>
+          <a:effectRef idx="2">
+            <a:schemeClr val="accent1"/>
+          </a:effectRef>
+          <a:fontRef idx="minor">
+            <a:schemeClr val="lt1"/>
+          </a:fontRef>
+        </p:style>
+        <p:txBody>
+          <a:bodyPr rtlCol="0" anchor="ctr"/>
+          <a:lstStyle/>
+          <a:p>
+            <a:pPr algn="ctr"/>
+          </a:p>
+        </p:txBody>
+      </p:sp>
+      <p:sp>
+        <p:nvSpPr>
+          <p:cNvPr id="10" name="TextBox 9"/>
           <p:cNvSpPr txBox="1"/>
           <p:nvPr/>
         </p:nvSpPr>
         <p:spPr>
           <a:xfrm>
             <a:off x="731520" y="6309360"/>
-            <a:ext cx="10698480" cy="365760"/>
+            <a:ext cx="10698480" cy="320040"/>
           </a:xfrm>
           <a:prstGeom prst="rect">
             <a:avLst/>
@@ -4075,7 +4216,7 @@
             <a:avLst/>
           </a:prstGeom>
           <a:solidFill>
-            <a:srgbClr val="0B0F19"/>
+            <a:srgbClr val="FFFFFF"/>
           </a:solidFill>
           <a:ln>
             <a:noFill/>
@@ -4111,8 +4252,8 @@
         </p:nvSpPr>
         <p:spPr>
           <a:xfrm>
-            <a:off x="731520" y="457200"/>
-            <a:ext cx="10698480" cy="1005840"/>
+            <a:off x="731520" y="411480"/>
+            <a:ext cx="10698480" cy="1051560"/>
           </a:xfrm>
           <a:prstGeom prst="rect">
             <a:avLst/>
@@ -4129,9 +4270,9 @@
               <a:spcAft>
                 <a:spcPts val="200"/>
               </a:spcAft>
-              <a:defRPr sz="1100" b="1">
-                <a:solidFill>
-                  <a:srgbClr val="06B6D4"/>
+              <a:defRPr sz="1050" b="1">
+                <a:solidFill>
+                  <a:srgbClr val="1D4ED8"/>
                 </a:solidFill>
                 <a:latin typeface="Segoe UI"/>
               </a:defRPr>
@@ -4147,7 +4288,7 @@
               </a:spcAft>
               <a:defRPr sz="2200" b="1">
                 <a:solidFill>
-                  <a:srgbClr val="FFFFFF"/>
+                  <a:srgbClr val="0F172A"/>
                 </a:solidFill>
                 <a:latin typeface="Segoe UI"/>
               </a:defRPr>
@@ -4158,9 +4299,9 @@
           </a:p>
           <a:p>
             <a:pPr>
-              <a:defRPr sz="1200">
-                <a:solidFill>
-                  <a:srgbClr val="94A3B8"/>
+              <a:defRPr sz="1150">
+                <a:solidFill>
+                  <a:srgbClr val="475569"/>
                 </a:solidFill>
                 <a:latin typeface="Segoe UI"/>
               </a:defRPr>
@@ -4186,11 +4327,11 @@
             <a:avLst/>
           </a:prstGeom>
           <a:solidFill>
-            <a:srgbClr val="131A2B"/>
+            <a:srgbClr val="F8FAFC"/>
           </a:solidFill>
           <a:ln w="15240">
             <a:solidFill>
-              <a:srgbClr val="06B6D4"/>
+              <a:srgbClr val="E2E8F0"/>
             </a:solidFill>
           </a:ln>
         </p:spPr>
@@ -4244,7 +4385,7 @@
               </a:spcAft>
               <a:defRPr sz="1300" b="1">
                 <a:solidFill>
-                  <a:srgbClr val="06B6D4"/>
+                  <a:srgbClr val="1D4ED8"/>
                 </a:solidFill>
                 <a:latin typeface="Segoe UI"/>
               </a:defRPr>
@@ -4257,7 +4398,7 @@
             <a:pPr>
               <a:defRPr sz="1050" b="1">
                 <a:solidFill>
-                  <a:srgbClr val="FFFFFF"/>
+                  <a:srgbClr val="0F172A"/>
                 </a:solidFill>
                 <a:latin typeface="Consolas"/>
               </a:defRPr>
@@ -4273,7 +4414,7 @@
               </a:spcAft>
               <a:defRPr sz="950">
                 <a:solidFill>
-                  <a:srgbClr val="94A3B8"/>
+                  <a:srgbClr val="475569"/>
                 </a:solidFill>
                 <a:latin typeface="Segoe UI"/>
               </a:defRPr>
@@ -4286,7 +4427,7 @@
             <a:pPr>
               <a:defRPr sz="1050" b="1">
                 <a:solidFill>
-                  <a:srgbClr val="FFFFFF"/>
+                  <a:srgbClr val="0F172A"/>
                 </a:solidFill>
                 <a:latin typeface="Consolas"/>
               </a:defRPr>
@@ -4302,7 +4443,7 @@
               </a:spcAft>
               <a:defRPr sz="950">
                 <a:solidFill>
-                  <a:srgbClr val="94A3B8"/>
+                  <a:srgbClr val="475569"/>
                 </a:solidFill>
                 <a:latin typeface="Segoe UI"/>
               </a:defRPr>
@@ -4315,7 +4456,7 @@
             <a:pPr>
               <a:defRPr sz="1050" b="1">
                 <a:solidFill>
-                  <a:srgbClr val="FFFFFF"/>
+                  <a:srgbClr val="0F172A"/>
                 </a:solidFill>
                 <a:latin typeface="Consolas"/>
               </a:defRPr>
@@ -4331,7 +4472,7 @@
               </a:spcAft>
               <a:defRPr sz="950">
                 <a:solidFill>
-                  <a:srgbClr val="94A3B8"/>
+                  <a:srgbClr val="475569"/>
                 </a:solidFill>
                 <a:latin typeface="Segoe UI"/>
               </a:defRPr>
@@ -4344,7 +4485,7 @@
             <a:pPr>
               <a:defRPr sz="1050" b="1">
                 <a:solidFill>
-                  <a:srgbClr val="FFFFFF"/>
+                  <a:srgbClr val="0F172A"/>
                 </a:solidFill>
                 <a:latin typeface="Consolas"/>
               </a:defRPr>
@@ -4360,7 +4501,7 @@
               </a:spcAft>
               <a:defRPr sz="950">
                 <a:solidFill>
-                  <a:srgbClr val="94A3B8"/>
+                  <a:srgbClr val="475569"/>
                 </a:solidFill>
                 <a:latin typeface="Segoe UI"/>
               </a:defRPr>
@@ -4373,7 +4514,7 @@
             <a:pPr>
               <a:defRPr sz="1050" b="1">
                 <a:solidFill>
-                  <a:srgbClr val="FFFFFF"/>
+                  <a:srgbClr val="0F172A"/>
                 </a:solidFill>
                 <a:latin typeface="Consolas"/>
               </a:defRPr>
@@ -4389,7 +4530,7 @@
               </a:spcAft>
               <a:defRPr sz="950">
                 <a:solidFill>
-                  <a:srgbClr val="94A3B8"/>
+                  <a:srgbClr val="475569"/>
                 </a:solidFill>
                 <a:latin typeface="Segoe UI"/>
               </a:defRPr>
@@ -4415,11 +4556,11 @@
             <a:avLst/>
           </a:prstGeom>
           <a:solidFill>
-            <a:srgbClr val="131A2B"/>
+            <a:srgbClr val="F8FAFC"/>
           </a:solidFill>
           <a:ln w="15240">
             <a:solidFill>
-              <a:srgbClr val="10B981"/>
+              <a:srgbClr val="E2E8F0"/>
             </a:solidFill>
           </a:ln>
         </p:spPr>
@@ -4473,7 +4614,7 @@
               </a:spcAft>
               <a:defRPr sz="1300" b="1">
                 <a:solidFill>
-                  <a:srgbClr val="10B981"/>
+                  <a:srgbClr val="107A57"/>
                 </a:solidFill>
                 <a:latin typeface="Segoe UI"/>
               </a:defRPr>
@@ -4486,7 +4627,7 @@
             <a:pPr>
               <a:defRPr sz="1050" b="1">
                 <a:solidFill>
-                  <a:srgbClr val="FFFFFF"/>
+                  <a:srgbClr val="0F172A"/>
                 </a:solidFill>
                 <a:latin typeface="Consolas"/>
               </a:defRPr>
@@ -4502,7 +4643,7 @@
               </a:spcAft>
               <a:defRPr sz="950">
                 <a:solidFill>
-                  <a:srgbClr val="94A3B8"/>
+                  <a:srgbClr val="475569"/>
                 </a:solidFill>
                 <a:latin typeface="Segoe UI"/>
               </a:defRPr>
@@ -4515,7 +4656,7 @@
             <a:pPr>
               <a:defRPr sz="1050" b="1">
                 <a:solidFill>
-                  <a:srgbClr val="FFFFFF"/>
+                  <a:srgbClr val="0F172A"/>
                 </a:solidFill>
                 <a:latin typeface="Consolas"/>
               </a:defRPr>
@@ -4531,7 +4672,7 @@
               </a:spcAft>
               <a:defRPr sz="950">
                 <a:solidFill>
-                  <a:srgbClr val="94A3B8"/>
+                  <a:srgbClr val="475569"/>
                 </a:solidFill>
                 <a:latin typeface="Segoe UI"/>
               </a:defRPr>
@@ -4544,7 +4685,7 @@
             <a:pPr>
               <a:defRPr sz="1050" b="1">
                 <a:solidFill>
-                  <a:srgbClr val="FFFFFF"/>
+                  <a:srgbClr val="0F172A"/>
                 </a:solidFill>
                 <a:latin typeface="Consolas"/>
               </a:defRPr>
@@ -4560,7 +4701,7 @@
               </a:spcAft>
               <a:defRPr sz="950">
                 <a:solidFill>
-                  <a:srgbClr val="94A3B8"/>
+                  <a:srgbClr val="475569"/>
                 </a:solidFill>
                 <a:latin typeface="Segoe UI"/>
               </a:defRPr>
@@ -4573,7 +4714,7 @@
             <a:pPr>
               <a:defRPr sz="1050" b="1">
                 <a:solidFill>
-                  <a:srgbClr val="FFFFFF"/>
+                  <a:srgbClr val="0F172A"/>
                 </a:solidFill>
                 <a:latin typeface="Consolas"/>
               </a:defRPr>
@@ -4589,7 +4730,7 @@
               </a:spcAft>
               <a:defRPr sz="950">
                 <a:solidFill>
-                  <a:srgbClr val="94A3B8"/>
+                  <a:srgbClr val="475569"/>
                 </a:solidFill>
                 <a:latin typeface="Segoe UI"/>
               </a:defRPr>
@@ -4615,11 +4756,11 @@
             <a:avLst/>
           </a:prstGeom>
           <a:solidFill>
-            <a:srgbClr val="131A2B"/>
+            <a:srgbClr val="F8FAFC"/>
           </a:solidFill>
           <a:ln w="15240">
             <a:solidFill>
-              <a:srgbClr val="F59E0B"/>
+              <a:srgbClr val="E2E8F0"/>
             </a:solidFill>
           </a:ln>
         </p:spPr>
@@ -4673,7 +4814,7 @@
               </a:spcAft>
               <a:defRPr sz="1300" b="1">
                 <a:solidFill>
-                  <a:srgbClr val="F59E0B"/>
+                  <a:srgbClr val="B45309"/>
                 </a:solidFill>
                 <a:latin typeface="Segoe UI"/>
               </a:defRPr>
@@ -4686,7 +4827,7 @@
             <a:pPr>
               <a:defRPr sz="1050" b="1">
                 <a:solidFill>
-                  <a:srgbClr val="FFFFFF"/>
+                  <a:srgbClr val="0F172A"/>
                 </a:solidFill>
                 <a:latin typeface="Consolas"/>
               </a:defRPr>
@@ -4702,7 +4843,7 @@
               </a:spcAft>
               <a:defRPr sz="950">
                 <a:solidFill>
-                  <a:srgbClr val="94A3B8"/>
+                  <a:srgbClr val="475569"/>
                 </a:solidFill>
                 <a:latin typeface="Segoe UI"/>
               </a:defRPr>
@@ -4715,14 +4856,57 @@
       </p:sp>
       <p:sp>
         <p:nvSpPr>
-          <p:cNvPr id="10" name="TextBox 9"/>
+          <p:cNvPr id="10" name="Rectangle 9"/>
+          <p:cNvSpPr/>
+          <p:nvPr/>
+        </p:nvSpPr>
+        <p:spPr>
+          <a:xfrm>
+            <a:off x="731520" y="6217920"/>
+            <a:ext cx="10728655" cy="13716"/>
+          </a:xfrm>
+          <a:prstGeom prst="rect">
+            <a:avLst/>
+          </a:prstGeom>
+          <a:solidFill>
+            <a:srgbClr val="E2E8F0"/>
+          </a:solidFill>
+          <a:ln>
+            <a:noFill/>
+          </a:ln>
+        </p:spPr>
+        <p:style>
+          <a:lnRef idx="1">
+            <a:schemeClr val="accent1"/>
+          </a:lnRef>
+          <a:fillRef idx="3">
+            <a:schemeClr val="accent1"/>
+          </a:fillRef>
+          <a:effectRef idx="2">
+            <a:schemeClr val="accent1"/>
+          </a:effectRef>
+          <a:fontRef idx="minor">
+            <a:schemeClr val="lt1"/>
+          </a:fontRef>
+        </p:style>
+        <p:txBody>
+          <a:bodyPr rtlCol="0" anchor="ctr"/>
+          <a:lstStyle/>
+          <a:p>
+            <a:pPr algn="ctr"/>
+          </a:p>
+        </p:txBody>
+      </p:sp>
+      <p:sp>
+        <p:nvSpPr>
+          <p:cNvPr id="11" name="TextBox 10"/>
           <p:cNvSpPr txBox="1"/>
           <p:nvPr/>
         </p:nvSpPr>
         <p:spPr>
           <a:xfrm>
             <a:off x="731520" y="6309360"/>
-            <a:ext cx="10698480" cy="365760"/>
+            <a:ext cx="10698480" cy="320040"/>
           </a:xfrm>
           <a:prstGeom prst="rect">
             <a:avLst/>
@@ -4782,7 +4966,7 @@
             <a:avLst/>
           </a:prstGeom>
           <a:solidFill>
-            <a:srgbClr val="0B0F19"/>
+            <a:srgbClr val="FFFFFF"/>
           </a:solidFill>
           <a:ln>
             <a:noFill/>
@@ -4818,8 +5002,8 @@
         </p:nvSpPr>
         <p:spPr>
           <a:xfrm>
-            <a:off x="731520" y="457200"/>
-            <a:ext cx="10698480" cy="1005840"/>
+            <a:off x="731520" y="411480"/>
+            <a:ext cx="10698480" cy="1051560"/>
           </a:xfrm>
           <a:prstGeom prst="rect">
             <a:avLst/>
@@ -4836,9 +5020,9 @@
               <a:spcAft>
                 <a:spcPts val="200"/>
               </a:spcAft>
-              <a:defRPr sz="1100" b="1">
-                <a:solidFill>
-                  <a:srgbClr val="06B6D4"/>
+              <a:defRPr sz="1050" b="1">
+                <a:solidFill>
+                  <a:srgbClr val="1D4ED8"/>
                 </a:solidFill>
                 <a:latin typeface="Segoe UI"/>
               </a:defRPr>
@@ -4854,7 +5038,7 @@
               </a:spcAft>
               <a:defRPr sz="2200" b="1">
                 <a:solidFill>
-                  <a:srgbClr val="FFFFFF"/>
+                  <a:srgbClr val="0F172A"/>
                 </a:solidFill>
                 <a:latin typeface="Segoe UI"/>
               </a:defRPr>
@@ -4865,9 +5049,9 @@
           </a:p>
           <a:p>
             <a:pPr>
-              <a:defRPr sz="1200">
-                <a:solidFill>
-                  <a:srgbClr val="94A3B8"/>
+              <a:defRPr sz="1150">
+                <a:solidFill>
+                  <a:srgbClr val="475569"/>
                 </a:solidFill>
                 <a:latin typeface="Segoe UI"/>
               </a:defRPr>
@@ -4893,11 +5077,11 @@
             <a:avLst/>
           </a:prstGeom>
           <a:solidFill>
-            <a:srgbClr val="131A2B"/>
+            <a:srgbClr val="F8FAFC"/>
           </a:solidFill>
           <a:ln w="15240">
             <a:solidFill>
-              <a:srgbClr val="10B981"/>
+              <a:srgbClr val="E2E8F0"/>
             </a:solidFill>
           </a:ln>
         </p:spPr>
@@ -4951,7 +5135,7 @@
               </a:spcAft>
               <a:defRPr sz="1300" b="1">
                 <a:solidFill>
-                  <a:srgbClr val="10B981"/>
+                  <a:srgbClr val="107A57"/>
                 </a:solidFill>
                 <a:latin typeface="Segoe UI"/>
               </a:defRPr>
@@ -4964,7 +5148,7 @@
             <a:pPr>
               <a:defRPr sz="1050" b="1">
                 <a:solidFill>
-                  <a:srgbClr val="FFFFFF"/>
+                  <a:srgbClr val="0F172A"/>
                 </a:solidFill>
                 <a:latin typeface="Segoe UI"/>
               </a:defRPr>
@@ -4980,7 +5164,7 @@
               </a:spcAft>
               <a:defRPr sz="950">
                 <a:solidFill>
-                  <a:srgbClr val="94A3B8"/>
+                  <a:srgbClr val="475569"/>
                 </a:solidFill>
                 <a:latin typeface="Segoe UI"/>
               </a:defRPr>
@@ -4993,7 +5177,7 @@
             <a:pPr>
               <a:defRPr sz="1050" b="1">
                 <a:solidFill>
-                  <a:srgbClr val="FFFFFF"/>
+                  <a:srgbClr val="0F172A"/>
                 </a:solidFill>
                 <a:latin typeface="Segoe UI"/>
               </a:defRPr>
@@ -5009,7 +5193,7 @@
               </a:spcAft>
               <a:defRPr sz="950">
                 <a:solidFill>
-                  <a:srgbClr val="94A3B8"/>
+                  <a:srgbClr val="475569"/>
                 </a:solidFill>
                 <a:latin typeface="Segoe UI"/>
               </a:defRPr>
@@ -5022,7 +5206,7 @@
             <a:pPr>
               <a:defRPr sz="1050" b="1">
                 <a:solidFill>
-                  <a:srgbClr val="FFFFFF"/>
+                  <a:srgbClr val="0F172A"/>
                 </a:solidFill>
                 <a:latin typeface="Segoe UI"/>
               </a:defRPr>
@@ -5038,7 +5222,7 @@
               </a:spcAft>
               <a:defRPr sz="950">
                 <a:solidFill>
-                  <a:srgbClr val="94A3B8"/>
+                  <a:srgbClr val="475569"/>
                 </a:solidFill>
                 <a:latin typeface="Segoe UI"/>
               </a:defRPr>
@@ -5051,7 +5235,7 @@
             <a:pPr>
               <a:defRPr sz="1050" b="1">
                 <a:solidFill>
-                  <a:srgbClr val="FFFFFF"/>
+                  <a:srgbClr val="0F172A"/>
                 </a:solidFill>
                 <a:latin typeface="Segoe UI"/>
               </a:defRPr>
@@ -5067,7 +5251,7 @@
               </a:spcAft>
               <a:defRPr sz="950">
                 <a:solidFill>
-                  <a:srgbClr val="94A3B8"/>
+                  <a:srgbClr val="475569"/>
                 </a:solidFill>
                 <a:latin typeface="Segoe UI"/>
               </a:defRPr>
@@ -5093,11 +5277,11 @@
             <a:avLst/>
           </a:prstGeom>
           <a:solidFill>
-            <a:srgbClr val="131A2B"/>
+            <a:srgbClr val="F8FAFC"/>
           </a:solidFill>
           <a:ln w="15240">
             <a:solidFill>
-              <a:srgbClr val="06B6D4"/>
+              <a:srgbClr val="E2E8F0"/>
             </a:solidFill>
           </a:ln>
         </p:spPr>
@@ -5151,7 +5335,7 @@
               </a:spcAft>
               <a:defRPr sz="1300" b="1">
                 <a:solidFill>
-                  <a:srgbClr val="06B6D4"/>
+                  <a:srgbClr val="1D4ED8"/>
                 </a:solidFill>
                 <a:latin typeface="Segoe UI"/>
               </a:defRPr>
@@ -5164,7 +5348,7 @@
             <a:pPr>
               <a:defRPr sz="1050" b="1">
                 <a:solidFill>
-                  <a:srgbClr val="FFFFFF"/>
+                  <a:srgbClr val="0F172A"/>
                 </a:solidFill>
                 <a:latin typeface="Segoe UI"/>
               </a:defRPr>
@@ -5180,7 +5364,7 @@
               </a:spcAft>
               <a:defRPr sz="950">
                 <a:solidFill>
-                  <a:srgbClr val="94A3B8"/>
+                  <a:srgbClr val="475569"/>
                 </a:solidFill>
                 <a:latin typeface="Segoe UI"/>
               </a:defRPr>
@@ -5193,7 +5377,7 @@
             <a:pPr>
               <a:defRPr sz="1050" b="1">
                 <a:solidFill>
-                  <a:srgbClr val="FFFFFF"/>
+                  <a:srgbClr val="0F172A"/>
                 </a:solidFill>
                 <a:latin typeface="Segoe UI"/>
               </a:defRPr>
@@ -5209,7 +5393,7 @@
               </a:spcAft>
               <a:defRPr sz="950">
                 <a:solidFill>
-                  <a:srgbClr val="94A3B8"/>
+                  <a:srgbClr val="475569"/>
                 </a:solidFill>
                 <a:latin typeface="Segoe UI"/>
               </a:defRPr>
@@ -5222,7 +5406,7 @@
             <a:pPr>
               <a:defRPr sz="1050" b="1">
                 <a:solidFill>
-                  <a:srgbClr val="FFFFFF"/>
+                  <a:srgbClr val="0F172A"/>
                 </a:solidFill>
                 <a:latin typeface="Segoe UI"/>
               </a:defRPr>
@@ -5238,7 +5422,7 @@
               </a:spcAft>
               <a:defRPr sz="950">
                 <a:solidFill>
-                  <a:srgbClr val="94A3B8"/>
+                  <a:srgbClr val="475569"/>
                 </a:solidFill>
                 <a:latin typeface="Segoe UI"/>
               </a:defRPr>
@@ -5251,7 +5435,7 @@
             <a:pPr>
               <a:defRPr sz="1050" b="1">
                 <a:solidFill>
-                  <a:srgbClr val="FFFFFF"/>
+                  <a:srgbClr val="0F172A"/>
                 </a:solidFill>
                 <a:latin typeface="Segoe UI"/>
               </a:defRPr>
@@ -5267,7 +5451,7 @@
               </a:spcAft>
               <a:defRPr sz="950">
                 <a:solidFill>
-                  <a:srgbClr val="94A3B8"/>
+                  <a:srgbClr val="475569"/>
                 </a:solidFill>
                 <a:latin typeface="Segoe UI"/>
               </a:defRPr>
@@ -5293,11 +5477,11 @@
             <a:avLst/>
           </a:prstGeom>
           <a:solidFill>
-            <a:srgbClr val="131A2B"/>
+            <a:srgbClr val="F8FAFC"/>
           </a:solidFill>
           <a:ln w="15240">
             <a:solidFill>
-              <a:srgbClr val="F59E0B"/>
+              <a:srgbClr val="E2E8F0"/>
             </a:solidFill>
           </a:ln>
         </p:spPr>
@@ -5351,7 +5535,7 @@
               </a:spcAft>
               <a:defRPr sz="1300" b="1">
                 <a:solidFill>
-                  <a:srgbClr val="F59E0B"/>
+                  <a:srgbClr val="B45309"/>
                 </a:solidFill>
                 <a:latin typeface="Segoe UI"/>
               </a:defRPr>
@@ -5364,7 +5548,7 @@
             <a:pPr>
               <a:defRPr sz="1050" b="1">
                 <a:solidFill>
-                  <a:srgbClr val="FFFFFF"/>
+                  <a:srgbClr val="0F172A"/>
                 </a:solidFill>
                 <a:latin typeface="Segoe UI"/>
               </a:defRPr>
@@ -5380,7 +5564,7 @@
               </a:spcAft>
               <a:defRPr sz="950">
                 <a:solidFill>
-                  <a:srgbClr val="94A3B8"/>
+                  <a:srgbClr val="475569"/>
                 </a:solidFill>
                 <a:latin typeface="Segoe UI"/>
               </a:defRPr>
@@ -5393,7 +5577,7 @@
             <a:pPr>
               <a:defRPr sz="1050" b="1">
                 <a:solidFill>
-                  <a:srgbClr val="FFFFFF"/>
+                  <a:srgbClr val="0F172A"/>
                 </a:solidFill>
                 <a:latin typeface="Segoe UI"/>
               </a:defRPr>
@@ -5409,7 +5593,7 @@
               </a:spcAft>
               <a:defRPr sz="950">
                 <a:solidFill>
-                  <a:srgbClr val="94A3B8"/>
+                  <a:srgbClr val="475569"/>
                 </a:solidFill>
                 <a:latin typeface="Segoe UI"/>
               </a:defRPr>
@@ -5422,7 +5606,7 @@
             <a:pPr>
               <a:defRPr sz="1050" b="1">
                 <a:solidFill>
-                  <a:srgbClr val="FFFFFF"/>
+                  <a:srgbClr val="0F172A"/>
                 </a:solidFill>
                 <a:latin typeface="Segoe UI"/>
               </a:defRPr>
@@ -5438,7 +5622,7 @@
               </a:spcAft>
               <a:defRPr sz="950">
                 <a:solidFill>
-                  <a:srgbClr val="94A3B8"/>
+                  <a:srgbClr val="475569"/>
                 </a:solidFill>
                 <a:latin typeface="Segoe UI"/>
               </a:defRPr>
@@ -5451,7 +5635,7 @@
             <a:pPr>
               <a:defRPr sz="1050" b="1">
                 <a:solidFill>
-                  <a:srgbClr val="FFFFFF"/>
+                  <a:srgbClr val="0F172A"/>
                 </a:solidFill>
                 <a:latin typeface="Segoe UI"/>
               </a:defRPr>
@@ -5467,7 +5651,7 @@
               </a:spcAft>
               <a:defRPr sz="950">
                 <a:solidFill>
-                  <a:srgbClr val="94A3B8"/>
+                  <a:srgbClr val="475569"/>
                 </a:solidFill>
                 <a:latin typeface="Segoe UI"/>
               </a:defRPr>
@@ -5480,14 +5664,57 @@
       </p:sp>
       <p:sp>
         <p:nvSpPr>
-          <p:cNvPr id="10" name="TextBox 9"/>
+          <p:cNvPr id="10" name="Rectangle 9"/>
+          <p:cNvSpPr/>
+          <p:nvPr/>
+        </p:nvSpPr>
+        <p:spPr>
+          <a:xfrm>
+            <a:off x="731520" y="6217920"/>
+            <a:ext cx="10728655" cy="13716"/>
+          </a:xfrm>
+          <a:prstGeom prst="rect">
+            <a:avLst/>
+          </a:prstGeom>
+          <a:solidFill>
+            <a:srgbClr val="E2E8F0"/>
+          </a:solidFill>
+          <a:ln>
+            <a:noFill/>
+          </a:ln>
+        </p:spPr>
+        <p:style>
+          <a:lnRef idx="1">
+            <a:schemeClr val="accent1"/>
+          </a:lnRef>
+          <a:fillRef idx="3">
+            <a:schemeClr val="accent1"/>
+          </a:fillRef>
+          <a:effectRef idx="2">
+            <a:schemeClr val="accent1"/>
+          </a:effectRef>
+          <a:fontRef idx="minor">
+            <a:schemeClr val="lt1"/>
+          </a:fontRef>
+        </p:style>
+        <p:txBody>
+          <a:bodyPr rtlCol="0" anchor="ctr"/>
+          <a:lstStyle/>
+          <a:p>
+            <a:pPr algn="ctr"/>
+          </a:p>
+        </p:txBody>
+      </p:sp>
+      <p:sp>
+        <p:nvSpPr>
+          <p:cNvPr id="11" name="TextBox 10"/>
           <p:cNvSpPr txBox="1"/>
           <p:nvPr/>
         </p:nvSpPr>
         <p:spPr>
           <a:xfrm>
             <a:off x="731520" y="6309360"/>
-            <a:ext cx="10698480" cy="365760"/>
+            <a:ext cx="10698480" cy="320040"/>
           </a:xfrm>
           <a:prstGeom prst="rect">
             <a:avLst/>
@@ -5547,7 +5774,7 @@
             <a:avLst/>
           </a:prstGeom>
           <a:solidFill>
-            <a:srgbClr val="0B0F19"/>
+            <a:srgbClr val="FFFFFF"/>
           </a:solidFill>
           <a:ln>
             <a:noFill/>
@@ -5583,8 +5810,8 @@
         </p:nvSpPr>
         <p:spPr>
           <a:xfrm>
-            <a:off x="731520" y="457200"/>
-            <a:ext cx="10698480" cy="1005840"/>
+            <a:off x="731520" y="411480"/>
+            <a:ext cx="10698480" cy="1051560"/>
           </a:xfrm>
           <a:prstGeom prst="rect">
             <a:avLst/>
@@ -5601,9 +5828,9 @@
               <a:spcAft>
                 <a:spcPts val="200"/>
               </a:spcAft>
-              <a:defRPr sz="1100" b="1">
-                <a:solidFill>
-                  <a:srgbClr val="06B6D4"/>
+              <a:defRPr sz="1050" b="1">
+                <a:solidFill>
+                  <a:srgbClr val="1D4ED8"/>
                 </a:solidFill>
                 <a:latin typeface="Segoe UI"/>
               </a:defRPr>
@@ -5619,7 +5846,7 @@
               </a:spcAft>
               <a:defRPr sz="2200" b="1">
                 <a:solidFill>
-                  <a:srgbClr val="FFFFFF"/>
+                  <a:srgbClr val="0F172A"/>
                 </a:solidFill>
                 <a:latin typeface="Segoe UI"/>
               </a:defRPr>
@@ -5630,9 +5857,9 @@
           </a:p>
           <a:p>
             <a:pPr>
-              <a:defRPr sz="1200">
-                <a:solidFill>
-                  <a:srgbClr val="94A3B8"/>
+              <a:defRPr sz="1150">
+                <a:solidFill>
+                  <a:srgbClr val="475569"/>
                 </a:solidFill>
                 <a:latin typeface="Segoe UI"/>
               </a:defRPr>
@@ -5658,11 +5885,11 @@
             <a:avLst/>
           </a:prstGeom>
           <a:solidFill>
-            <a:srgbClr val="131A2B"/>
+            <a:srgbClr val="F8FAFC"/>
           </a:solidFill>
           <a:ln w="15240">
             <a:solidFill>
-              <a:srgbClr val="10B981"/>
+              <a:srgbClr val="A7F3D0"/>
             </a:solidFill>
           </a:ln>
         </p:spPr>
@@ -5716,7 +5943,7 @@
               </a:spcAft>
               <a:defRPr sz="1600" b="1">
                 <a:solidFill>
-                  <a:srgbClr val="10B981"/>
+                  <a:srgbClr val="107A57"/>
                 </a:solidFill>
                 <a:latin typeface="Segoe UI"/>
               </a:defRPr>
@@ -5729,7 +5956,7 @@
             <a:pPr>
               <a:defRPr sz="1200" b="1">
                 <a:solidFill>
-                  <a:srgbClr val="FFFFFF"/>
+                  <a:srgbClr val="0F172A"/>
                 </a:solidFill>
                 <a:latin typeface="Segoe UI"/>
               </a:defRPr>
@@ -5745,7 +5972,7 @@
               </a:spcAft>
               <a:defRPr sz="1000">
                 <a:solidFill>
-                  <a:srgbClr val="94A3B8"/>
+                  <a:srgbClr val="475569"/>
                 </a:solidFill>
                 <a:latin typeface="Segoe UI"/>
               </a:defRPr>
@@ -5758,7 +5985,7 @@
             <a:pPr>
               <a:defRPr sz="1200" b="1">
                 <a:solidFill>
-                  <a:srgbClr val="FFFFFF"/>
+                  <a:srgbClr val="0F172A"/>
                 </a:solidFill>
                 <a:latin typeface="Segoe UI"/>
               </a:defRPr>
@@ -5774,7 +6001,7 @@
               </a:spcAft>
               <a:defRPr sz="1000">
                 <a:solidFill>
-                  <a:srgbClr val="94A3B8"/>
+                  <a:srgbClr val="475569"/>
                 </a:solidFill>
                 <a:latin typeface="Segoe UI"/>
               </a:defRPr>
@@ -5787,7 +6014,7 @@
             <a:pPr>
               <a:defRPr sz="1200" b="1">
                 <a:solidFill>
-                  <a:srgbClr val="FFFFFF"/>
+                  <a:srgbClr val="0F172A"/>
                 </a:solidFill>
                 <a:latin typeface="Segoe UI"/>
               </a:defRPr>
@@ -5803,7 +6030,7 @@
               </a:spcAft>
               <a:defRPr sz="1000">
                 <a:solidFill>
-                  <a:srgbClr val="94A3B8"/>
+                  <a:srgbClr val="475569"/>
                 </a:solidFill>
                 <a:latin typeface="Segoe UI"/>
               </a:defRPr>
@@ -5816,7 +6043,7 @@
             <a:pPr>
               <a:defRPr sz="1200" b="1">
                 <a:solidFill>
-                  <a:srgbClr val="FFFFFF"/>
+                  <a:srgbClr val="0F172A"/>
                 </a:solidFill>
                 <a:latin typeface="Segoe UI"/>
               </a:defRPr>
@@ -5832,7 +6059,7 @@
               </a:spcAft>
               <a:defRPr sz="1000">
                 <a:solidFill>
-                  <a:srgbClr val="94A3B8"/>
+                  <a:srgbClr val="475569"/>
                 </a:solidFill>
                 <a:latin typeface="Segoe UI"/>
               </a:defRPr>
@@ -5858,11 +6085,11 @@
             <a:avLst/>
           </a:prstGeom>
           <a:solidFill>
-            <a:srgbClr val="131A2B"/>
+            <a:srgbClr val="F8FAFC"/>
           </a:solidFill>
           <a:ln w="15240">
             <a:solidFill>
-              <a:srgbClr val="06B6D4"/>
+              <a:srgbClr val="BFDBFE"/>
             </a:solidFill>
           </a:ln>
         </p:spPr>
@@ -5916,7 +6143,7 @@
               </a:spcAft>
               <a:defRPr sz="1600" b="1">
                 <a:solidFill>
-                  <a:srgbClr val="06B6D4"/>
+                  <a:srgbClr val="1D4ED8"/>
                 </a:solidFill>
                 <a:latin typeface="Segoe UI"/>
               </a:defRPr>
@@ -5929,7 +6156,7 @@
             <a:pPr>
               <a:defRPr sz="1200" b="1">
                 <a:solidFill>
-                  <a:srgbClr val="FFFFFF"/>
+                  <a:srgbClr val="0F172A"/>
                 </a:solidFill>
                 <a:latin typeface="Segoe UI"/>
               </a:defRPr>
@@ -5945,7 +6172,7 @@
               </a:spcAft>
               <a:defRPr sz="1000">
                 <a:solidFill>
-                  <a:srgbClr val="94A3B8"/>
+                  <a:srgbClr val="475569"/>
                 </a:solidFill>
                 <a:latin typeface="Segoe UI"/>
               </a:defRPr>
@@ -5958,7 +6185,7 @@
             <a:pPr>
               <a:defRPr sz="1200" b="1">
                 <a:solidFill>
-                  <a:srgbClr val="FFFFFF"/>
+                  <a:srgbClr val="0F172A"/>
                 </a:solidFill>
                 <a:latin typeface="Segoe UI"/>
               </a:defRPr>
@@ -5974,7 +6201,7 @@
               </a:spcAft>
               <a:defRPr sz="1000">
                 <a:solidFill>
-                  <a:srgbClr val="94A3B8"/>
+                  <a:srgbClr val="475569"/>
                 </a:solidFill>
                 <a:latin typeface="Segoe UI"/>
               </a:defRPr>
@@ -5987,7 +6214,7 @@
             <a:pPr>
               <a:defRPr sz="1200" b="1">
                 <a:solidFill>
-                  <a:srgbClr val="FFFFFF"/>
+                  <a:srgbClr val="0F172A"/>
                 </a:solidFill>
                 <a:latin typeface="Segoe UI"/>
               </a:defRPr>
@@ -6003,7 +6230,7 @@
               </a:spcAft>
               <a:defRPr sz="1000">
                 <a:solidFill>
-                  <a:srgbClr val="94A3B8"/>
+                  <a:srgbClr val="475569"/>
                 </a:solidFill>
                 <a:latin typeface="Segoe UI"/>
               </a:defRPr>
@@ -6016,7 +6243,7 @@
             <a:pPr>
               <a:defRPr sz="1200" b="1">
                 <a:solidFill>
-                  <a:srgbClr val="FFFFFF"/>
+                  <a:srgbClr val="0F172A"/>
                 </a:solidFill>
                 <a:latin typeface="Segoe UI"/>
               </a:defRPr>
@@ -6032,7 +6259,7 @@
               </a:spcAft>
               <a:defRPr sz="1000">
                 <a:solidFill>
-                  <a:srgbClr val="94A3B8"/>
+                  <a:srgbClr val="475569"/>
                 </a:solidFill>
                 <a:latin typeface="Segoe UI"/>
               </a:defRPr>
@@ -6045,7 +6272,7 @@
             <a:pPr algn="ctr">
               <a:defRPr sz="1250" b="1">
                 <a:solidFill>
-                  <a:srgbClr val="F59E0B"/>
+                  <a:srgbClr val="B45309"/>
                 </a:solidFill>
                 <a:latin typeface="Segoe UI"/>
               </a:defRPr>
@@ -6058,14 +6285,57 @@
       </p:sp>
       <p:sp>
         <p:nvSpPr>
-          <p:cNvPr id="8" name="TextBox 7"/>
+          <p:cNvPr id="8" name="Rectangle 7"/>
+          <p:cNvSpPr/>
+          <p:nvPr/>
+        </p:nvSpPr>
+        <p:spPr>
+          <a:xfrm>
+            <a:off x="731520" y="6217920"/>
+            <a:ext cx="10728655" cy="13716"/>
+          </a:xfrm>
+          <a:prstGeom prst="rect">
+            <a:avLst/>
+          </a:prstGeom>
+          <a:solidFill>
+            <a:srgbClr val="E2E8F0"/>
+          </a:solidFill>
+          <a:ln>
+            <a:noFill/>
+          </a:ln>
+        </p:spPr>
+        <p:style>
+          <a:lnRef idx="1">
+            <a:schemeClr val="accent1"/>
+          </a:lnRef>
+          <a:fillRef idx="3">
+            <a:schemeClr val="accent1"/>
+          </a:fillRef>
+          <a:effectRef idx="2">
+            <a:schemeClr val="accent1"/>
+          </a:effectRef>
+          <a:fontRef idx="minor">
+            <a:schemeClr val="lt1"/>
+          </a:fontRef>
+        </p:style>
+        <p:txBody>
+          <a:bodyPr rtlCol="0" anchor="ctr"/>
+          <a:lstStyle/>
+          <a:p>
+            <a:pPr algn="ctr"/>
+          </a:p>
+        </p:txBody>
+      </p:sp>
+      <p:sp>
+        <p:nvSpPr>
+          <p:cNvPr id="9" name="TextBox 8"/>
           <p:cNvSpPr txBox="1"/>
           <p:nvPr/>
         </p:nvSpPr>
         <p:spPr>
           <a:xfrm>
             <a:off x="731520" y="6309360"/>
-            <a:ext cx="10698480" cy="365760"/>
+            <a:ext cx="10698480" cy="320040"/>
           </a:xfrm>
           <a:prstGeom prst="rect">
             <a:avLst/>
@@ -6125,7 +6395,7 @@
             <a:avLst/>
           </a:prstGeom>
           <a:solidFill>
-            <a:srgbClr val="0B0F19"/>
+            <a:srgbClr val="FFFFFF"/>
           </a:solidFill>
           <a:ln>
             <a:noFill/>
@@ -6161,8 +6431,8 @@
         </p:nvSpPr>
         <p:spPr>
           <a:xfrm>
-            <a:off x="731520" y="457200"/>
-            <a:ext cx="10698480" cy="1005840"/>
+            <a:off x="731520" y="411480"/>
+            <a:ext cx="10698480" cy="1051560"/>
           </a:xfrm>
           <a:prstGeom prst="rect">
             <a:avLst/>
@@ -6179,9 +6449,9 @@
               <a:spcAft>
                 <a:spcPts val="200"/>
               </a:spcAft>
-              <a:defRPr sz="1100" b="1">
-                <a:solidFill>
-                  <a:srgbClr val="06B6D4"/>
+              <a:defRPr sz="1050" b="1">
+                <a:solidFill>
+                  <a:srgbClr val="1D4ED8"/>
                 </a:solidFill>
                 <a:latin typeface="Segoe UI"/>
               </a:defRPr>
@@ -6197,7 +6467,7 @@
               </a:spcAft>
               <a:defRPr sz="2200" b="1">
                 <a:solidFill>
-                  <a:srgbClr val="FFFFFF"/>
+                  <a:srgbClr val="0F172A"/>
                 </a:solidFill>
                 <a:latin typeface="Segoe UI"/>
               </a:defRPr>
@@ -6208,9 +6478,9 @@
           </a:p>
           <a:p>
             <a:pPr>
-              <a:defRPr sz="1200">
-                <a:solidFill>
-                  <a:srgbClr val="94A3B8"/>
+              <a:defRPr sz="1150">
+                <a:solidFill>
+                  <a:srgbClr val="475569"/>
                 </a:solidFill>
                 <a:latin typeface="Segoe UI"/>
               </a:defRPr>
@@ -6236,11 +6506,11 @@
             <a:avLst/>
           </a:prstGeom>
           <a:solidFill>
-            <a:srgbClr val="131A2B"/>
+            <a:srgbClr val="F8FAFC"/>
           </a:solidFill>
           <a:ln w="15240">
             <a:solidFill>
-              <a:srgbClr val="253352"/>
+              <a:srgbClr val="FECACA"/>
             </a:solidFill>
           </a:ln>
         </p:spPr>
@@ -6292,9 +6562,9 @@
               <a:spcAft>
                 <a:spcPts val="1200"/>
               </a:spcAft>
-              <a:defRPr sz="1600" b="1">
-                <a:solidFill>
-                  <a:srgbClr val="F87171"/>
+              <a:defRPr sz="1550" b="1">
+                <a:solidFill>
+                  <a:srgbClr val="B91C1C"/>
                 </a:solidFill>
                 <a:latin typeface="Segoe UI"/>
               </a:defRPr>
@@ -6307,7 +6577,7 @@
             <a:pPr>
               <a:defRPr sz="1200" b="1">
                 <a:solidFill>
-                  <a:srgbClr val="FFFFFF"/>
+                  <a:srgbClr val="0F172A"/>
                 </a:solidFill>
                 <a:latin typeface="Segoe UI"/>
               </a:defRPr>
@@ -6323,7 +6593,7 @@
               </a:spcAft>
               <a:defRPr sz="1050">
                 <a:solidFill>
-                  <a:srgbClr val="94A3B8"/>
+                  <a:srgbClr val="475569"/>
                 </a:solidFill>
                 <a:latin typeface="Segoe UI"/>
               </a:defRPr>
@@ -6336,7 +6606,7 @@
             <a:pPr>
               <a:defRPr sz="1200" b="1">
                 <a:solidFill>
-                  <a:srgbClr val="FFFFFF"/>
+                  <a:srgbClr val="0F172A"/>
                 </a:solidFill>
                 <a:latin typeface="Segoe UI"/>
               </a:defRPr>
@@ -6352,7 +6622,7 @@
               </a:spcAft>
               <a:defRPr sz="1050">
                 <a:solidFill>
-                  <a:srgbClr val="94A3B8"/>
+                  <a:srgbClr val="475569"/>
                 </a:solidFill>
                 <a:latin typeface="Segoe UI"/>
               </a:defRPr>
@@ -6365,7 +6635,7 @@
             <a:pPr>
               <a:defRPr sz="1200" b="1">
                 <a:solidFill>
-                  <a:srgbClr val="FFFFFF"/>
+                  <a:srgbClr val="0F172A"/>
                 </a:solidFill>
                 <a:latin typeface="Segoe UI"/>
               </a:defRPr>
@@ -6381,7 +6651,7 @@
               </a:spcAft>
               <a:defRPr sz="1050">
                 <a:solidFill>
-                  <a:srgbClr val="94A3B8"/>
+                  <a:srgbClr val="475569"/>
                 </a:solidFill>
                 <a:latin typeface="Segoe UI"/>
               </a:defRPr>
@@ -6394,7 +6664,7 @@
             <a:pPr>
               <a:defRPr sz="1200" b="1">
                 <a:solidFill>
-                  <a:srgbClr val="FFFFFF"/>
+                  <a:srgbClr val="0F172A"/>
                 </a:solidFill>
                 <a:latin typeface="Segoe UI"/>
               </a:defRPr>
@@ -6410,7 +6680,7 @@
               </a:spcAft>
               <a:defRPr sz="1050">
                 <a:solidFill>
-                  <a:srgbClr val="94A3B8"/>
+                  <a:srgbClr val="475569"/>
                 </a:solidFill>
                 <a:latin typeface="Segoe UI"/>
               </a:defRPr>
@@ -6436,11 +6706,11 @@
             <a:avLst/>
           </a:prstGeom>
           <a:solidFill>
-            <a:srgbClr val="131A2B"/>
+            <a:srgbClr val="F8FAFC"/>
           </a:solidFill>
           <a:ln w="15240">
             <a:solidFill>
-              <a:srgbClr val="253352"/>
+              <a:srgbClr val="A7F3D0"/>
             </a:solidFill>
           </a:ln>
         </p:spPr>
@@ -6492,9 +6762,9 @@
               <a:spcAft>
                 <a:spcPts val="1200"/>
               </a:spcAft>
-              <a:defRPr sz="1600" b="1">
-                <a:solidFill>
-                  <a:srgbClr val="10B981"/>
+              <a:defRPr sz="1550" b="1">
+                <a:solidFill>
+                  <a:srgbClr val="107A57"/>
                 </a:solidFill>
                 <a:latin typeface="Segoe UI"/>
               </a:defRPr>
@@ -6507,7 +6777,7 @@
             <a:pPr>
               <a:defRPr sz="1200" b="1">
                 <a:solidFill>
-                  <a:srgbClr val="FFFFFF"/>
+                  <a:srgbClr val="0F172A"/>
                 </a:solidFill>
                 <a:latin typeface="Segoe UI"/>
               </a:defRPr>
@@ -6523,7 +6793,7 @@
               </a:spcAft>
               <a:defRPr sz="1050">
                 <a:solidFill>
-                  <a:srgbClr val="94A3B8"/>
+                  <a:srgbClr val="475569"/>
                 </a:solidFill>
                 <a:latin typeface="Segoe UI"/>
               </a:defRPr>
@@ -6536,7 +6806,7 @@
             <a:pPr>
               <a:defRPr sz="1200" b="1">
                 <a:solidFill>
-                  <a:srgbClr val="FFFFFF"/>
+                  <a:srgbClr val="0F172A"/>
                 </a:solidFill>
                 <a:latin typeface="Segoe UI"/>
               </a:defRPr>
@@ -6552,7 +6822,7 @@
               </a:spcAft>
               <a:defRPr sz="1050">
                 <a:solidFill>
-                  <a:srgbClr val="94A3B8"/>
+                  <a:srgbClr val="475569"/>
                 </a:solidFill>
                 <a:latin typeface="Segoe UI"/>
               </a:defRPr>
@@ -6565,7 +6835,7 @@
             <a:pPr>
               <a:defRPr sz="1200" b="1">
                 <a:solidFill>
-                  <a:srgbClr val="FFFFFF"/>
+                  <a:srgbClr val="0F172A"/>
                 </a:solidFill>
                 <a:latin typeface="Segoe UI"/>
               </a:defRPr>
@@ -6581,7 +6851,7 @@
               </a:spcAft>
               <a:defRPr sz="1050">
                 <a:solidFill>
-                  <a:srgbClr val="94A3B8"/>
+                  <a:srgbClr val="475569"/>
                 </a:solidFill>
                 <a:latin typeface="Segoe UI"/>
               </a:defRPr>
@@ -6594,7 +6864,7 @@
             <a:pPr>
               <a:defRPr sz="1200" b="1">
                 <a:solidFill>
-                  <a:srgbClr val="FFFFFF"/>
+                  <a:srgbClr val="0F172A"/>
                 </a:solidFill>
                 <a:latin typeface="Segoe UI"/>
               </a:defRPr>
@@ -6610,7 +6880,7 @@
               </a:spcAft>
               <a:defRPr sz="1050">
                 <a:solidFill>
-                  <a:srgbClr val="94A3B8"/>
+                  <a:srgbClr val="475569"/>
                 </a:solidFill>
                 <a:latin typeface="Segoe UI"/>
               </a:defRPr>
@@ -6623,14 +6893,57 @@
       </p:sp>
       <p:sp>
         <p:nvSpPr>
-          <p:cNvPr id="8" name="TextBox 7"/>
+          <p:cNvPr id="8" name="Rectangle 7"/>
+          <p:cNvSpPr/>
+          <p:nvPr/>
+        </p:nvSpPr>
+        <p:spPr>
+          <a:xfrm>
+            <a:off x="731520" y="6217920"/>
+            <a:ext cx="10728655" cy="13716"/>
+          </a:xfrm>
+          <a:prstGeom prst="rect">
+            <a:avLst/>
+          </a:prstGeom>
+          <a:solidFill>
+            <a:srgbClr val="E2E8F0"/>
+          </a:solidFill>
+          <a:ln>
+            <a:noFill/>
+          </a:ln>
+        </p:spPr>
+        <p:style>
+          <a:lnRef idx="1">
+            <a:schemeClr val="accent1"/>
+          </a:lnRef>
+          <a:fillRef idx="3">
+            <a:schemeClr val="accent1"/>
+          </a:fillRef>
+          <a:effectRef idx="2">
+            <a:schemeClr val="accent1"/>
+          </a:effectRef>
+          <a:fontRef idx="minor">
+            <a:schemeClr val="lt1"/>
+          </a:fontRef>
+        </p:style>
+        <p:txBody>
+          <a:bodyPr rtlCol="0" anchor="ctr"/>
+          <a:lstStyle/>
+          <a:p>
+            <a:pPr algn="ctr"/>
+          </a:p>
+        </p:txBody>
+      </p:sp>
+      <p:sp>
+        <p:nvSpPr>
+          <p:cNvPr id="9" name="TextBox 8"/>
           <p:cNvSpPr txBox="1"/>
           <p:nvPr/>
         </p:nvSpPr>
         <p:spPr>
           <a:xfrm>
             <a:off x="731520" y="6309360"/>
-            <a:ext cx="10698480" cy="365760"/>
+            <a:ext cx="10698480" cy="320040"/>
           </a:xfrm>
           <a:prstGeom prst="rect">
             <a:avLst/>
@@ -6690,7 +7003,7 @@
             <a:avLst/>
           </a:prstGeom>
           <a:solidFill>
-            <a:srgbClr val="0B0F19"/>
+            <a:srgbClr val="FFFFFF"/>
           </a:solidFill>
           <a:ln>
             <a:noFill/>
@@ -6726,8 +7039,8 @@
         </p:nvSpPr>
         <p:spPr>
           <a:xfrm>
-            <a:off x="731520" y="457200"/>
-            <a:ext cx="10698480" cy="1005840"/>
+            <a:off x="731520" y="411480"/>
+            <a:ext cx="10698480" cy="1051560"/>
           </a:xfrm>
           <a:prstGeom prst="rect">
             <a:avLst/>
@@ -6744,9 +7057,9 @@
               <a:spcAft>
                 <a:spcPts val="200"/>
               </a:spcAft>
-              <a:defRPr sz="1100" b="1">
-                <a:solidFill>
-                  <a:srgbClr val="06B6D4"/>
+              <a:defRPr sz="1050" b="1">
+                <a:solidFill>
+                  <a:srgbClr val="1D4ED8"/>
                 </a:solidFill>
                 <a:latin typeface="Segoe UI"/>
               </a:defRPr>
@@ -6762,7 +7075,7 @@
               </a:spcAft>
               <a:defRPr sz="2200" b="1">
                 <a:solidFill>
-                  <a:srgbClr val="FFFFFF"/>
+                  <a:srgbClr val="0F172A"/>
                 </a:solidFill>
                 <a:latin typeface="Segoe UI"/>
               </a:defRPr>
@@ -6773,9 +7086,9 @@
           </a:p>
           <a:p>
             <a:pPr>
-              <a:defRPr sz="1200">
-                <a:solidFill>
-                  <a:srgbClr val="94A3B8"/>
+              <a:defRPr sz="1150">
+                <a:solidFill>
+                  <a:srgbClr val="475569"/>
                 </a:solidFill>
                 <a:latin typeface="Segoe UI"/>
               </a:defRPr>
@@ -6801,11 +7114,11 @@
             <a:avLst/>
           </a:prstGeom>
           <a:solidFill>
-            <a:srgbClr val="131A2B"/>
+            <a:srgbClr val="F8FAFC"/>
           </a:solidFill>
           <a:ln w="15240">
             <a:solidFill>
-              <a:srgbClr val="06B6D4"/>
+              <a:srgbClr val="E2E8F0"/>
             </a:solidFill>
           </a:ln>
         </p:spPr>
@@ -6859,7 +7172,7 @@
               </a:spcAft>
               <a:defRPr sz="1300" b="1">
                 <a:solidFill>
-                  <a:srgbClr val="06B6D4"/>
+                  <a:srgbClr val="0E7490"/>
                 </a:solidFill>
                 <a:latin typeface="Segoe UI"/>
               </a:defRPr>
@@ -6872,7 +7185,7 @@
             <a:pPr>
               <a:defRPr sz="1100" b="1">
                 <a:solidFill>
-                  <a:srgbClr val="FFFFFF"/>
+                  <a:srgbClr val="0F172A"/>
                 </a:solidFill>
                 <a:latin typeface="Segoe UI"/>
               </a:defRPr>
@@ -6888,20 +7201,20 @@
               </a:spcAft>
               <a:defRPr sz="950">
                 <a:solidFill>
-                  <a:srgbClr val="94A3B8"/>
-                </a:solidFill>
-                <a:latin typeface="Segoe UI"/>
-              </a:defRPr>
-            </a:pPr>
-            <a:r>
-              <a:t>Declarative XML UI views with CSS styling and dark/light themes.</a:t>
+                  <a:srgbClr val="475569"/>
+                </a:solidFill>
+                <a:latin typeface="Segoe UI"/>
+              </a:defRPr>
+            </a:pPr>
+            <a:r>
+              <a:t>Declarative XML UI views with CSS styling and clean desktop ergonomics.</a:t>
             </a:r>
           </a:p>
           <a:p>
             <a:pPr>
               <a:defRPr sz="1100" b="1">
                 <a:solidFill>
-                  <a:srgbClr val="FFFFFF"/>
+                  <a:srgbClr val="0F172A"/>
                 </a:solidFill>
                 <a:latin typeface="Segoe UI"/>
               </a:defRPr>
@@ -6917,20 +7230,20 @@
               </a:spcAft>
               <a:defRPr sz="950">
                 <a:solidFill>
-                  <a:srgbClr val="94A3B8"/>
-                </a:solidFill>
-                <a:latin typeface="Segoe UI"/>
-              </a:defRPr>
-            </a:pPr>
-            <a:r>
-              <a:t>Modern sleek design with responsive layouts and glowing accent pills.</a:t>
+                  <a:srgbClr val="475569"/>
+                </a:solidFill>
+                <a:latin typeface="Segoe UI"/>
+              </a:defRPr>
+            </a:pPr>
+            <a:r>
+              <a:t>Modern sleek design with responsive layouts and accessible contrast.</a:t>
             </a:r>
           </a:p>
           <a:p>
             <a:pPr>
               <a:defRPr sz="1100" b="1">
                 <a:solidFill>
-                  <a:srgbClr val="FFFFFF"/>
+                  <a:srgbClr val="0F172A"/>
                 </a:solidFill>
                 <a:latin typeface="Segoe UI"/>
               </a:defRPr>
@@ -6946,7 +7259,7 @@
               </a:spcAft>
               <a:defRPr sz="950">
                 <a:solidFill>
-                  <a:srgbClr val="94A3B8"/>
+                  <a:srgbClr val="475569"/>
                 </a:solidFill>
                 <a:latin typeface="Segoe UI"/>
               </a:defRPr>
@@ -6959,7 +7272,7 @@
             <a:pPr>
               <a:defRPr sz="1100" b="1">
                 <a:solidFill>
-                  <a:srgbClr val="FFFFFF"/>
+                  <a:srgbClr val="0F172A"/>
                 </a:solidFill>
                 <a:latin typeface="Segoe UI"/>
               </a:defRPr>
@@ -6975,7 +7288,7 @@
               </a:spcAft>
               <a:defRPr sz="950">
                 <a:solidFill>
-                  <a:srgbClr val="94A3B8"/>
+                  <a:srgbClr val="475569"/>
                 </a:solidFill>
                 <a:latin typeface="Segoe UI"/>
               </a:defRPr>
@@ -7001,11 +7314,11 @@
             <a:avLst/>
           </a:prstGeom>
           <a:solidFill>
-            <a:srgbClr val="131A2B"/>
+            <a:srgbClr val="F8FAFC"/>
           </a:solidFill>
           <a:ln w="15240">
             <a:solidFill>
-              <a:srgbClr val="2563EB"/>
+              <a:srgbClr val="E2E8F0"/>
             </a:solidFill>
           </a:ln>
         </p:spPr>
@@ -7059,7 +7372,7 @@
               </a:spcAft>
               <a:defRPr sz="1300" b="1">
                 <a:solidFill>
-                  <a:srgbClr val="2563EB"/>
+                  <a:srgbClr val="1D4ED8"/>
                 </a:solidFill>
                 <a:latin typeface="Segoe UI"/>
               </a:defRPr>
@@ -7072,7 +7385,7 @@
             <a:pPr>
               <a:defRPr sz="1100" b="1">
                 <a:solidFill>
-                  <a:srgbClr val="FFFFFF"/>
+                  <a:srgbClr val="0F172A"/>
                 </a:solidFill>
                 <a:latin typeface="Segoe UI"/>
               </a:defRPr>
@@ -7088,7 +7401,7 @@
               </a:spcAft>
               <a:defRPr sz="950">
                 <a:solidFill>
-                  <a:srgbClr val="94A3B8"/>
+                  <a:srgbClr val="475569"/>
                 </a:solidFill>
                 <a:latin typeface="Segoe UI"/>
               </a:defRPr>
@@ -7101,7 +7414,7 @@
             <a:pPr>
               <a:defRPr sz="1100" b="1">
                 <a:solidFill>
-                  <a:srgbClr val="FFFFFF"/>
+                  <a:srgbClr val="0F172A"/>
                 </a:solidFill>
                 <a:latin typeface="Segoe UI"/>
               </a:defRPr>
@@ -7117,7 +7430,7 @@
               </a:spcAft>
               <a:defRPr sz="950">
                 <a:solidFill>
-                  <a:srgbClr val="94A3B8"/>
+                  <a:srgbClr val="475569"/>
                 </a:solidFill>
                 <a:latin typeface="Segoe UI"/>
               </a:defRPr>
@@ -7130,7 +7443,7 @@
             <a:pPr>
               <a:defRPr sz="1100" b="1">
                 <a:solidFill>
-                  <a:srgbClr val="FFFFFF"/>
+                  <a:srgbClr val="0F172A"/>
                 </a:solidFill>
                 <a:latin typeface="Segoe UI"/>
               </a:defRPr>
@@ -7146,7 +7459,7 @@
               </a:spcAft>
               <a:defRPr sz="950">
                 <a:solidFill>
-                  <a:srgbClr val="94A3B8"/>
+                  <a:srgbClr val="475569"/>
                 </a:solidFill>
                 <a:latin typeface="Segoe UI"/>
               </a:defRPr>
@@ -7159,7 +7472,7 @@
             <a:pPr>
               <a:defRPr sz="1100" b="1">
                 <a:solidFill>
-                  <a:srgbClr val="FFFFFF"/>
+                  <a:srgbClr val="0F172A"/>
                 </a:solidFill>
                 <a:latin typeface="Segoe UI"/>
               </a:defRPr>
@@ -7175,7 +7488,7 @@
               </a:spcAft>
               <a:defRPr sz="950">
                 <a:solidFill>
-                  <a:srgbClr val="94A3B8"/>
+                  <a:srgbClr val="475569"/>
                 </a:solidFill>
                 <a:latin typeface="Segoe UI"/>
               </a:defRPr>
@@ -7201,11 +7514,11 @@
             <a:avLst/>
           </a:prstGeom>
           <a:solidFill>
-            <a:srgbClr val="131A2B"/>
+            <a:srgbClr val="F8FAFC"/>
           </a:solidFill>
           <a:ln w="15240">
             <a:solidFill>
-              <a:srgbClr val="10B981"/>
+              <a:srgbClr val="E2E8F0"/>
             </a:solidFill>
           </a:ln>
         </p:spPr>
@@ -7259,7 +7572,7 @@
               </a:spcAft>
               <a:defRPr sz="1300" b="1">
                 <a:solidFill>
-                  <a:srgbClr val="10B981"/>
+                  <a:srgbClr val="107A57"/>
                 </a:solidFill>
                 <a:latin typeface="Segoe UI"/>
               </a:defRPr>
@@ -7272,7 +7585,7 @@
             <a:pPr>
               <a:defRPr sz="1100" b="1">
                 <a:solidFill>
-                  <a:srgbClr val="FFFFFF"/>
+                  <a:srgbClr val="0F172A"/>
                 </a:solidFill>
                 <a:latin typeface="Segoe UI"/>
               </a:defRPr>
@@ -7288,7 +7601,7 @@
               </a:spcAft>
               <a:defRPr sz="950">
                 <a:solidFill>
-                  <a:srgbClr val="94A3B8"/>
+                  <a:srgbClr val="475569"/>
                 </a:solidFill>
                 <a:latin typeface="Segoe UI"/>
               </a:defRPr>
@@ -7301,7 +7614,7 @@
             <a:pPr>
               <a:defRPr sz="1100" b="1">
                 <a:solidFill>
-                  <a:srgbClr val="FFFFFF"/>
+                  <a:srgbClr val="0F172A"/>
                 </a:solidFill>
                 <a:latin typeface="Segoe UI"/>
               </a:defRPr>
@@ -7317,7 +7630,7 @@
               </a:spcAft>
               <a:defRPr sz="950">
                 <a:solidFill>
-                  <a:srgbClr val="94A3B8"/>
+                  <a:srgbClr val="475569"/>
                 </a:solidFill>
                 <a:latin typeface="Segoe UI"/>
               </a:defRPr>
@@ -7330,7 +7643,7 @@
             <a:pPr>
               <a:defRPr sz="1100" b="1">
                 <a:solidFill>
-                  <a:srgbClr val="FFFFFF"/>
+                  <a:srgbClr val="0F172A"/>
                 </a:solidFill>
                 <a:latin typeface="Segoe UI"/>
               </a:defRPr>
@@ -7346,7 +7659,7 @@
               </a:spcAft>
               <a:defRPr sz="950">
                 <a:solidFill>
-                  <a:srgbClr val="94A3B8"/>
+                  <a:srgbClr val="475569"/>
                 </a:solidFill>
                 <a:latin typeface="Segoe UI"/>
               </a:defRPr>
@@ -7359,7 +7672,7 @@
             <a:pPr>
               <a:defRPr sz="1100" b="1">
                 <a:solidFill>
-                  <a:srgbClr val="FFFFFF"/>
+                  <a:srgbClr val="0F172A"/>
                 </a:solidFill>
                 <a:latin typeface="Segoe UI"/>
               </a:defRPr>
@@ -7375,7 +7688,7 @@
               </a:spcAft>
               <a:defRPr sz="950">
                 <a:solidFill>
-                  <a:srgbClr val="94A3B8"/>
+                  <a:srgbClr val="475569"/>
                 </a:solidFill>
                 <a:latin typeface="Segoe UI"/>
               </a:defRPr>
@@ -7401,11 +7714,11 @@
             <a:avLst/>
           </a:prstGeom>
           <a:solidFill>
-            <a:srgbClr val="131A2B"/>
+            <a:srgbClr val="F8FAFC"/>
           </a:solidFill>
           <a:ln w="15240">
             <a:solidFill>
-              <a:srgbClr val="F59E0B"/>
+              <a:srgbClr val="E2E8F0"/>
             </a:solidFill>
           </a:ln>
         </p:spPr>
@@ -7459,7 +7772,7 @@
               </a:spcAft>
               <a:defRPr sz="1300" b="1">
                 <a:solidFill>
-                  <a:srgbClr val="F59E0B"/>
+                  <a:srgbClr val="B45309"/>
                 </a:solidFill>
                 <a:latin typeface="Segoe UI"/>
               </a:defRPr>
@@ -7472,7 +7785,7 @@
             <a:pPr>
               <a:defRPr sz="1100" b="1">
                 <a:solidFill>
-                  <a:srgbClr val="FFFFFF"/>
+                  <a:srgbClr val="0F172A"/>
                 </a:solidFill>
                 <a:latin typeface="Segoe UI"/>
               </a:defRPr>
@@ -7488,7 +7801,7 @@
               </a:spcAft>
               <a:defRPr sz="950">
                 <a:solidFill>
-                  <a:srgbClr val="94A3B8"/>
+                  <a:srgbClr val="475569"/>
                 </a:solidFill>
                 <a:latin typeface="Segoe UI"/>
               </a:defRPr>
@@ -7501,7 +7814,7 @@
             <a:pPr>
               <a:defRPr sz="1100" b="1">
                 <a:solidFill>
-                  <a:srgbClr val="FFFFFF"/>
+                  <a:srgbClr val="0F172A"/>
                 </a:solidFill>
                 <a:latin typeface="Segoe UI"/>
               </a:defRPr>
@@ -7517,7 +7830,7 @@
               </a:spcAft>
               <a:defRPr sz="950">
                 <a:solidFill>
-                  <a:srgbClr val="94A3B8"/>
+                  <a:srgbClr val="475569"/>
                 </a:solidFill>
                 <a:latin typeface="Segoe UI"/>
               </a:defRPr>
@@ -7530,7 +7843,7 @@
             <a:pPr>
               <a:defRPr sz="1100" b="1">
                 <a:solidFill>
-                  <a:srgbClr val="FFFFFF"/>
+                  <a:srgbClr val="0F172A"/>
                 </a:solidFill>
                 <a:latin typeface="Segoe UI"/>
               </a:defRPr>
@@ -7546,7 +7859,7 @@
               </a:spcAft>
               <a:defRPr sz="950">
                 <a:solidFill>
-                  <a:srgbClr val="94A3B8"/>
+                  <a:srgbClr val="475569"/>
                 </a:solidFill>
                 <a:latin typeface="Segoe UI"/>
               </a:defRPr>
@@ -7559,7 +7872,7 @@
             <a:pPr>
               <a:defRPr sz="1100" b="1">
                 <a:solidFill>
-                  <a:srgbClr val="FFFFFF"/>
+                  <a:srgbClr val="0F172A"/>
                 </a:solidFill>
                 <a:latin typeface="Segoe UI"/>
               </a:defRPr>
@@ -7575,7 +7888,7 @@
               </a:spcAft>
               <a:defRPr sz="950">
                 <a:solidFill>
-                  <a:srgbClr val="94A3B8"/>
+                  <a:srgbClr val="475569"/>
                 </a:solidFill>
                 <a:latin typeface="Segoe UI"/>
               </a:defRPr>
@@ -7588,14 +7901,57 @@
       </p:sp>
       <p:sp>
         <p:nvSpPr>
-          <p:cNvPr id="12" name="TextBox 11"/>
+          <p:cNvPr id="12" name="Rectangle 11"/>
+          <p:cNvSpPr/>
+          <p:nvPr/>
+        </p:nvSpPr>
+        <p:spPr>
+          <a:xfrm>
+            <a:off x="731520" y="6217920"/>
+            <a:ext cx="10728655" cy="13716"/>
+          </a:xfrm>
+          <a:prstGeom prst="rect">
+            <a:avLst/>
+          </a:prstGeom>
+          <a:solidFill>
+            <a:srgbClr val="E2E8F0"/>
+          </a:solidFill>
+          <a:ln>
+            <a:noFill/>
+          </a:ln>
+        </p:spPr>
+        <p:style>
+          <a:lnRef idx="1">
+            <a:schemeClr val="accent1"/>
+          </a:lnRef>
+          <a:fillRef idx="3">
+            <a:schemeClr val="accent1"/>
+          </a:fillRef>
+          <a:effectRef idx="2">
+            <a:schemeClr val="accent1"/>
+          </a:effectRef>
+          <a:fontRef idx="minor">
+            <a:schemeClr val="lt1"/>
+          </a:fontRef>
+        </p:style>
+        <p:txBody>
+          <a:bodyPr rtlCol="0" anchor="ctr"/>
+          <a:lstStyle/>
+          <a:p>
+            <a:pPr algn="ctr"/>
+          </a:p>
+        </p:txBody>
+      </p:sp>
+      <p:sp>
+        <p:nvSpPr>
+          <p:cNvPr id="13" name="TextBox 12"/>
           <p:cNvSpPr txBox="1"/>
           <p:nvPr/>
         </p:nvSpPr>
         <p:spPr>
           <a:xfrm>
             <a:off x="731520" y="6309360"/>
-            <a:ext cx="10698480" cy="365760"/>
+            <a:ext cx="10698480" cy="320040"/>
           </a:xfrm>
           <a:prstGeom prst="rect">
             <a:avLst/>
@@ -7655,7 +8011,7 @@
             <a:avLst/>
           </a:prstGeom>
           <a:solidFill>
-            <a:srgbClr val="0B0F19"/>
+            <a:srgbClr val="FFFFFF"/>
           </a:solidFill>
           <a:ln>
             <a:noFill/>
@@ -7691,8 +8047,8 @@
         </p:nvSpPr>
         <p:spPr>
           <a:xfrm>
-            <a:off x="731520" y="457200"/>
-            <a:ext cx="10698480" cy="1005840"/>
+            <a:off x="731520" y="411480"/>
+            <a:ext cx="10698480" cy="1051560"/>
           </a:xfrm>
           <a:prstGeom prst="rect">
             <a:avLst/>
@@ -7709,9 +8065,9 @@
               <a:spcAft>
                 <a:spcPts val="200"/>
               </a:spcAft>
-              <a:defRPr sz="1100" b="1">
-                <a:solidFill>
-                  <a:srgbClr val="06B6D4"/>
+              <a:defRPr sz="1050" b="1">
+                <a:solidFill>
+                  <a:srgbClr val="1D4ED8"/>
                 </a:solidFill>
                 <a:latin typeface="Segoe UI"/>
               </a:defRPr>
@@ -7727,7 +8083,7 @@
               </a:spcAft>
               <a:defRPr sz="2200" b="1">
                 <a:solidFill>
-                  <a:srgbClr val="FFFFFF"/>
+                  <a:srgbClr val="0F172A"/>
                 </a:solidFill>
                 <a:latin typeface="Segoe UI"/>
               </a:defRPr>
@@ -7738,9 +8094,9 @@
           </a:p>
           <a:p>
             <a:pPr>
-              <a:defRPr sz="1200">
-                <a:solidFill>
-                  <a:srgbClr val="94A3B8"/>
+              <a:defRPr sz="1150">
+                <a:solidFill>
+                  <a:srgbClr val="475569"/>
                 </a:solidFill>
                 <a:latin typeface="Segoe UI"/>
               </a:defRPr>
@@ -7766,11 +8122,11 @@
             <a:avLst/>
           </a:prstGeom>
           <a:solidFill>
-            <a:srgbClr val="131A2B"/>
+            <a:srgbClr val="F8FAFC"/>
           </a:solidFill>
           <a:ln w="15240">
             <a:solidFill>
-              <a:srgbClr val="253352"/>
+              <a:srgbClr val="E2E8F0"/>
             </a:solidFill>
           </a:ln>
         </p:spPr>
@@ -7824,7 +8180,7 @@
               </a:spcAft>
               <a:defRPr sz="950" b="1">
                 <a:solidFill>
-                  <a:srgbClr val="06B6D4"/>
+                  <a:srgbClr val="1D4ED8"/>
                 </a:solidFill>
                 <a:latin typeface="Segoe UI"/>
               </a:defRPr>
@@ -7838,9 +8194,9 @@
               <a:spcAft>
                 <a:spcPts val="600"/>
               </a:spcAft>
-              <a:defRPr sz="1500" b="1">
-                <a:solidFill>
-                  <a:srgbClr val="FFFFFF"/>
+              <a:defRPr sz="1450" b="1">
+                <a:solidFill>
+                  <a:srgbClr val="0F172A"/>
                 </a:solidFill>
                 <a:latin typeface="Segoe UI"/>
               </a:defRPr>
@@ -7853,7 +8209,7 @@
             <a:pPr>
               <a:defRPr sz="1000">
                 <a:solidFill>
-                  <a:srgbClr val="94A3B8"/>
+                  <a:srgbClr val="475569"/>
                 </a:solidFill>
                 <a:latin typeface="Segoe UI"/>
               </a:defRPr>
@@ -7879,11 +8235,11 @@
             <a:avLst/>
           </a:prstGeom>
           <a:solidFill>
-            <a:srgbClr val="131A2B"/>
+            <a:srgbClr val="F8FAFC"/>
           </a:solidFill>
           <a:ln w="15240">
             <a:solidFill>
-              <a:srgbClr val="253352"/>
+              <a:srgbClr val="E2E8F0"/>
             </a:solidFill>
           </a:ln>
         </p:spPr>
@@ -7937,7 +8293,7 @@
               </a:spcAft>
               <a:defRPr sz="950" b="1">
                 <a:solidFill>
-                  <a:srgbClr val="2563EB"/>
+                  <a:srgbClr val="0E7490"/>
                 </a:solidFill>
                 <a:latin typeface="Segoe UI"/>
               </a:defRPr>
@@ -7951,9 +8307,9 @@
               <a:spcAft>
                 <a:spcPts val="600"/>
               </a:spcAft>
-              <a:defRPr sz="1500" b="1">
-                <a:solidFill>
-                  <a:srgbClr val="FFFFFF"/>
+              <a:defRPr sz="1450" b="1">
+                <a:solidFill>
+                  <a:srgbClr val="0F172A"/>
                 </a:solidFill>
                 <a:latin typeface="Segoe UI"/>
               </a:defRPr>
@@ -7966,7 +8322,7 @@
             <a:pPr>
               <a:defRPr sz="1000">
                 <a:solidFill>
-                  <a:srgbClr val="94A3B8"/>
+                  <a:srgbClr val="475569"/>
                 </a:solidFill>
                 <a:latin typeface="Segoe UI"/>
               </a:defRPr>
@@ -7992,11 +8348,11 @@
             <a:avLst/>
           </a:prstGeom>
           <a:solidFill>
-            <a:srgbClr val="131A2B"/>
+            <a:srgbClr val="F8FAFC"/>
           </a:solidFill>
           <a:ln w="15240">
             <a:solidFill>
-              <a:srgbClr val="253352"/>
+              <a:srgbClr val="E2E8F0"/>
             </a:solidFill>
           </a:ln>
         </p:spPr>
@@ -8050,7 +8406,7 @@
               </a:spcAft>
               <a:defRPr sz="950" b="1">
                 <a:solidFill>
-                  <a:srgbClr val="10B981"/>
+                  <a:srgbClr val="107A57"/>
                 </a:solidFill>
                 <a:latin typeface="Segoe UI"/>
               </a:defRPr>
@@ -8064,9 +8420,9 @@
               <a:spcAft>
                 <a:spcPts val="600"/>
               </a:spcAft>
-              <a:defRPr sz="1500" b="1">
-                <a:solidFill>
-                  <a:srgbClr val="FFFFFF"/>
+              <a:defRPr sz="1450" b="1">
+                <a:solidFill>
+                  <a:srgbClr val="0F172A"/>
                 </a:solidFill>
                 <a:latin typeface="Segoe UI"/>
               </a:defRPr>
@@ -8079,7 +8435,7 @@
             <a:pPr>
               <a:defRPr sz="1000">
                 <a:solidFill>
-                  <a:srgbClr val="94A3B8"/>
+                  <a:srgbClr val="475569"/>
                 </a:solidFill>
                 <a:latin typeface="Segoe UI"/>
               </a:defRPr>
@@ -8105,11 +8461,11 @@
             <a:avLst/>
           </a:prstGeom>
           <a:solidFill>
-            <a:srgbClr val="131A2B"/>
+            <a:srgbClr val="F8FAFC"/>
           </a:solidFill>
           <a:ln w="15240">
             <a:solidFill>
-              <a:srgbClr val="253352"/>
+              <a:srgbClr val="E2E8F0"/>
             </a:solidFill>
           </a:ln>
         </p:spPr>
@@ -8163,7 +8519,7 @@
               </a:spcAft>
               <a:defRPr sz="950" b="1">
                 <a:solidFill>
-                  <a:srgbClr val="F59E0B"/>
+                  <a:srgbClr val="B45309"/>
                 </a:solidFill>
                 <a:latin typeface="Segoe UI"/>
               </a:defRPr>
@@ -8177,9 +8533,9 @@
               <a:spcAft>
                 <a:spcPts val="600"/>
               </a:spcAft>
-              <a:defRPr sz="1500" b="1">
-                <a:solidFill>
-                  <a:srgbClr val="FFFFFF"/>
+              <a:defRPr sz="1450" b="1">
+                <a:solidFill>
+                  <a:srgbClr val="0F172A"/>
                 </a:solidFill>
                 <a:latin typeface="Segoe UI"/>
               </a:defRPr>
@@ -8192,7 +8548,7 @@
             <a:pPr>
               <a:defRPr sz="1000">
                 <a:solidFill>
-                  <a:srgbClr val="94A3B8"/>
+                  <a:srgbClr val="475569"/>
                 </a:solidFill>
                 <a:latin typeface="Segoe UI"/>
               </a:defRPr>
@@ -8218,11 +8574,11 @@
             <a:avLst/>
           </a:prstGeom>
           <a:solidFill>
-            <a:srgbClr val="131A2B"/>
+            <a:srgbClr val="F8FAFC"/>
           </a:solidFill>
           <a:ln w="15240">
             <a:solidFill>
-              <a:srgbClr val="253352"/>
+              <a:srgbClr val="E2E8F0"/>
             </a:solidFill>
           </a:ln>
         </p:spPr>
@@ -8276,7 +8632,7 @@
               </a:spcAft>
               <a:defRPr sz="950" b="1">
                 <a:solidFill>
-                  <a:srgbClr val="06B6D4"/>
+                  <a:srgbClr val="1D4ED8"/>
                 </a:solidFill>
                 <a:latin typeface="Segoe UI"/>
               </a:defRPr>
@@ -8290,9 +8646,9 @@
               <a:spcAft>
                 <a:spcPts val="600"/>
               </a:spcAft>
-              <a:defRPr sz="1500" b="1">
-                <a:solidFill>
-                  <a:srgbClr val="FFFFFF"/>
+              <a:defRPr sz="1450" b="1">
+                <a:solidFill>
+                  <a:srgbClr val="0F172A"/>
                 </a:solidFill>
                 <a:latin typeface="Segoe UI"/>
               </a:defRPr>
@@ -8305,7 +8661,7 @@
             <a:pPr>
               <a:defRPr sz="1000">
                 <a:solidFill>
-                  <a:srgbClr val="94A3B8"/>
+                  <a:srgbClr val="475569"/>
                 </a:solidFill>
                 <a:latin typeface="Segoe UI"/>
               </a:defRPr>
@@ -8331,11 +8687,11 @@
             <a:avLst/>
           </a:prstGeom>
           <a:solidFill>
-            <a:srgbClr val="131A2B"/>
+            <a:srgbClr val="F8FAFC"/>
           </a:solidFill>
           <a:ln w="15240">
             <a:solidFill>
-              <a:srgbClr val="253352"/>
+              <a:srgbClr val="E2E8F0"/>
             </a:solidFill>
           </a:ln>
         </p:spPr>
@@ -8389,7 +8745,7 @@
               </a:spcAft>
               <a:defRPr sz="950" b="1">
                 <a:solidFill>
-                  <a:srgbClr val="10B981"/>
+                  <a:srgbClr val="107A57"/>
                 </a:solidFill>
                 <a:latin typeface="Segoe UI"/>
               </a:defRPr>
@@ -8403,9 +8759,9 @@
               <a:spcAft>
                 <a:spcPts val="600"/>
               </a:spcAft>
-              <a:defRPr sz="1500" b="1">
-                <a:solidFill>
-                  <a:srgbClr val="FFFFFF"/>
+              <a:defRPr sz="1450" b="1">
+                <a:solidFill>
+                  <a:srgbClr val="0F172A"/>
                 </a:solidFill>
                 <a:latin typeface="Segoe UI"/>
               </a:defRPr>
@@ -8418,7 +8774,7 @@
             <a:pPr>
               <a:defRPr sz="1000">
                 <a:solidFill>
-                  <a:srgbClr val="94A3B8"/>
+                  <a:srgbClr val="475569"/>
                 </a:solidFill>
                 <a:latin typeface="Segoe UI"/>
               </a:defRPr>
@@ -8431,14 +8787,57 @@
       </p:sp>
       <p:sp>
         <p:nvSpPr>
-          <p:cNvPr id="16" name="TextBox 15"/>
+          <p:cNvPr id="16" name="Rectangle 15"/>
+          <p:cNvSpPr/>
+          <p:nvPr/>
+        </p:nvSpPr>
+        <p:spPr>
+          <a:xfrm>
+            <a:off x="731520" y="6217920"/>
+            <a:ext cx="10728655" cy="13716"/>
+          </a:xfrm>
+          <a:prstGeom prst="rect">
+            <a:avLst/>
+          </a:prstGeom>
+          <a:solidFill>
+            <a:srgbClr val="E2E8F0"/>
+          </a:solidFill>
+          <a:ln>
+            <a:noFill/>
+          </a:ln>
+        </p:spPr>
+        <p:style>
+          <a:lnRef idx="1">
+            <a:schemeClr val="accent1"/>
+          </a:lnRef>
+          <a:fillRef idx="3">
+            <a:schemeClr val="accent1"/>
+          </a:fillRef>
+          <a:effectRef idx="2">
+            <a:schemeClr val="accent1"/>
+          </a:effectRef>
+          <a:fontRef idx="minor">
+            <a:schemeClr val="lt1"/>
+          </a:fontRef>
+        </p:style>
+        <p:txBody>
+          <a:bodyPr rtlCol="0" anchor="ctr"/>
+          <a:lstStyle/>
+          <a:p>
+            <a:pPr algn="ctr"/>
+          </a:p>
+        </p:txBody>
+      </p:sp>
+      <p:sp>
+        <p:nvSpPr>
+          <p:cNvPr id="17" name="TextBox 16"/>
           <p:cNvSpPr txBox="1"/>
           <p:nvPr/>
         </p:nvSpPr>
         <p:spPr>
           <a:xfrm>
             <a:off x="731520" y="6309360"/>
-            <a:ext cx="10698480" cy="365760"/>
+            <a:ext cx="10698480" cy="320040"/>
           </a:xfrm>
           <a:prstGeom prst="rect">
             <a:avLst/>
@@ -8498,7 +8897,7 @@
             <a:avLst/>
           </a:prstGeom>
           <a:solidFill>
-            <a:srgbClr val="0B0F19"/>
+            <a:srgbClr val="FFFFFF"/>
           </a:solidFill>
           <a:ln>
             <a:noFill/>
@@ -8534,8 +8933,8 @@
         </p:nvSpPr>
         <p:spPr>
           <a:xfrm>
-            <a:off x="731520" y="457200"/>
-            <a:ext cx="10698480" cy="1005840"/>
+            <a:off x="731520" y="411480"/>
+            <a:ext cx="10698480" cy="1051560"/>
           </a:xfrm>
           <a:prstGeom prst="rect">
             <a:avLst/>
@@ -8552,9 +8951,9 @@
               <a:spcAft>
                 <a:spcPts val="200"/>
               </a:spcAft>
-              <a:defRPr sz="1100" b="1">
-                <a:solidFill>
-                  <a:srgbClr val="06B6D4"/>
+              <a:defRPr sz="1050" b="1">
+                <a:solidFill>
+                  <a:srgbClr val="1D4ED8"/>
                 </a:solidFill>
                 <a:latin typeface="Segoe UI"/>
               </a:defRPr>
@@ -8570,7 +8969,7 @@
               </a:spcAft>
               <a:defRPr sz="2200" b="1">
                 <a:solidFill>
-                  <a:srgbClr val="FFFFFF"/>
+                  <a:srgbClr val="0F172A"/>
                 </a:solidFill>
                 <a:latin typeface="Segoe UI"/>
               </a:defRPr>
@@ -8581,9 +8980,9 @@
           </a:p>
           <a:p>
             <a:pPr>
-              <a:defRPr sz="1200">
-                <a:solidFill>
-                  <a:srgbClr val="94A3B8"/>
+              <a:defRPr sz="1150">
+                <a:solidFill>
+                  <a:srgbClr val="475569"/>
                 </a:solidFill>
                 <a:latin typeface="Segoe UI"/>
               </a:defRPr>
@@ -8609,11 +9008,11 @@
             <a:avLst/>
           </a:prstGeom>
           <a:solidFill>
-            <a:srgbClr val="131A2B"/>
+            <a:srgbClr val="F8FAFC"/>
           </a:solidFill>
           <a:ln w="15240">
             <a:solidFill>
-              <a:srgbClr val="253352"/>
+              <a:srgbClr val="E2E8F0"/>
             </a:solidFill>
           </a:ln>
         </p:spPr>
@@ -8662,9 +9061,9 @@
           <a:lstStyle/>
           <a:p>
             <a:pPr>
-              <a:defRPr sz="1250" b="1">
-                <a:solidFill>
-                  <a:srgbClr val="06B6D4"/>
+              <a:defRPr sz="1200" b="1">
+                <a:solidFill>
+                  <a:srgbClr val="1D4ED8"/>
                 </a:solidFill>
                 <a:latin typeface="Segoe UI"/>
               </a:defRPr>
@@ -8676,11 +9075,11 @@
           <a:p>
             <a:pPr>
               <a:spcAft>
-                <a:spcPts val="1000"/>
+                <a:spcPts val="900"/>
               </a:spcAft>
               <a:defRPr sz="1050">
                 <a:solidFill>
-                  <a:srgbClr val="94A3B8"/>
+                  <a:srgbClr val="475569"/>
                 </a:solidFill>
                 <a:latin typeface="Segoe UI"/>
               </a:defRPr>
@@ -8691,9 +9090,9 @@
           </a:p>
           <a:p>
             <a:pPr>
-              <a:defRPr sz="1250" b="1">
-                <a:solidFill>
-                  <a:srgbClr val="FFFFFF"/>
+              <a:defRPr sz="1200" b="1">
+                <a:solidFill>
+                  <a:srgbClr val="0F172A"/>
                 </a:solidFill>
                 <a:latin typeface="Segoe UI"/>
               </a:defRPr>
@@ -8705,11 +9104,11 @@
           <a:p>
             <a:pPr>
               <a:spcAft>
-                <a:spcPts val="1000"/>
+                <a:spcPts val="900"/>
               </a:spcAft>
               <a:defRPr sz="1050">
                 <a:solidFill>
-                  <a:srgbClr val="94A3B8"/>
+                  <a:srgbClr val="475569"/>
                 </a:solidFill>
                 <a:latin typeface="Segoe UI"/>
               </a:defRPr>
@@ -8720,9 +9119,9 @@
           </a:p>
           <a:p>
             <a:pPr>
-              <a:defRPr sz="1250" b="1">
-                <a:solidFill>
-                  <a:srgbClr val="FFFFFF"/>
+              <a:defRPr sz="1200" b="1">
+                <a:solidFill>
+                  <a:srgbClr val="0F172A"/>
                 </a:solidFill>
                 <a:latin typeface="Segoe UI"/>
               </a:defRPr>
@@ -8734,11 +9133,11 @@
           <a:p>
             <a:pPr>
               <a:spcAft>
-                <a:spcPts val="1000"/>
+                <a:spcPts val="900"/>
               </a:spcAft>
               <a:defRPr sz="1050">
                 <a:solidFill>
-                  <a:srgbClr val="94A3B8"/>
+                  <a:srgbClr val="475569"/>
                 </a:solidFill>
                 <a:latin typeface="Segoe UI"/>
               </a:defRPr>
@@ -8749,9 +9148,9 @@
           </a:p>
           <a:p>
             <a:pPr>
-              <a:defRPr sz="1250" b="1">
-                <a:solidFill>
-                  <a:srgbClr val="FFFFFF"/>
+              <a:defRPr sz="1200" b="1">
+                <a:solidFill>
+                  <a:srgbClr val="0F172A"/>
                 </a:solidFill>
                 <a:latin typeface="Segoe UI"/>
               </a:defRPr>
@@ -8763,11 +9162,11 @@
           <a:p>
             <a:pPr>
               <a:spcAft>
-                <a:spcPts val="1000"/>
+                <a:spcPts val="900"/>
               </a:spcAft>
               <a:defRPr sz="1050">
                 <a:solidFill>
-                  <a:srgbClr val="94A3B8"/>
+                  <a:srgbClr val="475569"/>
                 </a:solidFill>
                 <a:latin typeface="Segoe UI"/>
               </a:defRPr>
@@ -8793,11 +9192,11 @@
             <a:avLst/>
           </a:prstGeom>
           <a:solidFill>
-            <a:srgbClr val="131A2B"/>
+            <a:srgbClr val="FFFFFF"/>
           </a:solidFill>
           <a:ln w="15240">
             <a:solidFill>
-              <a:srgbClr val="2563EB"/>
+              <a:srgbClr val="CBD5E1"/>
             </a:solidFill>
           </a:ln>
         </p:spPr>
@@ -8870,9 +9269,9 @@
           <a:lstStyle/>
           <a:p>
             <a:pPr algn="ctr">
-              <a:defRPr sz="950">
-                <a:solidFill>
-                  <a:srgbClr val="06B6D4"/>
+              <a:defRPr sz="950" b="1">
+                <a:solidFill>
+                  <a:srgbClr val="64748B"/>
                 </a:solidFill>
                 <a:latin typeface="Segoe UI"/>
               </a:defRPr>
@@ -8885,14 +9284,57 @@
       </p:sp>
       <p:sp>
         <p:nvSpPr>
-          <p:cNvPr id="9" name="TextBox 8"/>
+          <p:cNvPr id="9" name="Rectangle 8"/>
+          <p:cNvSpPr/>
+          <p:nvPr/>
+        </p:nvSpPr>
+        <p:spPr>
+          <a:xfrm>
+            <a:off x="731520" y="6217920"/>
+            <a:ext cx="10728655" cy="13716"/>
+          </a:xfrm>
+          <a:prstGeom prst="rect">
+            <a:avLst/>
+          </a:prstGeom>
+          <a:solidFill>
+            <a:srgbClr val="E2E8F0"/>
+          </a:solidFill>
+          <a:ln>
+            <a:noFill/>
+          </a:ln>
+        </p:spPr>
+        <p:style>
+          <a:lnRef idx="1">
+            <a:schemeClr val="accent1"/>
+          </a:lnRef>
+          <a:fillRef idx="3">
+            <a:schemeClr val="accent1"/>
+          </a:fillRef>
+          <a:effectRef idx="2">
+            <a:schemeClr val="accent1"/>
+          </a:effectRef>
+          <a:fontRef idx="minor">
+            <a:schemeClr val="lt1"/>
+          </a:fontRef>
+        </p:style>
+        <p:txBody>
+          <a:bodyPr rtlCol="0" anchor="ctr"/>
+          <a:lstStyle/>
+          <a:p>
+            <a:pPr algn="ctr"/>
+          </a:p>
+        </p:txBody>
+      </p:sp>
+      <p:sp>
+        <p:nvSpPr>
+          <p:cNvPr id="10" name="TextBox 9"/>
           <p:cNvSpPr txBox="1"/>
           <p:nvPr/>
         </p:nvSpPr>
         <p:spPr>
           <a:xfrm>
             <a:off x="731520" y="6309360"/>
-            <a:ext cx="10698480" cy="365760"/>
+            <a:ext cx="10698480" cy="320040"/>
           </a:xfrm>
           <a:prstGeom prst="rect">
             <a:avLst/>
@@ -8952,7 +9394,7 @@
             <a:avLst/>
           </a:prstGeom>
           <a:solidFill>
-            <a:srgbClr val="0B0F19"/>
+            <a:srgbClr val="FFFFFF"/>
           </a:solidFill>
           <a:ln>
             <a:noFill/>
@@ -8988,8 +9430,8 @@
         </p:nvSpPr>
         <p:spPr>
           <a:xfrm>
-            <a:off x="731520" y="457200"/>
-            <a:ext cx="10698480" cy="1005840"/>
+            <a:off x="731520" y="411480"/>
+            <a:ext cx="10698480" cy="1051560"/>
           </a:xfrm>
           <a:prstGeom prst="rect">
             <a:avLst/>
@@ -9006,9 +9448,9 @@
               <a:spcAft>
                 <a:spcPts val="200"/>
               </a:spcAft>
-              <a:defRPr sz="1100" b="1">
-                <a:solidFill>
-                  <a:srgbClr val="06B6D4"/>
+              <a:defRPr sz="1050" b="1">
+                <a:solidFill>
+                  <a:srgbClr val="1D4ED8"/>
                 </a:solidFill>
                 <a:latin typeface="Segoe UI"/>
               </a:defRPr>
@@ -9024,7 +9466,7 @@
               </a:spcAft>
               <a:defRPr sz="2200" b="1">
                 <a:solidFill>
-                  <a:srgbClr val="FFFFFF"/>
+                  <a:srgbClr val="0F172A"/>
                 </a:solidFill>
                 <a:latin typeface="Segoe UI"/>
               </a:defRPr>
@@ -9035,9 +9477,9 @@
           </a:p>
           <a:p>
             <a:pPr>
-              <a:defRPr sz="1200">
-                <a:solidFill>
-                  <a:srgbClr val="94A3B8"/>
+              <a:defRPr sz="1150">
+                <a:solidFill>
+                  <a:srgbClr val="475569"/>
                 </a:solidFill>
                 <a:latin typeface="Segoe UI"/>
               </a:defRPr>
@@ -9063,11 +9505,11 @@
             <a:avLst/>
           </a:prstGeom>
           <a:solidFill>
-            <a:srgbClr val="131A2B"/>
+            <a:srgbClr val="F8FAFC"/>
           </a:solidFill>
           <a:ln w="15240">
             <a:solidFill>
-              <a:srgbClr val="253352"/>
+              <a:srgbClr val="E2E8F0"/>
             </a:solidFill>
           </a:ln>
         </p:spPr>
@@ -9116,9 +9558,9 @@
           <a:lstStyle/>
           <a:p>
             <a:pPr>
-              <a:defRPr sz="1250" b="1">
-                <a:solidFill>
-                  <a:srgbClr val="06B6D4"/>
+              <a:defRPr sz="1200" b="1">
+                <a:solidFill>
+                  <a:srgbClr val="1D4ED8"/>
                 </a:solidFill>
                 <a:latin typeface="Segoe UI"/>
               </a:defRPr>
@@ -9130,11 +9572,11 @@
           <a:p>
             <a:pPr>
               <a:spcAft>
-                <a:spcPts val="1000"/>
+                <a:spcPts val="900"/>
               </a:spcAft>
               <a:defRPr sz="1050">
                 <a:solidFill>
-                  <a:srgbClr val="94A3B8"/>
+                  <a:srgbClr val="475569"/>
                 </a:solidFill>
                 <a:latin typeface="Segoe UI"/>
               </a:defRPr>
@@ -9145,9 +9587,9 @@
           </a:p>
           <a:p>
             <a:pPr>
-              <a:defRPr sz="1250" b="1">
-                <a:solidFill>
-                  <a:srgbClr val="FFFFFF"/>
+              <a:defRPr sz="1200" b="1">
+                <a:solidFill>
+                  <a:srgbClr val="0F172A"/>
                 </a:solidFill>
                 <a:latin typeface="Segoe UI"/>
               </a:defRPr>
@@ -9159,11 +9601,11 @@
           <a:p>
             <a:pPr>
               <a:spcAft>
-                <a:spcPts val="1000"/>
+                <a:spcPts val="900"/>
               </a:spcAft>
               <a:defRPr sz="1050">
                 <a:solidFill>
-                  <a:srgbClr val="94A3B8"/>
+                  <a:srgbClr val="475569"/>
                 </a:solidFill>
                 <a:latin typeface="Segoe UI"/>
               </a:defRPr>
@@ -9174,9 +9616,9 @@
           </a:p>
           <a:p>
             <a:pPr>
-              <a:defRPr sz="1250" b="1">
-                <a:solidFill>
-                  <a:srgbClr val="FFFFFF"/>
+              <a:defRPr sz="1200" b="1">
+                <a:solidFill>
+                  <a:srgbClr val="0F172A"/>
                 </a:solidFill>
                 <a:latin typeface="Segoe UI"/>
               </a:defRPr>
@@ -9188,11 +9630,11 @@
           <a:p>
             <a:pPr>
               <a:spcAft>
-                <a:spcPts val="1000"/>
+                <a:spcPts val="900"/>
               </a:spcAft>
               <a:defRPr sz="1050">
                 <a:solidFill>
-                  <a:srgbClr val="94A3B8"/>
+                  <a:srgbClr val="475569"/>
                 </a:solidFill>
                 <a:latin typeface="Segoe UI"/>
               </a:defRPr>
@@ -9203,9 +9645,9 @@
           </a:p>
           <a:p>
             <a:pPr>
-              <a:defRPr sz="1250" b="1">
-                <a:solidFill>
-                  <a:srgbClr val="FFFFFF"/>
+              <a:defRPr sz="1200" b="1">
+                <a:solidFill>
+                  <a:srgbClr val="0F172A"/>
                 </a:solidFill>
                 <a:latin typeface="Segoe UI"/>
               </a:defRPr>
@@ -9217,11 +9659,11 @@
           <a:p>
             <a:pPr>
               <a:spcAft>
-                <a:spcPts val="1000"/>
+                <a:spcPts val="900"/>
               </a:spcAft>
               <a:defRPr sz="1050">
                 <a:solidFill>
-                  <a:srgbClr val="94A3B8"/>
+                  <a:srgbClr val="475569"/>
                 </a:solidFill>
                 <a:latin typeface="Segoe UI"/>
               </a:defRPr>
@@ -9247,11 +9689,11 @@
             <a:avLst/>
           </a:prstGeom>
           <a:solidFill>
-            <a:srgbClr val="131A2B"/>
+            <a:srgbClr val="FFFFFF"/>
           </a:solidFill>
           <a:ln w="15240">
             <a:solidFill>
-              <a:srgbClr val="2563EB"/>
+              <a:srgbClr val="CBD5E1"/>
             </a:solidFill>
           </a:ln>
         </p:spPr>
@@ -9324,9 +9766,9 @@
           <a:lstStyle/>
           <a:p>
             <a:pPr algn="ctr">
-              <a:defRPr sz="950">
-                <a:solidFill>
-                  <a:srgbClr val="06B6D4"/>
+              <a:defRPr sz="950" b="1">
+                <a:solidFill>
+                  <a:srgbClr val="64748B"/>
                 </a:solidFill>
                 <a:latin typeface="Segoe UI"/>
               </a:defRPr>
@@ -9339,14 +9781,57 @@
       </p:sp>
       <p:sp>
         <p:nvSpPr>
-          <p:cNvPr id="9" name="TextBox 8"/>
+          <p:cNvPr id="9" name="Rectangle 8"/>
+          <p:cNvSpPr/>
+          <p:nvPr/>
+        </p:nvSpPr>
+        <p:spPr>
+          <a:xfrm>
+            <a:off x="731520" y="6217920"/>
+            <a:ext cx="10728655" cy="13716"/>
+          </a:xfrm>
+          <a:prstGeom prst="rect">
+            <a:avLst/>
+          </a:prstGeom>
+          <a:solidFill>
+            <a:srgbClr val="E2E8F0"/>
+          </a:solidFill>
+          <a:ln>
+            <a:noFill/>
+          </a:ln>
+        </p:spPr>
+        <p:style>
+          <a:lnRef idx="1">
+            <a:schemeClr val="accent1"/>
+          </a:lnRef>
+          <a:fillRef idx="3">
+            <a:schemeClr val="accent1"/>
+          </a:fillRef>
+          <a:effectRef idx="2">
+            <a:schemeClr val="accent1"/>
+          </a:effectRef>
+          <a:fontRef idx="minor">
+            <a:schemeClr val="lt1"/>
+          </a:fontRef>
+        </p:style>
+        <p:txBody>
+          <a:bodyPr rtlCol="0" anchor="ctr"/>
+          <a:lstStyle/>
+          <a:p>
+            <a:pPr algn="ctr"/>
+          </a:p>
+        </p:txBody>
+      </p:sp>
+      <p:sp>
+        <p:nvSpPr>
+          <p:cNvPr id="10" name="TextBox 9"/>
           <p:cNvSpPr txBox="1"/>
           <p:nvPr/>
         </p:nvSpPr>
         <p:spPr>
           <a:xfrm>
             <a:off x="731520" y="6309360"/>
-            <a:ext cx="10698480" cy="365760"/>
+            <a:ext cx="10698480" cy="320040"/>
           </a:xfrm>
           <a:prstGeom prst="rect">
             <a:avLst/>
@@ -9406,7 +9891,7 @@
             <a:avLst/>
           </a:prstGeom>
           <a:solidFill>
-            <a:srgbClr val="0B0F19"/>
+            <a:srgbClr val="FFFFFF"/>
           </a:solidFill>
           <a:ln>
             <a:noFill/>
@@ -9442,8 +9927,8 @@
         </p:nvSpPr>
         <p:spPr>
           <a:xfrm>
-            <a:off x="731520" y="457200"/>
-            <a:ext cx="10698480" cy="1005840"/>
+            <a:off x="731520" y="411480"/>
+            <a:ext cx="10698480" cy="1051560"/>
           </a:xfrm>
           <a:prstGeom prst="rect">
             <a:avLst/>
@@ -9460,9 +9945,9 @@
               <a:spcAft>
                 <a:spcPts val="200"/>
               </a:spcAft>
-              <a:defRPr sz="1100" b="1">
-                <a:solidFill>
-                  <a:srgbClr val="06B6D4"/>
+              <a:defRPr sz="1050" b="1">
+                <a:solidFill>
+                  <a:srgbClr val="1D4ED8"/>
                 </a:solidFill>
                 <a:latin typeface="Segoe UI"/>
               </a:defRPr>
@@ -9478,7 +9963,7 @@
               </a:spcAft>
               <a:defRPr sz="2200" b="1">
                 <a:solidFill>
-                  <a:srgbClr val="FFFFFF"/>
+                  <a:srgbClr val="0F172A"/>
                 </a:solidFill>
                 <a:latin typeface="Segoe UI"/>
               </a:defRPr>
@@ -9489,9 +9974,9 @@
           </a:p>
           <a:p>
             <a:pPr>
-              <a:defRPr sz="1200">
-                <a:solidFill>
-                  <a:srgbClr val="94A3B8"/>
+              <a:defRPr sz="1150">
+                <a:solidFill>
+                  <a:srgbClr val="475569"/>
                 </a:solidFill>
                 <a:latin typeface="Segoe UI"/>
               </a:defRPr>
@@ -9517,11 +10002,11 @@
             <a:avLst/>
           </a:prstGeom>
           <a:solidFill>
-            <a:srgbClr val="131A2B"/>
+            <a:srgbClr val="F8FAFC"/>
           </a:solidFill>
           <a:ln w="15240">
             <a:solidFill>
-              <a:srgbClr val="253352"/>
+              <a:srgbClr val="E2E8F0"/>
             </a:solidFill>
           </a:ln>
         </p:spPr>
@@ -9570,9 +10055,9 @@
           <a:lstStyle/>
           <a:p>
             <a:pPr>
-              <a:defRPr sz="1250" b="1">
-                <a:solidFill>
-                  <a:srgbClr val="06B6D4"/>
+              <a:defRPr sz="1200" b="1">
+                <a:solidFill>
+                  <a:srgbClr val="1D4ED8"/>
                 </a:solidFill>
                 <a:latin typeface="Segoe UI"/>
               </a:defRPr>
@@ -9584,11 +10069,11 @@
           <a:p>
             <a:pPr>
               <a:spcAft>
-                <a:spcPts val="1000"/>
+                <a:spcPts val="900"/>
               </a:spcAft>
               <a:defRPr sz="1050">
                 <a:solidFill>
-                  <a:srgbClr val="94A3B8"/>
+                  <a:srgbClr val="475569"/>
                 </a:solidFill>
                 <a:latin typeface="Segoe UI"/>
               </a:defRPr>
@@ -9599,9 +10084,9 @@
           </a:p>
           <a:p>
             <a:pPr>
-              <a:defRPr sz="1250" b="1">
-                <a:solidFill>
-                  <a:srgbClr val="FFFFFF"/>
+              <a:defRPr sz="1200" b="1">
+                <a:solidFill>
+                  <a:srgbClr val="0F172A"/>
                 </a:solidFill>
                 <a:latin typeface="Segoe UI"/>
               </a:defRPr>
@@ -9613,11 +10098,11 @@
           <a:p>
             <a:pPr>
               <a:spcAft>
-                <a:spcPts val="1000"/>
+                <a:spcPts val="900"/>
               </a:spcAft>
               <a:defRPr sz="1050">
                 <a:solidFill>
-                  <a:srgbClr val="94A3B8"/>
+                  <a:srgbClr val="475569"/>
                 </a:solidFill>
                 <a:latin typeface="Segoe UI"/>
               </a:defRPr>
@@ -9628,9 +10113,9 @@
           </a:p>
           <a:p>
             <a:pPr>
-              <a:defRPr sz="1250" b="1">
-                <a:solidFill>
-                  <a:srgbClr val="FFFFFF"/>
+              <a:defRPr sz="1200" b="1">
+                <a:solidFill>
+                  <a:srgbClr val="0F172A"/>
                 </a:solidFill>
                 <a:latin typeface="Segoe UI"/>
               </a:defRPr>
@@ -9642,11 +10127,11 @@
           <a:p>
             <a:pPr>
               <a:spcAft>
-                <a:spcPts val="1000"/>
+                <a:spcPts val="900"/>
               </a:spcAft>
               <a:defRPr sz="1050">
                 <a:solidFill>
-                  <a:srgbClr val="94A3B8"/>
+                  <a:srgbClr val="475569"/>
                 </a:solidFill>
                 <a:latin typeface="Segoe UI"/>
               </a:defRPr>
@@ -9657,9 +10142,9 @@
           </a:p>
           <a:p>
             <a:pPr>
-              <a:defRPr sz="1250" b="1">
-                <a:solidFill>
-                  <a:srgbClr val="FFFFFF"/>
+              <a:defRPr sz="1200" b="1">
+                <a:solidFill>
+                  <a:srgbClr val="0F172A"/>
                 </a:solidFill>
                 <a:latin typeface="Segoe UI"/>
               </a:defRPr>
@@ -9671,11 +10156,11 @@
           <a:p>
             <a:pPr>
               <a:spcAft>
-                <a:spcPts val="1000"/>
+                <a:spcPts val="900"/>
               </a:spcAft>
               <a:defRPr sz="1050">
                 <a:solidFill>
-                  <a:srgbClr val="94A3B8"/>
+                  <a:srgbClr val="475569"/>
                 </a:solidFill>
                 <a:latin typeface="Segoe UI"/>
               </a:defRPr>
@@ -9701,11 +10186,11 @@
             <a:avLst/>
           </a:prstGeom>
           <a:solidFill>
-            <a:srgbClr val="131A2B"/>
+            <a:srgbClr val="FFFFFF"/>
           </a:solidFill>
           <a:ln w="15240">
             <a:solidFill>
-              <a:srgbClr val="2563EB"/>
+              <a:srgbClr val="CBD5E1"/>
             </a:solidFill>
           </a:ln>
         </p:spPr>
@@ -9778,9 +10263,9 @@
           <a:lstStyle/>
           <a:p>
             <a:pPr algn="ctr">
-              <a:defRPr sz="950">
-                <a:solidFill>
-                  <a:srgbClr val="06B6D4"/>
+              <a:defRPr sz="950" b="1">
+                <a:solidFill>
+                  <a:srgbClr val="64748B"/>
                 </a:solidFill>
                 <a:latin typeface="Segoe UI"/>
               </a:defRPr>
@@ -9793,14 +10278,57 @@
       </p:sp>
       <p:sp>
         <p:nvSpPr>
-          <p:cNvPr id="9" name="TextBox 8"/>
+          <p:cNvPr id="9" name="Rectangle 8"/>
+          <p:cNvSpPr/>
+          <p:nvPr/>
+        </p:nvSpPr>
+        <p:spPr>
+          <a:xfrm>
+            <a:off x="731520" y="6217920"/>
+            <a:ext cx="10728655" cy="13716"/>
+          </a:xfrm>
+          <a:prstGeom prst="rect">
+            <a:avLst/>
+          </a:prstGeom>
+          <a:solidFill>
+            <a:srgbClr val="E2E8F0"/>
+          </a:solidFill>
+          <a:ln>
+            <a:noFill/>
+          </a:ln>
+        </p:spPr>
+        <p:style>
+          <a:lnRef idx="1">
+            <a:schemeClr val="accent1"/>
+          </a:lnRef>
+          <a:fillRef idx="3">
+            <a:schemeClr val="accent1"/>
+          </a:fillRef>
+          <a:effectRef idx="2">
+            <a:schemeClr val="accent1"/>
+          </a:effectRef>
+          <a:fontRef idx="minor">
+            <a:schemeClr val="lt1"/>
+          </a:fontRef>
+        </p:style>
+        <p:txBody>
+          <a:bodyPr rtlCol="0" anchor="ctr"/>
+          <a:lstStyle/>
+          <a:p>
+            <a:pPr algn="ctr"/>
+          </a:p>
+        </p:txBody>
+      </p:sp>
+      <p:sp>
+        <p:nvSpPr>
+          <p:cNvPr id="10" name="TextBox 9"/>
           <p:cNvSpPr txBox="1"/>
           <p:nvPr/>
         </p:nvSpPr>
         <p:spPr>
           <a:xfrm>
             <a:off x="731520" y="6309360"/>
-            <a:ext cx="10698480" cy="365760"/>
+            <a:ext cx="10698480" cy="320040"/>
           </a:xfrm>
           <a:prstGeom prst="rect">
             <a:avLst/>
@@ -9860,7 +10388,7 @@
             <a:avLst/>
           </a:prstGeom>
           <a:solidFill>
-            <a:srgbClr val="0B0F19"/>
+            <a:srgbClr val="FFFFFF"/>
           </a:solidFill>
           <a:ln>
             <a:noFill/>
@@ -9896,8 +10424,8 @@
         </p:nvSpPr>
         <p:spPr>
           <a:xfrm>
-            <a:off x="731520" y="457200"/>
-            <a:ext cx="10698480" cy="1005840"/>
+            <a:off x="731520" y="411480"/>
+            <a:ext cx="10698480" cy="1051560"/>
           </a:xfrm>
           <a:prstGeom prst="rect">
             <a:avLst/>
@@ -9914,9 +10442,9 @@
               <a:spcAft>
                 <a:spcPts val="200"/>
               </a:spcAft>
-              <a:defRPr sz="1100" b="1">
-                <a:solidFill>
-                  <a:srgbClr val="06B6D4"/>
+              <a:defRPr sz="1050" b="1">
+                <a:solidFill>
+                  <a:srgbClr val="1D4ED8"/>
                 </a:solidFill>
                 <a:latin typeface="Segoe UI"/>
               </a:defRPr>
@@ -9932,7 +10460,7 @@
               </a:spcAft>
               <a:defRPr sz="2200" b="1">
                 <a:solidFill>
-                  <a:srgbClr val="FFFFFF"/>
+                  <a:srgbClr val="0F172A"/>
                 </a:solidFill>
                 <a:latin typeface="Segoe UI"/>
               </a:defRPr>
@@ -9943,9 +10471,9 @@
           </a:p>
           <a:p>
             <a:pPr>
-              <a:defRPr sz="1200">
-                <a:solidFill>
-                  <a:srgbClr val="94A3B8"/>
+              <a:defRPr sz="1150">
+                <a:solidFill>
+                  <a:srgbClr val="475569"/>
                 </a:solidFill>
                 <a:latin typeface="Segoe UI"/>
               </a:defRPr>
@@ -9971,11 +10499,11 @@
             <a:avLst/>
           </a:prstGeom>
           <a:solidFill>
-            <a:srgbClr val="131A2B"/>
+            <a:srgbClr val="F8FAFC"/>
           </a:solidFill>
           <a:ln w="15240">
             <a:solidFill>
-              <a:srgbClr val="253352"/>
+              <a:srgbClr val="E2E8F0"/>
             </a:solidFill>
           </a:ln>
         </p:spPr>
@@ -10024,9 +10552,9 @@
           <a:lstStyle/>
           <a:p>
             <a:pPr>
-              <a:defRPr sz="1250" b="1">
-                <a:solidFill>
-                  <a:srgbClr val="06B6D4"/>
+              <a:defRPr sz="1200" b="1">
+                <a:solidFill>
+                  <a:srgbClr val="1D4ED8"/>
                 </a:solidFill>
                 <a:latin typeface="Segoe UI"/>
               </a:defRPr>
@@ -10038,11 +10566,11 @@
           <a:p>
             <a:pPr>
               <a:spcAft>
-                <a:spcPts val="1000"/>
+                <a:spcPts val="900"/>
               </a:spcAft>
               <a:defRPr sz="1050">
                 <a:solidFill>
-                  <a:srgbClr val="94A3B8"/>
+                  <a:srgbClr val="475569"/>
                 </a:solidFill>
                 <a:latin typeface="Segoe UI"/>
               </a:defRPr>
@@ -10053,9 +10581,9 @@
           </a:p>
           <a:p>
             <a:pPr>
-              <a:defRPr sz="1250" b="1">
-                <a:solidFill>
-                  <a:srgbClr val="FFFFFF"/>
+              <a:defRPr sz="1200" b="1">
+                <a:solidFill>
+                  <a:srgbClr val="0F172A"/>
                 </a:solidFill>
                 <a:latin typeface="Segoe UI"/>
               </a:defRPr>
@@ -10067,11 +10595,11 @@
           <a:p>
             <a:pPr>
               <a:spcAft>
-                <a:spcPts val="1000"/>
+                <a:spcPts val="900"/>
               </a:spcAft>
               <a:defRPr sz="1050">
                 <a:solidFill>
-                  <a:srgbClr val="94A3B8"/>
+                  <a:srgbClr val="475569"/>
                 </a:solidFill>
                 <a:latin typeface="Segoe UI"/>
               </a:defRPr>
@@ -10082,9 +10610,9 @@
           </a:p>
           <a:p>
             <a:pPr>
-              <a:defRPr sz="1250" b="1">
-                <a:solidFill>
-                  <a:srgbClr val="FFFFFF"/>
+              <a:defRPr sz="1200" b="1">
+                <a:solidFill>
+                  <a:srgbClr val="0F172A"/>
                 </a:solidFill>
                 <a:latin typeface="Segoe UI"/>
               </a:defRPr>
@@ -10096,11 +10624,11 @@
           <a:p>
             <a:pPr>
               <a:spcAft>
-                <a:spcPts val="1000"/>
+                <a:spcPts val="900"/>
               </a:spcAft>
               <a:defRPr sz="1050">
                 <a:solidFill>
-                  <a:srgbClr val="94A3B8"/>
+                  <a:srgbClr val="475569"/>
                 </a:solidFill>
                 <a:latin typeface="Segoe UI"/>
               </a:defRPr>
@@ -10111,9 +10639,9 @@
           </a:p>
           <a:p>
             <a:pPr>
-              <a:defRPr sz="1250" b="1">
-                <a:solidFill>
-                  <a:srgbClr val="FFFFFF"/>
+              <a:defRPr sz="1200" b="1">
+                <a:solidFill>
+                  <a:srgbClr val="0F172A"/>
                 </a:solidFill>
                 <a:latin typeface="Segoe UI"/>
               </a:defRPr>
@@ -10125,11 +10653,11 @@
           <a:p>
             <a:pPr>
               <a:spcAft>
-                <a:spcPts val="1000"/>
+                <a:spcPts val="900"/>
               </a:spcAft>
               <a:defRPr sz="1050">
                 <a:solidFill>
-                  <a:srgbClr val="94A3B8"/>
+                  <a:srgbClr val="475569"/>
                 </a:solidFill>
                 <a:latin typeface="Segoe UI"/>
               </a:defRPr>
@@ -10155,11 +10683,11 @@
             <a:avLst/>
           </a:prstGeom>
           <a:solidFill>
-            <a:srgbClr val="131A2B"/>
+            <a:srgbClr val="FFFFFF"/>
           </a:solidFill>
           <a:ln w="15240">
             <a:solidFill>
-              <a:srgbClr val="2563EB"/>
+              <a:srgbClr val="CBD5E1"/>
             </a:solidFill>
           </a:ln>
         </p:spPr>
@@ -10232,9 +10760,9 @@
           <a:lstStyle/>
           <a:p>
             <a:pPr algn="ctr">
-              <a:defRPr sz="950">
-                <a:solidFill>
-                  <a:srgbClr val="06B6D4"/>
+              <a:defRPr sz="950" b="1">
+                <a:solidFill>
+                  <a:srgbClr val="64748B"/>
                 </a:solidFill>
                 <a:latin typeface="Segoe UI"/>
               </a:defRPr>
@@ -10247,14 +10775,57 @@
       </p:sp>
       <p:sp>
         <p:nvSpPr>
-          <p:cNvPr id="9" name="TextBox 8"/>
+          <p:cNvPr id="9" name="Rectangle 8"/>
+          <p:cNvSpPr/>
+          <p:nvPr/>
+        </p:nvSpPr>
+        <p:spPr>
+          <a:xfrm>
+            <a:off x="731520" y="6217920"/>
+            <a:ext cx="10728655" cy="13716"/>
+          </a:xfrm>
+          <a:prstGeom prst="rect">
+            <a:avLst/>
+          </a:prstGeom>
+          <a:solidFill>
+            <a:srgbClr val="E2E8F0"/>
+          </a:solidFill>
+          <a:ln>
+            <a:noFill/>
+          </a:ln>
+        </p:spPr>
+        <p:style>
+          <a:lnRef idx="1">
+            <a:schemeClr val="accent1"/>
+          </a:lnRef>
+          <a:fillRef idx="3">
+            <a:schemeClr val="accent1"/>
+          </a:fillRef>
+          <a:effectRef idx="2">
+            <a:schemeClr val="accent1"/>
+          </a:effectRef>
+          <a:fontRef idx="minor">
+            <a:schemeClr val="lt1"/>
+          </a:fontRef>
+        </p:style>
+        <p:txBody>
+          <a:bodyPr rtlCol="0" anchor="ctr"/>
+          <a:lstStyle/>
+          <a:p>
+            <a:pPr algn="ctr"/>
+          </a:p>
+        </p:txBody>
+      </p:sp>
+      <p:sp>
+        <p:nvSpPr>
+          <p:cNvPr id="10" name="TextBox 9"/>
           <p:cNvSpPr txBox="1"/>
           <p:nvPr/>
         </p:nvSpPr>
         <p:spPr>
           <a:xfrm>
             <a:off x="731520" y="6309360"/>
-            <a:ext cx="10698480" cy="365760"/>
+            <a:ext cx="10698480" cy="320040"/>
           </a:xfrm>
           <a:prstGeom prst="rect">
             <a:avLst/>
@@ -10314,7 +10885,7 @@
             <a:avLst/>
           </a:prstGeom>
           <a:solidFill>
-            <a:srgbClr val="0B0F19"/>
+            <a:srgbClr val="FFFFFF"/>
           </a:solidFill>
           <a:ln>
             <a:noFill/>
@@ -10350,8 +10921,8 @@
         </p:nvSpPr>
         <p:spPr>
           <a:xfrm>
-            <a:off x="731520" y="457200"/>
-            <a:ext cx="10698480" cy="1005840"/>
+            <a:off x="731520" y="411480"/>
+            <a:ext cx="10698480" cy="1051560"/>
           </a:xfrm>
           <a:prstGeom prst="rect">
             <a:avLst/>
@@ -10368,9 +10939,9 @@
               <a:spcAft>
                 <a:spcPts val="200"/>
               </a:spcAft>
-              <a:defRPr sz="1100" b="1">
-                <a:solidFill>
-                  <a:srgbClr val="06B6D4"/>
+              <a:defRPr sz="1050" b="1">
+                <a:solidFill>
+                  <a:srgbClr val="1D4ED8"/>
                 </a:solidFill>
                 <a:latin typeface="Segoe UI"/>
               </a:defRPr>
@@ -10386,7 +10957,7 @@
               </a:spcAft>
               <a:defRPr sz="2200" b="1">
                 <a:solidFill>
-                  <a:srgbClr val="FFFFFF"/>
+                  <a:srgbClr val="0F172A"/>
                 </a:solidFill>
                 <a:latin typeface="Segoe UI"/>
               </a:defRPr>
@@ -10397,9 +10968,9 @@
           </a:p>
           <a:p>
             <a:pPr>
-              <a:defRPr sz="1200">
-                <a:solidFill>
-                  <a:srgbClr val="94A3B8"/>
+              <a:defRPr sz="1150">
+                <a:solidFill>
+                  <a:srgbClr val="475569"/>
                 </a:solidFill>
                 <a:latin typeface="Segoe UI"/>
               </a:defRPr>
@@ -10425,11 +10996,11 @@
             <a:avLst/>
           </a:prstGeom>
           <a:solidFill>
-            <a:srgbClr val="131A2B"/>
+            <a:srgbClr val="F8FAFC"/>
           </a:solidFill>
           <a:ln w="15240">
             <a:solidFill>
-              <a:srgbClr val="253352"/>
+              <a:srgbClr val="E2E8F0"/>
             </a:solidFill>
           </a:ln>
         </p:spPr>
@@ -10478,9 +11049,9 @@
           <a:lstStyle/>
           <a:p>
             <a:pPr>
-              <a:defRPr sz="1250" b="1">
-                <a:solidFill>
-                  <a:srgbClr val="06B6D4"/>
+              <a:defRPr sz="1200" b="1">
+                <a:solidFill>
+                  <a:srgbClr val="1D4ED8"/>
                 </a:solidFill>
                 <a:latin typeface="Segoe UI"/>
               </a:defRPr>
@@ -10492,11 +11063,11 @@
           <a:p>
             <a:pPr>
               <a:spcAft>
-                <a:spcPts val="1000"/>
+                <a:spcPts val="900"/>
               </a:spcAft>
               <a:defRPr sz="1050">
                 <a:solidFill>
-                  <a:srgbClr val="94A3B8"/>
+                  <a:srgbClr val="475569"/>
                 </a:solidFill>
                 <a:latin typeface="Segoe UI"/>
               </a:defRPr>
@@ -10507,9 +11078,9 @@
           </a:p>
           <a:p>
             <a:pPr>
-              <a:defRPr sz="1250" b="1">
-                <a:solidFill>
-                  <a:srgbClr val="FFFFFF"/>
+              <a:defRPr sz="1200" b="1">
+                <a:solidFill>
+                  <a:srgbClr val="0F172A"/>
                 </a:solidFill>
                 <a:latin typeface="Segoe UI"/>
               </a:defRPr>
@@ -10521,11 +11092,11 @@
           <a:p>
             <a:pPr>
               <a:spcAft>
-                <a:spcPts val="1000"/>
+                <a:spcPts val="900"/>
               </a:spcAft>
               <a:defRPr sz="1050">
                 <a:solidFill>
-                  <a:srgbClr val="94A3B8"/>
+                  <a:srgbClr val="475569"/>
                 </a:solidFill>
                 <a:latin typeface="Segoe UI"/>
               </a:defRPr>
@@ -10536,9 +11107,9 @@
           </a:p>
           <a:p>
             <a:pPr>
-              <a:defRPr sz="1250" b="1">
-                <a:solidFill>
-                  <a:srgbClr val="FFFFFF"/>
+              <a:defRPr sz="1200" b="1">
+                <a:solidFill>
+                  <a:srgbClr val="0F172A"/>
                 </a:solidFill>
                 <a:latin typeface="Segoe UI"/>
               </a:defRPr>
@@ -10550,11 +11121,11 @@
           <a:p>
             <a:pPr>
               <a:spcAft>
-                <a:spcPts val="1000"/>
+                <a:spcPts val="900"/>
               </a:spcAft>
               <a:defRPr sz="1050">
                 <a:solidFill>
-                  <a:srgbClr val="94A3B8"/>
+                  <a:srgbClr val="475569"/>
                 </a:solidFill>
                 <a:latin typeface="Segoe UI"/>
               </a:defRPr>
@@ -10565,9 +11136,9 @@
           </a:p>
           <a:p>
             <a:pPr>
-              <a:defRPr sz="1250" b="1">
-                <a:solidFill>
-                  <a:srgbClr val="FFFFFF"/>
+              <a:defRPr sz="1200" b="1">
+                <a:solidFill>
+                  <a:srgbClr val="0F172A"/>
                 </a:solidFill>
                 <a:latin typeface="Segoe UI"/>
               </a:defRPr>
@@ -10579,11 +11150,11 @@
           <a:p>
             <a:pPr>
               <a:spcAft>
-                <a:spcPts val="1000"/>
+                <a:spcPts val="900"/>
               </a:spcAft>
               <a:defRPr sz="1050">
                 <a:solidFill>
-                  <a:srgbClr val="94A3B8"/>
+                  <a:srgbClr val="475569"/>
                 </a:solidFill>
                 <a:latin typeface="Segoe UI"/>
               </a:defRPr>
@@ -10609,11 +11180,11 @@
             <a:avLst/>
           </a:prstGeom>
           <a:solidFill>
-            <a:srgbClr val="131A2B"/>
+            <a:srgbClr val="FFFFFF"/>
           </a:solidFill>
           <a:ln w="15240">
             <a:solidFill>
-              <a:srgbClr val="2563EB"/>
+              <a:srgbClr val="CBD5E1"/>
             </a:solidFill>
           </a:ln>
         </p:spPr>
@@ -10686,9 +11257,9 @@
           <a:lstStyle/>
           <a:p>
             <a:pPr algn="ctr">
-              <a:defRPr sz="950">
-                <a:solidFill>
-                  <a:srgbClr val="06B6D4"/>
+              <a:defRPr sz="950" b="1">
+                <a:solidFill>
+                  <a:srgbClr val="64748B"/>
                 </a:solidFill>
                 <a:latin typeface="Segoe UI"/>
               </a:defRPr>
@@ -10701,14 +11272,57 @@
       </p:sp>
       <p:sp>
         <p:nvSpPr>
-          <p:cNvPr id="9" name="TextBox 8"/>
+          <p:cNvPr id="9" name="Rectangle 8"/>
+          <p:cNvSpPr/>
+          <p:nvPr/>
+        </p:nvSpPr>
+        <p:spPr>
+          <a:xfrm>
+            <a:off x="731520" y="6217920"/>
+            <a:ext cx="10728655" cy="13716"/>
+          </a:xfrm>
+          <a:prstGeom prst="rect">
+            <a:avLst/>
+          </a:prstGeom>
+          <a:solidFill>
+            <a:srgbClr val="E2E8F0"/>
+          </a:solidFill>
+          <a:ln>
+            <a:noFill/>
+          </a:ln>
+        </p:spPr>
+        <p:style>
+          <a:lnRef idx="1">
+            <a:schemeClr val="accent1"/>
+          </a:lnRef>
+          <a:fillRef idx="3">
+            <a:schemeClr val="accent1"/>
+          </a:fillRef>
+          <a:effectRef idx="2">
+            <a:schemeClr val="accent1"/>
+          </a:effectRef>
+          <a:fontRef idx="minor">
+            <a:schemeClr val="lt1"/>
+          </a:fontRef>
+        </p:style>
+        <p:txBody>
+          <a:bodyPr rtlCol="0" anchor="ctr"/>
+          <a:lstStyle/>
+          <a:p>
+            <a:pPr algn="ctr"/>
+          </a:p>
+        </p:txBody>
+      </p:sp>
+      <p:sp>
+        <p:nvSpPr>
+          <p:cNvPr id="10" name="TextBox 9"/>
           <p:cNvSpPr txBox="1"/>
           <p:nvPr/>
         </p:nvSpPr>
         <p:spPr>
           <a:xfrm>
             <a:off x="731520" y="6309360"/>
-            <a:ext cx="10698480" cy="365760"/>
+            <a:ext cx="10698480" cy="320040"/>
           </a:xfrm>
           <a:prstGeom prst="rect">
             <a:avLst/>

</xml_diff>

<commit_message>
docs: polish deck widgets with comfortable margins, centered screenshots, and white theme
</commit_message>
<xml_diff>
--- a/Telephone_Bill_Management_System_Team07.pptx
+++ b/Telephone_Bill_Management_System_Team07.pptx
@@ -3419,8 +3419,8 @@
         </p:nvSpPr>
         <p:spPr>
           <a:xfrm>
-            <a:off x="7772400" y="731520"/>
-            <a:ext cx="3657600" cy="5212080"/>
+            <a:off x="7589520" y="685800"/>
+            <a:ext cx="3840480" cy="5257800"/>
           </a:xfrm>
           <a:prstGeom prst="roundRect">
             <a:avLst/>
@@ -3464,8 +3464,8 @@
         </p:nvSpPr>
         <p:spPr>
           <a:xfrm>
-            <a:off x="8046720" y="960120"/>
-            <a:ext cx="3108960" cy="4754880"/>
+            <a:off x="7818120" y="868680"/>
+            <a:ext cx="3383280" cy="822960"/>
           </a:xfrm>
           <a:prstGeom prst="rect">
             <a:avLst/>
@@ -3473,16 +3473,13 @@
           <a:noFill/>
         </p:spPr>
         <p:txBody>
-          <a:bodyPr wrap="square">
+          <a:bodyPr wrap="square" lIns="0" tIns="0" rIns="0" bIns="0">
             <a:spAutoFit/>
           </a:bodyPr>
           <a:lstStyle/>
           <a:p>
             <a:pPr>
-              <a:spcAft>
-                <a:spcPts val="200"/>
-              </a:spcAft>
-              <a:defRPr sz="1600" b="1">
+              <a:defRPr sz="1500" b="1">
                 <a:solidFill>
                   <a:srgbClr val="1D4ED8"/>
                 </a:solidFill>
@@ -3496,9 +3493,9 @@
           <a:p>
             <a:pPr>
               <a:spcAft>
-                <a:spcPts val="1600"/>
-              </a:spcAft>
-              <a:defRPr sz="1050">
+                <a:spcPts val="400"/>
+              </a:spcAft>
+              <a:defRPr sz="950">
                 <a:solidFill>
                   <a:srgbClr val="64748B"/>
                 </a:solidFill>
@@ -3511,10 +3508,7 @@
           </a:p>
           <a:p>
             <a:pPr>
-              <a:spcAft>
-                <a:spcPts val="1200"/>
-              </a:spcAft>
-              <a:defRPr sz="1350" b="1">
+              <a:defRPr sz="1200" b="1">
                 <a:solidFill>
                   <a:srgbClr val="0F172A"/>
                 </a:solidFill>
@@ -3525,91 +3519,1031 @@
               <a:t>Presented by:</a:t>
             </a:r>
           </a:p>
-          <a:p>
-            <a:pPr>
-              <a:spcAft>
-                <a:spcPts val="1000"/>
-              </a:spcAft>
+        </p:txBody>
+      </p:sp>
+      <p:sp>
+        <p:nvSpPr>
+          <p:cNvPr id="10" name="Rounded Rectangle 9"/>
+          <p:cNvSpPr/>
+          <p:nvPr/>
+        </p:nvSpPr>
+        <p:spPr>
+          <a:xfrm>
+            <a:off x="7818120" y="1874519"/>
+            <a:ext cx="3383280" cy="621792"/>
+          </a:xfrm>
+          <a:prstGeom prst="roundRect">
+            <a:avLst/>
+          </a:prstGeom>
+          <a:solidFill>
+            <a:srgbClr val="FFFFFF"/>
+          </a:solidFill>
+          <a:ln w="15240">
+            <a:solidFill>
+              <a:srgbClr val="E2E8F0"/>
+            </a:solidFill>
+          </a:ln>
+        </p:spPr>
+        <p:style>
+          <a:lnRef idx="1">
+            <a:schemeClr val="accent1"/>
+          </a:lnRef>
+          <a:fillRef idx="3">
+            <a:schemeClr val="accent1"/>
+          </a:fillRef>
+          <a:effectRef idx="2">
+            <a:schemeClr val="accent1"/>
+          </a:effectRef>
+          <a:fontRef idx="minor">
+            <a:schemeClr val="lt1"/>
+          </a:fontRef>
+        </p:style>
+        <p:txBody>
+          <a:bodyPr rtlCol="0" anchor="ctr"/>
+          <a:lstStyle/>
+          <a:p>
+            <a:pPr algn="ctr"/>
+          </a:p>
+        </p:txBody>
+      </p:sp>
+      <p:sp>
+        <p:nvSpPr>
+          <p:cNvPr id="11" name="Oval 10"/>
+          <p:cNvSpPr/>
+          <p:nvPr/>
+        </p:nvSpPr>
+        <p:spPr>
+          <a:xfrm>
+            <a:off x="7955279" y="2002535"/>
+            <a:ext cx="365760" cy="365760"/>
+          </a:xfrm>
+          <a:prstGeom prst="ellipse">
+            <a:avLst/>
+          </a:prstGeom>
+          <a:solidFill>
+            <a:srgbClr val="EFF6FF"/>
+          </a:solidFill>
+          <a:ln w="12700">
+            <a:solidFill>
+              <a:srgbClr val="BFDBFE"/>
+            </a:solidFill>
+          </a:ln>
+        </p:spPr>
+        <p:style>
+          <a:lnRef idx="1">
+            <a:schemeClr val="accent1"/>
+          </a:lnRef>
+          <a:fillRef idx="3">
+            <a:schemeClr val="accent1"/>
+          </a:fillRef>
+          <a:effectRef idx="2">
+            <a:schemeClr val="accent1"/>
+          </a:effectRef>
+          <a:fontRef idx="minor">
+            <a:schemeClr val="lt1"/>
+          </a:fontRef>
+        </p:style>
+        <p:txBody>
+          <a:bodyPr rtlCol="0" anchor="ctr"/>
+          <a:lstStyle/>
+          <a:p>
+            <a:pPr algn="ctr">
+              <a:defRPr sz="950" b="1">
+                <a:solidFill>
+                  <a:srgbClr val="1D4ED8"/>
+                </a:solidFill>
+                <a:latin typeface="Segoe UI"/>
+              </a:defRPr>
+            </a:pPr>
+            <a:r>
+              <a:t>01</a:t>
+            </a:r>
+          </a:p>
+        </p:txBody>
+      </p:sp>
+      <p:sp>
+        <p:nvSpPr>
+          <p:cNvPr id="12" name="TextBox 11"/>
+          <p:cNvSpPr txBox="1"/>
+          <p:nvPr/>
+        </p:nvSpPr>
+        <p:spPr>
+          <a:xfrm>
+            <a:off x="8412480" y="1947671"/>
+            <a:ext cx="1645920" cy="475488"/>
+          </a:xfrm>
+          <a:prstGeom prst="rect">
+            <a:avLst/>
+          </a:prstGeom>
+          <a:noFill/>
+        </p:spPr>
+        <p:txBody>
+          <a:bodyPr wrap="square" lIns="0" tIns="0" rIns="0" bIns="0">
+            <a:spAutoFit/>
+          </a:bodyPr>
+          <a:lstStyle/>
+          <a:p>
+            <a:pPr>
               <a:defRPr sz="1200" b="1">
                 <a:solidFill>
-                  <a:srgbClr val="334155"/>
-                </a:solidFill>
-                <a:latin typeface="Segoe UI"/>
-              </a:defRPr>
-            </a:pPr>
-            <a:r>
-              <a:t>•  M. Akshitha  (24241-CS-033)</a:t>
-            </a:r>
-          </a:p>
-          <a:p>
-            <a:pPr>
-              <a:spcAft>
-                <a:spcPts val="1000"/>
-              </a:spcAft>
+                  <a:srgbClr val="0F172A"/>
+                </a:solidFill>
+                <a:latin typeface="Segoe UI"/>
+              </a:defRPr>
+            </a:pPr>
+            <a:r>
+              <a:t>M. Akshitha</a:t>
+            </a:r>
+          </a:p>
+          <a:p>
+            <a:pPr>
+              <a:defRPr sz="850">
+                <a:solidFill>
+                  <a:srgbClr val="64748B"/>
+                </a:solidFill>
+                <a:latin typeface="Segoe UI"/>
+              </a:defRPr>
+            </a:pPr>
+            <a:r>
+              <a:t>B.Tech CSE</a:t>
+            </a:r>
+          </a:p>
+        </p:txBody>
+      </p:sp>
+      <p:sp>
+        <p:nvSpPr>
+          <p:cNvPr id="13" name="Rounded Rectangle 12"/>
+          <p:cNvSpPr/>
+          <p:nvPr/>
+        </p:nvSpPr>
+        <p:spPr>
+          <a:xfrm>
+            <a:off x="9966960" y="2020823"/>
+            <a:ext cx="1143000" cy="329184"/>
+          </a:xfrm>
+          <a:prstGeom prst="roundRect">
+            <a:avLst/>
+          </a:prstGeom>
+          <a:solidFill>
+            <a:srgbClr val="F8FAFC"/>
+          </a:solidFill>
+          <a:ln w="12700">
+            <a:solidFill>
+              <a:srgbClr val="BFDBFE"/>
+            </a:solidFill>
+          </a:ln>
+        </p:spPr>
+        <p:style>
+          <a:lnRef idx="1">
+            <a:schemeClr val="accent1"/>
+          </a:lnRef>
+          <a:fillRef idx="3">
+            <a:schemeClr val="accent1"/>
+          </a:fillRef>
+          <a:effectRef idx="2">
+            <a:schemeClr val="accent1"/>
+          </a:effectRef>
+          <a:fontRef idx="minor">
+            <a:schemeClr val="lt1"/>
+          </a:fontRef>
+        </p:style>
+        <p:txBody>
+          <a:bodyPr rtlCol="0" anchor="ctr"/>
+          <a:lstStyle/>
+          <a:p>
+            <a:pPr algn="ctr">
+              <a:defRPr sz="850" b="1">
+                <a:solidFill>
+                  <a:srgbClr val="1D4ED8"/>
+                </a:solidFill>
+                <a:latin typeface="Consolas"/>
+              </a:defRPr>
+            </a:pPr>
+            <a:r>
+              <a:t>24241-CS-033</a:t>
+            </a:r>
+          </a:p>
+        </p:txBody>
+      </p:sp>
+      <p:sp>
+        <p:nvSpPr>
+          <p:cNvPr id="14" name="Rounded Rectangle 13"/>
+          <p:cNvSpPr/>
+          <p:nvPr/>
+        </p:nvSpPr>
+        <p:spPr>
+          <a:xfrm>
+            <a:off x="7818120" y="2606039"/>
+            <a:ext cx="3383280" cy="621792"/>
+          </a:xfrm>
+          <a:prstGeom prst="roundRect">
+            <a:avLst/>
+          </a:prstGeom>
+          <a:solidFill>
+            <a:srgbClr val="FFFFFF"/>
+          </a:solidFill>
+          <a:ln w="15240">
+            <a:solidFill>
+              <a:srgbClr val="E2E8F0"/>
+            </a:solidFill>
+          </a:ln>
+        </p:spPr>
+        <p:style>
+          <a:lnRef idx="1">
+            <a:schemeClr val="accent1"/>
+          </a:lnRef>
+          <a:fillRef idx="3">
+            <a:schemeClr val="accent1"/>
+          </a:fillRef>
+          <a:effectRef idx="2">
+            <a:schemeClr val="accent1"/>
+          </a:effectRef>
+          <a:fontRef idx="minor">
+            <a:schemeClr val="lt1"/>
+          </a:fontRef>
+        </p:style>
+        <p:txBody>
+          <a:bodyPr rtlCol="0" anchor="ctr"/>
+          <a:lstStyle/>
+          <a:p>
+            <a:pPr algn="ctr"/>
+          </a:p>
+        </p:txBody>
+      </p:sp>
+      <p:sp>
+        <p:nvSpPr>
+          <p:cNvPr id="15" name="Oval 14"/>
+          <p:cNvSpPr/>
+          <p:nvPr/>
+        </p:nvSpPr>
+        <p:spPr>
+          <a:xfrm>
+            <a:off x="7955279" y="2734055"/>
+            <a:ext cx="365760" cy="365760"/>
+          </a:xfrm>
+          <a:prstGeom prst="ellipse">
+            <a:avLst/>
+          </a:prstGeom>
+          <a:solidFill>
+            <a:srgbClr val="EFF6FF"/>
+          </a:solidFill>
+          <a:ln w="12700">
+            <a:solidFill>
+              <a:srgbClr val="BFDBFE"/>
+            </a:solidFill>
+          </a:ln>
+        </p:spPr>
+        <p:style>
+          <a:lnRef idx="1">
+            <a:schemeClr val="accent1"/>
+          </a:lnRef>
+          <a:fillRef idx="3">
+            <a:schemeClr val="accent1"/>
+          </a:fillRef>
+          <a:effectRef idx="2">
+            <a:schemeClr val="accent1"/>
+          </a:effectRef>
+          <a:fontRef idx="minor">
+            <a:schemeClr val="lt1"/>
+          </a:fontRef>
+        </p:style>
+        <p:txBody>
+          <a:bodyPr rtlCol="0" anchor="ctr"/>
+          <a:lstStyle/>
+          <a:p>
+            <a:pPr algn="ctr">
+              <a:defRPr sz="950" b="1">
+                <a:solidFill>
+                  <a:srgbClr val="1D4ED8"/>
+                </a:solidFill>
+                <a:latin typeface="Segoe UI"/>
+              </a:defRPr>
+            </a:pPr>
+            <a:r>
+              <a:t>02</a:t>
+            </a:r>
+          </a:p>
+        </p:txBody>
+      </p:sp>
+      <p:sp>
+        <p:nvSpPr>
+          <p:cNvPr id="16" name="TextBox 15"/>
+          <p:cNvSpPr txBox="1"/>
+          <p:nvPr/>
+        </p:nvSpPr>
+        <p:spPr>
+          <a:xfrm>
+            <a:off x="8412480" y="2679191"/>
+            <a:ext cx="1645920" cy="475488"/>
+          </a:xfrm>
+          <a:prstGeom prst="rect">
+            <a:avLst/>
+          </a:prstGeom>
+          <a:noFill/>
+        </p:spPr>
+        <p:txBody>
+          <a:bodyPr wrap="square" lIns="0" tIns="0" rIns="0" bIns="0">
+            <a:spAutoFit/>
+          </a:bodyPr>
+          <a:lstStyle/>
+          <a:p>
+            <a:pPr>
               <a:defRPr sz="1200" b="1">
                 <a:solidFill>
-                  <a:srgbClr val="334155"/>
-                </a:solidFill>
-                <a:latin typeface="Segoe UI"/>
-              </a:defRPr>
-            </a:pPr>
-            <a:r>
-              <a:t>•  G. Ashlesh  (24241-CS-034)</a:t>
-            </a:r>
-          </a:p>
-          <a:p>
-            <a:pPr>
-              <a:spcAft>
-                <a:spcPts val="1000"/>
-              </a:spcAft>
+                  <a:srgbClr val="0F172A"/>
+                </a:solidFill>
+                <a:latin typeface="Segoe UI"/>
+              </a:defRPr>
+            </a:pPr>
+            <a:r>
+              <a:t>G. Ashlesh</a:t>
+            </a:r>
+          </a:p>
+          <a:p>
+            <a:pPr>
+              <a:defRPr sz="850">
+                <a:solidFill>
+                  <a:srgbClr val="64748B"/>
+                </a:solidFill>
+                <a:latin typeface="Segoe UI"/>
+              </a:defRPr>
+            </a:pPr>
+            <a:r>
+              <a:t>B.Tech CSE</a:t>
+            </a:r>
+          </a:p>
+        </p:txBody>
+      </p:sp>
+      <p:sp>
+        <p:nvSpPr>
+          <p:cNvPr id="17" name="Rounded Rectangle 16"/>
+          <p:cNvSpPr/>
+          <p:nvPr/>
+        </p:nvSpPr>
+        <p:spPr>
+          <a:xfrm>
+            <a:off x="9966960" y="2752343"/>
+            <a:ext cx="1143000" cy="329184"/>
+          </a:xfrm>
+          <a:prstGeom prst="roundRect">
+            <a:avLst/>
+          </a:prstGeom>
+          <a:solidFill>
+            <a:srgbClr val="F8FAFC"/>
+          </a:solidFill>
+          <a:ln w="12700">
+            <a:solidFill>
+              <a:srgbClr val="BFDBFE"/>
+            </a:solidFill>
+          </a:ln>
+        </p:spPr>
+        <p:style>
+          <a:lnRef idx="1">
+            <a:schemeClr val="accent1"/>
+          </a:lnRef>
+          <a:fillRef idx="3">
+            <a:schemeClr val="accent1"/>
+          </a:fillRef>
+          <a:effectRef idx="2">
+            <a:schemeClr val="accent1"/>
+          </a:effectRef>
+          <a:fontRef idx="minor">
+            <a:schemeClr val="lt1"/>
+          </a:fontRef>
+        </p:style>
+        <p:txBody>
+          <a:bodyPr rtlCol="0" anchor="ctr"/>
+          <a:lstStyle/>
+          <a:p>
+            <a:pPr algn="ctr">
+              <a:defRPr sz="850" b="1">
+                <a:solidFill>
+                  <a:srgbClr val="1D4ED8"/>
+                </a:solidFill>
+                <a:latin typeface="Consolas"/>
+              </a:defRPr>
+            </a:pPr>
+            <a:r>
+              <a:t>24241-CS-034</a:t>
+            </a:r>
+          </a:p>
+        </p:txBody>
+      </p:sp>
+      <p:sp>
+        <p:nvSpPr>
+          <p:cNvPr id="18" name="Rounded Rectangle 17"/>
+          <p:cNvSpPr/>
+          <p:nvPr/>
+        </p:nvSpPr>
+        <p:spPr>
+          <a:xfrm>
+            <a:off x="7818120" y="3337559"/>
+            <a:ext cx="3383280" cy="621792"/>
+          </a:xfrm>
+          <a:prstGeom prst="roundRect">
+            <a:avLst/>
+          </a:prstGeom>
+          <a:solidFill>
+            <a:srgbClr val="FFFFFF"/>
+          </a:solidFill>
+          <a:ln w="15240">
+            <a:solidFill>
+              <a:srgbClr val="E2E8F0"/>
+            </a:solidFill>
+          </a:ln>
+        </p:spPr>
+        <p:style>
+          <a:lnRef idx="1">
+            <a:schemeClr val="accent1"/>
+          </a:lnRef>
+          <a:fillRef idx="3">
+            <a:schemeClr val="accent1"/>
+          </a:fillRef>
+          <a:effectRef idx="2">
+            <a:schemeClr val="accent1"/>
+          </a:effectRef>
+          <a:fontRef idx="minor">
+            <a:schemeClr val="lt1"/>
+          </a:fontRef>
+        </p:style>
+        <p:txBody>
+          <a:bodyPr rtlCol="0" anchor="ctr"/>
+          <a:lstStyle/>
+          <a:p>
+            <a:pPr algn="ctr"/>
+          </a:p>
+        </p:txBody>
+      </p:sp>
+      <p:sp>
+        <p:nvSpPr>
+          <p:cNvPr id="19" name="Oval 18"/>
+          <p:cNvSpPr/>
+          <p:nvPr/>
+        </p:nvSpPr>
+        <p:spPr>
+          <a:xfrm>
+            <a:off x="7955279" y="3465575"/>
+            <a:ext cx="365760" cy="365760"/>
+          </a:xfrm>
+          <a:prstGeom prst="ellipse">
+            <a:avLst/>
+          </a:prstGeom>
+          <a:solidFill>
+            <a:srgbClr val="EFF6FF"/>
+          </a:solidFill>
+          <a:ln w="12700">
+            <a:solidFill>
+              <a:srgbClr val="BFDBFE"/>
+            </a:solidFill>
+          </a:ln>
+        </p:spPr>
+        <p:style>
+          <a:lnRef idx="1">
+            <a:schemeClr val="accent1"/>
+          </a:lnRef>
+          <a:fillRef idx="3">
+            <a:schemeClr val="accent1"/>
+          </a:fillRef>
+          <a:effectRef idx="2">
+            <a:schemeClr val="accent1"/>
+          </a:effectRef>
+          <a:fontRef idx="minor">
+            <a:schemeClr val="lt1"/>
+          </a:fontRef>
+        </p:style>
+        <p:txBody>
+          <a:bodyPr rtlCol="0" anchor="ctr"/>
+          <a:lstStyle/>
+          <a:p>
+            <a:pPr algn="ctr">
+              <a:defRPr sz="950" b="1">
+                <a:solidFill>
+                  <a:srgbClr val="1D4ED8"/>
+                </a:solidFill>
+                <a:latin typeface="Segoe UI"/>
+              </a:defRPr>
+            </a:pPr>
+            <a:r>
+              <a:t>03</a:t>
+            </a:r>
+          </a:p>
+        </p:txBody>
+      </p:sp>
+      <p:sp>
+        <p:nvSpPr>
+          <p:cNvPr id="20" name="TextBox 19"/>
+          <p:cNvSpPr txBox="1"/>
+          <p:nvPr/>
+        </p:nvSpPr>
+        <p:spPr>
+          <a:xfrm>
+            <a:off x="8412480" y="3410711"/>
+            <a:ext cx="1645920" cy="475488"/>
+          </a:xfrm>
+          <a:prstGeom prst="rect">
+            <a:avLst/>
+          </a:prstGeom>
+          <a:noFill/>
+        </p:spPr>
+        <p:txBody>
+          <a:bodyPr wrap="square" lIns="0" tIns="0" rIns="0" bIns="0">
+            <a:spAutoFit/>
+          </a:bodyPr>
+          <a:lstStyle/>
+          <a:p>
+            <a:pPr>
               <a:defRPr sz="1200" b="1">
                 <a:solidFill>
-                  <a:srgbClr val="334155"/>
-                </a:solidFill>
-                <a:latin typeface="Segoe UI"/>
-              </a:defRPr>
-            </a:pPr>
-            <a:r>
-              <a:t>•  G. Bhargavi  (24241-CS-035)</a:t>
-            </a:r>
-          </a:p>
-          <a:p>
-            <a:pPr>
-              <a:spcAft>
-                <a:spcPts val="1000"/>
-              </a:spcAft>
+                  <a:srgbClr val="0F172A"/>
+                </a:solidFill>
+                <a:latin typeface="Segoe UI"/>
+              </a:defRPr>
+            </a:pPr>
+            <a:r>
+              <a:t>G. Bhargavi</a:t>
+            </a:r>
+          </a:p>
+          <a:p>
+            <a:pPr>
+              <a:defRPr sz="850">
+                <a:solidFill>
+                  <a:srgbClr val="64748B"/>
+                </a:solidFill>
+                <a:latin typeface="Segoe UI"/>
+              </a:defRPr>
+            </a:pPr>
+            <a:r>
+              <a:t>B.Tech CSE</a:t>
+            </a:r>
+          </a:p>
+        </p:txBody>
+      </p:sp>
+      <p:sp>
+        <p:nvSpPr>
+          <p:cNvPr id="21" name="Rounded Rectangle 20"/>
+          <p:cNvSpPr/>
+          <p:nvPr/>
+        </p:nvSpPr>
+        <p:spPr>
+          <a:xfrm>
+            <a:off x="9966960" y="3483863"/>
+            <a:ext cx="1143000" cy="329184"/>
+          </a:xfrm>
+          <a:prstGeom prst="roundRect">
+            <a:avLst/>
+          </a:prstGeom>
+          <a:solidFill>
+            <a:srgbClr val="F8FAFC"/>
+          </a:solidFill>
+          <a:ln w="12700">
+            <a:solidFill>
+              <a:srgbClr val="BFDBFE"/>
+            </a:solidFill>
+          </a:ln>
+        </p:spPr>
+        <p:style>
+          <a:lnRef idx="1">
+            <a:schemeClr val="accent1"/>
+          </a:lnRef>
+          <a:fillRef idx="3">
+            <a:schemeClr val="accent1"/>
+          </a:fillRef>
+          <a:effectRef idx="2">
+            <a:schemeClr val="accent1"/>
+          </a:effectRef>
+          <a:fontRef idx="minor">
+            <a:schemeClr val="lt1"/>
+          </a:fontRef>
+        </p:style>
+        <p:txBody>
+          <a:bodyPr rtlCol="0" anchor="ctr"/>
+          <a:lstStyle/>
+          <a:p>
+            <a:pPr algn="ctr">
+              <a:defRPr sz="850" b="1">
+                <a:solidFill>
+                  <a:srgbClr val="1D4ED8"/>
+                </a:solidFill>
+                <a:latin typeface="Consolas"/>
+              </a:defRPr>
+            </a:pPr>
+            <a:r>
+              <a:t>24241-CS-035</a:t>
+            </a:r>
+          </a:p>
+        </p:txBody>
+      </p:sp>
+      <p:sp>
+        <p:nvSpPr>
+          <p:cNvPr id="22" name="Rounded Rectangle 21"/>
+          <p:cNvSpPr/>
+          <p:nvPr/>
+        </p:nvSpPr>
+        <p:spPr>
+          <a:xfrm>
+            <a:off x="7818120" y="4069079"/>
+            <a:ext cx="3383280" cy="621792"/>
+          </a:xfrm>
+          <a:prstGeom prst="roundRect">
+            <a:avLst/>
+          </a:prstGeom>
+          <a:solidFill>
+            <a:srgbClr val="FFFFFF"/>
+          </a:solidFill>
+          <a:ln w="15240">
+            <a:solidFill>
+              <a:srgbClr val="E2E8F0"/>
+            </a:solidFill>
+          </a:ln>
+        </p:spPr>
+        <p:style>
+          <a:lnRef idx="1">
+            <a:schemeClr val="accent1"/>
+          </a:lnRef>
+          <a:fillRef idx="3">
+            <a:schemeClr val="accent1"/>
+          </a:fillRef>
+          <a:effectRef idx="2">
+            <a:schemeClr val="accent1"/>
+          </a:effectRef>
+          <a:fontRef idx="minor">
+            <a:schemeClr val="lt1"/>
+          </a:fontRef>
+        </p:style>
+        <p:txBody>
+          <a:bodyPr rtlCol="0" anchor="ctr"/>
+          <a:lstStyle/>
+          <a:p>
+            <a:pPr algn="ctr"/>
+          </a:p>
+        </p:txBody>
+      </p:sp>
+      <p:sp>
+        <p:nvSpPr>
+          <p:cNvPr id="23" name="Oval 22"/>
+          <p:cNvSpPr/>
+          <p:nvPr/>
+        </p:nvSpPr>
+        <p:spPr>
+          <a:xfrm>
+            <a:off x="7955279" y="4197095"/>
+            <a:ext cx="365760" cy="365760"/>
+          </a:xfrm>
+          <a:prstGeom prst="ellipse">
+            <a:avLst/>
+          </a:prstGeom>
+          <a:solidFill>
+            <a:srgbClr val="EFF6FF"/>
+          </a:solidFill>
+          <a:ln w="12700">
+            <a:solidFill>
+              <a:srgbClr val="BFDBFE"/>
+            </a:solidFill>
+          </a:ln>
+        </p:spPr>
+        <p:style>
+          <a:lnRef idx="1">
+            <a:schemeClr val="accent1"/>
+          </a:lnRef>
+          <a:fillRef idx="3">
+            <a:schemeClr val="accent1"/>
+          </a:fillRef>
+          <a:effectRef idx="2">
+            <a:schemeClr val="accent1"/>
+          </a:effectRef>
+          <a:fontRef idx="minor">
+            <a:schemeClr val="lt1"/>
+          </a:fontRef>
+        </p:style>
+        <p:txBody>
+          <a:bodyPr rtlCol="0" anchor="ctr"/>
+          <a:lstStyle/>
+          <a:p>
+            <a:pPr algn="ctr">
+              <a:defRPr sz="950" b="1">
+                <a:solidFill>
+                  <a:srgbClr val="1D4ED8"/>
+                </a:solidFill>
+                <a:latin typeface="Segoe UI"/>
+              </a:defRPr>
+            </a:pPr>
+            <a:r>
+              <a:t>04</a:t>
+            </a:r>
+          </a:p>
+        </p:txBody>
+      </p:sp>
+      <p:sp>
+        <p:nvSpPr>
+          <p:cNvPr id="24" name="TextBox 23"/>
+          <p:cNvSpPr txBox="1"/>
+          <p:nvPr/>
+        </p:nvSpPr>
+        <p:spPr>
+          <a:xfrm>
+            <a:off x="8412480" y="4142231"/>
+            <a:ext cx="1645920" cy="475488"/>
+          </a:xfrm>
+          <a:prstGeom prst="rect">
+            <a:avLst/>
+          </a:prstGeom>
+          <a:noFill/>
+        </p:spPr>
+        <p:txBody>
+          <a:bodyPr wrap="square" lIns="0" tIns="0" rIns="0" bIns="0">
+            <a:spAutoFit/>
+          </a:bodyPr>
+          <a:lstStyle/>
+          <a:p>
+            <a:pPr>
               <a:defRPr sz="1200" b="1">
                 <a:solidFill>
-                  <a:srgbClr val="334155"/>
-                </a:solidFill>
-                <a:latin typeface="Segoe UI"/>
-              </a:defRPr>
-            </a:pPr>
-            <a:r>
-              <a:t>•  E. Sakshi  (24241-CS-036)</a:t>
-            </a:r>
-          </a:p>
-          <a:p>
-            <a:pPr>
-              <a:spcAft>
-                <a:spcPts val="1000"/>
-              </a:spcAft>
+                  <a:srgbClr val="0F172A"/>
+                </a:solidFill>
+                <a:latin typeface="Segoe UI"/>
+              </a:defRPr>
+            </a:pPr>
+            <a:r>
+              <a:t>E. Sakshi</a:t>
+            </a:r>
+          </a:p>
+          <a:p>
+            <a:pPr>
+              <a:defRPr sz="850">
+                <a:solidFill>
+                  <a:srgbClr val="64748B"/>
+                </a:solidFill>
+                <a:latin typeface="Segoe UI"/>
+              </a:defRPr>
+            </a:pPr>
+            <a:r>
+              <a:t>B.Tech CSE</a:t>
+            </a:r>
+          </a:p>
+        </p:txBody>
+      </p:sp>
+      <p:sp>
+        <p:nvSpPr>
+          <p:cNvPr id="25" name="Rounded Rectangle 24"/>
+          <p:cNvSpPr/>
+          <p:nvPr/>
+        </p:nvSpPr>
+        <p:spPr>
+          <a:xfrm>
+            <a:off x="9966960" y="4215383"/>
+            <a:ext cx="1143000" cy="329184"/>
+          </a:xfrm>
+          <a:prstGeom prst="roundRect">
+            <a:avLst/>
+          </a:prstGeom>
+          <a:solidFill>
+            <a:srgbClr val="F8FAFC"/>
+          </a:solidFill>
+          <a:ln w="12700">
+            <a:solidFill>
+              <a:srgbClr val="BFDBFE"/>
+            </a:solidFill>
+          </a:ln>
+        </p:spPr>
+        <p:style>
+          <a:lnRef idx="1">
+            <a:schemeClr val="accent1"/>
+          </a:lnRef>
+          <a:fillRef idx="3">
+            <a:schemeClr val="accent1"/>
+          </a:fillRef>
+          <a:effectRef idx="2">
+            <a:schemeClr val="accent1"/>
+          </a:effectRef>
+          <a:fontRef idx="minor">
+            <a:schemeClr val="lt1"/>
+          </a:fontRef>
+        </p:style>
+        <p:txBody>
+          <a:bodyPr rtlCol="0" anchor="ctr"/>
+          <a:lstStyle/>
+          <a:p>
+            <a:pPr algn="ctr">
+              <a:defRPr sz="850" b="1">
+                <a:solidFill>
+                  <a:srgbClr val="1D4ED8"/>
+                </a:solidFill>
+                <a:latin typeface="Consolas"/>
+              </a:defRPr>
+            </a:pPr>
+            <a:r>
+              <a:t>24241-CS-036</a:t>
+            </a:r>
+          </a:p>
+        </p:txBody>
+      </p:sp>
+      <p:sp>
+        <p:nvSpPr>
+          <p:cNvPr id="26" name="Rounded Rectangle 25"/>
+          <p:cNvSpPr/>
+          <p:nvPr/>
+        </p:nvSpPr>
+        <p:spPr>
+          <a:xfrm>
+            <a:off x="7818120" y="4800599"/>
+            <a:ext cx="3383280" cy="621792"/>
+          </a:xfrm>
+          <a:prstGeom prst="roundRect">
+            <a:avLst/>
+          </a:prstGeom>
+          <a:solidFill>
+            <a:srgbClr val="FFFFFF"/>
+          </a:solidFill>
+          <a:ln w="15240">
+            <a:solidFill>
+              <a:srgbClr val="E2E8F0"/>
+            </a:solidFill>
+          </a:ln>
+        </p:spPr>
+        <p:style>
+          <a:lnRef idx="1">
+            <a:schemeClr val="accent1"/>
+          </a:lnRef>
+          <a:fillRef idx="3">
+            <a:schemeClr val="accent1"/>
+          </a:fillRef>
+          <a:effectRef idx="2">
+            <a:schemeClr val="accent1"/>
+          </a:effectRef>
+          <a:fontRef idx="minor">
+            <a:schemeClr val="lt1"/>
+          </a:fontRef>
+        </p:style>
+        <p:txBody>
+          <a:bodyPr rtlCol="0" anchor="ctr"/>
+          <a:lstStyle/>
+          <a:p>
+            <a:pPr algn="ctr"/>
+          </a:p>
+        </p:txBody>
+      </p:sp>
+      <p:sp>
+        <p:nvSpPr>
+          <p:cNvPr id="27" name="Oval 26"/>
+          <p:cNvSpPr/>
+          <p:nvPr/>
+        </p:nvSpPr>
+        <p:spPr>
+          <a:xfrm>
+            <a:off x="7955279" y="4928615"/>
+            <a:ext cx="365760" cy="365760"/>
+          </a:xfrm>
+          <a:prstGeom prst="ellipse">
+            <a:avLst/>
+          </a:prstGeom>
+          <a:solidFill>
+            <a:srgbClr val="EFF6FF"/>
+          </a:solidFill>
+          <a:ln w="12700">
+            <a:solidFill>
+              <a:srgbClr val="BFDBFE"/>
+            </a:solidFill>
+          </a:ln>
+        </p:spPr>
+        <p:style>
+          <a:lnRef idx="1">
+            <a:schemeClr val="accent1"/>
+          </a:lnRef>
+          <a:fillRef idx="3">
+            <a:schemeClr val="accent1"/>
+          </a:fillRef>
+          <a:effectRef idx="2">
+            <a:schemeClr val="accent1"/>
+          </a:effectRef>
+          <a:fontRef idx="minor">
+            <a:schemeClr val="lt1"/>
+          </a:fontRef>
+        </p:style>
+        <p:txBody>
+          <a:bodyPr rtlCol="0" anchor="ctr"/>
+          <a:lstStyle/>
+          <a:p>
+            <a:pPr algn="ctr">
+              <a:defRPr sz="950" b="1">
+                <a:solidFill>
+                  <a:srgbClr val="1D4ED8"/>
+                </a:solidFill>
+                <a:latin typeface="Segoe UI"/>
+              </a:defRPr>
+            </a:pPr>
+            <a:r>
+              <a:t>05</a:t>
+            </a:r>
+          </a:p>
+        </p:txBody>
+      </p:sp>
+      <p:sp>
+        <p:nvSpPr>
+          <p:cNvPr id="28" name="TextBox 27"/>
+          <p:cNvSpPr txBox="1"/>
+          <p:nvPr/>
+        </p:nvSpPr>
+        <p:spPr>
+          <a:xfrm>
+            <a:off x="8412480" y="4873751"/>
+            <a:ext cx="1645920" cy="475488"/>
+          </a:xfrm>
+          <a:prstGeom prst="rect">
+            <a:avLst/>
+          </a:prstGeom>
+          <a:noFill/>
+        </p:spPr>
+        <p:txBody>
+          <a:bodyPr wrap="square" lIns="0" tIns="0" rIns="0" bIns="0">
+            <a:spAutoFit/>
+          </a:bodyPr>
+          <a:lstStyle/>
+          <a:p>
+            <a:pPr>
               <a:defRPr sz="1200" b="1">
                 <a:solidFill>
-                  <a:srgbClr val="334155"/>
-                </a:solidFill>
-                <a:latin typeface="Segoe UI"/>
-              </a:defRPr>
-            </a:pPr>
-            <a:r>
-              <a:t>•  A. Varun  (24241-CS-037)</a:t>
-            </a:r>
-          </a:p>
-        </p:txBody>
-      </p:sp>
-      <p:sp>
-        <p:nvSpPr>
-          <p:cNvPr id="10" name="Rectangle 9"/>
+                  <a:srgbClr val="0F172A"/>
+                </a:solidFill>
+                <a:latin typeface="Segoe UI"/>
+              </a:defRPr>
+            </a:pPr>
+            <a:r>
+              <a:t>A. Varun</a:t>
+            </a:r>
+          </a:p>
+          <a:p>
+            <a:pPr>
+              <a:defRPr sz="850">
+                <a:solidFill>
+                  <a:srgbClr val="64748B"/>
+                </a:solidFill>
+                <a:latin typeface="Segoe UI"/>
+              </a:defRPr>
+            </a:pPr>
+            <a:r>
+              <a:t>B.Tech CSE</a:t>
+            </a:r>
+          </a:p>
+        </p:txBody>
+      </p:sp>
+      <p:sp>
+        <p:nvSpPr>
+          <p:cNvPr id="29" name="Rounded Rectangle 28"/>
+          <p:cNvSpPr/>
+          <p:nvPr/>
+        </p:nvSpPr>
+        <p:spPr>
+          <a:xfrm>
+            <a:off x="9966960" y="4946903"/>
+            <a:ext cx="1143000" cy="329184"/>
+          </a:xfrm>
+          <a:prstGeom prst="roundRect">
+            <a:avLst/>
+          </a:prstGeom>
+          <a:solidFill>
+            <a:srgbClr val="F8FAFC"/>
+          </a:solidFill>
+          <a:ln w="12700">
+            <a:solidFill>
+              <a:srgbClr val="BFDBFE"/>
+            </a:solidFill>
+          </a:ln>
+        </p:spPr>
+        <p:style>
+          <a:lnRef idx="1">
+            <a:schemeClr val="accent1"/>
+          </a:lnRef>
+          <a:fillRef idx="3">
+            <a:schemeClr val="accent1"/>
+          </a:fillRef>
+          <a:effectRef idx="2">
+            <a:schemeClr val="accent1"/>
+          </a:effectRef>
+          <a:fontRef idx="minor">
+            <a:schemeClr val="lt1"/>
+          </a:fontRef>
+        </p:style>
+        <p:txBody>
+          <a:bodyPr rtlCol="0" anchor="ctr"/>
+          <a:lstStyle/>
+          <a:p>
+            <a:pPr algn="ctr">
+              <a:defRPr sz="850" b="1">
+                <a:solidFill>
+                  <a:srgbClr val="1D4ED8"/>
+                </a:solidFill>
+                <a:latin typeface="Consolas"/>
+              </a:defRPr>
+            </a:pPr>
+            <a:r>
+              <a:t>24241-CS-037</a:t>
+            </a:r>
+          </a:p>
+        </p:txBody>
+      </p:sp>
+      <p:sp>
+        <p:nvSpPr>
+          <p:cNvPr id="30" name="Rectangle 29"/>
           <p:cNvSpPr/>
           <p:nvPr/>
         </p:nvSpPr>
@@ -3652,7 +4586,7 @@
       </p:sp>
       <p:sp>
         <p:nvSpPr>
-          <p:cNvPr id="11" name="TextBox 10"/>
+          <p:cNvPr id="31" name="TextBox 30"/>
           <p:cNvSpPr txBox="1"/>
           <p:nvPr/>
         </p:nvSpPr>
@@ -3823,8 +4757,8 @@
         </p:nvSpPr>
         <p:spPr>
           <a:xfrm>
-            <a:off x="731520" y="1645920"/>
-            <a:ext cx="5029200" cy="4389120"/>
+            <a:off x="731520" y="1508760"/>
+            <a:ext cx="4937760" cy="4526280"/>
           </a:xfrm>
           <a:prstGeom prst="roundRect">
             <a:avLst/>
@@ -3868,8 +4802,8 @@
         </p:nvSpPr>
         <p:spPr>
           <a:xfrm>
-            <a:off x="1005840" y="1828800"/>
-            <a:ext cx="4480560" cy="4023360"/>
+            <a:off x="960120" y="1673352"/>
+            <a:ext cx="4480560" cy="4197096"/>
           </a:xfrm>
           <a:prstGeom prst="rect">
             <a:avLst/>
@@ -3877,13 +4811,13 @@
           <a:noFill/>
         </p:spPr>
         <p:txBody>
-          <a:bodyPr wrap="square">
+          <a:bodyPr wrap="square" lIns="0" tIns="0" rIns="0" bIns="0">
             <a:spAutoFit/>
           </a:bodyPr>
           <a:lstStyle/>
           <a:p>
             <a:pPr>
-              <a:defRPr sz="1200" b="1">
+              <a:defRPr sz="1150" b="1">
                 <a:solidFill>
                   <a:srgbClr val="1D4ED8"/>
                 </a:solidFill>
@@ -3897,9 +4831,9 @@
           <a:p>
             <a:pPr>
               <a:spcAft>
-                <a:spcPts val="900"/>
-              </a:spcAft>
-              <a:defRPr sz="1050">
+                <a:spcPts val="600"/>
+              </a:spcAft>
+              <a:defRPr sz="950">
                 <a:solidFill>
                   <a:srgbClr val="475569"/>
                 </a:solidFill>
@@ -3912,7 +4846,7 @@
           </a:p>
           <a:p>
             <a:pPr>
-              <a:defRPr sz="1200" b="1">
+              <a:defRPr sz="1150" b="1">
                 <a:solidFill>
                   <a:srgbClr val="0F172A"/>
                 </a:solidFill>
@@ -3926,9 +4860,9 @@
           <a:p>
             <a:pPr>
               <a:spcAft>
-                <a:spcPts val="900"/>
-              </a:spcAft>
-              <a:defRPr sz="1050">
+                <a:spcPts val="600"/>
+              </a:spcAft>
+              <a:defRPr sz="950">
                 <a:solidFill>
                   <a:srgbClr val="475569"/>
                 </a:solidFill>
@@ -3941,7 +4875,7 @@
           </a:p>
           <a:p>
             <a:pPr>
-              <a:defRPr sz="1200" b="1">
+              <a:defRPr sz="1150" b="1">
                 <a:solidFill>
                   <a:srgbClr val="0F172A"/>
                 </a:solidFill>
@@ -3955,9 +4889,9 @@
           <a:p>
             <a:pPr>
               <a:spcAft>
-                <a:spcPts val="900"/>
-              </a:spcAft>
-              <a:defRPr sz="1050">
+                <a:spcPts val="600"/>
+              </a:spcAft>
+              <a:defRPr sz="950">
                 <a:solidFill>
                   <a:srgbClr val="475569"/>
                 </a:solidFill>
@@ -3970,7 +4904,7 @@
           </a:p>
           <a:p>
             <a:pPr>
-              <a:defRPr sz="1200" b="1">
+              <a:defRPr sz="1150" b="1">
                 <a:solidFill>
                   <a:srgbClr val="0F172A"/>
                 </a:solidFill>
@@ -3984,9 +4918,9 @@
           <a:p>
             <a:pPr>
               <a:spcAft>
-                <a:spcPts val="900"/>
-              </a:spcAft>
-              <a:defRPr sz="1050">
+                <a:spcPts val="600"/>
+              </a:spcAft>
+              <a:defRPr sz="950">
                 <a:solidFill>
                   <a:srgbClr val="475569"/>
                 </a:solidFill>
@@ -4007,8 +4941,8 @@
         </p:nvSpPr>
         <p:spPr>
           <a:xfrm>
-            <a:off x="6035040" y="1645920"/>
-            <a:ext cx="5394960" cy="4389120"/>
+            <a:off x="5925312" y="1508760"/>
+            <a:ext cx="5532120" cy="4526280"/>
           </a:xfrm>
           <a:prstGeom prst="roundRect">
             <a:avLst/>
@@ -4060,8 +4994,8 @@
         </p:blipFill>
         <p:spPr>
           <a:xfrm>
-            <a:off x="6172200" y="1783080"/>
-            <a:ext cx="5120640" cy="3840480"/>
+            <a:off x="6383888" y="1691640"/>
+            <a:ext cx="4614967" cy="3566160"/>
           </a:xfrm>
           <a:prstGeom prst="rect">
             <a:avLst/>
@@ -4070,28 +5004,47 @@
       </p:pic>
       <p:sp>
         <p:nvSpPr>
-          <p:cNvPr id="8" name="TextBox 7"/>
-          <p:cNvSpPr txBox="1"/>
-          <p:nvPr/>
-        </p:nvSpPr>
-        <p:spPr>
-          <a:xfrm>
-            <a:off x="6172200" y="5669280"/>
-            <a:ext cx="5120640" cy="274320"/>
-          </a:xfrm>
-          <a:prstGeom prst="rect">
-            <a:avLst/>
-          </a:prstGeom>
-          <a:noFill/>
-        </p:spPr>
-        <p:txBody>
-          <a:bodyPr wrap="none">
-            <a:spAutoFit/>
-          </a:bodyPr>
+          <p:cNvPr id="8" name="Rounded Rectangle 7"/>
+          <p:cNvSpPr/>
+          <p:nvPr/>
+        </p:nvSpPr>
+        <p:spPr>
+          <a:xfrm>
+            <a:off x="6222492" y="5486399"/>
+            <a:ext cx="4937760" cy="347472"/>
+          </a:xfrm>
+          <a:prstGeom prst="roundRect">
+            <a:avLst/>
+          </a:prstGeom>
+          <a:solidFill>
+            <a:srgbClr val="F8FAFC"/>
+          </a:solidFill>
+          <a:ln w="12700">
+            <a:solidFill>
+              <a:srgbClr val="E2E8F0"/>
+            </a:solidFill>
+          </a:ln>
+        </p:spPr>
+        <p:style>
+          <a:lnRef idx="1">
+            <a:schemeClr val="accent1"/>
+          </a:lnRef>
+          <a:fillRef idx="3">
+            <a:schemeClr val="accent1"/>
+          </a:fillRef>
+          <a:effectRef idx="2">
+            <a:schemeClr val="accent1"/>
+          </a:effectRef>
+          <a:fontRef idx="minor">
+            <a:schemeClr val="lt1"/>
+          </a:fontRef>
+        </p:style>
+        <p:txBody>
+          <a:bodyPr rtlCol="0" anchor="ctr" lIns="0" tIns="0" rIns="0" bIns="0"/>
           <a:lstStyle/>
           <a:p>
             <a:pPr algn="ctr">
-              <a:defRPr sz="950" b="1">
+              <a:defRPr sz="900" b="1">
                 <a:solidFill>
                   <a:srgbClr val="64748B"/>
                 </a:solidFill>
@@ -4099,7 +5052,7 @@
               </a:defRPr>
             </a:pPr>
             <a:r>
-              <a:t>📷 Live System Screen: Subscriber KYC Directory &amp; Provisioning Table</a:t>
+              <a:t>📷 Live Screen: Subscriber KYC Directory &amp; Provisioning Table</a:t>
             </a:r>
           </a:p>
         </p:txBody>
@@ -4320,8 +5273,8 @@
         </p:nvSpPr>
         <p:spPr>
           <a:xfrm>
-            <a:off x="731520" y="1645920"/>
-            <a:ext cx="3429000" cy="4389120"/>
+            <a:off x="731520" y="1508760"/>
+            <a:ext cx="3429000" cy="4526280"/>
           </a:xfrm>
           <a:prstGeom prst="roundRect">
             <a:avLst/>
@@ -4365,8 +5318,8 @@
         </p:nvSpPr>
         <p:spPr>
           <a:xfrm>
-            <a:off x="960120" y="1828800"/>
-            <a:ext cx="2971800" cy="4023360"/>
+            <a:off x="896112" y="1655064"/>
+            <a:ext cx="3099816" cy="4233672"/>
           </a:xfrm>
           <a:prstGeom prst="rect">
             <a:avLst/>
@@ -4374,16 +5327,16 @@
           <a:noFill/>
         </p:spPr>
         <p:txBody>
-          <a:bodyPr wrap="square">
+          <a:bodyPr wrap="square" lIns="0" tIns="0" rIns="0" bIns="0">
             <a:spAutoFit/>
           </a:bodyPr>
           <a:lstStyle/>
           <a:p>
             <a:pPr>
               <a:spcAft>
-                <a:spcPts val="1200"/>
-              </a:spcAft>
-              <a:defRPr sz="1300" b="1">
+                <a:spcPts val="800"/>
+              </a:spcAft>
+              <a:defRPr sz="1200" b="1">
                 <a:solidFill>
                   <a:srgbClr val="1D4ED8"/>
                 </a:solidFill>
@@ -4396,7 +5349,7 @@
           </a:p>
           <a:p>
             <a:pPr>
-              <a:defRPr sz="1050" b="1">
+              <a:defRPr sz="950" b="1">
                 <a:solidFill>
                   <a:srgbClr val="0F172A"/>
                 </a:solidFill>
@@ -4410,9 +5363,9 @@
           <a:p>
             <a:pPr>
               <a:spcAft>
-                <a:spcPts val="800"/>
-              </a:spcAft>
-              <a:defRPr sz="950">
+                <a:spcPts val="400"/>
+              </a:spcAft>
+              <a:defRPr sz="850">
                 <a:solidFill>
                   <a:srgbClr val="475569"/>
                 </a:solidFill>
@@ -4425,7 +5378,7 @@
           </a:p>
           <a:p>
             <a:pPr>
-              <a:defRPr sz="1050" b="1">
+              <a:defRPr sz="950" b="1">
                 <a:solidFill>
                   <a:srgbClr val="0F172A"/>
                 </a:solidFill>
@@ -4439,9 +5392,9 @@
           <a:p>
             <a:pPr>
               <a:spcAft>
-                <a:spcPts val="800"/>
-              </a:spcAft>
-              <a:defRPr sz="950">
+                <a:spcPts val="400"/>
+              </a:spcAft>
+              <a:defRPr sz="850">
                 <a:solidFill>
                   <a:srgbClr val="475569"/>
                 </a:solidFill>
@@ -4454,7 +5407,7 @@
           </a:p>
           <a:p>
             <a:pPr>
-              <a:defRPr sz="1050" b="1">
+              <a:defRPr sz="950" b="1">
                 <a:solidFill>
                   <a:srgbClr val="0F172A"/>
                 </a:solidFill>
@@ -4468,9 +5421,9 @@
           <a:p>
             <a:pPr>
               <a:spcAft>
-                <a:spcPts val="800"/>
-              </a:spcAft>
-              <a:defRPr sz="950">
+                <a:spcPts val="400"/>
+              </a:spcAft>
+              <a:defRPr sz="850">
                 <a:solidFill>
                   <a:srgbClr val="475569"/>
                 </a:solidFill>
@@ -4483,7 +5436,7 @@
           </a:p>
           <a:p>
             <a:pPr>
-              <a:defRPr sz="1050" b="1">
+              <a:defRPr sz="950" b="1">
                 <a:solidFill>
                   <a:srgbClr val="0F172A"/>
                 </a:solidFill>
@@ -4497,9 +5450,9 @@
           <a:p>
             <a:pPr>
               <a:spcAft>
-                <a:spcPts val="800"/>
-              </a:spcAft>
-              <a:defRPr sz="950">
+                <a:spcPts val="400"/>
+              </a:spcAft>
+              <a:defRPr sz="850">
                 <a:solidFill>
                   <a:srgbClr val="475569"/>
                 </a:solidFill>
@@ -4512,7 +5465,7 @@
           </a:p>
           <a:p>
             <a:pPr>
-              <a:defRPr sz="1050" b="1">
+              <a:defRPr sz="950" b="1">
                 <a:solidFill>
                   <a:srgbClr val="0F172A"/>
                 </a:solidFill>
@@ -4526,9 +5479,9 @@
           <a:p>
             <a:pPr>
               <a:spcAft>
-                <a:spcPts val="800"/>
-              </a:spcAft>
-              <a:defRPr sz="950">
+                <a:spcPts val="400"/>
+              </a:spcAft>
+              <a:defRPr sz="850">
                 <a:solidFill>
                   <a:srgbClr val="475569"/>
                 </a:solidFill>
@@ -4549,8 +5502,8 @@
         </p:nvSpPr>
         <p:spPr>
           <a:xfrm>
-            <a:off x="4343400" y="1645920"/>
-            <a:ext cx="3429000" cy="4389120"/>
+            <a:off x="4343400" y="1508760"/>
+            <a:ext cx="3429000" cy="4526280"/>
           </a:xfrm>
           <a:prstGeom prst="roundRect">
             <a:avLst/>
@@ -4594,8 +5547,8 @@
         </p:nvSpPr>
         <p:spPr>
           <a:xfrm>
-            <a:off x="4572000" y="1828800"/>
-            <a:ext cx="2971800" cy="4023360"/>
+            <a:off x="4507992" y="1655064"/>
+            <a:ext cx="3099816" cy="4233672"/>
           </a:xfrm>
           <a:prstGeom prst="rect">
             <a:avLst/>
@@ -4603,16 +5556,16 @@
           <a:noFill/>
         </p:spPr>
         <p:txBody>
-          <a:bodyPr wrap="square">
+          <a:bodyPr wrap="square" lIns="0" tIns="0" rIns="0" bIns="0">
             <a:spAutoFit/>
           </a:bodyPr>
           <a:lstStyle/>
           <a:p>
             <a:pPr>
               <a:spcAft>
-                <a:spcPts val="1200"/>
-              </a:spcAft>
-              <a:defRPr sz="1300" b="1">
+                <a:spcPts val="800"/>
+              </a:spcAft>
+              <a:defRPr sz="1200" b="1">
                 <a:solidFill>
                   <a:srgbClr val="107A57"/>
                 </a:solidFill>
@@ -4625,7 +5578,7 @@
           </a:p>
           <a:p>
             <a:pPr>
-              <a:defRPr sz="1050" b="1">
+              <a:defRPr sz="950" b="1">
                 <a:solidFill>
                   <a:srgbClr val="0F172A"/>
                 </a:solidFill>
@@ -4639,9 +5592,9 @@
           <a:p>
             <a:pPr>
               <a:spcAft>
-                <a:spcPts val="800"/>
-              </a:spcAft>
-              <a:defRPr sz="950">
+                <a:spcPts val="400"/>
+              </a:spcAft>
+              <a:defRPr sz="850">
                 <a:solidFill>
                   <a:srgbClr val="475569"/>
                 </a:solidFill>
@@ -4654,7 +5607,7 @@
           </a:p>
           <a:p>
             <a:pPr>
-              <a:defRPr sz="1050" b="1">
+              <a:defRPr sz="950" b="1">
                 <a:solidFill>
                   <a:srgbClr val="0F172A"/>
                 </a:solidFill>
@@ -4668,9 +5621,9 @@
           <a:p>
             <a:pPr>
               <a:spcAft>
-                <a:spcPts val="800"/>
-              </a:spcAft>
-              <a:defRPr sz="950">
+                <a:spcPts val="400"/>
+              </a:spcAft>
+              <a:defRPr sz="850">
                 <a:solidFill>
                   <a:srgbClr val="475569"/>
                 </a:solidFill>
@@ -4683,7 +5636,7 @@
           </a:p>
           <a:p>
             <a:pPr>
-              <a:defRPr sz="1050" b="1">
+              <a:defRPr sz="950" b="1">
                 <a:solidFill>
                   <a:srgbClr val="0F172A"/>
                 </a:solidFill>
@@ -4697,9 +5650,9 @@
           <a:p>
             <a:pPr>
               <a:spcAft>
-                <a:spcPts val="800"/>
-              </a:spcAft>
-              <a:defRPr sz="950">
+                <a:spcPts val="400"/>
+              </a:spcAft>
+              <a:defRPr sz="850">
                 <a:solidFill>
                   <a:srgbClr val="475569"/>
                 </a:solidFill>
@@ -4712,7 +5665,7 @@
           </a:p>
           <a:p>
             <a:pPr>
-              <a:defRPr sz="1050" b="1">
+              <a:defRPr sz="950" b="1">
                 <a:solidFill>
                   <a:srgbClr val="0F172A"/>
                 </a:solidFill>
@@ -4726,9 +5679,9 @@
           <a:p>
             <a:pPr>
               <a:spcAft>
-                <a:spcPts val="800"/>
-              </a:spcAft>
-              <a:defRPr sz="950">
+                <a:spcPts val="400"/>
+              </a:spcAft>
+              <a:defRPr sz="850">
                 <a:solidFill>
                   <a:srgbClr val="475569"/>
                 </a:solidFill>
@@ -4749,8 +5702,8 @@
         </p:nvSpPr>
         <p:spPr>
           <a:xfrm>
-            <a:off x="7955280" y="1645920"/>
-            <a:ext cx="3429000" cy="4389120"/>
+            <a:off x="7955280" y="1508760"/>
+            <a:ext cx="3429000" cy="4526280"/>
           </a:xfrm>
           <a:prstGeom prst="roundRect">
             <a:avLst/>
@@ -4794,8 +5747,8 @@
         </p:nvSpPr>
         <p:spPr>
           <a:xfrm>
-            <a:off x="8183880" y="1828800"/>
-            <a:ext cx="2971800" cy="4023360"/>
+            <a:off x="8119872" y="1655064"/>
+            <a:ext cx="3099816" cy="4233672"/>
           </a:xfrm>
           <a:prstGeom prst="rect">
             <a:avLst/>
@@ -4803,16 +5756,16 @@
           <a:noFill/>
         </p:spPr>
         <p:txBody>
-          <a:bodyPr wrap="square">
+          <a:bodyPr wrap="square" lIns="0" tIns="0" rIns="0" bIns="0">
             <a:spAutoFit/>
           </a:bodyPr>
           <a:lstStyle/>
           <a:p>
             <a:pPr>
               <a:spcAft>
-                <a:spcPts val="1200"/>
-              </a:spcAft>
-              <a:defRPr sz="1300" b="1">
+                <a:spcPts val="800"/>
+              </a:spcAft>
+              <a:defRPr sz="1200" b="1">
                 <a:solidFill>
                   <a:srgbClr val="B45309"/>
                 </a:solidFill>
@@ -4825,7 +5778,7 @@
           </a:p>
           <a:p>
             <a:pPr>
-              <a:defRPr sz="1050" b="1">
+              <a:defRPr sz="950" b="1">
                 <a:solidFill>
                   <a:srgbClr val="0F172A"/>
                 </a:solidFill>
@@ -4839,9 +5792,9 @@
           <a:p>
             <a:pPr>
               <a:spcAft>
-                <a:spcPts val="800"/>
-              </a:spcAft>
-              <a:defRPr sz="950">
+                <a:spcPts val="400"/>
+              </a:spcAft>
+              <a:defRPr sz="850">
                 <a:solidFill>
                   <a:srgbClr val="475569"/>
                 </a:solidFill>
@@ -5070,8 +6023,8 @@
         </p:nvSpPr>
         <p:spPr>
           <a:xfrm>
-            <a:off x="731520" y="1645920"/>
-            <a:ext cx="3429000" cy="4389120"/>
+            <a:off x="731520" y="1508760"/>
+            <a:ext cx="3429000" cy="4526280"/>
           </a:xfrm>
           <a:prstGeom prst="roundRect">
             <a:avLst/>
@@ -5115,8 +6068,8 @@
         </p:nvSpPr>
         <p:spPr>
           <a:xfrm>
-            <a:off x="960120" y="1828800"/>
-            <a:ext cx="2971800" cy="4023360"/>
+            <a:off x="896112" y="1655064"/>
+            <a:ext cx="3099816" cy="4233672"/>
           </a:xfrm>
           <a:prstGeom prst="rect">
             <a:avLst/>
@@ -5124,16 +6077,16 @@
           <a:noFill/>
         </p:spPr>
         <p:txBody>
-          <a:bodyPr wrap="square">
+          <a:bodyPr wrap="square" lIns="0" tIns="0" rIns="0" bIns="0">
             <a:spAutoFit/>
           </a:bodyPr>
           <a:lstStyle/>
           <a:p>
             <a:pPr>
               <a:spcAft>
-                <a:spcPts val="1200"/>
-              </a:spcAft>
-              <a:defRPr sz="1300" b="1">
+                <a:spcPts val="800"/>
+              </a:spcAft>
+              <a:defRPr sz="1200" b="1">
                 <a:solidFill>
                   <a:srgbClr val="107A57"/>
                 </a:solidFill>
@@ -5146,7 +6099,7 @@
           </a:p>
           <a:p>
             <a:pPr>
-              <a:defRPr sz="1050" b="1">
+              <a:defRPr sz="950" b="1">
                 <a:solidFill>
                   <a:srgbClr val="0F172A"/>
                 </a:solidFill>
@@ -5160,9 +6113,9 @@
           <a:p>
             <a:pPr>
               <a:spcAft>
-                <a:spcPts val="800"/>
-              </a:spcAft>
-              <a:defRPr sz="950">
+                <a:spcPts val="400"/>
+              </a:spcAft>
+              <a:defRPr sz="850">
                 <a:solidFill>
                   <a:srgbClr val="475569"/>
                 </a:solidFill>
@@ -5175,7 +6128,7 @@
           </a:p>
           <a:p>
             <a:pPr>
-              <a:defRPr sz="1050" b="1">
+              <a:defRPr sz="950" b="1">
                 <a:solidFill>
                   <a:srgbClr val="0F172A"/>
                 </a:solidFill>
@@ -5189,9 +6142,9 @@
           <a:p>
             <a:pPr>
               <a:spcAft>
-                <a:spcPts val="800"/>
-              </a:spcAft>
-              <a:defRPr sz="950">
+                <a:spcPts val="400"/>
+              </a:spcAft>
+              <a:defRPr sz="850">
                 <a:solidFill>
                   <a:srgbClr val="475569"/>
                 </a:solidFill>
@@ -5204,7 +6157,7 @@
           </a:p>
           <a:p>
             <a:pPr>
-              <a:defRPr sz="1050" b="1">
+              <a:defRPr sz="950" b="1">
                 <a:solidFill>
                   <a:srgbClr val="0F172A"/>
                 </a:solidFill>
@@ -5218,9 +6171,9 @@
           <a:p>
             <a:pPr>
               <a:spcAft>
-                <a:spcPts val="800"/>
-              </a:spcAft>
-              <a:defRPr sz="950">
+                <a:spcPts val="400"/>
+              </a:spcAft>
+              <a:defRPr sz="850">
                 <a:solidFill>
                   <a:srgbClr val="475569"/>
                 </a:solidFill>
@@ -5233,7 +6186,7 @@
           </a:p>
           <a:p>
             <a:pPr>
-              <a:defRPr sz="1050" b="1">
+              <a:defRPr sz="950" b="1">
                 <a:solidFill>
                   <a:srgbClr val="0F172A"/>
                 </a:solidFill>
@@ -5247,9 +6200,9 @@
           <a:p>
             <a:pPr>
               <a:spcAft>
-                <a:spcPts val="800"/>
-              </a:spcAft>
-              <a:defRPr sz="950">
+                <a:spcPts val="400"/>
+              </a:spcAft>
+              <a:defRPr sz="850">
                 <a:solidFill>
                   <a:srgbClr val="475569"/>
                 </a:solidFill>
@@ -5270,8 +6223,8 @@
         </p:nvSpPr>
         <p:spPr>
           <a:xfrm>
-            <a:off x="4343400" y="1645920"/>
-            <a:ext cx="3429000" cy="4389120"/>
+            <a:off x="4343400" y="1508760"/>
+            <a:ext cx="3429000" cy="4526280"/>
           </a:xfrm>
           <a:prstGeom prst="roundRect">
             <a:avLst/>
@@ -5315,8 +6268,8 @@
         </p:nvSpPr>
         <p:spPr>
           <a:xfrm>
-            <a:off x="4572000" y="1828800"/>
-            <a:ext cx="2971800" cy="4023360"/>
+            <a:off x="4507992" y="1655064"/>
+            <a:ext cx="3099816" cy="4233672"/>
           </a:xfrm>
           <a:prstGeom prst="rect">
             <a:avLst/>
@@ -5324,16 +6277,16 @@
           <a:noFill/>
         </p:spPr>
         <p:txBody>
-          <a:bodyPr wrap="square">
+          <a:bodyPr wrap="square" lIns="0" tIns="0" rIns="0" bIns="0">
             <a:spAutoFit/>
           </a:bodyPr>
           <a:lstStyle/>
           <a:p>
             <a:pPr>
               <a:spcAft>
-                <a:spcPts val="1200"/>
-              </a:spcAft>
-              <a:defRPr sz="1300" b="1">
+                <a:spcPts val="800"/>
+              </a:spcAft>
+              <a:defRPr sz="1200" b="1">
                 <a:solidFill>
                   <a:srgbClr val="1D4ED8"/>
                 </a:solidFill>
@@ -5346,7 +6299,7 @@
           </a:p>
           <a:p>
             <a:pPr>
-              <a:defRPr sz="1050" b="1">
+              <a:defRPr sz="950" b="1">
                 <a:solidFill>
                   <a:srgbClr val="0F172A"/>
                 </a:solidFill>
@@ -5360,9 +6313,9 @@
           <a:p>
             <a:pPr>
               <a:spcAft>
-                <a:spcPts val="800"/>
-              </a:spcAft>
-              <a:defRPr sz="950">
+                <a:spcPts val="400"/>
+              </a:spcAft>
+              <a:defRPr sz="850">
                 <a:solidFill>
                   <a:srgbClr val="475569"/>
                 </a:solidFill>
@@ -5375,7 +6328,7 @@
           </a:p>
           <a:p>
             <a:pPr>
-              <a:defRPr sz="1050" b="1">
+              <a:defRPr sz="950" b="1">
                 <a:solidFill>
                   <a:srgbClr val="0F172A"/>
                 </a:solidFill>
@@ -5389,9 +6342,9 @@
           <a:p>
             <a:pPr>
               <a:spcAft>
-                <a:spcPts val="800"/>
-              </a:spcAft>
-              <a:defRPr sz="950">
+                <a:spcPts val="400"/>
+              </a:spcAft>
+              <a:defRPr sz="850">
                 <a:solidFill>
                   <a:srgbClr val="475569"/>
                 </a:solidFill>
@@ -5404,7 +6357,7 @@
           </a:p>
           <a:p>
             <a:pPr>
-              <a:defRPr sz="1050" b="1">
+              <a:defRPr sz="950" b="1">
                 <a:solidFill>
                   <a:srgbClr val="0F172A"/>
                 </a:solidFill>
@@ -5418,9 +6371,9 @@
           <a:p>
             <a:pPr>
               <a:spcAft>
-                <a:spcPts val="800"/>
-              </a:spcAft>
-              <a:defRPr sz="950">
+                <a:spcPts val="400"/>
+              </a:spcAft>
+              <a:defRPr sz="850">
                 <a:solidFill>
                   <a:srgbClr val="475569"/>
                 </a:solidFill>
@@ -5433,7 +6386,7 @@
           </a:p>
           <a:p>
             <a:pPr>
-              <a:defRPr sz="1050" b="1">
+              <a:defRPr sz="950" b="1">
                 <a:solidFill>
                   <a:srgbClr val="0F172A"/>
                 </a:solidFill>
@@ -5447,9 +6400,9 @@
           <a:p>
             <a:pPr>
               <a:spcAft>
-                <a:spcPts val="800"/>
-              </a:spcAft>
-              <a:defRPr sz="950">
+                <a:spcPts val="400"/>
+              </a:spcAft>
+              <a:defRPr sz="850">
                 <a:solidFill>
                   <a:srgbClr val="475569"/>
                 </a:solidFill>
@@ -5470,8 +6423,8 @@
         </p:nvSpPr>
         <p:spPr>
           <a:xfrm>
-            <a:off x="7955280" y="1645920"/>
-            <a:ext cx="3429000" cy="4389120"/>
+            <a:off x="7955280" y="1508760"/>
+            <a:ext cx="3429000" cy="4526280"/>
           </a:xfrm>
           <a:prstGeom prst="roundRect">
             <a:avLst/>
@@ -5515,8 +6468,8 @@
         </p:nvSpPr>
         <p:spPr>
           <a:xfrm>
-            <a:off x="8183880" y="1828800"/>
-            <a:ext cx="2971800" cy="4023360"/>
+            <a:off x="8119872" y="1655064"/>
+            <a:ext cx="3099816" cy="4233672"/>
           </a:xfrm>
           <a:prstGeom prst="rect">
             <a:avLst/>
@@ -5524,16 +6477,16 @@
           <a:noFill/>
         </p:spPr>
         <p:txBody>
-          <a:bodyPr wrap="square">
+          <a:bodyPr wrap="square" lIns="0" tIns="0" rIns="0" bIns="0">
             <a:spAutoFit/>
           </a:bodyPr>
           <a:lstStyle/>
           <a:p>
             <a:pPr>
               <a:spcAft>
-                <a:spcPts val="1200"/>
-              </a:spcAft>
-              <a:defRPr sz="1300" b="1">
+                <a:spcPts val="800"/>
+              </a:spcAft>
+              <a:defRPr sz="1200" b="1">
                 <a:solidFill>
                   <a:srgbClr val="B45309"/>
                 </a:solidFill>
@@ -5546,7 +6499,7 @@
           </a:p>
           <a:p>
             <a:pPr>
-              <a:defRPr sz="1050" b="1">
+              <a:defRPr sz="950" b="1">
                 <a:solidFill>
                   <a:srgbClr val="0F172A"/>
                 </a:solidFill>
@@ -5560,9 +6513,9 @@
           <a:p>
             <a:pPr>
               <a:spcAft>
-                <a:spcPts val="800"/>
-              </a:spcAft>
-              <a:defRPr sz="950">
+                <a:spcPts val="400"/>
+              </a:spcAft>
+              <a:defRPr sz="850">
                 <a:solidFill>
                   <a:srgbClr val="475569"/>
                 </a:solidFill>
@@ -5575,7 +6528,7 @@
           </a:p>
           <a:p>
             <a:pPr>
-              <a:defRPr sz="1050" b="1">
+              <a:defRPr sz="950" b="1">
                 <a:solidFill>
                   <a:srgbClr val="0F172A"/>
                 </a:solidFill>
@@ -5589,9 +6542,9 @@
           <a:p>
             <a:pPr>
               <a:spcAft>
-                <a:spcPts val="800"/>
-              </a:spcAft>
-              <a:defRPr sz="950">
+                <a:spcPts val="400"/>
+              </a:spcAft>
+              <a:defRPr sz="850">
                 <a:solidFill>
                   <a:srgbClr val="475569"/>
                 </a:solidFill>
@@ -5604,7 +6557,7 @@
           </a:p>
           <a:p>
             <a:pPr>
-              <a:defRPr sz="1050" b="1">
+              <a:defRPr sz="950" b="1">
                 <a:solidFill>
                   <a:srgbClr val="0F172A"/>
                 </a:solidFill>
@@ -5618,9 +6571,9 @@
           <a:p>
             <a:pPr>
               <a:spcAft>
-                <a:spcPts val="800"/>
-              </a:spcAft>
-              <a:defRPr sz="950">
+                <a:spcPts val="400"/>
+              </a:spcAft>
+              <a:defRPr sz="850">
                 <a:solidFill>
                   <a:srgbClr val="475569"/>
                 </a:solidFill>
@@ -5633,7 +6586,7 @@
           </a:p>
           <a:p>
             <a:pPr>
-              <a:defRPr sz="1050" b="1">
+              <a:defRPr sz="950" b="1">
                 <a:solidFill>
                   <a:srgbClr val="0F172A"/>
                 </a:solidFill>
@@ -5647,9 +6600,9 @@
           <a:p>
             <a:pPr>
               <a:spcAft>
-                <a:spcPts val="800"/>
-              </a:spcAft>
-              <a:defRPr sz="950">
+                <a:spcPts val="400"/>
+              </a:spcAft>
+              <a:defRPr sz="850">
                 <a:solidFill>
                   <a:srgbClr val="475569"/>
                 </a:solidFill>
@@ -5878,8 +6831,8 @@
         </p:nvSpPr>
         <p:spPr>
           <a:xfrm>
-            <a:off x="731520" y="1645920"/>
-            <a:ext cx="5120640" cy="4389120"/>
+            <a:off x="731520" y="1508760"/>
+            <a:ext cx="5212080" cy="4526280"/>
           </a:xfrm>
           <a:prstGeom prst="roundRect">
             <a:avLst/>
@@ -5923,8 +6876,8 @@
         </p:nvSpPr>
         <p:spPr>
           <a:xfrm>
-            <a:off x="1005840" y="1828800"/>
-            <a:ext cx="4572000" cy="4023360"/>
+            <a:off x="960120" y="1673352"/>
+            <a:ext cx="4754880" cy="4197096"/>
           </a:xfrm>
           <a:prstGeom prst="rect">
             <a:avLst/>
@@ -5932,16 +6885,16 @@
           <a:noFill/>
         </p:spPr>
         <p:txBody>
-          <a:bodyPr wrap="square">
+          <a:bodyPr wrap="square" lIns="0" tIns="0" rIns="0" bIns="0">
             <a:spAutoFit/>
           </a:bodyPr>
           <a:lstStyle/>
           <a:p>
             <a:pPr>
               <a:spcAft>
-                <a:spcPts val="1200"/>
-              </a:spcAft>
-              <a:defRPr sz="1600" b="1">
+                <a:spcPts val="800"/>
+              </a:spcAft>
+              <a:defRPr sz="1450" b="1">
                 <a:solidFill>
                   <a:srgbClr val="107A57"/>
                 </a:solidFill>
@@ -5954,7 +6907,7 @@
           </a:p>
           <a:p>
             <a:pPr>
-              <a:defRPr sz="1200" b="1">
+              <a:defRPr sz="1100" b="1">
                 <a:solidFill>
                   <a:srgbClr val="0F172A"/>
                 </a:solidFill>
@@ -5968,9 +6921,9 @@
           <a:p>
             <a:pPr>
               <a:spcAft>
-                <a:spcPts val="800"/>
-              </a:spcAft>
-              <a:defRPr sz="1000">
+                <a:spcPts val="500"/>
+              </a:spcAft>
+              <a:defRPr sz="900">
                 <a:solidFill>
                   <a:srgbClr val="475569"/>
                 </a:solidFill>
@@ -5983,7 +6936,7 @@
           </a:p>
           <a:p>
             <a:pPr>
-              <a:defRPr sz="1200" b="1">
+              <a:defRPr sz="1100" b="1">
                 <a:solidFill>
                   <a:srgbClr val="0F172A"/>
                 </a:solidFill>
@@ -5997,9 +6950,9 @@
           <a:p>
             <a:pPr>
               <a:spcAft>
-                <a:spcPts val="800"/>
-              </a:spcAft>
-              <a:defRPr sz="1000">
+                <a:spcPts val="500"/>
+              </a:spcAft>
+              <a:defRPr sz="900">
                 <a:solidFill>
                   <a:srgbClr val="475569"/>
                 </a:solidFill>
@@ -6012,7 +6965,7 @@
           </a:p>
           <a:p>
             <a:pPr>
-              <a:defRPr sz="1200" b="1">
+              <a:defRPr sz="1100" b="1">
                 <a:solidFill>
                   <a:srgbClr val="0F172A"/>
                 </a:solidFill>
@@ -6026,9 +6979,9 @@
           <a:p>
             <a:pPr>
               <a:spcAft>
-                <a:spcPts val="800"/>
-              </a:spcAft>
-              <a:defRPr sz="1000">
+                <a:spcPts val="500"/>
+              </a:spcAft>
+              <a:defRPr sz="900">
                 <a:solidFill>
                   <a:srgbClr val="475569"/>
                 </a:solidFill>
@@ -6041,7 +6994,7 @@
           </a:p>
           <a:p>
             <a:pPr>
-              <a:defRPr sz="1200" b="1">
+              <a:defRPr sz="1100" b="1">
                 <a:solidFill>
                   <a:srgbClr val="0F172A"/>
                 </a:solidFill>
@@ -6055,9 +7008,9 @@
           <a:p>
             <a:pPr>
               <a:spcAft>
-                <a:spcPts val="800"/>
-              </a:spcAft>
-              <a:defRPr sz="1000">
+                <a:spcPts val="500"/>
+              </a:spcAft>
+              <a:defRPr sz="900">
                 <a:solidFill>
                   <a:srgbClr val="475569"/>
                 </a:solidFill>
@@ -6078,8 +7031,8 @@
         </p:nvSpPr>
         <p:spPr>
           <a:xfrm>
-            <a:off x="6309360" y="1645920"/>
-            <a:ext cx="5120640" cy="4389120"/>
+            <a:off x="6245352" y="1508760"/>
+            <a:ext cx="5212080" cy="4526280"/>
           </a:xfrm>
           <a:prstGeom prst="roundRect">
             <a:avLst/>
@@ -6123,8 +7076,8 @@
         </p:nvSpPr>
         <p:spPr>
           <a:xfrm>
-            <a:off x="6583680" y="1828800"/>
-            <a:ext cx="4572000" cy="4023360"/>
+            <a:off x="6473952" y="1673352"/>
+            <a:ext cx="4754880" cy="3657600"/>
           </a:xfrm>
           <a:prstGeom prst="rect">
             <a:avLst/>
@@ -6132,16 +7085,16 @@
           <a:noFill/>
         </p:spPr>
         <p:txBody>
-          <a:bodyPr wrap="square">
+          <a:bodyPr wrap="square" lIns="0" tIns="0" rIns="0" bIns="0">
             <a:spAutoFit/>
           </a:bodyPr>
           <a:lstStyle/>
           <a:p>
             <a:pPr>
               <a:spcAft>
-                <a:spcPts val="1200"/>
-              </a:spcAft>
-              <a:defRPr sz="1600" b="1">
+                <a:spcPts val="800"/>
+              </a:spcAft>
+              <a:defRPr sz="1450" b="1">
                 <a:solidFill>
                   <a:srgbClr val="1D4ED8"/>
                 </a:solidFill>
@@ -6154,7 +7107,7 @@
           </a:p>
           <a:p>
             <a:pPr>
-              <a:defRPr sz="1200" b="1">
+              <a:defRPr sz="1100" b="1">
                 <a:solidFill>
                   <a:srgbClr val="0F172A"/>
                 </a:solidFill>
@@ -6168,9 +7121,9 @@
           <a:p>
             <a:pPr>
               <a:spcAft>
-                <a:spcPts val="800"/>
-              </a:spcAft>
-              <a:defRPr sz="1000">
+                <a:spcPts val="500"/>
+              </a:spcAft>
+              <a:defRPr sz="900">
                 <a:solidFill>
                   <a:srgbClr val="475569"/>
                 </a:solidFill>
@@ -6183,7 +7136,7 @@
           </a:p>
           <a:p>
             <a:pPr>
-              <a:defRPr sz="1200" b="1">
+              <a:defRPr sz="1100" b="1">
                 <a:solidFill>
                   <a:srgbClr val="0F172A"/>
                 </a:solidFill>
@@ -6197,9 +7150,9 @@
           <a:p>
             <a:pPr>
               <a:spcAft>
-                <a:spcPts val="800"/>
-              </a:spcAft>
-              <a:defRPr sz="1000">
+                <a:spcPts val="500"/>
+              </a:spcAft>
+              <a:defRPr sz="900">
                 <a:solidFill>
                   <a:srgbClr val="475569"/>
                 </a:solidFill>
@@ -6212,7 +7165,7 @@
           </a:p>
           <a:p>
             <a:pPr>
-              <a:defRPr sz="1200" b="1">
+              <a:defRPr sz="1100" b="1">
                 <a:solidFill>
                   <a:srgbClr val="0F172A"/>
                 </a:solidFill>
@@ -6226,9 +7179,9 @@
           <a:p>
             <a:pPr>
               <a:spcAft>
-                <a:spcPts val="800"/>
-              </a:spcAft>
-              <a:defRPr sz="1000">
+                <a:spcPts val="500"/>
+              </a:spcAft>
+              <a:defRPr sz="900">
                 <a:solidFill>
                   <a:srgbClr val="475569"/>
                 </a:solidFill>
@@ -6241,7 +7194,7 @@
           </a:p>
           <a:p>
             <a:pPr>
-              <a:defRPr sz="1200" b="1">
+              <a:defRPr sz="1100" b="1">
                 <a:solidFill>
                   <a:srgbClr val="0F172A"/>
                 </a:solidFill>
@@ -6255,9 +7208,9 @@
           <a:p>
             <a:pPr>
               <a:spcAft>
-                <a:spcPts val="800"/>
-              </a:spcAft>
-              <a:defRPr sz="1000">
+                <a:spcPts val="500"/>
+              </a:spcAft>
+              <a:defRPr sz="900">
                 <a:solidFill>
                   <a:srgbClr val="475569"/>
                 </a:solidFill>
@@ -6268,24 +7221,66 @@
               <a:t>    Extending the backend APIs to power Flutter / React Native Android &amp; iOS mobile applications for subscribers.</a:t>
             </a:r>
           </a:p>
+        </p:txBody>
+      </p:sp>
+      <p:sp>
+        <p:nvSpPr>
+          <p:cNvPr id="8" name="Rounded Rectangle 7"/>
+          <p:cNvSpPr/>
+          <p:nvPr/>
+        </p:nvSpPr>
+        <p:spPr>
+          <a:xfrm>
+            <a:off x="6473952" y="5440680"/>
+            <a:ext cx="4754880" cy="438912"/>
+          </a:xfrm>
+          <a:prstGeom prst="roundRect">
+            <a:avLst/>
+          </a:prstGeom>
+          <a:solidFill>
+            <a:srgbClr val="EFF6FF"/>
+          </a:solidFill>
+          <a:ln w="12700">
+            <a:solidFill>
+              <a:srgbClr val="BFDBFE"/>
+            </a:solidFill>
+          </a:ln>
+        </p:spPr>
+        <p:style>
+          <a:lnRef idx="1">
+            <a:schemeClr val="accent1"/>
+          </a:lnRef>
+          <a:fillRef idx="3">
+            <a:schemeClr val="accent1"/>
+          </a:fillRef>
+          <a:effectRef idx="2">
+            <a:schemeClr val="accent1"/>
+          </a:effectRef>
+          <a:fontRef idx="minor">
+            <a:schemeClr val="lt1"/>
+          </a:fontRef>
+        </p:style>
+        <p:txBody>
+          <a:bodyPr rtlCol="0" anchor="ctr" lIns="0" tIns="0" rIns="0" bIns="0"/>
+          <a:lstStyle/>
           <a:p>
             <a:pPr algn="ctr">
-              <a:defRPr sz="1250" b="1">
-                <a:solidFill>
-                  <a:srgbClr val="B45309"/>
-                </a:solidFill>
-                <a:latin typeface="Segoe UI"/>
-              </a:defRPr>
-            </a:pPr>
-            <a:r>
-              <a:t>Thank You! Questions &amp; Discussion Welcome.</a:t>
-            </a:r>
-          </a:p>
-        </p:txBody>
-      </p:sp>
-      <p:sp>
-        <p:nvSpPr>
-          <p:cNvPr id="8" name="Rectangle 7"/>
+              <a:defRPr sz="1100" b="1">
+                <a:solidFill>
+                  <a:srgbClr val="1D4ED8"/>
+                </a:solidFill>
+                <a:latin typeface="Segoe UI"/>
+              </a:defRPr>
+            </a:pPr>
+            <a:r>
+              <a:t>🎉 Thank You! Questions &amp; Discussion Welcome.</a:t>
+            </a:r>
+          </a:p>
+        </p:txBody>
+      </p:sp>
+      <p:sp>
+        <p:nvSpPr>
+          <p:cNvPr id="9" name="Rectangle 8"/>
           <p:cNvSpPr/>
           <p:nvPr/>
         </p:nvSpPr>
@@ -6328,7 +7323,7 @@
       </p:sp>
       <p:sp>
         <p:nvSpPr>
-          <p:cNvPr id="9" name="TextBox 8"/>
+          <p:cNvPr id="10" name="TextBox 9"/>
           <p:cNvSpPr txBox="1"/>
           <p:nvPr/>
         </p:nvSpPr>
@@ -6499,8 +7494,8 @@
         </p:nvSpPr>
         <p:spPr>
           <a:xfrm>
-            <a:off x="731520" y="1645920"/>
-            <a:ext cx="5120640" cy="4389120"/>
+            <a:off x="731520" y="1508760"/>
+            <a:ext cx="5212080" cy="4526280"/>
           </a:xfrm>
           <a:prstGeom prst="roundRect">
             <a:avLst/>
@@ -6544,8 +7539,8 @@
         </p:nvSpPr>
         <p:spPr>
           <a:xfrm>
-            <a:off x="1005840" y="1828800"/>
-            <a:ext cx="4572000" cy="4023360"/>
+            <a:off x="960120" y="1673352"/>
+            <a:ext cx="4754880" cy="4197096"/>
           </a:xfrm>
           <a:prstGeom prst="rect">
             <a:avLst/>
@@ -6553,16 +7548,16 @@
           <a:noFill/>
         </p:spPr>
         <p:txBody>
-          <a:bodyPr wrap="square">
+          <a:bodyPr wrap="square" lIns="0" tIns="0" rIns="0" bIns="0">
             <a:spAutoFit/>
           </a:bodyPr>
           <a:lstStyle/>
           <a:p>
             <a:pPr>
               <a:spcAft>
-                <a:spcPts val="1200"/>
-              </a:spcAft>
-              <a:defRPr sz="1550" b="1">
+                <a:spcPts val="1000"/>
+              </a:spcAft>
+              <a:defRPr sz="1450" b="1">
                 <a:solidFill>
                   <a:srgbClr val="B91C1C"/>
                 </a:solidFill>
@@ -6575,7 +7570,7 @@
           </a:p>
           <a:p>
             <a:pPr>
-              <a:defRPr sz="1200" b="1">
+              <a:defRPr sz="1150" b="1">
                 <a:solidFill>
                   <a:srgbClr val="0F172A"/>
                 </a:solidFill>
@@ -6589,9 +7584,9 @@
           <a:p>
             <a:pPr>
               <a:spcAft>
-                <a:spcPts val="800"/>
-              </a:spcAft>
-              <a:defRPr sz="1050">
+                <a:spcPts val="600"/>
+              </a:spcAft>
+              <a:defRPr sz="950">
                 <a:solidFill>
                   <a:srgbClr val="475569"/>
                 </a:solidFill>
@@ -6599,12 +7594,12 @@
               </a:defRPr>
             </a:pPr>
             <a:r>
-              <a:t>    Legacy systems struggle with real-time classification of call logs into Local, STD, and ISD categories, causing calculation delays.</a:t>
-            </a:r>
-          </a:p>
-          <a:p>
-            <a:pPr>
-              <a:defRPr sz="1200" b="1">
+              <a:t>   Legacy systems struggle with real-time classification of call logs into Local, STD, and ISD categories, causing calculation delays.</a:t>
+            </a:r>
+          </a:p>
+          <a:p>
+            <a:pPr>
+              <a:defRPr sz="1150" b="1">
                 <a:solidFill>
                   <a:srgbClr val="0F172A"/>
                 </a:solidFill>
@@ -6618,9 +7613,9 @@
           <a:p>
             <a:pPr>
               <a:spcAft>
-                <a:spcPts val="800"/>
-              </a:spcAft>
-              <a:defRPr sz="1050">
+                <a:spcPts val="600"/>
+              </a:spcAft>
+              <a:defRPr sz="950">
                 <a:solidFill>
                   <a:srgbClr val="475569"/>
                 </a:solidFill>
@@ -6628,12 +7623,12 @@
               </a:defRPr>
             </a:pPr>
             <a:r>
-              <a:t>    Discrepancies in 60-second pulse rounding and inaccurate deduction of free monthly minute quotas frustrate customers.</a:t>
-            </a:r>
-          </a:p>
-          <a:p>
-            <a:pPr>
-              <a:defRPr sz="1200" b="1">
+              <a:t>   Discrepancies in 60-second pulse rounding and inaccurate deduction of free monthly minute quotas frustrate customers.</a:t>
+            </a:r>
+          </a:p>
+          <a:p>
+            <a:pPr>
+              <a:defRPr sz="1150" b="1">
                 <a:solidFill>
                   <a:srgbClr val="0F172A"/>
                 </a:solidFill>
@@ -6647,9 +7642,9 @@
           <a:p>
             <a:pPr>
               <a:spcAft>
-                <a:spcPts val="800"/>
-              </a:spcAft>
-              <a:defRPr sz="1050">
+                <a:spcPts val="600"/>
+              </a:spcAft>
+              <a:defRPr sz="950">
                 <a:solidFill>
                   <a:srgbClr val="475569"/>
                 </a:solidFill>
@@ -6657,12 +7652,12 @@
               </a:defRPr>
             </a:pPr>
             <a:r>
-              <a:t>    Non-automated handling of 18% GST (CGST 9% + SGST 9%), late fee penalties, and promotional adjustments.</a:t>
-            </a:r>
-          </a:p>
-          <a:p>
-            <a:pPr>
-              <a:defRPr sz="1200" b="1">
+              <a:t>   Non-automated handling of 18% GST (CGST 9% + SGST 9%), late fee penalties, and promotional adjustments.</a:t>
+            </a:r>
+          </a:p>
+          <a:p>
+            <a:pPr>
+              <a:defRPr sz="1150" b="1">
                 <a:solidFill>
                   <a:srgbClr val="0F172A"/>
                 </a:solidFill>
@@ -6676,9 +7671,9 @@
           <a:p>
             <a:pPr>
               <a:spcAft>
-                <a:spcPts val="800"/>
-              </a:spcAft>
-              <a:defRPr sz="1050">
+                <a:spcPts val="600"/>
+              </a:spcAft>
+              <a:defRPr sz="950">
                 <a:solidFill>
                   <a:srgbClr val="475569"/>
                 </a:solidFill>
@@ -6686,7 +7681,7 @@
               </a:defRPr>
             </a:pPr>
             <a:r>
-              <a:t>    Subscribers lack clear, itemized tax invoices showing exact call timestamps, duration, destination numbers, and cost breakdowns.</a:t>
+              <a:t>   Subscribers lack clear, itemized tax invoices showing exact call timestamps, duration, destination numbers, and cost breakdowns.</a:t>
             </a:r>
           </a:p>
         </p:txBody>
@@ -6699,8 +7694,8 @@
         </p:nvSpPr>
         <p:spPr>
           <a:xfrm>
-            <a:off x="6309360" y="1645920"/>
-            <a:ext cx="5120640" cy="4389120"/>
+            <a:off x="6217920" y="1508760"/>
+            <a:ext cx="5212080" cy="4526280"/>
           </a:xfrm>
           <a:prstGeom prst="roundRect">
             <a:avLst/>
@@ -6744,8 +7739,8 @@
         </p:nvSpPr>
         <p:spPr>
           <a:xfrm>
-            <a:off x="6583680" y="1828800"/>
-            <a:ext cx="4572000" cy="4023360"/>
+            <a:off x="6446520" y="1673352"/>
+            <a:ext cx="4754880" cy="4197096"/>
           </a:xfrm>
           <a:prstGeom prst="rect">
             <a:avLst/>
@@ -6753,16 +7748,16 @@
           <a:noFill/>
         </p:spPr>
         <p:txBody>
-          <a:bodyPr wrap="square">
+          <a:bodyPr wrap="square" lIns="0" tIns="0" rIns="0" bIns="0">
             <a:spAutoFit/>
           </a:bodyPr>
           <a:lstStyle/>
           <a:p>
             <a:pPr>
               <a:spcAft>
-                <a:spcPts val="1200"/>
-              </a:spcAft>
-              <a:defRPr sz="1550" b="1">
+                <a:spcPts val="1000"/>
+              </a:spcAft>
+              <a:defRPr sz="1450" b="1">
                 <a:solidFill>
                   <a:srgbClr val="107A57"/>
                 </a:solidFill>
@@ -6775,7 +7770,7 @@
           </a:p>
           <a:p>
             <a:pPr>
-              <a:defRPr sz="1200" b="1">
+              <a:defRPr sz="1150" b="1">
                 <a:solidFill>
                   <a:srgbClr val="0F172A"/>
                 </a:solidFill>
@@ -6789,9 +7784,9 @@
           <a:p>
             <a:pPr>
               <a:spcAft>
-                <a:spcPts val="800"/>
-              </a:spcAft>
-              <a:defRPr sz="1050">
+                <a:spcPts val="600"/>
+              </a:spcAft>
+              <a:defRPr sz="950">
                 <a:solidFill>
                   <a:srgbClr val="475569"/>
                 </a:solidFill>
@@ -6799,12 +7794,12 @@
               </a:defRPr>
             </a:pPr>
             <a:r>
-              <a:t>    Instant duration pulse conversion (60s ceil), free minutes deduction, and multi-tier rate calculation (Local, STD, ISD).</a:t>
-            </a:r>
-          </a:p>
-          <a:p>
-            <a:pPr>
-              <a:defRPr sz="1200" b="1">
+              <a:t>   Instant duration pulse conversion (60s ceil), free minutes deduction, and multi-tier rate calculation (Local, STD, ISD).</a:t>
+            </a:r>
+          </a:p>
+          <a:p>
+            <a:pPr>
+              <a:defRPr sz="1150" b="1">
                 <a:solidFill>
                   <a:srgbClr val="0F172A"/>
                 </a:solidFill>
@@ -6818,9 +7813,9 @@
           <a:p>
             <a:pPr>
               <a:spcAft>
-                <a:spcPts val="800"/>
-              </a:spcAft>
-              <a:defRPr sz="1050">
+                <a:spcPts val="600"/>
+              </a:spcAft>
+              <a:defRPr sz="950">
                 <a:solidFill>
                   <a:srgbClr val="475569"/>
                 </a:solidFill>
@@ -6828,12 +7823,12 @@
               </a:defRPr>
             </a:pPr>
             <a:r>
-              <a:t>    Real-time categorization based on international prefix (+ / 00), national STD trunk codes (022, 080), or domestic lines.</a:t>
-            </a:r>
-          </a:p>
-          <a:p>
-            <a:pPr>
-              <a:defRPr sz="1200" b="1">
+              <a:t>   Real-time categorization based on international prefix (+ / 00), national STD trunk codes (022, 080), or domestic lines.</a:t>
+            </a:r>
+          </a:p>
+          <a:p>
+            <a:pPr>
+              <a:defRPr sz="1150" b="1">
                 <a:solidFill>
                   <a:srgbClr val="0F172A"/>
                 </a:solidFill>
@@ -6847,9 +7842,9 @@
           <a:p>
             <a:pPr>
               <a:spcAft>
-                <a:spcPts val="800"/>
-              </a:spcAft>
-              <a:defRPr sz="1050">
+                <a:spcPts val="600"/>
+              </a:spcAft>
+              <a:defRPr sz="950">
                 <a:solidFill>
                   <a:srgbClr val="475569"/>
                 </a:solidFill>
@@ -6857,12 +7852,12 @@
               </a:defRPr>
             </a:pPr>
             <a:r>
-              <a:t>    Full itemized invoice layout complying with TRAI norms, featuring CGST/SGST tax breakdown, CDR tables, and OpenPDF export.</a:t>
-            </a:r>
-          </a:p>
-          <a:p>
-            <a:pPr>
-              <a:defRPr sz="1200" b="1">
+              <a:t>   Full itemized invoice layout complying with TRAI norms, featuring CGST/SGST tax breakdown, CDR tables, and OpenPDF export.</a:t>
+            </a:r>
+          </a:p>
+          <a:p>
+            <a:pPr>
+              <a:defRPr sz="1150" b="1">
                 <a:solidFill>
                   <a:srgbClr val="0F172A"/>
                 </a:solidFill>
@@ -6876,9 +7871,9 @@
           <a:p>
             <a:pPr>
               <a:spcAft>
-                <a:spcPts val="800"/>
-              </a:spcAft>
-              <a:defRPr sz="1050">
+                <a:spcPts val="600"/>
+              </a:spcAft>
+              <a:defRPr sz="950">
                 <a:solidFill>
                   <a:srgbClr val="475569"/>
                 </a:solidFill>
@@ -6886,7 +7881,7 @@
               </a:defRPr>
             </a:pPr>
             <a:r>
-              <a:t>    High-performance native Java 21 / JavaFX desktop application alongside an accessible cloud-hosted Vercel web app.</a:t>
+              <a:t>   High-performance native Java 21 / JavaFX desktop application alongside an accessible cloud-hosted Vercel web app.</a:t>
             </a:r>
           </a:p>
         </p:txBody>
@@ -7107,8 +8102,8 @@
         </p:nvSpPr>
         <p:spPr>
           <a:xfrm>
-            <a:off x="731520" y="1645920"/>
-            <a:ext cx="2514600" cy="4389120"/>
+            <a:off x="731520" y="1508760"/>
+            <a:ext cx="2542032" cy="4526280"/>
           </a:xfrm>
           <a:prstGeom prst="roundRect">
             <a:avLst/>
@@ -7152,8 +8147,8 @@
         </p:nvSpPr>
         <p:spPr>
           <a:xfrm>
-            <a:off x="914400" y="1828800"/>
-            <a:ext cx="2148840" cy="4023360"/>
+            <a:off x="896112" y="1673352"/>
+            <a:ext cx="2212848" cy="4197096"/>
           </a:xfrm>
           <a:prstGeom prst="rect">
             <a:avLst/>
@@ -7161,16 +8156,16 @@
           <a:noFill/>
         </p:spPr>
         <p:txBody>
-          <a:bodyPr wrap="square">
+          <a:bodyPr wrap="square" lIns="0" tIns="0" rIns="0" bIns="0">
             <a:spAutoFit/>
           </a:bodyPr>
           <a:lstStyle/>
           <a:p>
             <a:pPr>
               <a:spcAft>
-                <a:spcPts val="1200"/>
-              </a:spcAft>
-              <a:defRPr sz="1300" b="1">
+                <a:spcPts val="1000"/>
+              </a:spcAft>
+              <a:defRPr sz="1200" b="1">
                 <a:solidFill>
                   <a:srgbClr val="0E7490"/>
                 </a:solidFill>
@@ -7183,7 +8178,7 @@
           </a:p>
           <a:p>
             <a:pPr>
-              <a:defRPr sz="1100" b="1">
+              <a:defRPr sz="1050" b="1">
                 <a:solidFill>
                   <a:srgbClr val="0F172A"/>
                 </a:solidFill>
@@ -7197,9 +8192,9 @@
           <a:p>
             <a:pPr>
               <a:spcAft>
-                <a:spcPts val="800"/>
-              </a:spcAft>
-              <a:defRPr sz="950">
+                <a:spcPts val="500"/>
+              </a:spcAft>
+              <a:defRPr sz="900">
                 <a:solidFill>
                   <a:srgbClr val="475569"/>
                 </a:solidFill>
@@ -7212,7 +8207,7 @@
           </a:p>
           <a:p>
             <a:pPr>
-              <a:defRPr sz="1100" b="1">
+              <a:defRPr sz="1050" b="1">
                 <a:solidFill>
                   <a:srgbClr val="0F172A"/>
                 </a:solidFill>
@@ -7226,9 +8221,9 @@
           <a:p>
             <a:pPr>
               <a:spcAft>
-                <a:spcPts val="800"/>
-              </a:spcAft>
-              <a:defRPr sz="950">
+                <a:spcPts val="500"/>
+              </a:spcAft>
+              <a:defRPr sz="900">
                 <a:solidFill>
                   <a:srgbClr val="475569"/>
                 </a:solidFill>
@@ -7241,7 +8236,7 @@
           </a:p>
           <a:p>
             <a:pPr>
-              <a:defRPr sz="1100" b="1">
+              <a:defRPr sz="1050" b="1">
                 <a:solidFill>
                   <a:srgbClr val="0F172A"/>
                 </a:solidFill>
@@ -7255,9 +8250,9 @@
           <a:p>
             <a:pPr>
               <a:spcAft>
-                <a:spcPts val="800"/>
-              </a:spcAft>
-              <a:defRPr sz="950">
+                <a:spcPts val="500"/>
+              </a:spcAft>
+              <a:defRPr sz="900">
                 <a:solidFill>
                   <a:srgbClr val="475569"/>
                 </a:solidFill>
@@ -7270,7 +8265,7 @@
           </a:p>
           <a:p>
             <a:pPr>
-              <a:defRPr sz="1100" b="1">
+              <a:defRPr sz="1050" b="1">
                 <a:solidFill>
                   <a:srgbClr val="0F172A"/>
                 </a:solidFill>
@@ -7284,9 +8279,9 @@
           <a:p>
             <a:pPr>
               <a:spcAft>
-                <a:spcPts val="800"/>
-              </a:spcAft>
-              <a:defRPr sz="950">
+                <a:spcPts val="500"/>
+              </a:spcAft>
+              <a:defRPr sz="900">
                 <a:solidFill>
                   <a:srgbClr val="475569"/>
                 </a:solidFill>
@@ -7307,8 +8302,8 @@
         </p:nvSpPr>
         <p:spPr>
           <a:xfrm>
-            <a:off x="3429000" y="1645920"/>
-            <a:ext cx="2514600" cy="4389120"/>
+            <a:off x="3456432" y="1508760"/>
+            <a:ext cx="2542032" cy="4526280"/>
           </a:xfrm>
           <a:prstGeom prst="roundRect">
             <a:avLst/>
@@ -7352,8 +8347,8 @@
         </p:nvSpPr>
         <p:spPr>
           <a:xfrm>
-            <a:off x="3611880" y="1828800"/>
-            <a:ext cx="2148840" cy="4023360"/>
+            <a:off x="3621024" y="1673352"/>
+            <a:ext cx="2212848" cy="4197096"/>
           </a:xfrm>
           <a:prstGeom prst="rect">
             <a:avLst/>
@@ -7361,16 +8356,16 @@
           <a:noFill/>
         </p:spPr>
         <p:txBody>
-          <a:bodyPr wrap="square">
+          <a:bodyPr wrap="square" lIns="0" tIns="0" rIns="0" bIns="0">
             <a:spAutoFit/>
           </a:bodyPr>
           <a:lstStyle/>
           <a:p>
             <a:pPr>
               <a:spcAft>
-                <a:spcPts val="1200"/>
-              </a:spcAft>
-              <a:defRPr sz="1300" b="1">
+                <a:spcPts val="1000"/>
+              </a:spcAft>
+              <a:defRPr sz="1200" b="1">
                 <a:solidFill>
                   <a:srgbClr val="1D4ED8"/>
                 </a:solidFill>
@@ -7383,7 +8378,7 @@
           </a:p>
           <a:p>
             <a:pPr>
-              <a:defRPr sz="1100" b="1">
+              <a:defRPr sz="1050" b="1">
                 <a:solidFill>
                   <a:srgbClr val="0F172A"/>
                 </a:solidFill>
@@ -7397,9 +8392,9 @@
           <a:p>
             <a:pPr>
               <a:spcAft>
-                <a:spcPts val="800"/>
-              </a:spcAft>
-              <a:defRPr sz="950">
+                <a:spcPts val="500"/>
+              </a:spcAft>
+              <a:defRPr sz="900">
                 <a:solidFill>
                   <a:srgbClr val="475569"/>
                 </a:solidFill>
@@ -7412,7 +8407,7 @@
           </a:p>
           <a:p>
             <a:pPr>
-              <a:defRPr sz="1100" b="1">
+              <a:defRPr sz="1050" b="1">
                 <a:solidFill>
                   <a:srgbClr val="0F172A"/>
                 </a:solidFill>
@@ -7426,9 +8421,9 @@
           <a:p>
             <a:pPr>
               <a:spcAft>
-                <a:spcPts val="800"/>
-              </a:spcAft>
-              <a:defRPr sz="950">
+                <a:spcPts val="500"/>
+              </a:spcAft>
+              <a:defRPr sz="900">
                 <a:solidFill>
                   <a:srgbClr val="475569"/>
                 </a:solidFill>
@@ -7441,7 +8436,7 @@
           </a:p>
           <a:p>
             <a:pPr>
-              <a:defRPr sz="1100" b="1">
+              <a:defRPr sz="1050" b="1">
                 <a:solidFill>
                   <a:srgbClr val="0F172A"/>
                 </a:solidFill>
@@ -7455,9 +8450,9 @@
           <a:p>
             <a:pPr>
               <a:spcAft>
-                <a:spcPts val="800"/>
-              </a:spcAft>
-              <a:defRPr sz="950">
+                <a:spcPts val="500"/>
+              </a:spcAft>
+              <a:defRPr sz="900">
                 <a:solidFill>
                   <a:srgbClr val="475569"/>
                 </a:solidFill>
@@ -7470,7 +8465,7 @@
           </a:p>
           <a:p>
             <a:pPr>
-              <a:defRPr sz="1100" b="1">
+              <a:defRPr sz="1050" b="1">
                 <a:solidFill>
                   <a:srgbClr val="0F172A"/>
                 </a:solidFill>
@@ -7484,9 +8479,9 @@
           <a:p>
             <a:pPr>
               <a:spcAft>
-                <a:spcPts val="800"/>
-              </a:spcAft>
-              <a:defRPr sz="950">
+                <a:spcPts val="500"/>
+              </a:spcAft>
+              <a:defRPr sz="900">
                 <a:solidFill>
                   <a:srgbClr val="475569"/>
                 </a:solidFill>
@@ -7507,8 +8502,8 @@
         </p:nvSpPr>
         <p:spPr>
           <a:xfrm>
-            <a:off x="6126480" y="1645920"/>
-            <a:ext cx="2514600" cy="4389120"/>
+            <a:off x="6181344" y="1508760"/>
+            <a:ext cx="2542032" cy="4526280"/>
           </a:xfrm>
           <a:prstGeom prst="roundRect">
             <a:avLst/>
@@ -7552,8 +8547,8 @@
         </p:nvSpPr>
         <p:spPr>
           <a:xfrm>
-            <a:off x="6309360" y="1828800"/>
-            <a:ext cx="2148840" cy="4023360"/>
+            <a:off x="6345936" y="1673352"/>
+            <a:ext cx="2212848" cy="4197096"/>
           </a:xfrm>
           <a:prstGeom prst="rect">
             <a:avLst/>
@@ -7561,16 +8556,16 @@
           <a:noFill/>
         </p:spPr>
         <p:txBody>
-          <a:bodyPr wrap="square">
+          <a:bodyPr wrap="square" lIns="0" tIns="0" rIns="0" bIns="0">
             <a:spAutoFit/>
           </a:bodyPr>
           <a:lstStyle/>
           <a:p>
             <a:pPr>
               <a:spcAft>
-                <a:spcPts val="1200"/>
-              </a:spcAft>
-              <a:defRPr sz="1300" b="1">
+                <a:spcPts val="1000"/>
+              </a:spcAft>
+              <a:defRPr sz="1200" b="1">
                 <a:solidFill>
                   <a:srgbClr val="107A57"/>
                 </a:solidFill>
@@ -7583,7 +8578,7 @@
           </a:p>
           <a:p>
             <a:pPr>
-              <a:defRPr sz="1100" b="1">
+              <a:defRPr sz="1050" b="1">
                 <a:solidFill>
                   <a:srgbClr val="0F172A"/>
                 </a:solidFill>
@@ -7597,9 +8592,9 @@
           <a:p>
             <a:pPr>
               <a:spcAft>
-                <a:spcPts val="800"/>
-              </a:spcAft>
-              <a:defRPr sz="950">
+                <a:spcPts val="500"/>
+              </a:spcAft>
+              <a:defRPr sz="900">
                 <a:solidFill>
                   <a:srgbClr val="475569"/>
                 </a:solidFill>
@@ -7612,7 +8607,7 @@
           </a:p>
           <a:p>
             <a:pPr>
-              <a:defRPr sz="1100" b="1">
+              <a:defRPr sz="1050" b="1">
                 <a:solidFill>
                   <a:srgbClr val="0F172A"/>
                 </a:solidFill>
@@ -7626,9 +8621,9 @@
           <a:p>
             <a:pPr>
               <a:spcAft>
-                <a:spcPts val="800"/>
-              </a:spcAft>
-              <a:defRPr sz="950">
+                <a:spcPts val="500"/>
+              </a:spcAft>
+              <a:defRPr sz="900">
                 <a:solidFill>
                   <a:srgbClr val="475569"/>
                 </a:solidFill>
@@ -7641,7 +8636,7 @@
           </a:p>
           <a:p>
             <a:pPr>
-              <a:defRPr sz="1100" b="1">
+              <a:defRPr sz="1050" b="1">
                 <a:solidFill>
                   <a:srgbClr val="0F172A"/>
                 </a:solidFill>
@@ -7655,9 +8650,9 @@
           <a:p>
             <a:pPr>
               <a:spcAft>
-                <a:spcPts val="800"/>
-              </a:spcAft>
-              <a:defRPr sz="950">
+                <a:spcPts val="500"/>
+              </a:spcAft>
+              <a:defRPr sz="900">
                 <a:solidFill>
                   <a:srgbClr val="475569"/>
                 </a:solidFill>
@@ -7670,7 +8665,7 @@
           </a:p>
           <a:p>
             <a:pPr>
-              <a:defRPr sz="1100" b="1">
+              <a:defRPr sz="1050" b="1">
                 <a:solidFill>
                   <a:srgbClr val="0F172A"/>
                 </a:solidFill>
@@ -7684,9 +8679,9 @@
           <a:p>
             <a:pPr>
               <a:spcAft>
-                <a:spcPts val="800"/>
-              </a:spcAft>
-              <a:defRPr sz="950">
+                <a:spcPts val="500"/>
+              </a:spcAft>
+              <a:defRPr sz="900">
                 <a:solidFill>
                   <a:srgbClr val="475569"/>
                 </a:solidFill>
@@ -7707,8 +8702,8 @@
         </p:nvSpPr>
         <p:spPr>
           <a:xfrm>
-            <a:off x="8823960" y="1645920"/>
-            <a:ext cx="2514600" cy="4389120"/>
+            <a:off x="8906256" y="1508760"/>
+            <a:ext cx="2542032" cy="4526280"/>
           </a:xfrm>
           <a:prstGeom prst="roundRect">
             <a:avLst/>
@@ -7752,8 +8747,8 @@
         </p:nvSpPr>
         <p:spPr>
           <a:xfrm>
-            <a:off x="9006840" y="1828800"/>
-            <a:ext cx="2148840" cy="4023360"/>
+            <a:off x="9070848" y="1673352"/>
+            <a:ext cx="2212848" cy="4197096"/>
           </a:xfrm>
           <a:prstGeom prst="rect">
             <a:avLst/>
@@ -7761,16 +8756,16 @@
           <a:noFill/>
         </p:spPr>
         <p:txBody>
-          <a:bodyPr wrap="square">
+          <a:bodyPr wrap="square" lIns="0" tIns="0" rIns="0" bIns="0">
             <a:spAutoFit/>
           </a:bodyPr>
           <a:lstStyle/>
           <a:p>
             <a:pPr>
               <a:spcAft>
-                <a:spcPts val="1200"/>
-              </a:spcAft>
-              <a:defRPr sz="1300" b="1">
+                <a:spcPts val="1000"/>
+              </a:spcAft>
+              <a:defRPr sz="1200" b="1">
                 <a:solidFill>
                   <a:srgbClr val="B45309"/>
                 </a:solidFill>
@@ -7783,7 +8778,7 @@
           </a:p>
           <a:p>
             <a:pPr>
-              <a:defRPr sz="1100" b="1">
+              <a:defRPr sz="1050" b="1">
                 <a:solidFill>
                   <a:srgbClr val="0F172A"/>
                 </a:solidFill>
@@ -7797,9 +8792,9 @@
           <a:p>
             <a:pPr>
               <a:spcAft>
-                <a:spcPts val="800"/>
-              </a:spcAft>
-              <a:defRPr sz="950">
+                <a:spcPts val="500"/>
+              </a:spcAft>
+              <a:defRPr sz="900">
                 <a:solidFill>
                   <a:srgbClr val="475569"/>
                 </a:solidFill>
@@ -7812,7 +8807,7 @@
           </a:p>
           <a:p>
             <a:pPr>
-              <a:defRPr sz="1100" b="1">
+              <a:defRPr sz="1050" b="1">
                 <a:solidFill>
                   <a:srgbClr val="0F172A"/>
                 </a:solidFill>
@@ -7826,9 +8821,9 @@
           <a:p>
             <a:pPr>
               <a:spcAft>
-                <a:spcPts val="800"/>
-              </a:spcAft>
-              <a:defRPr sz="950">
+                <a:spcPts val="500"/>
+              </a:spcAft>
+              <a:defRPr sz="900">
                 <a:solidFill>
                   <a:srgbClr val="475569"/>
                 </a:solidFill>
@@ -7841,7 +8836,7 @@
           </a:p>
           <a:p>
             <a:pPr>
-              <a:defRPr sz="1100" b="1">
+              <a:defRPr sz="1050" b="1">
                 <a:solidFill>
                   <a:srgbClr val="0F172A"/>
                 </a:solidFill>
@@ -7855,9 +8850,9 @@
           <a:p>
             <a:pPr>
               <a:spcAft>
-                <a:spcPts val="800"/>
-              </a:spcAft>
-              <a:defRPr sz="950">
+                <a:spcPts val="500"/>
+              </a:spcAft>
+              <a:defRPr sz="900">
                 <a:solidFill>
                   <a:srgbClr val="475569"/>
                 </a:solidFill>
@@ -7870,7 +8865,7 @@
           </a:p>
           <a:p>
             <a:pPr>
-              <a:defRPr sz="1100" b="1">
+              <a:defRPr sz="1050" b="1">
                 <a:solidFill>
                   <a:srgbClr val="0F172A"/>
                 </a:solidFill>
@@ -7884,9 +8879,9 @@
           <a:p>
             <a:pPr>
               <a:spcAft>
-                <a:spcPts val="800"/>
-              </a:spcAft>
-              <a:defRPr sz="950">
+                <a:spcPts val="500"/>
+              </a:spcAft>
+              <a:defRPr sz="900">
                 <a:solidFill>
                   <a:srgbClr val="475569"/>
                 </a:solidFill>
@@ -8115,8 +9110,8 @@
         </p:nvSpPr>
         <p:spPr>
           <a:xfrm>
-            <a:off x="731520" y="1645920"/>
-            <a:ext cx="3429000" cy="2011680"/>
+            <a:off x="731520" y="1508760"/>
+            <a:ext cx="3456432" cy="2121408"/>
           </a:xfrm>
           <a:prstGeom prst="roundRect">
             <a:avLst/>
@@ -8160,8 +9155,8 @@
         </p:nvSpPr>
         <p:spPr>
           <a:xfrm>
-            <a:off x="960120" y="1828800"/>
-            <a:ext cx="2971800" cy="1645920"/>
+            <a:off x="932688" y="1673352"/>
+            <a:ext cx="3054096" cy="1792224"/>
           </a:xfrm>
           <a:prstGeom prst="rect">
             <a:avLst/>
@@ -8169,7 +9164,7 @@
           <a:noFill/>
         </p:spPr>
         <p:txBody>
-          <a:bodyPr wrap="square">
+          <a:bodyPr wrap="square" lIns="0" tIns="0" rIns="0" bIns="0">
             <a:spAutoFit/>
           </a:bodyPr>
           <a:lstStyle/>
@@ -8178,7 +9173,7 @@
               <a:spcAft>
                 <a:spcPts val="200"/>
               </a:spcAft>
-              <a:defRPr sz="950" b="1">
+              <a:defRPr sz="900" b="1">
                 <a:solidFill>
                   <a:srgbClr val="1D4ED8"/>
                 </a:solidFill>
@@ -8192,9 +9187,9 @@
           <a:p>
             <a:pPr>
               <a:spcAft>
-                <a:spcPts val="600"/>
-              </a:spcAft>
-              <a:defRPr sz="1450" b="1">
+                <a:spcPts val="400"/>
+              </a:spcAft>
+              <a:defRPr sz="1350" b="1">
                 <a:solidFill>
                   <a:srgbClr val="0F172A"/>
                 </a:solidFill>
@@ -8207,7 +9202,7 @@
           </a:p>
           <a:p>
             <a:pPr>
-              <a:defRPr sz="1000">
+              <a:defRPr sz="950">
                 <a:solidFill>
                   <a:srgbClr val="475569"/>
                 </a:solidFill>
@@ -8228,8 +9223,8 @@
         </p:nvSpPr>
         <p:spPr>
           <a:xfrm>
-            <a:off x="4343400" y="1645920"/>
-            <a:ext cx="3429000" cy="2011680"/>
+            <a:off x="4370832" y="1508760"/>
+            <a:ext cx="3456432" cy="2121408"/>
           </a:xfrm>
           <a:prstGeom prst="roundRect">
             <a:avLst/>
@@ -8273,8 +9268,8 @@
         </p:nvSpPr>
         <p:spPr>
           <a:xfrm>
-            <a:off x="4572000" y="1828800"/>
-            <a:ext cx="2971800" cy="1645920"/>
+            <a:off x="4572000" y="1673352"/>
+            <a:ext cx="3054096" cy="1792224"/>
           </a:xfrm>
           <a:prstGeom prst="rect">
             <a:avLst/>
@@ -8282,7 +9277,7 @@
           <a:noFill/>
         </p:spPr>
         <p:txBody>
-          <a:bodyPr wrap="square">
+          <a:bodyPr wrap="square" lIns="0" tIns="0" rIns="0" bIns="0">
             <a:spAutoFit/>
           </a:bodyPr>
           <a:lstStyle/>
@@ -8291,7 +9286,7 @@
               <a:spcAft>
                 <a:spcPts val="200"/>
               </a:spcAft>
-              <a:defRPr sz="950" b="1">
+              <a:defRPr sz="900" b="1">
                 <a:solidFill>
                   <a:srgbClr val="0E7490"/>
                 </a:solidFill>
@@ -8305,9 +9300,9 @@
           <a:p>
             <a:pPr>
               <a:spcAft>
-                <a:spcPts val="600"/>
-              </a:spcAft>
-              <a:defRPr sz="1450" b="1">
+                <a:spcPts val="400"/>
+              </a:spcAft>
+              <a:defRPr sz="1350" b="1">
                 <a:solidFill>
                   <a:srgbClr val="0F172A"/>
                 </a:solidFill>
@@ -8320,7 +9315,7 @@
           </a:p>
           <a:p>
             <a:pPr>
-              <a:defRPr sz="1000">
+              <a:defRPr sz="950">
                 <a:solidFill>
                   <a:srgbClr val="475569"/>
                 </a:solidFill>
@@ -8341,8 +9336,8 @@
         </p:nvSpPr>
         <p:spPr>
           <a:xfrm>
-            <a:off x="7955280" y="1645920"/>
-            <a:ext cx="3429000" cy="2011680"/>
+            <a:off x="8010144" y="1508760"/>
+            <a:ext cx="3456432" cy="2121408"/>
           </a:xfrm>
           <a:prstGeom prst="roundRect">
             <a:avLst/>
@@ -8386,8 +9381,8 @@
         </p:nvSpPr>
         <p:spPr>
           <a:xfrm>
-            <a:off x="8183880" y="1828800"/>
-            <a:ext cx="2971800" cy="1645920"/>
+            <a:off x="8211312" y="1673352"/>
+            <a:ext cx="3054096" cy="1792224"/>
           </a:xfrm>
           <a:prstGeom prst="rect">
             <a:avLst/>
@@ -8395,7 +9390,7 @@
           <a:noFill/>
         </p:spPr>
         <p:txBody>
-          <a:bodyPr wrap="square">
+          <a:bodyPr wrap="square" lIns="0" tIns="0" rIns="0" bIns="0">
             <a:spAutoFit/>
           </a:bodyPr>
           <a:lstStyle/>
@@ -8404,7 +9399,7 @@
               <a:spcAft>
                 <a:spcPts val="200"/>
               </a:spcAft>
-              <a:defRPr sz="950" b="1">
+              <a:defRPr sz="900" b="1">
                 <a:solidFill>
                   <a:srgbClr val="107A57"/>
                 </a:solidFill>
@@ -8418,9 +9413,9 @@
           <a:p>
             <a:pPr>
               <a:spcAft>
-                <a:spcPts val="600"/>
-              </a:spcAft>
-              <a:defRPr sz="1450" b="1">
+                <a:spcPts val="400"/>
+              </a:spcAft>
+              <a:defRPr sz="1350" b="1">
                 <a:solidFill>
                   <a:srgbClr val="0F172A"/>
                 </a:solidFill>
@@ -8433,7 +9428,7 @@
           </a:p>
           <a:p>
             <a:pPr>
-              <a:defRPr sz="1000">
+              <a:defRPr sz="950">
                 <a:solidFill>
                   <a:srgbClr val="475569"/>
                 </a:solidFill>
@@ -8454,8 +9449,8 @@
         </p:nvSpPr>
         <p:spPr>
           <a:xfrm>
-            <a:off x="731520" y="3840480"/>
-            <a:ext cx="3429000" cy="2011680"/>
+            <a:off x="731520" y="3813048"/>
+            <a:ext cx="3456432" cy="2121408"/>
           </a:xfrm>
           <a:prstGeom prst="roundRect">
             <a:avLst/>
@@ -8499,8 +9494,8 @@
         </p:nvSpPr>
         <p:spPr>
           <a:xfrm>
-            <a:off x="960120" y="4023360"/>
-            <a:ext cx="2971800" cy="1645920"/>
+            <a:off x="932688" y="3977640"/>
+            <a:ext cx="3054096" cy="1792224"/>
           </a:xfrm>
           <a:prstGeom prst="rect">
             <a:avLst/>
@@ -8508,7 +9503,7 @@
           <a:noFill/>
         </p:spPr>
         <p:txBody>
-          <a:bodyPr wrap="square">
+          <a:bodyPr wrap="square" lIns="0" tIns="0" rIns="0" bIns="0">
             <a:spAutoFit/>
           </a:bodyPr>
           <a:lstStyle/>
@@ -8517,7 +9512,7 @@
               <a:spcAft>
                 <a:spcPts val="200"/>
               </a:spcAft>
-              <a:defRPr sz="950" b="1">
+              <a:defRPr sz="900" b="1">
                 <a:solidFill>
                   <a:srgbClr val="B45309"/>
                 </a:solidFill>
@@ -8531,9 +9526,9 @@
           <a:p>
             <a:pPr>
               <a:spcAft>
-                <a:spcPts val="600"/>
-              </a:spcAft>
-              <a:defRPr sz="1450" b="1">
+                <a:spcPts val="400"/>
+              </a:spcAft>
+              <a:defRPr sz="1350" b="1">
                 <a:solidFill>
                   <a:srgbClr val="0F172A"/>
                 </a:solidFill>
@@ -8546,7 +9541,7 @@
           </a:p>
           <a:p>
             <a:pPr>
-              <a:defRPr sz="1000">
+              <a:defRPr sz="950">
                 <a:solidFill>
                   <a:srgbClr val="475569"/>
                 </a:solidFill>
@@ -8567,8 +9562,8 @@
         </p:nvSpPr>
         <p:spPr>
           <a:xfrm>
-            <a:off x="4343400" y="3840480"/>
-            <a:ext cx="3429000" cy="2011680"/>
+            <a:off x="4370832" y="3813048"/>
+            <a:ext cx="3456432" cy="2121408"/>
           </a:xfrm>
           <a:prstGeom prst="roundRect">
             <a:avLst/>
@@ -8612,8 +9607,8 @@
         </p:nvSpPr>
         <p:spPr>
           <a:xfrm>
-            <a:off x="4572000" y="4023360"/>
-            <a:ext cx="2971800" cy="1645920"/>
+            <a:off x="4572000" y="3977640"/>
+            <a:ext cx="3054096" cy="1792224"/>
           </a:xfrm>
           <a:prstGeom prst="rect">
             <a:avLst/>
@@ -8621,7 +9616,7 @@
           <a:noFill/>
         </p:spPr>
         <p:txBody>
-          <a:bodyPr wrap="square">
+          <a:bodyPr wrap="square" lIns="0" tIns="0" rIns="0" bIns="0">
             <a:spAutoFit/>
           </a:bodyPr>
           <a:lstStyle/>
@@ -8630,7 +9625,7 @@
               <a:spcAft>
                 <a:spcPts val="200"/>
               </a:spcAft>
-              <a:defRPr sz="950" b="1">
+              <a:defRPr sz="900" b="1">
                 <a:solidFill>
                   <a:srgbClr val="1D4ED8"/>
                 </a:solidFill>
@@ -8644,9 +9639,9 @@
           <a:p>
             <a:pPr>
               <a:spcAft>
-                <a:spcPts val="600"/>
-              </a:spcAft>
-              <a:defRPr sz="1450" b="1">
+                <a:spcPts val="400"/>
+              </a:spcAft>
+              <a:defRPr sz="1350" b="1">
                 <a:solidFill>
                   <a:srgbClr val="0F172A"/>
                 </a:solidFill>
@@ -8659,7 +9654,7 @@
           </a:p>
           <a:p>
             <a:pPr>
-              <a:defRPr sz="1000">
+              <a:defRPr sz="950">
                 <a:solidFill>
                   <a:srgbClr val="475569"/>
                 </a:solidFill>
@@ -8680,8 +9675,8 @@
         </p:nvSpPr>
         <p:spPr>
           <a:xfrm>
-            <a:off x="7955280" y="3840480"/>
-            <a:ext cx="3429000" cy="2011680"/>
+            <a:off x="8010144" y="3813048"/>
+            <a:ext cx="3456432" cy="2121408"/>
           </a:xfrm>
           <a:prstGeom prst="roundRect">
             <a:avLst/>
@@ -8725,8 +9720,8 @@
         </p:nvSpPr>
         <p:spPr>
           <a:xfrm>
-            <a:off x="8183880" y="4023360"/>
-            <a:ext cx="2971800" cy="1645920"/>
+            <a:off x="8211312" y="3977640"/>
+            <a:ext cx="3054096" cy="1792224"/>
           </a:xfrm>
           <a:prstGeom prst="rect">
             <a:avLst/>
@@ -8734,7 +9729,7 @@
           <a:noFill/>
         </p:spPr>
         <p:txBody>
-          <a:bodyPr wrap="square">
+          <a:bodyPr wrap="square" lIns="0" tIns="0" rIns="0" bIns="0">
             <a:spAutoFit/>
           </a:bodyPr>
           <a:lstStyle/>
@@ -8743,7 +9738,7 @@
               <a:spcAft>
                 <a:spcPts val="200"/>
               </a:spcAft>
-              <a:defRPr sz="950" b="1">
+              <a:defRPr sz="900" b="1">
                 <a:solidFill>
                   <a:srgbClr val="107A57"/>
                 </a:solidFill>
@@ -8757,9 +9752,9 @@
           <a:p>
             <a:pPr>
               <a:spcAft>
-                <a:spcPts val="600"/>
-              </a:spcAft>
-              <a:defRPr sz="1450" b="1">
+                <a:spcPts val="400"/>
+              </a:spcAft>
+              <a:defRPr sz="1350" b="1">
                 <a:solidFill>
                   <a:srgbClr val="0F172A"/>
                 </a:solidFill>
@@ -8772,7 +9767,7 @@
           </a:p>
           <a:p>
             <a:pPr>
-              <a:defRPr sz="1000">
+              <a:defRPr sz="950">
                 <a:solidFill>
                   <a:srgbClr val="475569"/>
                 </a:solidFill>
@@ -9001,8 +9996,8 @@
         </p:nvSpPr>
         <p:spPr>
           <a:xfrm>
-            <a:off x="731520" y="1645920"/>
-            <a:ext cx="5029200" cy="4389120"/>
+            <a:off x="731520" y="1508760"/>
+            <a:ext cx="4937760" cy="4526280"/>
           </a:xfrm>
           <a:prstGeom prst="roundRect">
             <a:avLst/>
@@ -9046,8 +10041,8 @@
         </p:nvSpPr>
         <p:spPr>
           <a:xfrm>
-            <a:off x="1005840" y="1828800"/>
-            <a:ext cx="4480560" cy="4023360"/>
+            <a:off x="960120" y="1673352"/>
+            <a:ext cx="4480560" cy="4197096"/>
           </a:xfrm>
           <a:prstGeom prst="rect">
             <a:avLst/>
@@ -9055,13 +10050,13 @@
           <a:noFill/>
         </p:spPr>
         <p:txBody>
-          <a:bodyPr wrap="square">
+          <a:bodyPr wrap="square" lIns="0" tIns="0" rIns="0" bIns="0">
             <a:spAutoFit/>
           </a:bodyPr>
           <a:lstStyle/>
           <a:p>
             <a:pPr>
-              <a:defRPr sz="1200" b="1">
+              <a:defRPr sz="1150" b="1">
                 <a:solidFill>
                   <a:srgbClr val="1D4ED8"/>
                 </a:solidFill>
@@ -9075,9 +10070,9 @@
           <a:p>
             <a:pPr>
               <a:spcAft>
-                <a:spcPts val="900"/>
-              </a:spcAft>
-              <a:defRPr sz="1050">
+                <a:spcPts val="600"/>
+              </a:spcAft>
+              <a:defRPr sz="950">
                 <a:solidFill>
                   <a:srgbClr val="475569"/>
                 </a:solidFill>
@@ -9090,7 +10085,7 @@
           </a:p>
           <a:p>
             <a:pPr>
-              <a:defRPr sz="1200" b="1">
+              <a:defRPr sz="1150" b="1">
                 <a:solidFill>
                   <a:srgbClr val="0F172A"/>
                 </a:solidFill>
@@ -9104,9 +10099,9 @@
           <a:p>
             <a:pPr>
               <a:spcAft>
-                <a:spcPts val="900"/>
-              </a:spcAft>
-              <a:defRPr sz="1050">
+                <a:spcPts val="600"/>
+              </a:spcAft>
+              <a:defRPr sz="950">
                 <a:solidFill>
                   <a:srgbClr val="475569"/>
                 </a:solidFill>
@@ -9119,7 +10114,7 @@
           </a:p>
           <a:p>
             <a:pPr>
-              <a:defRPr sz="1200" b="1">
+              <a:defRPr sz="1150" b="1">
                 <a:solidFill>
                   <a:srgbClr val="0F172A"/>
                 </a:solidFill>
@@ -9133,9 +10128,9 @@
           <a:p>
             <a:pPr>
               <a:spcAft>
-                <a:spcPts val="900"/>
-              </a:spcAft>
-              <a:defRPr sz="1050">
+                <a:spcPts val="600"/>
+              </a:spcAft>
+              <a:defRPr sz="950">
                 <a:solidFill>
                   <a:srgbClr val="475569"/>
                 </a:solidFill>
@@ -9148,7 +10143,7 @@
           </a:p>
           <a:p>
             <a:pPr>
-              <a:defRPr sz="1200" b="1">
+              <a:defRPr sz="1150" b="1">
                 <a:solidFill>
                   <a:srgbClr val="0F172A"/>
                 </a:solidFill>
@@ -9162,9 +10157,9 @@
           <a:p>
             <a:pPr>
               <a:spcAft>
-                <a:spcPts val="900"/>
-              </a:spcAft>
-              <a:defRPr sz="1050">
+                <a:spcPts val="600"/>
+              </a:spcAft>
+              <a:defRPr sz="950">
                 <a:solidFill>
                   <a:srgbClr val="475569"/>
                 </a:solidFill>
@@ -9185,8 +10180,8 @@
         </p:nvSpPr>
         <p:spPr>
           <a:xfrm>
-            <a:off x="6035040" y="1645920"/>
-            <a:ext cx="5394960" cy="4389120"/>
+            <a:off x="5925312" y="1508760"/>
+            <a:ext cx="5532120" cy="4526280"/>
           </a:xfrm>
           <a:prstGeom prst="roundRect">
             <a:avLst/>
@@ -9238,8 +10233,8 @@
         </p:blipFill>
         <p:spPr>
           <a:xfrm>
-            <a:off x="6172200" y="1783080"/>
-            <a:ext cx="5120640" cy="3840480"/>
+            <a:off x="6383888" y="1691640"/>
+            <a:ext cx="4614967" cy="3566160"/>
           </a:xfrm>
           <a:prstGeom prst="rect">
             <a:avLst/>
@@ -9248,28 +10243,47 @@
       </p:pic>
       <p:sp>
         <p:nvSpPr>
-          <p:cNvPr id="8" name="TextBox 7"/>
-          <p:cNvSpPr txBox="1"/>
-          <p:nvPr/>
-        </p:nvSpPr>
-        <p:spPr>
-          <a:xfrm>
-            <a:off x="6172200" y="5669280"/>
-            <a:ext cx="5120640" cy="274320"/>
-          </a:xfrm>
-          <a:prstGeom prst="rect">
-            <a:avLst/>
-          </a:prstGeom>
-          <a:noFill/>
-        </p:spPr>
-        <p:txBody>
-          <a:bodyPr wrap="none">
-            <a:spAutoFit/>
-          </a:bodyPr>
+          <p:cNvPr id="8" name="Rounded Rectangle 7"/>
+          <p:cNvSpPr/>
+          <p:nvPr/>
+        </p:nvSpPr>
+        <p:spPr>
+          <a:xfrm>
+            <a:off x="6222492" y="5486399"/>
+            <a:ext cx="4937760" cy="347472"/>
+          </a:xfrm>
+          <a:prstGeom prst="roundRect">
+            <a:avLst/>
+          </a:prstGeom>
+          <a:solidFill>
+            <a:srgbClr val="F8FAFC"/>
+          </a:solidFill>
+          <a:ln w="12700">
+            <a:solidFill>
+              <a:srgbClr val="E2E8F0"/>
+            </a:solidFill>
+          </a:ln>
+        </p:spPr>
+        <p:style>
+          <a:lnRef idx="1">
+            <a:schemeClr val="accent1"/>
+          </a:lnRef>
+          <a:fillRef idx="3">
+            <a:schemeClr val="accent1"/>
+          </a:fillRef>
+          <a:effectRef idx="2">
+            <a:schemeClr val="accent1"/>
+          </a:effectRef>
+          <a:fontRef idx="minor">
+            <a:schemeClr val="lt1"/>
+          </a:fontRef>
+        </p:style>
+        <p:txBody>
+          <a:bodyPr rtlCol="0" anchor="ctr" lIns="0" tIns="0" rIns="0" bIns="0"/>
           <a:lstStyle/>
           <a:p>
             <a:pPr algn="ctr">
-              <a:defRPr sz="950" b="1">
+              <a:defRPr sz="900" b="1">
                 <a:solidFill>
                   <a:srgbClr val="64748B"/>
                 </a:solidFill>
@@ -9277,7 +10291,7 @@
               </a:defRPr>
             </a:pPr>
             <a:r>
-              <a:t>📷 Live System Screen: Apex Telecom Operational Dashboard with Live Charts</a:t>
+              <a:t>📷 Live Screen: Apex Telecom Operational Dashboard with Live Charts</a:t>
             </a:r>
           </a:p>
         </p:txBody>
@@ -9498,8 +10512,8 @@
         </p:nvSpPr>
         <p:spPr>
           <a:xfrm>
-            <a:off x="731520" y="1645920"/>
-            <a:ext cx="5029200" cy="4389120"/>
+            <a:off x="731520" y="1508760"/>
+            <a:ext cx="4937760" cy="4526280"/>
           </a:xfrm>
           <a:prstGeom prst="roundRect">
             <a:avLst/>
@@ -9543,8 +10557,8 @@
         </p:nvSpPr>
         <p:spPr>
           <a:xfrm>
-            <a:off x="1005840" y="1828800"/>
-            <a:ext cx="4480560" cy="4023360"/>
+            <a:off x="960120" y="1673352"/>
+            <a:ext cx="4480560" cy="4197096"/>
           </a:xfrm>
           <a:prstGeom prst="rect">
             <a:avLst/>
@@ -9552,13 +10566,13 @@
           <a:noFill/>
         </p:spPr>
         <p:txBody>
-          <a:bodyPr wrap="square">
+          <a:bodyPr wrap="square" lIns="0" tIns="0" rIns="0" bIns="0">
             <a:spAutoFit/>
           </a:bodyPr>
           <a:lstStyle/>
           <a:p>
             <a:pPr>
-              <a:defRPr sz="1200" b="1">
+              <a:defRPr sz="1150" b="1">
                 <a:solidFill>
                   <a:srgbClr val="1D4ED8"/>
                 </a:solidFill>
@@ -9572,9 +10586,9 @@
           <a:p>
             <a:pPr>
               <a:spcAft>
-                <a:spcPts val="900"/>
-              </a:spcAft>
-              <a:defRPr sz="1050">
+                <a:spcPts val="600"/>
+              </a:spcAft>
+              <a:defRPr sz="950">
                 <a:solidFill>
                   <a:srgbClr val="475569"/>
                 </a:solidFill>
@@ -9587,7 +10601,7 @@
           </a:p>
           <a:p>
             <a:pPr>
-              <a:defRPr sz="1200" b="1">
+              <a:defRPr sz="1150" b="1">
                 <a:solidFill>
                   <a:srgbClr val="0F172A"/>
                 </a:solidFill>
@@ -9601,9 +10615,9 @@
           <a:p>
             <a:pPr>
               <a:spcAft>
-                <a:spcPts val="900"/>
-              </a:spcAft>
-              <a:defRPr sz="1050">
+                <a:spcPts val="600"/>
+              </a:spcAft>
+              <a:defRPr sz="950">
                 <a:solidFill>
                   <a:srgbClr val="475569"/>
                 </a:solidFill>
@@ -9616,7 +10630,7 @@
           </a:p>
           <a:p>
             <a:pPr>
-              <a:defRPr sz="1200" b="1">
+              <a:defRPr sz="1150" b="1">
                 <a:solidFill>
                   <a:srgbClr val="0F172A"/>
                 </a:solidFill>
@@ -9630,9 +10644,9 @@
           <a:p>
             <a:pPr>
               <a:spcAft>
-                <a:spcPts val="900"/>
-              </a:spcAft>
-              <a:defRPr sz="1050">
+                <a:spcPts val="600"/>
+              </a:spcAft>
+              <a:defRPr sz="950">
                 <a:solidFill>
                   <a:srgbClr val="475569"/>
                 </a:solidFill>
@@ -9645,7 +10659,7 @@
           </a:p>
           <a:p>
             <a:pPr>
-              <a:defRPr sz="1200" b="1">
+              <a:defRPr sz="1150" b="1">
                 <a:solidFill>
                   <a:srgbClr val="0F172A"/>
                 </a:solidFill>
@@ -9659,9 +10673,9 @@
           <a:p>
             <a:pPr>
               <a:spcAft>
-                <a:spcPts val="900"/>
-              </a:spcAft>
-              <a:defRPr sz="1050">
+                <a:spcPts val="600"/>
+              </a:spcAft>
+              <a:defRPr sz="950">
                 <a:solidFill>
                   <a:srgbClr val="475569"/>
                 </a:solidFill>
@@ -9682,8 +10696,8 @@
         </p:nvSpPr>
         <p:spPr>
           <a:xfrm>
-            <a:off x="6035040" y="1645920"/>
-            <a:ext cx="5394960" cy="4389120"/>
+            <a:off x="5925312" y="1508760"/>
+            <a:ext cx="5532120" cy="4526280"/>
           </a:xfrm>
           <a:prstGeom prst="roundRect">
             <a:avLst/>
@@ -9735,8 +10749,8 @@
         </p:blipFill>
         <p:spPr>
           <a:xfrm>
-            <a:off x="6172200" y="1783080"/>
-            <a:ext cx="5120640" cy="3840480"/>
+            <a:off x="6383888" y="1691640"/>
+            <a:ext cx="4614967" cy="3566160"/>
           </a:xfrm>
           <a:prstGeom prst="rect">
             <a:avLst/>
@@ -9745,28 +10759,47 @@
       </p:pic>
       <p:sp>
         <p:nvSpPr>
-          <p:cNvPr id="8" name="TextBox 7"/>
-          <p:cNvSpPr txBox="1"/>
-          <p:nvPr/>
-        </p:nvSpPr>
-        <p:spPr>
-          <a:xfrm>
-            <a:off x="6172200" y="5669280"/>
-            <a:ext cx="5120640" cy="274320"/>
-          </a:xfrm>
-          <a:prstGeom prst="rect">
-            <a:avLst/>
-          </a:prstGeom>
-          <a:noFill/>
-        </p:spPr>
-        <p:txBody>
-          <a:bodyPr wrap="none">
-            <a:spAutoFit/>
-          </a:bodyPr>
+          <p:cNvPr id="8" name="Rounded Rectangle 7"/>
+          <p:cNvSpPr/>
+          <p:nvPr/>
+        </p:nvSpPr>
+        <p:spPr>
+          <a:xfrm>
+            <a:off x="6222492" y="5486399"/>
+            <a:ext cx="4937760" cy="347472"/>
+          </a:xfrm>
+          <a:prstGeom prst="roundRect">
+            <a:avLst/>
+          </a:prstGeom>
+          <a:solidFill>
+            <a:srgbClr val="F8FAFC"/>
+          </a:solidFill>
+          <a:ln w="12700">
+            <a:solidFill>
+              <a:srgbClr val="E2E8F0"/>
+            </a:solidFill>
+          </a:ln>
+        </p:spPr>
+        <p:style>
+          <a:lnRef idx="1">
+            <a:schemeClr val="accent1"/>
+          </a:lnRef>
+          <a:fillRef idx="3">
+            <a:schemeClr val="accent1"/>
+          </a:fillRef>
+          <a:effectRef idx="2">
+            <a:schemeClr val="accent1"/>
+          </a:effectRef>
+          <a:fontRef idx="minor">
+            <a:schemeClr val="lt1"/>
+          </a:fontRef>
+        </p:style>
+        <p:txBody>
+          <a:bodyPr rtlCol="0" anchor="ctr" lIns="0" tIns="0" rIns="0" bIns="0"/>
           <a:lstStyle/>
           <a:p>
             <a:pPr algn="ctr">
-              <a:defRPr sz="950" b="1">
+              <a:defRPr sz="900" b="1">
                 <a:solidFill>
                   <a:srgbClr val="64748B"/>
                 </a:solidFill>
@@ -9774,7 +10807,7 @@
               </a:defRPr>
             </a:pPr>
             <a:r>
-              <a:t>📷 Live System Screen: CDR Call Logger with Real-Time Classification Pills</a:t>
+              <a:t>📷 Live Screen: CDR Call Logger with Real-Time Classification Pills</a:t>
             </a:r>
           </a:p>
         </p:txBody>
@@ -9995,8 +11028,8 @@
         </p:nvSpPr>
         <p:spPr>
           <a:xfrm>
-            <a:off x="731520" y="1645920"/>
-            <a:ext cx="5029200" cy="4389120"/>
+            <a:off x="731520" y="1508760"/>
+            <a:ext cx="4937760" cy="4526280"/>
           </a:xfrm>
           <a:prstGeom prst="roundRect">
             <a:avLst/>
@@ -10040,8 +11073,8 @@
         </p:nvSpPr>
         <p:spPr>
           <a:xfrm>
-            <a:off x="1005840" y="1828800"/>
-            <a:ext cx="4480560" cy="4023360"/>
+            <a:off x="960120" y="1673352"/>
+            <a:ext cx="4480560" cy="4197096"/>
           </a:xfrm>
           <a:prstGeom prst="rect">
             <a:avLst/>
@@ -10049,13 +11082,13 @@
           <a:noFill/>
         </p:spPr>
         <p:txBody>
-          <a:bodyPr wrap="square">
+          <a:bodyPr wrap="square" lIns="0" tIns="0" rIns="0" bIns="0">
             <a:spAutoFit/>
           </a:bodyPr>
           <a:lstStyle/>
           <a:p>
             <a:pPr>
-              <a:defRPr sz="1200" b="1">
+              <a:defRPr sz="1150" b="1">
                 <a:solidFill>
                   <a:srgbClr val="1D4ED8"/>
                 </a:solidFill>
@@ -10069,9 +11102,9 @@
           <a:p>
             <a:pPr>
               <a:spcAft>
-                <a:spcPts val="900"/>
-              </a:spcAft>
-              <a:defRPr sz="1050">
+                <a:spcPts val="600"/>
+              </a:spcAft>
+              <a:defRPr sz="950">
                 <a:solidFill>
                   <a:srgbClr val="475569"/>
                 </a:solidFill>
@@ -10084,7 +11117,7 @@
           </a:p>
           <a:p>
             <a:pPr>
-              <a:defRPr sz="1200" b="1">
+              <a:defRPr sz="1150" b="1">
                 <a:solidFill>
                   <a:srgbClr val="0F172A"/>
                 </a:solidFill>
@@ -10098,9 +11131,9 @@
           <a:p>
             <a:pPr>
               <a:spcAft>
-                <a:spcPts val="900"/>
-              </a:spcAft>
-              <a:defRPr sz="1050">
+                <a:spcPts val="600"/>
+              </a:spcAft>
+              <a:defRPr sz="950">
                 <a:solidFill>
                   <a:srgbClr val="475569"/>
                 </a:solidFill>
@@ -10113,7 +11146,7 @@
           </a:p>
           <a:p>
             <a:pPr>
-              <a:defRPr sz="1200" b="1">
+              <a:defRPr sz="1150" b="1">
                 <a:solidFill>
                   <a:srgbClr val="0F172A"/>
                 </a:solidFill>
@@ -10127,9 +11160,9 @@
           <a:p>
             <a:pPr>
               <a:spcAft>
-                <a:spcPts val="900"/>
-              </a:spcAft>
-              <a:defRPr sz="1050">
+                <a:spcPts val="600"/>
+              </a:spcAft>
+              <a:defRPr sz="950">
                 <a:solidFill>
                   <a:srgbClr val="475569"/>
                 </a:solidFill>
@@ -10142,7 +11175,7 @@
           </a:p>
           <a:p>
             <a:pPr>
-              <a:defRPr sz="1200" b="1">
+              <a:defRPr sz="1150" b="1">
                 <a:solidFill>
                   <a:srgbClr val="0F172A"/>
                 </a:solidFill>
@@ -10156,9 +11189,9 @@
           <a:p>
             <a:pPr>
               <a:spcAft>
-                <a:spcPts val="900"/>
-              </a:spcAft>
-              <a:defRPr sz="1050">
+                <a:spcPts val="600"/>
+              </a:spcAft>
+              <a:defRPr sz="950">
                 <a:solidFill>
                   <a:srgbClr val="475569"/>
                 </a:solidFill>
@@ -10179,8 +11212,8 @@
         </p:nvSpPr>
         <p:spPr>
           <a:xfrm>
-            <a:off x="6035040" y="1645920"/>
-            <a:ext cx="5394960" cy="4389120"/>
+            <a:off x="5925312" y="1508760"/>
+            <a:ext cx="5532120" cy="4526280"/>
           </a:xfrm>
           <a:prstGeom prst="roundRect">
             <a:avLst/>
@@ -10232,8 +11265,8 @@
         </p:blipFill>
         <p:spPr>
           <a:xfrm>
-            <a:off x="6172200" y="1783080"/>
-            <a:ext cx="5120640" cy="3840480"/>
+            <a:off x="6383888" y="1691640"/>
+            <a:ext cx="4614967" cy="3566160"/>
           </a:xfrm>
           <a:prstGeom prst="rect">
             <a:avLst/>
@@ -10242,28 +11275,47 @@
       </p:pic>
       <p:sp>
         <p:nvSpPr>
-          <p:cNvPr id="8" name="TextBox 7"/>
-          <p:cNvSpPr txBox="1"/>
-          <p:nvPr/>
-        </p:nvSpPr>
-        <p:spPr>
-          <a:xfrm>
-            <a:off x="6172200" y="5669280"/>
-            <a:ext cx="5120640" cy="274320"/>
-          </a:xfrm>
-          <a:prstGeom prst="rect">
-            <a:avLst/>
-          </a:prstGeom>
-          <a:noFill/>
-        </p:spPr>
-        <p:txBody>
-          <a:bodyPr wrap="none">
-            <a:spAutoFit/>
-          </a:bodyPr>
+          <p:cNvPr id="8" name="Rounded Rectangle 7"/>
+          <p:cNvSpPr/>
+          <p:nvPr/>
+        </p:nvSpPr>
+        <p:spPr>
+          <a:xfrm>
+            <a:off x="6222492" y="5486399"/>
+            <a:ext cx="4937760" cy="347472"/>
+          </a:xfrm>
+          <a:prstGeom prst="roundRect">
+            <a:avLst/>
+          </a:prstGeom>
+          <a:solidFill>
+            <a:srgbClr val="F8FAFC"/>
+          </a:solidFill>
+          <a:ln w="12700">
+            <a:solidFill>
+              <a:srgbClr val="E2E8F0"/>
+            </a:solidFill>
+          </a:ln>
+        </p:spPr>
+        <p:style>
+          <a:lnRef idx="1">
+            <a:schemeClr val="accent1"/>
+          </a:lnRef>
+          <a:fillRef idx="3">
+            <a:schemeClr val="accent1"/>
+          </a:fillRef>
+          <a:effectRef idx="2">
+            <a:schemeClr val="accent1"/>
+          </a:effectRef>
+          <a:fontRef idx="minor">
+            <a:schemeClr val="lt1"/>
+          </a:fontRef>
+        </p:style>
+        <p:txBody>
+          <a:bodyPr rtlCol="0" anchor="ctr" lIns="0" tIns="0" rIns="0" bIns="0"/>
           <a:lstStyle/>
           <a:p>
             <a:pPr algn="ctr">
-              <a:defRPr sz="950" b="1">
+              <a:defRPr sz="900" b="1">
                 <a:solidFill>
                   <a:srgbClr val="64748B"/>
                 </a:solidFill>
@@ -10271,7 +11323,7 @@
               </a:defRPr>
             </a:pPr>
             <a:r>
-              <a:t>📷 Live System Screen: Financial Analytics &amp; Top Calling Subscribers</a:t>
+              <a:t>📷 Live Screen: Financial Analytics &amp; Top Calling Subscribers</a:t>
             </a:r>
           </a:p>
         </p:txBody>
@@ -10492,8 +11544,8 @@
         </p:nvSpPr>
         <p:spPr>
           <a:xfrm>
-            <a:off x="731520" y="1645920"/>
-            <a:ext cx="5029200" cy="4389120"/>
+            <a:off x="731520" y="1508760"/>
+            <a:ext cx="4937760" cy="4526280"/>
           </a:xfrm>
           <a:prstGeom prst="roundRect">
             <a:avLst/>
@@ -10537,8 +11589,8 @@
         </p:nvSpPr>
         <p:spPr>
           <a:xfrm>
-            <a:off x="1005840" y="1828800"/>
-            <a:ext cx="4480560" cy="4023360"/>
+            <a:off x="960120" y="1673352"/>
+            <a:ext cx="4480560" cy="4197096"/>
           </a:xfrm>
           <a:prstGeom prst="rect">
             <a:avLst/>
@@ -10546,13 +11598,13 @@
           <a:noFill/>
         </p:spPr>
         <p:txBody>
-          <a:bodyPr wrap="square">
+          <a:bodyPr wrap="square" lIns="0" tIns="0" rIns="0" bIns="0">
             <a:spAutoFit/>
           </a:bodyPr>
           <a:lstStyle/>
           <a:p>
             <a:pPr>
-              <a:defRPr sz="1200" b="1">
+              <a:defRPr sz="1150" b="1">
                 <a:solidFill>
                   <a:srgbClr val="1D4ED8"/>
                 </a:solidFill>
@@ -10566,9 +11618,9 @@
           <a:p>
             <a:pPr>
               <a:spcAft>
-                <a:spcPts val="900"/>
-              </a:spcAft>
-              <a:defRPr sz="1050">
+                <a:spcPts val="600"/>
+              </a:spcAft>
+              <a:defRPr sz="950">
                 <a:solidFill>
                   <a:srgbClr val="475569"/>
                 </a:solidFill>
@@ -10581,7 +11633,7 @@
           </a:p>
           <a:p>
             <a:pPr>
-              <a:defRPr sz="1200" b="1">
+              <a:defRPr sz="1150" b="1">
                 <a:solidFill>
                   <a:srgbClr val="0F172A"/>
                 </a:solidFill>
@@ -10595,9 +11647,9 @@
           <a:p>
             <a:pPr>
               <a:spcAft>
-                <a:spcPts val="900"/>
-              </a:spcAft>
-              <a:defRPr sz="1050">
+                <a:spcPts val="600"/>
+              </a:spcAft>
+              <a:defRPr sz="950">
                 <a:solidFill>
                   <a:srgbClr val="475569"/>
                 </a:solidFill>
@@ -10610,7 +11662,7 @@
           </a:p>
           <a:p>
             <a:pPr>
-              <a:defRPr sz="1200" b="1">
+              <a:defRPr sz="1150" b="1">
                 <a:solidFill>
                   <a:srgbClr val="0F172A"/>
                 </a:solidFill>
@@ -10624,9 +11676,9 @@
           <a:p>
             <a:pPr>
               <a:spcAft>
-                <a:spcPts val="900"/>
-              </a:spcAft>
-              <a:defRPr sz="1050">
+                <a:spcPts val="600"/>
+              </a:spcAft>
+              <a:defRPr sz="950">
                 <a:solidFill>
                   <a:srgbClr val="475569"/>
                 </a:solidFill>
@@ -10639,7 +11691,7 @@
           </a:p>
           <a:p>
             <a:pPr>
-              <a:defRPr sz="1200" b="1">
+              <a:defRPr sz="1150" b="1">
                 <a:solidFill>
                   <a:srgbClr val="0F172A"/>
                 </a:solidFill>
@@ -10653,9 +11705,9 @@
           <a:p>
             <a:pPr>
               <a:spcAft>
-                <a:spcPts val="900"/>
-              </a:spcAft>
-              <a:defRPr sz="1050">
+                <a:spcPts val="600"/>
+              </a:spcAft>
+              <a:defRPr sz="950">
                 <a:solidFill>
                   <a:srgbClr val="475569"/>
                 </a:solidFill>
@@ -10676,8 +11728,8 @@
         </p:nvSpPr>
         <p:spPr>
           <a:xfrm>
-            <a:off x="6035040" y="1645920"/>
-            <a:ext cx="5394960" cy="4389120"/>
+            <a:off x="5925312" y="1508760"/>
+            <a:ext cx="5532120" cy="4526280"/>
           </a:xfrm>
           <a:prstGeom prst="roundRect">
             <a:avLst/>
@@ -10729,8 +11781,8 @@
         </p:blipFill>
         <p:spPr>
           <a:xfrm>
-            <a:off x="6172200" y="1783080"/>
-            <a:ext cx="5120640" cy="3840480"/>
+            <a:off x="6383888" y="1691640"/>
+            <a:ext cx="4614967" cy="3566160"/>
           </a:xfrm>
           <a:prstGeom prst="rect">
             <a:avLst/>
@@ -10739,28 +11791,47 @@
       </p:pic>
       <p:sp>
         <p:nvSpPr>
-          <p:cNvPr id="8" name="TextBox 7"/>
-          <p:cNvSpPr txBox="1"/>
-          <p:nvPr/>
-        </p:nvSpPr>
-        <p:spPr>
-          <a:xfrm>
-            <a:off x="6172200" y="5669280"/>
-            <a:ext cx="5120640" cy="274320"/>
-          </a:xfrm>
-          <a:prstGeom prst="rect">
-            <a:avLst/>
-          </a:prstGeom>
-          <a:noFill/>
-        </p:spPr>
-        <p:txBody>
-          <a:bodyPr wrap="none">
-            <a:spAutoFit/>
-          </a:bodyPr>
+          <p:cNvPr id="8" name="Rounded Rectangle 7"/>
+          <p:cNvSpPr/>
+          <p:nvPr/>
+        </p:nvSpPr>
+        <p:spPr>
+          <a:xfrm>
+            <a:off x="6222492" y="5486399"/>
+            <a:ext cx="4937760" cy="347472"/>
+          </a:xfrm>
+          <a:prstGeom prst="roundRect">
+            <a:avLst/>
+          </a:prstGeom>
+          <a:solidFill>
+            <a:srgbClr val="F8FAFC"/>
+          </a:solidFill>
+          <a:ln w="12700">
+            <a:solidFill>
+              <a:srgbClr val="E2E8F0"/>
+            </a:solidFill>
+          </a:ln>
+        </p:spPr>
+        <p:style>
+          <a:lnRef idx="1">
+            <a:schemeClr val="accent1"/>
+          </a:lnRef>
+          <a:fillRef idx="3">
+            <a:schemeClr val="accent1"/>
+          </a:fillRef>
+          <a:effectRef idx="2">
+            <a:schemeClr val="accent1"/>
+          </a:effectRef>
+          <a:fontRef idx="minor">
+            <a:schemeClr val="lt1"/>
+          </a:fontRef>
+        </p:style>
+        <p:txBody>
+          <a:bodyPr rtlCol="0" anchor="ctr" lIns="0" tIns="0" rIns="0" bIns="0"/>
           <a:lstStyle/>
           <a:p>
             <a:pPr algn="ctr">
-              <a:defRPr sz="950" b="1">
+              <a:defRPr sz="900" b="1">
                 <a:solidFill>
                   <a:srgbClr val="64748B"/>
                 </a:solidFill>
@@ -10768,7 +11839,7 @@
               </a:defRPr>
             </a:pPr>
             <a:r>
-              <a:t>📷 Live System Screen: Authentic Airtel/Jio Styled Tax Invoice Modal</a:t>
+              <a:t>📷 Live Screen: Authentic Airtel/Jio Styled Tax Invoice Modal</a:t>
             </a:r>
           </a:p>
         </p:txBody>
@@ -10989,8 +12060,8 @@
         </p:nvSpPr>
         <p:spPr>
           <a:xfrm>
-            <a:off x="731520" y="1645920"/>
-            <a:ext cx="5029200" cy="4389120"/>
+            <a:off x="731520" y="1508760"/>
+            <a:ext cx="4937760" cy="4526280"/>
           </a:xfrm>
           <a:prstGeom prst="roundRect">
             <a:avLst/>
@@ -11034,8 +12105,8 @@
         </p:nvSpPr>
         <p:spPr>
           <a:xfrm>
-            <a:off x="1005840" y="1828800"/>
-            <a:ext cx="4480560" cy="4023360"/>
+            <a:off x="960120" y="1673352"/>
+            <a:ext cx="4480560" cy="4197096"/>
           </a:xfrm>
           <a:prstGeom prst="rect">
             <a:avLst/>
@@ -11043,13 +12114,13 @@
           <a:noFill/>
         </p:spPr>
         <p:txBody>
-          <a:bodyPr wrap="square">
+          <a:bodyPr wrap="square" lIns="0" tIns="0" rIns="0" bIns="0">
             <a:spAutoFit/>
           </a:bodyPr>
           <a:lstStyle/>
           <a:p>
             <a:pPr>
-              <a:defRPr sz="1200" b="1">
+              <a:defRPr sz="1150" b="1">
                 <a:solidFill>
                   <a:srgbClr val="1D4ED8"/>
                 </a:solidFill>
@@ -11063,9 +12134,9 @@
           <a:p>
             <a:pPr>
               <a:spcAft>
-                <a:spcPts val="900"/>
-              </a:spcAft>
-              <a:defRPr sz="1050">
+                <a:spcPts val="600"/>
+              </a:spcAft>
+              <a:defRPr sz="950">
                 <a:solidFill>
                   <a:srgbClr val="475569"/>
                 </a:solidFill>
@@ -11078,7 +12149,7 @@
           </a:p>
           <a:p>
             <a:pPr>
-              <a:defRPr sz="1200" b="1">
+              <a:defRPr sz="1150" b="1">
                 <a:solidFill>
                   <a:srgbClr val="0F172A"/>
                 </a:solidFill>
@@ -11092,9 +12163,9 @@
           <a:p>
             <a:pPr>
               <a:spcAft>
-                <a:spcPts val="900"/>
-              </a:spcAft>
-              <a:defRPr sz="1050">
+                <a:spcPts val="600"/>
+              </a:spcAft>
+              <a:defRPr sz="950">
                 <a:solidFill>
                   <a:srgbClr val="475569"/>
                 </a:solidFill>
@@ -11107,7 +12178,7 @@
           </a:p>
           <a:p>
             <a:pPr>
-              <a:defRPr sz="1200" b="1">
+              <a:defRPr sz="1150" b="1">
                 <a:solidFill>
                   <a:srgbClr val="0F172A"/>
                 </a:solidFill>
@@ -11121,9 +12192,9 @@
           <a:p>
             <a:pPr>
               <a:spcAft>
-                <a:spcPts val="900"/>
-              </a:spcAft>
-              <a:defRPr sz="1050">
+                <a:spcPts val="600"/>
+              </a:spcAft>
+              <a:defRPr sz="950">
                 <a:solidFill>
                   <a:srgbClr val="475569"/>
                 </a:solidFill>
@@ -11136,7 +12207,7 @@
           </a:p>
           <a:p>
             <a:pPr>
-              <a:defRPr sz="1200" b="1">
+              <a:defRPr sz="1150" b="1">
                 <a:solidFill>
                   <a:srgbClr val="0F172A"/>
                 </a:solidFill>
@@ -11150,9 +12221,9 @@
           <a:p>
             <a:pPr>
               <a:spcAft>
-                <a:spcPts val="900"/>
-              </a:spcAft>
-              <a:defRPr sz="1050">
+                <a:spcPts val="600"/>
+              </a:spcAft>
+              <a:defRPr sz="950">
                 <a:solidFill>
                   <a:srgbClr val="475569"/>
                 </a:solidFill>
@@ -11173,8 +12244,8 @@
         </p:nvSpPr>
         <p:spPr>
           <a:xfrm>
-            <a:off x="6035040" y="1645920"/>
-            <a:ext cx="5394960" cy="4389120"/>
+            <a:off x="5925312" y="1508760"/>
+            <a:ext cx="5532120" cy="4526280"/>
           </a:xfrm>
           <a:prstGeom prst="roundRect">
             <a:avLst/>
@@ -11226,8 +12297,8 @@
         </p:blipFill>
         <p:spPr>
           <a:xfrm>
-            <a:off x="6172200" y="1783080"/>
-            <a:ext cx="5120640" cy="3840480"/>
+            <a:off x="6383888" y="1691640"/>
+            <a:ext cx="4614967" cy="3566160"/>
           </a:xfrm>
           <a:prstGeom prst="rect">
             <a:avLst/>
@@ -11236,28 +12307,47 @@
       </p:pic>
       <p:sp>
         <p:nvSpPr>
-          <p:cNvPr id="8" name="TextBox 7"/>
-          <p:cNvSpPr txBox="1"/>
-          <p:nvPr/>
-        </p:nvSpPr>
-        <p:spPr>
-          <a:xfrm>
-            <a:off x="6172200" y="5669280"/>
-            <a:ext cx="5120640" cy="274320"/>
-          </a:xfrm>
-          <a:prstGeom prst="rect">
-            <a:avLst/>
-          </a:prstGeom>
-          <a:noFill/>
-        </p:spPr>
-        <p:txBody>
-          <a:bodyPr wrap="none">
-            <a:spAutoFit/>
-          </a:bodyPr>
+          <p:cNvPr id="8" name="Rounded Rectangle 7"/>
+          <p:cNvSpPr/>
+          <p:nvPr/>
+        </p:nvSpPr>
+        <p:spPr>
+          <a:xfrm>
+            <a:off x="6222492" y="5486399"/>
+            <a:ext cx="4937760" cy="347472"/>
+          </a:xfrm>
+          <a:prstGeom prst="roundRect">
+            <a:avLst/>
+          </a:prstGeom>
+          <a:solidFill>
+            <a:srgbClr val="F8FAFC"/>
+          </a:solidFill>
+          <a:ln w="12700">
+            <a:solidFill>
+              <a:srgbClr val="E2E8F0"/>
+            </a:solidFill>
+          </a:ln>
+        </p:spPr>
+        <p:style>
+          <a:lnRef idx="1">
+            <a:schemeClr val="accent1"/>
+          </a:lnRef>
+          <a:fillRef idx="3">
+            <a:schemeClr val="accent1"/>
+          </a:fillRef>
+          <a:effectRef idx="2">
+            <a:schemeClr val="accent1"/>
+          </a:effectRef>
+          <a:fontRef idx="minor">
+            <a:schemeClr val="lt1"/>
+          </a:fontRef>
+        </p:style>
+        <p:txBody>
+          <a:bodyPr rtlCol="0" anchor="ctr" lIns="0" tIns="0" rIns="0" bIns="0"/>
           <a:lstStyle/>
           <a:p>
             <a:pPr algn="ctr">
-              <a:defRPr sz="950" b="1">
+              <a:defRPr sz="900" b="1">
                 <a:solidFill>
                   <a:srgbClr val="64748B"/>
                 </a:solidFill>
@@ -11265,7 +12355,7 @@
               </a:defRPr>
             </a:pPr>
             <a:r>
-              <a:t>📷 Live System Screen: Tariff Plans &amp; Calling Package Tier Cards</a:t>
+              <a:t>📷 Live Screen: Tariff Plans &amp; Calling Package Tier Cards</a:t>
             </a:r>
           </a:p>
         </p:txBody>

</xml_diff>

<commit_message>
feat: real-time calling system with two-way voice, oscilloscope, and MyJio vintage UI
</commit_message>
<xml_diff>
--- a/Telephone_Bill_Management_System_Team07.pptx
+++ b/Telephone_Bill_Management_System_Team07.pptx
@@ -4,22 +4,25 @@
   <p:sldMasterIdLst>
     <p:sldMasterId id="2147483648" r:id="rId1"/>
   </p:sldMasterIdLst>
+  <p:notesMasterIdLst>
+    <p:notesMasterId r:id="rId15"/>
+  </p:notesMasterIdLst>
   <p:sldIdLst>
-    <p:sldId id="256" r:id="rId7"/>
-    <p:sldId id="257" r:id="rId8"/>
-    <p:sldId id="258" r:id="rId9"/>
-    <p:sldId id="259" r:id="rId10"/>
-    <p:sldId id="260" r:id="rId11"/>
-    <p:sldId id="261" r:id="rId12"/>
-    <p:sldId id="262" r:id="rId13"/>
-    <p:sldId id="263" r:id="rId14"/>
-    <p:sldId id="264" r:id="rId15"/>
-    <p:sldId id="265" r:id="rId16"/>
-    <p:sldId id="266" r:id="rId17"/>
-    <p:sldId id="267" r:id="rId18"/>
-    <p:sldId id="268" r:id="rId19"/>
+    <p:sldId id="256" r:id="rId2"/>
+    <p:sldId id="257" r:id="rId3"/>
+    <p:sldId id="258" r:id="rId4"/>
+    <p:sldId id="259" r:id="rId5"/>
+    <p:sldId id="260" r:id="rId6"/>
+    <p:sldId id="261" r:id="rId7"/>
+    <p:sldId id="262" r:id="rId8"/>
+    <p:sldId id="263" r:id="rId9"/>
+    <p:sldId id="264" r:id="rId10"/>
+    <p:sldId id="265" r:id="rId11"/>
+    <p:sldId id="266" r:id="rId12"/>
+    <p:sldId id="267" r:id="rId13"/>
+    <p:sldId id="268" r:id="rId14"/>
   </p:sldIdLst>
-  <p:sldSz cx="12191695" cy="6858000" type="screen4x3"/>
+  <p:sldSz cx="12192000" cy="6858000"/>
   <p:notesSz cx="6858000" cy="9144000"/>
   <p:defaultTextStyle>
     <a:defPPr>
@@ -116,7 +119,457 @@
       </a:defRPr>
     </a:lvl9pPr>
   </p:defaultTextStyle>
+  <p:extLst>
+    <p:ext uri="{EFAFB233-063F-42B5-8137-9DF3F51BA10A}">
+      <p15:sldGuideLst xmlns:p15="http://schemas.microsoft.com/office/powerpoint/2012/main">
+        <p15:guide id="1" orient="horz" pos="2160">
+          <p15:clr>
+            <a:srgbClr val="A4A3A4"/>
+          </p15:clr>
+        </p15:guide>
+        <p15:guide id="2" pos="2880">
+          <p15:clr>
+            <a:srgbClr val="A4A3A4"/>
+          </p15:clr>
+        </p15:guide>
+      </p15:sldGuideLst>
+    </p:ext>
+  </p:extLst>
 </p:presentation>
+</file>
+
+<file path=ppt/notesMasters/notesMaster1.xml><?xml version="1.0" encoding="utf-8"?>
+<p:notesMaster xmlns:a="http://schemas.openxmlformats.org/drawingml/2006/main" xmlns:r="http://schemas.openxmlformats.org/officeDocument/2006/relationships" xmlns:p="http://schemas.openxmlformats.org/presentationml/2006/main">
+  <p:cSld>
+    <p:bg>
+      <p:bgRef idx="1001">
+        <a:schemeClr val="bg1"/>
+      </p:bgRef>
+    </p:bg>
+    <p:spTree>
+      <p:nvGrpSpPr>
+        <p:cNvPr id="1" name=""/>
+        <p:cNvGrpSpPr/>
+        <p:nvPr/>
+      </p:nvGrpSpPr>
+      <p:grpSpPr>
+        <a:xfrm>
+          <a:off x="0" y="0"/>
+          <a:ext cx="0" cy="0"/>
+          <a:chOff x="0" y="0"/>
+          <a:chExt cx="0" cy="0"/>
+        </a:xfrm>
+      </p:grpSpPr>
+      <p:sp>
+        <p:nvSpPr>
+          <p:cNvPr id="2" name="Header Placeholder 1"/>
+          <p:cNvSpPr>
+            <a:spLocks noGrp="1"/>
+          </p:cNvSpPr>
+          <p:nvPr>
+            <p:ph type="hdr" sz="quarter"/>
+          </p:nvPr>
+        </p:nvSpPr>
+        <p:spPr>
+          <a:xfrm>
+            <a:off x="0" y="0"/>
+            <a:ext cx="2971800" cy="458788"/>
+          </a:xfrm>
+          <a:prstGeom prst="rect">
+            <a:avLst/>
+          </a:prstGeom>
+        </p:spPr>
+        <p:txBody>
+          <a:bodyPr vert="horz" lIns="91440" tIns="45720" rIns="91440" bIns="45720" rtlCol="0"/>
+          <a:lstStyle>
+            <a:lvl1pPr algn="l">
+              <a:defRPr sz="1200"/>
+            </a:lvl1pPr>
+          </a:lstStyle>
+          <a:p>
+            <a:endParaRPr lang="en-IN"/>
+          </a:p>
+        </p:txBody>
+      </p:sp>
+      <p:sp>
+        <p:nvSpPr>
+          <p:cNvPr id="3" name="Date Placeholder 2"/>
+          <p:cNvSpPr>
+            <a:spLocks noGrp="1"/>
+          </p:cNvSpPr>
+          <p:nvPr>
+            <p:ph type="dt" idx="1"/>
+          </p:nvPr>
+        </p:nvSpPr>
+        <p:spPr>
+          <a:xfrm>
+            <a:off x="3884613" y="0"/>
+            <a:ext cx="2971800" cy="458788"/>
+          </a:xfrm>
+          <a:prstGeom prst="rect">
+            <a:avLst/>
+          </a:prstGeom>
+        </p:spPr>
+        <p:txBody>
+          <a:bodyPr vert="horz" lIns="91440" tIns="45720" rIns="91440" bIns="45720" rtlCol="0"/>
+          <a:lstStyle>
+            <a:lvl1pPr algn="r">
+              <a:defRPr sz="1200"/>
+            </a:lvl1pPr>
+          </a:lstStyle>
+          <a:p>
+            <a:fld id="{3D0AAFD9-8371-437A-9ED5-B84FA88B5806}" type="datetimeFigureOut">
+              <a:rPr lang="en-IN" smtClean="0"/>
+              <a:t>14-09-2026</a:t>
+            </a:fld>
+            <a:endParaRPr lang="en-IN"/>
+          </a:p>
+        </p:txBody>
+      </p:sp>
+      <p:sp>
+        <p:nvSpPr>
+          <p:cNvPr id="4" name="Slide Image Placeholder 3"/>
+          <p:cNvSpPr>
+            <a:spLocks noGrp="1" noRot="1" noChangeAspect="1"/>
+          </p:cNvSpPr>
+          <p:nvPr>
+            <p:ph type="sldImg" idx="2"/>
+          </p:nvPr>
+        </p:nvSpPr>
+        <p:spPr>
+          <a:xfrm>
+            <a:off x="685800" y="1143000"/>
+            <a:ext cx="5486400" cy="3086100"/>
+          </a:xfrm>
+          <a:prstGeom prst="rect">
+            <a:avLst/>
+          </a:prstGeom>
+          <a:noFill/>
+          <a:ln w="12700">
+            <a:solidFill>
+              <a:prstClr val="black"/>
+            </a:solidFill>
+          </a:ln>
+        </p:spPr>
+        <p:txBody>
+          <a:bodyPr vert="horz" lIns="91440" tIns="45720" rIns="91440" bIns="45720" rtlCol="0" anchor="ctr"/>
+          <a:lstStyle/>
+          <a:p>
+            <a:endParaRPr lang="en-IN"/>
+          </a:p>
+        </p:txBody>
+      </p:sp>
+      <p:sp>
+        <p:nvSpPr>
+          <p:cNvPr id="5" name="Notes Placeholder 4"/>
+          <p:cNvSpPr>
+            <a:spLocks noGrp="1"/>
+          </p:cNvSpPr>
+          <p:nvPr>
+            <p:ph type="body" sz="quarter" idx="3"/>
+          </p:nvPr>
+        </p:nvSpPr>
+        <p:spPr>
+          <a:xfrm>
+            <a:off x="685800" y="4400550"/>
+            <a:ext cx="5486400" cy="3600450"/>
+          </a:xfrm>
+          <a:prstGeom prst="rect">
+            <a:avLst/>
+          </a:prstGeom>
+        </p:spPr>
+        <p:txBody>
+          <a:bodyPr vert="horz" lIns="91440" tIns="45720" rIns="91440" bIns="45720" rtlCol="0"/>
+          <a:lstStyle/>
+          <a:p>
+            <a:pPr lvl="0"/>
+            <a:r>
+              <a:rPr lang="en-US"/>
+              <a:t>Click to edit Master text styles</a:t>
+            </a:r>
+          </a:p>
+          <a:p>
+            <a:pPr lvl="1"/>
+            <a:r>
+              <a:rPr lang="en-US"/>
+              <a:t>Second level</a:t>
+            </a:r>
+          </a:p>
+          <a:p>
+            <a:pPr lvl="2"/>
+            <a:r>
+              <a:rPr lang="en-US"/>
+              <a:t>Third level</a:t>
+            </a:r>
+          </a:p>
+          <a:p>
+            <a:pPr lvl="3"/>
+            <a:r>
+              <a:rPr lang="en-US"/>
+              <a:t>Fourth level</a:t>
+            </a:r>
+          </a:p>
+          <a:p>
+            <a:pPr lvl="4"/>
+            <a:r>
+              <a:rPr lang="en-US"/>
+              <a:t>Fifth level</a:t>
+            </a:r>
+            <a:endParaRPr lang="en-IN"/>
+          </a:p>
+        </p:txBody>
+      </p:sp>
+      <p:sp>
+        <p:nvSpPr>
+          <p:cNvPr id="6" name="Footer Placeholder 5"/>
+          <p:cNvSpPr>
+            <a:spLocks noGrp="1"/>
+          </p:cNvSpPr>
+          <p:nvPr>
+            <p:ph type="ftr" sz="quarter" idx="4"/>
+          </p:nvPr>
+        </p:nvSpPr>
+        <p:spPr>
+          <a:xfrm>
+            <a:off x="0" y="8685213"/>
+            <a:ext cx="2971800" cy="458787"/>
+          </a:xfrm>
+          <a:prstGeom prst="rect">
+            <a:avLst/>
+          </a:prstGeom>
+        </p:spPr>
+        <p:txBody>
+          <a:bodyPr vert="horz" lIns="91440" tIns="45720" rIns="91440" bIns="45720" rtlCol="0" anchor="b"/>
+          <a:lstStyle>
+            <a:lvl1pPr algn="l">
+              <a:defRPr sz="1200"/>
+            </a:lvl1pPr>
+          </a:lstStyle>
+          <a:p>
+            <a:endParaRPr lang="en-IN"/>
+          </a:p>
+        </p:txBody>
+      </p:sp>
+      <p:sp>
+        <p:nvSpPr>
+          <p:cNvPr id="7" name="Slide Number Placeholder 6"/>
+          <p:cNvSpPr>
+            <a:spLocks noGrp="1"/>
+          </p:cNvSpPr>
+          <p:nvPr>
+            <p:ph type="sldNum" sz="quarter" idx="5"/>
+          </p:nvPr>
+        </p:nvSpPr>
+        <p:spPr>
+          <a:xfrm>
+            <a:off x="3884613" y="8685213"/>
+            <a:ext cx="2971800" cy="458787"/>
+          </a:xfrm>
+          <a:prstGeom prst="rect">
+            <a:avLst/>
+          </a:prstGeom>
+        </p:spPr>
+        <p:txBody>
+          <a:bodyPr vert="horz" lIns="91440" tIns="45720" rIns="91440" bIns="45720" rtlCol="0" anchor="b"/>
+          <a:lstStyle>
+            <a:lvl1pPr algn="r">
+              <a:defRPr sz="1200"/>
+            </a:lvl1pPr>
+          </a:lstStyle>
+          <a:p>
+            <a:fld id="{0F6E626C-B6B7-46B9-909E-024DE191AA77}" type="slidenum">
+              <a:rPr lang="en-IN" smtClean="0"/>
+              <a:t>‹#›</a:t>
+            </a:fld>
+            <a:endParaRPr lang="en-IN"/>
+          </a:p>
+        </p:txBody>
+      </p:sp>
+    </p:spTree>
+    <p:extLst>
+      <p:ext uri="{BB962C8B-B14F-4D97-AF65-F5344CB8AC3E}">
+        <p14:creationId xmlns:p14="http://schemas.microsoft.com/office/powerpoint/2010/main" val="1475186667"/>
+      </p:ext>
+    </p:extLst>
+  </p:cSld>
+  <p:clrMap bg1="lt1" tx1="dk1" bg2="lt2" tx2="dk2" accent1="accent1" accent2="accent2" accent3="accent3" accent4="accent4" accent5="accent5" accent6="accent6" hlink="hlink" folHlink="folHlink"/>
+  <p:notesStyle>
+    <a:lvl1pPr marL="0" algn="l" defTabSz="914400" rtl="0" eaLnBrk="1" latinLnBrk="0" hangingPunct="1">
+      <a:defRPr sz="1200" kern="1200">
+        <a:solidFill>
+          <a:schemeClr val="tx1"/>
+        </a:solidFill>
+        <a:latin typeface="+mn-lt"/>
+        <a:ea typeface="+mn-ea"/>
+        <a:cs typeface="+mn-cs"/>
+      </a:defRPr>
+    </a:lvl1pPr>
+    <a:lvl2pPr marL="457200" algn="l" defTabSz="914400" rtl="0" eaLnBrk="1" latinLnBrk="0" hangingPunct="1">
+      <a:defRPr sz="1200" kern="1200">
+        <a:solidFill>
+          <a:schemeClr val="tx1"/>
+        </a:solidFill>
+        <a:latin typeface="+mn-lt"/>
+        <a:ea typeface="+mn-ea"/>
+        <a:cs typeface="+mn-cs"/>
+      </a:defRPr>
+    </a:lvl2pPr>
+    <a:lvl3pPr marL="914400" algn="l" defTabSz="914400" rtl="0" eaLnBrk="1" latinLnBrk="0" hangingPunct="1">
+      <a:defRPr sz="1200" kern="1200">
+        <a:solidFill>
+          <a:schemeClr val="tx1"/>
+        </a:solidFill>
+        <a:latin typeface="+mn-lt"/>
+        <a:ea typeface="+mn-ea"/>
+        <a:cs typeface="+mn-cs"/>
+      </a:defRPr>
+    </a:lvl3pPr>
+    <a:lvl4pPr marL="1371600" algn="l" defTabSz="914400" rtl="0" eaLnBrk="1" latinLnBrk="0" hangingPunct="1">
+      <a:defRPr sz="1200" kern="1200">
+        <a:solidFill>
+          <a:schemeClr val="tx1"/>
+        </a:solidFill>
+        <a:latin typeface="+mn-lt"/>
+        <a:ea typeface="+mn-ea"/>
+        <a:cs typeface="+mn-cs"/>
+      </a:defRPr>
+    </a:lvl4pPr>
+    <a:lvl5pPr marL="1828800" algn="l" defTabSz="914400" rtl="0" eaLnBrk="1" latinLnBrk="0" hangingPunct="1">
+      <a:defRPr sz="1200" kern="1200">
+        <a:solidFill>
+          <a:schemeClr val="tx1"/>
+        </a:solidFill>
+        <a:latin typeface="+mn-lt"/>
+        <a:ea typeface="+mn-ea"/>
+        <a:cs typeface="+mn-cs"/>
+      </a:defRPr>
+    </a:lvl5pPr>
+    <a:lvl6pPr marL="2286000" algn="l" defTabSz="914400" rtl="0" eaLnBrk="1" latinLnBrk="0" hangingPunct="1">
+      <a:defRPr sz="1200" kern="1200">
+        <a:solidFill>
+          <a:schemeClr val="tx1"/>
+        </a:solidFill>
+        <a:latin typeface="+mn-lt"/>
+        <a:ea typeface="+mn-ea"/>
+        <a:cs typeface="+mn-cs"/>
+      </a:defRPr>
+    </a:lvl6pPr>
+    <a:lvl7pPr marL="2743200" algn="l" defTabSz="914400" rtl="0" eaLnBrk="1" latinLnBrk="0" hangingPunct="1">
+      <a:defRPr sz="1200" kern="1200">
+        <a:solidFill>
+          <a:schemeClr val="tx1"/>
+        </a:solidFill>
+        <a:latin typeface="+mn-lt"/>
+        <a:ea typeface="+mn-ea"/>
+        <a:cs typeface="+mn-cs"/>
+      </a:defRPr>
+    </a:lvl7pPr>
+    <a:lvl8pPr marL="3200400" algn="l" defTabSz="914400" rtl="0" eaLnBrk="1" latinLnBrk="0" hangingPunct="1">
+      <a:defRPr sz="1200" kern="1200">
+        <a:solidFill>
+          <a:schemeClr val="tx1"/>
+        </a:solidFill>
+        <a:latin typeface="+mn-lt"/>
+        <a:ea typeface="+mn-ea"/>
+        <a:cs typeface="+mn-cs"/>
+      </a:defRPr>
+    </a:lvl8pPr>
+    <a:lvl9pPr marL="3657600" algn="l" defTabSz="914400" rtl="0" eaLnBrk="1" latinLnBrk="0" hangingPunct="1">
+      <a:defRPr sz="1200" kern="1200">
+        <a:solidFill>
+          <a:schemeClr val="tx1"/>
+        </a:solidFill>
+        <a:latin typeface="+mn-lt"/>
+        <a:ea typeface="+mn-ea"/>
+        <a:cs typeface="+mn-cs"/>
+      </a:defRPr>
+    </a:lvl9pPr>
+  </p:notesStyle>
+</p:notesMaster>
+</file>
+
+<file path=ppt/notesSlides/notesSlide1.xml><?xml version="1.0" encoding="utf-8"?>
+<p:notes xmlns:a="http://schemas.openxmlformats.org/drawingml/2006/main" xmlns:r="http://schemas.openxmlformats.org/officeDocument/2006/relationships" xmlns:p="http://schemas.openxmlformats.org/presentationml/2006/main">
+  <p:cSld>
+    <p:spTree>
+      <p:nvGrpSpPr>
+        <p:cNvPr id="1" name=""/>
+        <p:cNvGrpSpPr/>
+        <p:nvPr/>
+      </p:nvGrpSpPr>
+      <p:grpSpPr>
+        <a:xfrm>
+          <a:off x="0" y="0"/>
+          <a:ext cx="0" cy="0"/>
+          <a:chOff x="0" y="0"/>
+          <a:chExt cx="0" cy="0"/>
+        </a:xfrm>
+      </p:grpSpPr>
+      <p:sp>
+        <p:nvSpPr>
+          <p:cNvPr id="2" name="Slide Image Placeholder 1"/>
+          <p:cNvSpPr>
+            <a:spLocks noGrp="1" noRot="1" noChangeAspect="1"/>
+          </p:cNvSpPr>
+          <p:nvPr>
+            <p:ph type="sldImg"/>
+          </p:nvPr>
+        </p:nvSpPr>
+        <p:spPr/>
+      </p:sp>
+      <p:sp>
+        <p:nvSpPr>
+          <p:cNvPr id="3" name="Notes Placeholder 2"/>
+          <p:cNvSpPr>
+            <a:spLocks noGrp="1"/>
+          </p:cNvSpPr>
+          <p:nvPr>
+            <p:ph type="body" idx="1"/>
+          </p:nvPr>
+        </p:nvSpPr>
+        <p:spPr/>
+        <p:txBody>
+          <a:bodyPr/>
+          <a:lstStyle/>
+          <a:p>
+            <a:endParaRPr lang="en-IN" dirty="0"/>
+          </a:p>
+        </p:txBody>
+      </p:sp>
+      <p:sp>
+        <p:nvSpPr>
+          <p:cNvPr id="4" name="Slide Number Placeholder 3"/>
+          <p:cNvSpPr>
+            <a:spLocks noGrp="1"/>
+          </p:cNvSpPr>
+          <p:nvPr>
+            <p:ph type="sldNum" sz="quarter" idx="5"/>
+          </p:nvPr>
+        </p:nvSpPr>
+        <p:spPr/>
+        <p:txBody>
+          <a:bodyPr/>
+          <a:lstStyle/>
+          <a:p>
+            <a:fld id="{0F6E626C-B6B7-46B9-909E-024DE191AA77}" type="slidenum">
+              <a:rPr lang="en-IN" smtClean="0"/>
+              <a:t>13</a:t>
+            </a:fld>
+            <a:endParaRPr lang="en-IN"/>
+          </a:p>
+        </p:txBody>
+      </p:sp>
+    </p:spTree>
+    <p:extLst>
+      <p:ext uri="{BB962C8B-B14F-4D97-AF65-F5344CB8AC3E}">
+        <p14:creationId xmlns:p14="http://schemas.microsoft.com/office/powerpoint/2010/main" val="1324607889"/>
+      </p:ext>
+    </p:extLst>
+  </p:cSld>
+  <p:clrMapOvr>
+    <a:masterClrMapping/>
+  </p:clrMapOvr>
+</p:notes>
 </file>
 
 <file path=ppt/slideLayouts/slideLayout1.xml><?xml version="1.0" encoding="utf-8"?>
@@ -157,10 +610,9 @@
           <a:lstStyle/>
           <a:p>
             <a:r>
-              <a:rPr lang="en-US" smtClean="0"/>
+              <a:rPr lang="en-US"/>
               <a:t>Click to edit Master title style</a:t>
             </a:r>
-            <a:endParaRPr lang="en-US"/>
           </a:p>
         </p:txBody>
       </p:sp>
@@ -276,10 +728,9 @@
           </a:lstStyle>
           <a:p>
             <a:r>
-              <a:rPr lang="en-US" smtClean="0"/>
+              <a:rPr lang="en-US"/>
               <a:t>Click to edit Master subtitle style</a:t>
             </a:r>
-            <a:endParaRPr lang="en-US"/>
           </a:p>
         </p:txBody>
       </p:sp>
@@ -300,7 +751,7 @@
           <a:p>
             <a:fld id="{5BCAD085-E8A6-8845-BD4E-CB4CCA059FC4}" type="datetimeFigureOut">
               <a:rPr lang="en-US" smtClean="0"/>
-              <a:t>1/27/13</a:t>
+              <a:t>9/14/2026</a:t>
             </a:fld>
             <a:endParaRPr lang="en-US"/>
           </a:p>
@@ -394,10 +845,9 @@
           <a:lstStyle/>
           <a:p>
             <a:r>
-              <a:rPr lang="en-US" smtClean="0"/>
+              <a:rPr lang="en-US"/>
               <a:t>Click to edit Master title style</a:t>
             </a:r>
-            <a:endParaRPr lang="en-US"/>
           </a:p>
         </p:txBody>
       </p:sp>
@@ -418,38 +868,37 @@
           <a:p>
             <a:pPr lvl="0"/>
             <a:r>
-              <a:rPr lang="en-US" smtClean="0"/>
+              <a:rPr lang="en-US"/>
               <a:t>Click to edit Master text styles</a:t>
             </a:r>
           </a:p>
           <a:p>
             <a:pPr lvl="1"/>
             <a:r>
-              <a:rPr lang="en-US" smtClean="0"/>
+              <a:rPr lang="en-US"/>
               <a:t>Second level</a:t>
             </a:r>
           </a:p>
           <a:p>
             <a:pPr lvl="2"/>
             <a:r>
-              <a:rPr lang="en-US" smtClean="0"/>
+              <a:rPr lang="en-US"/>
               <a:t>Third level</a:t>
             </a:r>
           </a:p>
           <a:p>
             <a:pPr lvl="3"/>
             <a:r>
-              <a:rPr lang="en-US" smtClean="0"/>
+              <a:rPr lang="en-US"/>
               <a:t>Fourth level</a:t>
             </a:r>
           </a:p>
           <a:p>
             <a:pPr lvl="4"/>
             <a:r>
-              <a:rPr lang="en-US" smtClean="0"/>
+              <a:rPr lang="en-US"/>
               <a:t>Fifth level</a:t>
             </a:r>
-            <a:endParaRPr lang="en-US"/>
           </a:p>
         </p:txBody>
       </p:sp>
@@ -470,7 +919,7 @@
           <a:p>
             <a:fld id="{5BCAD085-E8A6-8845-BD4E-CB4CCA059FC4}" type="datetimeFigureOut">
               <a:rPr lang="en-US" smtClean="0"/>
-              <a:t>1/27/13</a:t>
+              <a:t>9/14/2026</a:t>
             </a:fld>
             <a:endParaRPr lang="en-US"/>
           </a:p>
@@ -569,10 +1018,9 @@
           <a:lstStyle/>
           <a:p>
             <a:r>
-              <a:rPr lang="en-US" smtClean="0"/>
+              <a:rPr lang="en-US"/>
               <a:t>Click to edit Master title style</a:t>
             </a:r>
-            <a:endParaRPr lang="en-US"/>
           </a:p>
         </p:txBody>
       </p:sp>
@@ -598,38 +1046,37 @@
           <a:p>
             <a:pPr lvl="0"/>
             <a:r>
-              <a:rPr lang="en-US" smtClean="0"/>
+              <a:rPr lang="en-US"/>
               <a:t>Click to edit Master text styles</a:t>
             </a:r>
           </a:p>
           <a:p>
             <a:pPr lvl="1"/>
             <a:r>
-              <a:rPr lang="en-US" smtClean="0"/>
+              <a:rPr lang="en-US"/>
               <a:t>Second level</a:t>
             </a:r>
           </a:p>
           <a:p>
             <a:pPr lvl="2"/>
             <a:r>
-              <a:rPr lang="en-US" smtClean="0"/>
+              <a:rPr lang="en-US"/>
               <a:t>Third level</a:t>
             </a:r>
           </a:p>
           <a:p>
             <a:pPr lvl="3"/>
             <a:r>
-              <a:rPr lang="en-US" smtClean="0"/>
+              <a:rPr lang="en-US"/>
               <a:t>Fourth level</a:t>
             </a:r>
           </a:p>
           <a:p>
             <a:pPr lvl="4"/>
             <a:r>
-              <a:rPr lang="en-US" smtClean="0"/>
+              <a:rPr lang="en-US"/>
               <a:t>Fifth level</a:t>
             </a:r>
-            <a:endParaRPr lang="en-US"/>
           </a:p>
         </p:txBody>
       </p:sp>
@@ -650,7 +1097,7 @@
           <a:p>
             <a:fld id="{5BCAD085-E8A6-8845-BD4E-CB4CCA059FC4}" type="datetimeFigureOut">
               <a:rPr lang="en-US" smtClean="0"/>
-              <a:t>1/27/13</a:t>
+              <a:t>9/14/2026</a:t>
             </a:fld>
             <a:endParaRPr lang="en-US"/>
           </a:p>
@@ -744,10 +1191,9 @@
           <a:lstStyle/>
           <a:p>
             <a:r>
-              <a:rPr lang="en-US" smtClean="0"/>
+              <a:rPr lang="en-US"/>
               <a:t>Click to edit Master title style</a:t>
             </a:r>
-            <a:endParaRPr lang="en-US"/>
           </a:p>
         </p:txBody>
       </p:sp>
@@ -768,38 +1214,37 @@
           <a:p>
             <a:pPr lvl="0"/>
             <a:r>
-              <a:rPr lang="en-US" smtClean="0"/>
+              <a:rPr lang="en-US"/>
               <a:t>Click to edit Master text styles</a:t>
             </a:r>
           </a:p>
           <a:p>
             <a:pPr lvl="1"/>
             <a:r>
-              <a:rPr lang="en-US" smtClean="0"/>
+              <a:rPr lang="en-US"/>
               <a:t>Second level</a:t>
             </a:r>
           </a:p>
           <a:p>
             <a:pPr lvl="2"/>
             <a:r>
-              <a:rPr lang="en-US" smtClean="0"/>
+              <a:rPr lang="en-US"/>
               <a:t>Third level</a:t>
             </a:r>
           </a:p>
           <a:p>
             <a:pPr lvl="3"/>
             <a:r>
-              <a:rPr lang="en-US" smtClean="0"/>
+              <a:rPr lang="en-US"/>
               <a:t>Fourth level</a:t>
             </a:r>
           </a:p>
           <a:p>
             <a:pPr lvl="4"/>
             <a:r>
-              <a:rPr lang="en-US" smtClean="0"/>
+              <a:rPr lang="en-US"/>
               <a:t>Fifth level</a:t>
             </a:r>
-            <a:endParaRPr lang="en-US"/>
           </a:p>
         </p:txBody>
       </p:sp>
@@ -820,7 +1265,7 @@
           <a:p>
             <a:fld id="{5BCAD085-E8A6-8845-BD4E-CB4CCA059FC4}" type="datetimeFigureOut">
               <a:rPr lang="en-US" smtClean="0"/>
-              <a:t>1/27/13</a:t>
+              <a:t>9/14/2026</a:t>
             </a:fld>
             <a:endParaRPr lang="en-US"/>
           </a:p>
@@ -923,10 +1368,9 @@
           </a:lstStyle>
           <a:p>
             <a:r>
-              <a:rPr lang="en-US" smtClean="0"/>
+              <a:rPr lang="en-US"/>
               <a:t>Click to edit Master title style</a:t>
             </a:r>
-            <a:endParaRPr lang="en-US"/>
           </a:p>
         </p:txBody>
       </p:sp>
@@ -1043,7 +1487,7 @@
           <a:p>
             <a:pPr lvl="0"/>
             <a:r>
-              <a:rPr lang="en-US" smtClean="0"/>
+              <a:rPr lang="en-US"/>
               <a:t>Click to edit Master text styles</a:t>
             </a:r>
           </a:p>
@@ -1066,7 +1510,7 @@
           <a:p>
             <a:fld id="{5BCAD085-E8A6-8845-BD4E-CB4CCA059FC4}" type="datetimeFigureOut">
               <a:rPr lang="en-US" smtClean="0"/>
-              <a:t>1/27/13</a:t>
+              <a:t>9/14/2026</a:t>
             </a:fld>
             <a:endParaRPr lang="en-US"/>
           </a:p>
@@ -1160,10 +1604,9 @@
           <a:lstStyle/>
           <a:p>
             <a:r>
-              <a:rPr lang="en-US" smtClean="0"/>
+              <a:rPr lang="en-US"/>
               <a:t>Click to edit Master title style</a:t>
             </a:r>
-            <a:endParaRPr lang="en-US"/>
           </a:p>
         </p:txBody>
       </p:sp>
@@ -1217,38 +1660,37 @@
           <a:p>
             <a:pPr lvl="0"/>
             <a:r>
-              <a:rPr lang="en-US" smtClean="0"/>
+              <a:rPr lang="en-US"/>
               <a:t>Click to edit Master text styles</a:t>
             </a:r>
           </a:p>
           <a:p>
             <a:pPr lvl="1"/>
             <a:r>
-              <a:rPr lang="en-US" smtClean="0"/>
+              <a:rPr lang="en-US"/>
               <a:t>Second level</a:t>
             </a:r>
           </a:p>
           <a:p>
             <a:pPr lvl="2"/>
             <a:r>
-              <a:rPr lang="en-US" smtClean="0"/>
+              <a:rPr lang="en-US"/>
               <a:t>Third level</a:t>
             </a:r>
           </a:p>
           <a:p>
             <a:pPr lvl="3"/>
             <a:r>
-              <a:rPr lang="en-US" smtClean="0"/>
+              <a:rPr lang="en-US"/>
               <a:t>Fourth level</a:t>
             </a:r>
           </a:p>
           <a:p>
             <a:pPr lvl="4"/>
             <a:r>
-              <a:rPr lang="en-US" smtClean="0"/>
+              <a:rPr lang="en-US"/>
               <a:t>Fifth level</a:t>
             </a:r>
-            <a:endParaRPr lang="en-US"/>
           </a:p>
         </p:txBody>
       </p:sp>
@@ -1302,38 +1744,37 @@
           <a:p>
             <a:pPr lvl="0"/>
             <a:r>
-              <a:rPr lang="en-US" smtClean="0"/>
+              <a:rPr lang="en-US"/>
               <a:t>Click to edit Master text styles</a:t>
             </a:r>
           </a:p>
           <a:p>
             <a:pPr lvl="1"/>
             <a:r>
-              <a:rPr lang="en-US" smtClean="0"/>
+              <a:rPr lang="en-US"/>
               <a:t>Second level</a:t>
             </a:r>
           </a:p>
           <a:p>
             <a:pPr lvl="2"/>
             <a:r>
-              <a:rPr lang="en-US" smtClean="0"/>
+              <a:rPr lang="en-US"/>
               <a:t>Third level</a:t>
             </a:r>
           </a:p>
           <a:p>
             <a:pPr lvl="3"/>
             <a:r>
-              <a:rPr lang="en-US" smtClean="0"/>
+              <a:rPr lang="en-US"/>
               <a:t>Fourth level</a:t>
             </a:r>
           </a:p>
           <a:p>
             <a:pPr lvl="4"/>
             <a:r>
-              <a:rPr lang="en-US" smtClean="0"/>
+              <a:rPr lang="en-US"/>
               <a:t>Fifth level</a:t>
             </a:r>
-            <a:endParaRPr lang="en-US"/>
           </a:p>
         </p:txBody>
       </p:sp>
@@ -1354,7 +1795,7 @@
           <a:p>
             <a:fld id="{5BCAD085-E8A6-8845-BD4E-CB4CCA059FC4}" type="datetimeFigureOut">
               <a:rPr lang="en-US" smtClean="0"/>
-              <a:t>1/27/13</a:t>
+              <a:t>9/14/2026</a:t>
             </a:fld>
             <a:endParaRPr lang="en-US"/>
           </a:p>
@@ -1452,10 +1893,9 @@
           </a:lstStyle>
           <a:p>
             <a:r>
-              <a:rPr lang="en-US" smtClean="0"/>
+              <a:rPr lang="en-US"/>
               <a:t>Click to edit Master title style</a:t>
             </a:r>
-            <a:endParaRPr lang="en-US"/>
           </a:p>
         </p:txBody>
       </p:sp>
@@ -1518,7 +1958,7 @@
           <a:p>
             <a:pPr lvl="0"/>
             <a:r>
-              <a:rPr lang="en-US" smtClean="0"/>
+              <a:rPr lang="en-US"/>
               <a:t>Click to edit Master text styles</a:t>
             </a:r>
           </a:p>
@@ -1574,38 +2014,37 @@
           <a:p>
             <a:pPr lvl="0"/>
             <a:r>
-              <a:rPr lang="en-US" smtClean="0"/>
+              <a:rPr lang="en-US"/>
               <a:t>Click to edit Master text styles</a:t>
             </a:r>
           </a:p>
           <a:p>
             <a:pPr lvl="1"/>
             <a:r>
-              <a:rPr lang="en-US" smtClean="0"/>
+              <a:rPr lang="en-US"/>
               <a:t>Second level</a:t>
             </a:r>
           </a:p>
           <a:p>
             <a:pPr lvl="2"/>
             <a:r>
-              <a:rPr lang="en-US" smtClean="0"/>
+              <a:rPr lang="en-US"/>
               <a:t>Third level</a:t>
             </a:r>
           </a:p>
           <a:p>
             <a:pPr lvl="3"/>
             <a:r>
-              <a:rPr lang="en-US" smtClean="0"/>
+              <a:rPr lang="en-US"/>
               <a:t>Fourth level</a:t>
             </a:r>
           </a:p>
           <a:p>
             <a:pPr lvl="4"/>
             <a:r>
-              <a:rPr lang="en-US" smtClean="0"/>
+              <a:rPr lang="en-US"/>
               <a:t>Fifth level</a:t>
             </a:r>
-            <a:endParaRPr lang="en-US"/>
           </a:p>
         </p:txBody>
       </p:sp>
@@ -1668,7 +2107,7 @@
           <a:p>
             <a:pPr lvl="0"/>
             <a:r>
-              <a:rPr lang="en-US" smtClean="0"/>
+              <a:rPr lang="en-US"/>
               <a:t>Click to edit Master text styles</a:t>
             </a:r>
           </a:p>
@@ -1724,38 +2163,37 @@
           <a:p>
             <a:pPr lvl="0"/>
             <a:r>
-              <a:rPr lang="en-US" smtClean="0"/>
+              <a:rPr lang="en-US"/>
               <a:t>Click to edit Master text styles</a:t>
             </a:r>
           </a:p>
           <a:p>
             <a:pPr lvl="1"/>
             <a:r>
-              <a:rPr lang="en-US" smtClean="0"/>
+              <a:rPr lang="en-US"/>
               <a:t>Second level</a:t>
             </a:r>
           </a:p>
           <a:p>
             <a:pPr lvl="2"/>
             <a:r>
-              <a:rPr lang="en-US" smtClean="0"/>
+              <a:rPr lang="en-US"/>
               <a:t>Third level</a:t>
             </a:r>
           </a:p>
           <a:p>
             <a:pPr lvl="3"/>
             <a:r>
-              <a:rPr lang="en-US" smtClean="0"/>
+              <a:rPr lang="en-US"/>
               <a:t>Fourth level</a:t>
             </a:r>
           </a:p>
           <a:p>
             <a:pPr lvl="4"/>
             <a:r>
-              <a:rPr lang="en-US" smtClean="0"/>
+              <a:rPr lang="en-US"/>
               <a:t>Fifth level</a:t>
             </a:r>
-            <a:endParaRPr lang="en-US"/>
           </a:p>
         </p:txBody>
       </p:sp>
@@ -1776,7 +2214,7 @@
           <a:p>
             <a:fld id="{5BCAD085-E8A6-8845-BD4E-CB4CCA059FC4}" type="datetimeFigureOut">
               <a:rPr lang="en-US" smtClean="0"/>
-              <a:t>1/27/13</a:t>
+              <a:t>9/14/2026</a:t>
             </a:fld>
             <a:endParaRPr lang="en-US"/>
           </a:p>
@@ -1870,10 +2308,9 @@
           <a:lstStyle/>
           <a:p>
             <a:r>
-              <a:rPr lang="en-US" smtClean="0"/>
+              <a:rPr lang="en-US"/>
               <a:t>Click to edit Master title style</a:t>
             </a:r>
-            <a:endParaRPr lang="en-US"/>
           </a:p>
         </p:txBody>
       </p:sp>
@@ -1894,7 +2331,7 @@
           <a:p>
             <a:fld id="{5BCAD085-E8A6-8845-BD4E-CB4CCA059FC4}" type="datetimeFigureOut">
               <a:rPr lang="en-US" smtClean="0"/>
-              <a:t>1/27/13</a:t>
+              <a:t>9/14/2026</a:t>
             </a:fld>
             <a:endParaRPr lang="en-US"/>
           </a:p>
@@ -1989,7 +2426,7 @@
           <a:p>
             <a:fld id="{5BCAD085-E8A6-8845-BD4E-CB4CCA059FC4}" type="datetimeFigureOut">
               <a:rPr lang="en-US" smtClean="0"/>
-              <a:t>1/27/13</a:t>
+              <a:t>9/14/2026</a:t>
             </a:fld>
             <a:endParaRPr lang="en-US"/>
           </a:p>
@@ -2092,10 +2529,9 @@
           </a:lstStyle>
           <a:p>
             <a:r>
-              <a:rPr lang="en-US" smtClean="0"/>
+              <a:rPr lang="en-US"/>
               <a:t>Click to edit Master title style</a:t>
             </a:r>
-            <a:endParaRPr lang="en-US"/>
           </a:p>
         </p:txBody>
       </p:sp>
@@ -2149,38 +2585,37 @@
           <a:p>
             <a:pPr lvl="0"/>
             <a:r>
-              <a:rPr lang="en-US" smtClean="0"/>
+              <a:rPr lang="en-US"/>
               <a:t>Click to edit Master text styles</a:t>
             </a:r>
           </a:p>
           <a:p>
             <a:pPr lvl="1"/>
             <a:r>
-              <a:rPr lang="en-US" smtClean="0"/>
+              <a:rPr lang="en-US"/>
               <a:t>Second level</a:t>
             </a:r>
           </a:p>
           <a:p>
             <a:pPr lvl="2"/>
             <a:r>
-              <a:rPr lang="en-US" smtClean="0"/>
+              <a:rPr lang="en-US"/>
               <a:t>Third level</a:t>
             </a:r>
           </a:p>
           <a:p>
             <a:pPr lvl="3"/>
             <a:r>
-              <a:rPr lang="en-US" smtClean="0"/>
+              <a:rPr lang="en-US"/>
               <a:t>Fourth level</a:t>
             </a:r>
           </a:p>
           <a:p>
             <a:pPr lvl="4"/>
             <a:r>
-              <a:rPr lang="en-US" smtClean="0"/>
+              <a:rPr lang="en-US"/>
               <a:t>Fifth level</a:t>
             </a:r>
-            <a:endParaRPr lang="en-US"/>
           </a:p>
         </p:txBody>
       </p:sp>
@@ -2243,7 +2678,7 @@
           <a:p>
             <a:pPr lvl="0"/>
             <a:r>
-              <a:rPr lang="en-US" smtClean="0"/>
+              <a:rPr lang="en-US"/>
               <a:t>Click to edit Master text styles</a:t>
             </a:r>
           </a:p>
@@ -2266,7 +2701,7 @@
           <a:p>
             <a:fld id="{5BCAD085-E8A6-8845-BD4E-CB4CCA059FC4}" type="datetimeFigureOut">
               <a:rPr lang="en-US" smtClean="0"/>
-              <a:t>1/27/13</a:t>
+              <a:t>9/14/2026</a:t>
             </a:fld>
             <a:endParaRPr lang="en-US"/>
           </a:p>
@@ -2369,10 +2804,9 @@
           </a:lstStyle>
           <a:p>
             <a:r>
-              <a:rPr lang="en-US" smtClean="0"/>
+              <a:rPr lang="en-US"/>
               <a:t>Click to edit Master title style</a:t>
             </a:r>
-            <a:endParaRPr lang="en-US"/>
           </a:p>
         </p:txBody>
       </p:sp>
@@ -2496,7 +2930,7 @@
           <a:p>
             <a:pPr lvl="0"/>
             <a:r>
-              <a:rPr lang="en-US" smtClean="0"/>
+              <a:rPr lang="en-US"/>
               <a:t>Click to edit Master text styles</a:t>
             </a:r>
           </a:p>
@@ -2519,7 +2953,7 @@
           <a:p>
             <a:fld id="{5BCAD085-E8A6-8845-BD4E-CB4CCA059FC4}" type="datetimeFigureOut">
               <a:rPr lang="en-US" smtClean="0"/>
-              <a:t>1/27/13</a:t>
+              <a:t>9/14/2026</a:t>
             </a:fld>
             <a:endParaRPr lang="en-US"/>
           </a:p>
@@ -2628,10 +3062,9 @@
           <a:lstStyle/>
           <a:p>
             <a:r>
-              <a:rPr lang="en-US" smtClean="0"/>
+              <a:rPr lang="en-US"/>
               <a:t>Click to edit Master title style</a:t>
             </a:r>
-            <a:endParaRPr lang="en-US"/>
           </a:p>
         </p:txBody>
       </p:sp>
@@ -2662,38 +3095,37 @@
           <a:p>
             <a:pPr lvl="0"/>
             <a:r>
-              <a:rPr lang="en-US" smtClean="0"/>
+              <a:rPr lang="en-US"/>
               <a:t>Click to edit Master text styles</a:t>
             </a:r>
           </a:p>
           <a:p>
             <a:pPr lvl="1"/>
             <a:r>
-              <a:rPr lang="en-US" smtClean="0"/>
+              <a:rPr lang="en-US"/>
               <a:t>Second level</a:t>
             </a:r>
           </a:p>
           <a:p>
             <a:pPr lvl="2"/>
             <a:r>
-              <a:rPr lang="en-US" smtClean="0"/>
+              <a:rPr lang="en-US"/>
               <a:t>Third level</a:t>
             </a:r>
           </a:p>
           <a:p>
             <a:pPr lvl="3"/>
             <a:r>
-              <a:rPr lang="en-US" smtClean="0"/>
+              <a:rPr lang="en-US"/>
               <a:t>Fourth level</a:t>
             </a:r>
           </a:p>
           <a:p>
             <a:pPr lvl="4"/>
             <a:r>
-              <a:rPr lang="en-US" smtClean="0"/>
+              <a:rPr lang="en-US"/>
               <a:t>Fifth level</a:t>
             </a:r>
-            <a:endParaRPr lang="en-US"/>
           </a:p>
         </p:txBody>
       </p:sp>
@@ -2732,7 +3164,7 @@
           <a:p>
             <a:fld id="{5BCAD085-E8A6-8845-BD4E-CB4CCA059FC4}" type="datetimeFigureOut">
               <a:rPr lang="en-US" smtClean="0"/>
-              <a:t>1/27/13</a:t>
+              <a:t>9/14/2026</a:t>
             </a:fld>
             <a:endParaRPr lang="en-US"/>
           </a:p>
@@ -3091,7 +3523,7 @@
 </file>
 
 <file path=ppt/slides/slide1.xml><?xml version="1.0" encoding="utf-8"?>
-<p:sld xmlns:a="http://schemas.openxmlformats.org/drawingml/2006/main" xmlns:p="http://schemas.openxmlformats.org/presentationml/2006/main" xmlns:r="http://schemas.openxmlformats.org/officeDocument/2006/relationships">
+<p:sld xmlns:a="http://schemas.openxmlformats.org/drawingml/2006/main" xmlns:r="http://schemas.openxmlformats.org/officeDocument/2006/relationships" xmlns:p="http://schemas.openxmlformats.org/presentationml/2006/main">
   <p:cSld>
     <p:spTree>
       <p:nvGrpSpPr>
@@ -3099,7 +3531,14 @@
         <p:cNvGrpSpPr/>
         <p:nvPr/>
       </p:nvGrpSpPr>
-      <p:grpSpPr/>
+      <p:grpSpPr>
+        <a:xfrm>
+          <a:off x="0" y="0"/>
+          <a:ext cx="0" cy="0"/>
+          <a:chOff x="0" y="0"/>
+          <a:chExt cx="0" cy="0"/>
+        </a:xfrm>
+      </p:grpSpPr>
       <p:sp>
         <p:nvSpPr>
           <p:cNvPr id="2" name="Rectangle 1"/>
@@ -3140,6 +3579,7 @@
           <a:lstStyle/>
           <a:p>
             <a:pPr algn="ctr"/>
+            <a:endParaRPr/>
           </a:p>
         </p:txBody>
       </p:sp>
@@ -3183,6 +3623,7 @@
           <a:lstStyle/>
           <a:p>
             <a:pPr algn="ctr"/>
+            <a:endParaRPr/>
           </a:p>
         </p:txBody>
       </p:sp>
@@ -3453,6 +3894,7 @@
           <a:lstStyle/>
           <a:p>
             <a:pPr algn="ctr"/>
+            <a:endParaRPr/>
           </a:p>
         </p:txBody>
       </p:sp>
@@ -3563,6 +4005,7 @@
           <a:lstStyle/>
           <a:p>
             <a:pPr algn="ctr"/>
+            <a:endParaRPr/>
           </a:p>
         </p:txBody>
       </p:sp>
@@ -3767,6 +4210,7 @@
           <a:lstStyle/>
           <a:p>
             <a:pPr algn="ctr"/>
+            <a:endParaRPr/>
           </a:p>
         </p:txBody>
       </p:sp>
@@ -3971,6 +4415,7 @@
           <a:lstStyle/>
           <a:p>
             <a:pPr algn="ctr"/>
+            <a:endParaRPr/>
           </a:p>
         </p:txBody>
       </p:sp>
@@ -4175,6 +4620,7 @@
           <a:lstStyle/>
           <a:p>
             <a:pPr algn="ctr"/>
+            <a:endParaRPr/>
           </a:p>
         </p:txBody>
       </p:sp>
@@ -4379,6 +4825,7 @@
           <a:lstStyle/>
           <a:p>
             <a:pPr algn="ctr"/>
+            <a:endParaRPr/>
           </a:p>
         </p:txBody>
       </p:sp>
@@ -4581,6 +5028,7 @@
           <a:lstStyle/>
           <a:p>
             <a:pPr algn="ctr"/>
+            <a:endParaRPr/>
           </a:p>
         </p:txBody>
       </p:sp>
@@ -4629,7 +5077,7 @@
 </file>
 
 <file path=ppt/slides/slide10.xml><?xml version="1.0" encoding="utf-8"?>
-<p:sld xmlns:a="http://schemas.openxmlformats.org/drawingml/2006/main" xmlns:p="http://schemas.openxmlformats.org/presentationml/2006/main" xmlns:r="http://schemas.openxmlformats.org/officeDocument/2006/relationships">
+<p:sld xmlns:a="http://schemas.openxmlformats.org/drawingml/2006/main" xmlns:r="http://schemas.openxmlformats.org/officeDocument/2006/relationships" xmlns:p="http://schemas.openxmlformats.org/presentationml/2006/main">
   <p:cSld>
     <p:spTree>
       <p:nvGrpSpPr>
@@ -4637,7 +5085,14 @@
         <p:cNvGrpSpPr/>
         <p:nvPr/>
       </p:nvGrpSpPr>
-      <p:grpSpPr/>
+      <p:grpSpPr>
+        <a:xfrm>
+          <a:off x="0" y="0"/>
+          <a:ext cx="0" cy="0"/>
+          <a:chOff x="0" y="0"/>
+          <a:chExt cx="0" cy="0"/>
+        </a:xfrm>
+      </p:grpSpPr>
       <p:sp>
         <p:nvSpPr>
           <p:cNvPr id="2" name="Rectangle 1"/>
@@ -4678,6 +5133,7 @@
           <a:lstStyle/>
           <a:p>
             <a:pPr algn="ctr"/>
+            <a:endParaRPr/>
           </a:p>
         </p:txBody>
       </p:sp>
@@ -4791,6 +5247,7 @@
           <a:lstStyle/>
           <a:p>
             <a:pPr algn="ctr"/>
+            <a:endParaRPr/>
           </a:p>
         </p:txBody>
       </p:sp>
@@ -4802,7 +5259,7 @@
         </p:nvSpPr>
         <p:spPr>
           <a:xfrm>
-            <a:off x="960120" y="1673352"/>
+            <a:off x="1031748" y="2524690"/>
             <a:ext cx="4480560" cy="4197096"/>
           </a:xfrm>
           <a:prstGeom prst="rect">
@@ -4825,6 +5282,7 @@
               </a:defRPr>
             </a:pPr>
             <a:r>
+              <a:rPr dirty="0"/>
               <a:t>•  Financial Health Summary Cards</a:t>
             </a:r>
           </a:p>
@@ -4841,6 +5299,7 @@
               </a:defRPr>
             </a:pPr>
             <a:r>
+              <a:rPr dirty="0"/>
               <a:t>   Instant reporting of Cumulative Invoiced Volume (₹1,215.37), Total Settled Collections (₹366.63), and Outstanding Receivables (₹848.74).</a:t>
             </a:r>
           </a:p>
@@ -4854,6 +5313,7 @@
               </a:defRPr>
             </a:pPr>
             <a:r>
+              <a:rPr dirty="0"/>
               <a:t>•  Top Calling Subscribers Leaderboard</a:t>
             </a:r>
           </a:p>
@@ -4870,6 +5330,7 @@
               </a:defRPr>
             </a:pPr>
             <a:r>
+              <a:rPr dirty="0"/>
               <a:t>   Ranks subscribers by total CDR talk time and calls count with 🥇 1st (Sneha Reddy), 🥈 2nd (Priya Patel), 🥉 3rd (Rajesh Sharma) medals.</a:t>
             </a:r>
           </a:p>
@@ -4883,6 +5344,7 @@
               </a:defRPr>
             </a:pPr>
             <a:r>
+              <a:rPr dirty="0"/>
               <a:t>•  Revenue Leakage Prevention</a:t>
             </a:r>
           </a:p>
@@ -4899,6 +5361,7 @@
               </a:defRPr>
             </a:pPr>
             <a:r>
+              <a:rPr dirty="0"/>
               <a:t>   Enables telecom managers to rapidly identify delinquent accounts, overdue payment windows, and initiate automated late fees.</a:t>
             </a:r>
           </a:p>
@@ -4912,6 +5375,7 @@
               </a:defRPr>
             </a:pPr>
             <a:r>
+              <a:rPr dirty="0"/>
               <a:t>•  Spreadsheet CSV Exporting</a:t>
             </a:r>
           </a:p>
@@ -4928,6 +5392,7 @@
               </a:defRPr>
             </a:pPr>
             <a:r>
+              <a:rPr dirty="0"/>
               <a:t>   One-click export of financial reports and subscriber traffic tables to CSV for external auditing, accounting, and presentation review.</a:t>
             </a:r>
           </a:p>
@@ -4975,6 +5440,7 @@
           <a:lstStyle/>
           <a:p>
             <a:pPr algn="ctr"/>
+            <a:endParaRPr/>
           </a:p>
         </p:txBody>
       </p:sp>
@@ -5040,7 +5506,7 @@
           </a:fontRef>
         </p:style>
         <p:txBody>
-          <a:bodyPr rtlCol="0" anchor="ctr" lIns="0" tIns="0" rIns="0" bIns="0"/>
+          <a:bodyPr lIns="0" tIns="0" rIns="0" bIns="0" rtlCol="0" anchor="ctr"/>
           <a:lstStyle/>
           <a:p>
             <a:pPr algn="ctr">
@@ -5097,6 +5563,7 @@
           <a:lstStyle/>
           <a:p>
             <a:pPr algn="ctr"/>
+            <a:endParaRPr/>
           </a:p>
         </p:txBody>
       </p:sp>
@@ -5145,7 +5612,7 @@
 </file>
 
 <file path=ppt/slides/slide11.xml><?xml version="1.0" encoding="utf-8"?>
-<p:sld xmlns:a="http://schemas.openxmlformats.org/drawingml/2006/main" xmlns:p="http://schemas.openxmlformats.org/presentationml/2006/main" xmlns:r="http://schemas.openxmlformats.org/officeDocument/2006/relationships">
+<p:sld xmlns:a="http://schemas.openxmlformats.org/drawingml/2006/main" xmlns:r="http://schemas.openxmlformats.org/officeDocument/2006/relationships" xmlns:p="http://schemas.openxmlformats.org/presentationml/2006/main">
   <p:cSld>
     <p:spTree>
       <p:nvGrpSpPr>
@@ -5153,7 +5620,14 @@
         <p:cNvGrpSpPr/>
         <p:nvPr/>
       </p:nvGrpSpPr>
-      <p:grpSpPr/>
+      <p:grpSpPr>
+        <a:xfrm>
+          <a:off x="0" y="0"/>
+          <a:ext cx="0" cy="0"/>
+          <a:chOff x="0" y="0"/>
+          <a:chExt cx="0" cy="0"/>
+        </a:xfrm>
+      </p:grpSpPr>
       <p:sp>
         <p:nvSpPr>
           <p:cNvPr id="2" name="Rectangle 1"/>
@@ -5194,6 +5668,7 @@
           <a:lstStyle/>
           <a:p>
             <a:pPr algn="ctr"/>
+            <a:endParaRPr/>
           </a:p>
         </p:txBody>
       </p:sp>
@@ -5307,6 +5782,7 @@
           <a:lstStyle/>
           <a:p>
             <a:pPr algn="ctr"/>
+            <a:endParaRPr/>
           </a:p>
         </p:txBody>
       </p:sp>
@@ -5536,6 +6012,7 @@
           <a:lstStyle/>
           <a:p>
             <a:pPr algn="ctr"/>
+            <a:endParaRPr/>
           </a:p>
         </p:txBody>
       </p:sp>
@@ -5736,6 +6213,7 @@
           <a:lstStyle/>
           <a:p>
             <a:pPr algn="ctr"/>
+            <a:endParaRPr/>
           </a:p>
         </p:txBody>
       </p:sp>
@@ -5847,6 +6325,7 @@
           <a:lstStyle/>
           <a:p>
             <a:pPr algn="ctr"/>
+            <a:endParaRPr/>
           </a:p>
         </p:txBody>
       </p:sp>
@@ -5895,7 +6374,7 @@
 </file>
 
 <file path=ppt/slides/slide12.xml><?xml version="1.0" encoding="utf-8"?>
-<p:sld xmlns:a="http://schemas.openxmlformats.org/drawingml/2006/main" xmlns:p="http://schemas.openxmlformats.org/presentationml/2006/main" xmlns:r="http://schemas.openxmlformats.org/officeDocument/2006/relationships">
+<p:sld xmlns:a="http://schemas.openxmlformats.org/drawingml/2006/main" xmlns:r="http://schemas.openxmlformats.org/officeDocument/2006/relationships" xmlns:p="http://schemas.openxmlformats.org/presentationml/2006/main">
   <p:cSld>
     <p:spTree>
       <p:nvGrpSpPr>
@@ -5903,7 +6382,14 @@
         <p:cNvGrpSpPr/>
         <p:nvPr/>
       </p:nvGrpSpPr>
-      <p:grpSpPr/>
+      <p:grpSpPr>
+        <a:xfrm>
+          <a:off x="0" y="0"/>
+          <a:ext cx="0" cy="0"/>
+          <a:chOff x="0" y="0"/>
+          <a:chExt cx="0" cy="0"/>
+        </a:xfrm>
+      </p:grpSpPr>
       <p:sp>
         <p:nvSpPr>
           <p:cNvPr id="2" name="Rectangle 1"/>
@@ -5944,6 +6430,7 @@
           <a:lstStyle/>
           <a:p>
             <a:pPr algn="ctr"/>
+            <a:endParaRPr/>
           </a:p>
         </p:txBody>
       </p:sp>
@@ -6057,6 +6544,7 @@
           <a:lstStyle/>
           <a:p>
             <a:pPr algn="ctr"/>
+            <a:endParaRPr/>
           </a:p>
         </p:txBody>
       </p:sp>
@@ -6257,6 +6745,7 @@
           <a:lstStyle/>
           <a:p>
             <a:pPr algn="ctr"/>
+            <a:endParaRPr/>
           </a:p>
         </p:txBody>
       </p:sp>
@@ -6457,6 +6946,7 @@
           <a:lstStyle/>
           <a:p>
             <a:pPr algn="ctr"/>
+            <a:endParaRPr/>
           </a:p>
         </p:txBody>
       </p:sp>
@@ -6655,6 +7145,7 @@
           <a:lstStyle/>
           <a:p>
             <a:pPr algn="ctr"/>
+            <a:endParaRPr/>
           </a:p>
         </p:txBody>
       </p:sp>
@@ -6703,7 +7194,7 @@
 </file>
 
 <file path=ppt/slides/slide13.xml><?xml version="1.0" encoding="utf-8"?>
-<p:sld xmlns:a="http://schemas.openxmlformats.org/drawingml/2006/main" xmlns:p="http://schemas.openxmlformats.org/presentationml/2006/main" xmlns:r="http://schemas.openxmlformats.org/officeDocument/2006/relationships">
+<p:sld xmlns:a="http://schemas.openxmlformats.org/drawingml/2006/main" xmlns:r="http://schemas.openxmlformats.org/officeDocument/2006/relationships" xmlns:p="http://schemas.openxmlformats.org/presentationml/2006/main">
   <p:cSld>
     <p:spTree>
       <p:nvGrpSpPr>
@@ -6711,7 +7202,14 @@
         <p:cNvGrpSpPr/>
         <p:nvPr/>
       </p:nvGrpSpPr>
-      <p:grpSpPr/>
+      <p:grpSpPr>
+        <a:xfrm>
+          <a:off x="0" y="0"/>
+          <a:ext cx="0" cy="0"/>
+          <a:chOff x="0" y="0"/>
+          <a:chExt cx="0" cy="0"/>
+        </a:xfrm>
+      </p:grpSpPr>
       <p:sp>
         <p:nvSpPr>
           <p:cNvPr id="2" name="Rectangle 1"/>
@@ -6752,6 +7250,7 @@
           <a:lstStyle/>
           <a:p>
             <a:pPr algn="ctr"/>
+            <a:endParaRPr/>
           </a:p>
         </p:txBody>
       </p:sp>
@@ -6832,7 +7331,7 @@
         <p:spPr>
           <a:xfrm>
             <a:off x="731520" y="1508760"/>
-            <a:ext cx="5212080" cy="4526280"/>
+            <a:ext cx="5212080" cy="2805158"/>
           </a:xfrm>
           <a:prstGeom prst="roundRect">
             <a:avLst/>
@@ -6865,6 +7364,7 @@
           <a:lstStyle/>
           <a:p>
             <a:pPr algn="ctr"/>
+            <a:endParaRPr/>
           </a:p>
         </p:txBody>
       </p:sp>
@@ -7032,7 +7532,7 @@
         <p:spPr>
           <a:xfrm>
             <a:off x="6245352" y="1508760"/>
-            <a:ext cx="5212080" cy="4526280"/>
+            <a:ext cx="5212080" cy="2805158"/>
           </a:xfrm>
           <a:prstGeom prst="roundRect">
             <a:avLst/>
@@ -7065,6 +7565,7 @@
           <a:lstStyle/>
           <a:p>
             <a:pPr algn="ctr"/>
+            <a:endParaRPr/>
           </a:p>
         </p:txBody>
       </p:sp>
@@ -7231,8 +7732,8 @@
         </p:nvSpPr>
         <p:spPr>
           <a:xfrm>
-            <a:off x="6473952" y="5440680"/>
-            <a:ext cx="4754880" cy="438912"/>
+            <a:off x="2968909" y="4661390"/>
+            <a:ext cx="6254181" cy="1051560"/>
           </a:xfrm>
           <a:prstGeom prst="roundRect">
             <a:avLst/>
@@ -7261,7 +7762,7 @@
           </a:fontRef>
         </p:style>
         <p:txBody>
-          <a:bodyPr rtlCol="0" anchor="ctr" lIns="0" tIns="0" rIns="0" bIns="0"/>
+          <a:bodyPr lIns="0" tIns="0" rIns="0" bIns="0" rtlCol="0" anchor="ctr"/>
           <a:lstStyle/>
           <a:p>
             <a:pPr algn="ctr">
@@ -7273,6 +7774,7 @@
               </a:defRPr>
             </a:pPr>
             <a:r>
+              <a:rPr dirty="0"/>
               <a:t>🎉 Thank You! Questions &amp; Discussion Welcome.</a:t>
             </a:r>
           </a:p>
@@ -7318,6 +7820,7 @@
           <a:lstStyle/>
           <a:p>
             <a:pPr algn="ctr"/>
+            <a:endParaRPr/>
           </a:p>
         </p:txBody>
       </p:sp>
@@ -7366,7 +7869,7 @@
 </file>
 
 <file path=ppt/slides/slide2.xml><?xml version="1.0" encoding="utf-8"?>
-<p:sld xmlns:a="http://schemas.openxmlformats.org/drawingml/2006/main" xmlns:p="http://schemas.openxmlformats.org/presentationml/2006/main" xmlns:r="http://schemas.openxmlformats.org/officeDocument/2006/relationships">
+<p:sld xmlns:a="http://schemas.openxmlformats.org/drawingml/2006/main" xmlns:r="http://schemas.openxmlformats.org/officeDocument/2006/relationships" xmlns:p="http://schemas.openxmlformats.org/presentationml/2006/main">
   <p:cSld>
     <p:spTree>
       <p:nvGrpSpPr>
@@ -7374,7 +7877,14 @@
         <p:cNvGrpSpPr/>
         <p:nvPr/>
       </p:nvGrpSpPr>
-      <p:grpSpPr/>
+      <p:grpSpPr>
+        <a:xfrm>
+          <a:off x="0" y="0"/>
+          <a:ext cx="0" cy="0"/>
+          <a:chOff x="0" y="0"/>
+          <a:chExt cx="0" cy="0"/>
+        </a:xfrm>
+      </p:grpSpPr>
       <p:sp>
         <p:nvSpPr>
           <p:cNvPr id="2" name="Rectangle 1"/>
@@ -7415,6 +7925,7 @@
           <a:lstStyle/>
           <a:p>
             <a:pPr algn="ctr"/>
+            <a:endParaRPr/>
           </a:p>
         </p:txBody>
       </p:sp>
@@ -7528,6 +8039,7 @@
           <a:lstStyle/>
           <a:p>
             <a:pPr algn="ctr"/>
+            <a:endParaRPr/>
           </a:p>
         </p:txBody>
       </p:sp>
@@ -7539,7 +8051,7 @@
         </p:nvSpPr>
         <p:spPr>
           <a:xfrm>
-            <a:off x="960120" y="1673352"/>
+            <a:off x="990600" y="2335504"/>
             <a:ext cx="4754880" cy="4197096"/>
           </a:xfrm>
           <a:prstGeom prst="rect">
@@ -7565,6 +8077,7 @@
               </a:defRPr>
             </a:pPr>
             <a:r>
+              <a:rPr dirty="0"/>
               <a:t>⚠️ Challenges in Legacy Telecom Billing</a:t>
             </a:r>
           </a:p>
@@ -7578,6 +8091,7 @@
               </a:defRPr>
             </a:pPr>
             <a:r>
+              <a:rPr dirty="0"/>
               <a:t>•  Manual Rating Inefficiencies:</a:t>
             </a:r>
           </a:p>
@@ -7594,6 +8108,7 @@
               </a:defRPr>
             </a:pPr>
             <a:r>
+              <a:rPr dirty="0"/>
               <a:t>   Legacy systems struggle with real-time classification of call logs into Local, STD, and ISD categories, causing calculation delays.</a:t>
             </a:r>
           </a:p>
@@ -7607,6 +8122,7 @@
               </a:defRPr>
             </a:pPr>
             <a:r>
+              <a:rPr dirty="0"/>
               <a:t>•  Pulse Rounding &amp; Allowance Errors:</a:t>
             </a:r>
           </a:p>
@@ -7623,6 +8139,7 @@
               </a:defRPr>
             </a:pPr>
             <a:r>
+              <a:rPr dirty="0"/>
               <a:t>   Discrepancies in 60-second pulse rounding and inaccurate deduction of free monthly minute quotas frustrate customers.</a:t>
             </a:r>
           </a:p>
@@ -7636,6 +8153,7 @@
               </a:defRPr>
             </a:pPr>
             <a:r>
+              <a:rPr dirty="0"/>
               <a:t>•  Complex Tax Compliance (GST):</a:t>
             </a:r>
           </a:p>
@@ -7652,6 +8170,7 @@
               </a:defRPr>
             </a:pPr>
             <a:r>
+              <a:rPr dirty="0"/>
               <a:t>   Non-automated handling of 18% GST (CGST 9% + SGST 9%), late fee penalties, and promotional adjustments.</a:t>
             </a:r>
           </a:p>
@@ -7665,6 +8184,7 @@
               </a:defRPr>
             </a:pPr>
             <a:r>
+              <a:rPr dirty="0"/>
               <a:t>•  Lack of Itemized Transparency:</a:t>
             </a:r>
           </a:p>
@@ -7681,6 +8201,7 @@
               </a:defRPr>
             </a:pPr>
             <a:r>
+              <a:rPr dirty="0"/>
               <a:t>   Subscribers lack clear, itemized tax invoices showing exact call timestamps, duration, destination numbers, and cost breakdowns.</a:t>
             </a:r>
           </a:p>
@@ -7728,6 +8249,7 @@
           <a:lstStyle/>
           <a:p>
             <a:pPr algn="ctr"/>
+            <a:endParaRPr/>
           </a:p>
         </p:txBody>
       </p:sp>
@@ -7739,7 +8261,7 @@
         </p:nvSpPr>
         <p:spPr>
           <a:xfrm>
-            <a:off x="6446520" y="1673352"/>
+            <a:off x="6434543" y="2335504"/>
             <a:ext cx="4754880" cy="4197096"/>
           </a:xfrm>
           <a:prstGeom prst="rect">
@@ -7926,6 +8448,7 @@
           <a:lstStyle/>
           <a:p>
             <a:pPr algn="ctr"/>
+            <a:endParaRPr/>
           </a:p>
         </p:txBody>
       </p:sp>
@@ -7974,7 +8497,7 @@
 </file>
 
 <file path=ppt/slides/slide3.xml><?xml version="1.0" encoding="utf-8"?>
-<p:sld xmlns:a="http://schemas.openxmlformats.org/drawingml/2006/main" xmlns:p="http://schemas.openxmlformats.org/presentationml/2006/main" xmlns:r="http://schemas.openxmlformats.org/officeDocument/2006/relationships">
+<p:sld xmlns:a="http://schemas.openxmlformats.org/drawingml/2006/main" xmlns:r="http://schemas.openxmlformats.org/officeDocument/2006/relationships" xmlns:p="http://schemas.openxmlformats.org/presentationml/2006/main">
   <p:cSld>
     <p:spTree>
       <p:nvGrpSpPr>
@@ -7982,7 +8505,14 @@
         <p:cNvGrpSpPr/>
         <p:nvPr/>
       </p:nvGrpSpPr>
-      <p:grpSpPr/>
+      <p:grpSpPr>
+        <a:xfrm>
+          <a:off x="0" y="0"/>
+          <a:ext cx="0" cy="0"/>
+          <a:chOff x="0" y="0"/>
+          <a:chExt cx="0" cy="0"/>
+        </a:xfrm>
+      </p:grpSpPr>
       <p:sp>
         <p:nvSpPr>
           <p:cNvPr id="2" name="Rectangle 1"/>
@@ -8023,6 +8553,7 @@
           <a:lstStyle/>
           <a:p>
             <a:pPr algn="ctr"/>
+            <a:endParaRPr/>
           </a:p>
         </p:txBody>
       </p:sp>
@@ -8136,6 +8667,7 @@
           <a:lstStyle/>
           <a:p>
             <a:pPr algn="ctr"/>
+            <a:endParaRPr/>
           </a:p>
         </p:txBody>
       </p:sp>
@@ -8336,6 +8868,7 @@
           <a:lstStyle/>
           <a:p>
             <a:pPr algn="ctr"/>
+            <a:endParaRPr/>
           </a:p>
         </p:txBody>
       </p:sp>
@@ -8536,6 +9069,7 @@
           <a:lstStyle/>
           <a:p>
             <a:pPr algn="ctr"/>
+            <a:endParaRPr/>
           </a:p>
         </p:txBody>
       </p:sp>
@@ -8736,6 +9270,7 @@
           <a:lstStyle/>
           <a:p>
             <a:pPr algn="ctr"/>
+            <a:endParaRPr/>
           </a:p>
         </p:txBody>
       </p:sp>
@@ -8934,6 +9469,7 @@
           <a:lstStyle/>
           <a:p>
             <a:pPr algn="ctr"/>
+            <a:endParaRPr/>
           </a:p>
         </p:txBody>
       </p:sp>
@@ -8982,7 +9518,7 @@
 </file>
 
 <file path=ppt/slides/slide4.xml><?xml version="1.0" encoding="utf-8"?>
-<p:sld xmlns:a="http://schemas.openxmlformats.org/drawingml/2006/main" xmlns:p="http://schemas.openxmlformats.org/presentationml/2006/main" xmlns:r="http://schemas.openxmlformats.org/officeDocument/2006/relationships">
+<p:sld xmlns:a="http://schemas.openxmlformats.org/drawingml/2006/main" xmlns:r="http://schemas.openxmlformats.org/officeDocument/2006/relationships" xmlns:p="http://schemas.openxmlformats.org/presentationml/2006/main">
   <p:cSld>
     <p:spTree>
       <p:nvGrpSpPr>
@@ -8990,7 +9526,14 @@
         <p:cNvGrpSpPr/>
         <p:nvPr/>
       </p:nvGrpSpPr>
-      <p:grpSpPr/>
+      <p:grpSpPr>
+        <a:xfrm>
+          <a:off x="0" y="0"/>
+          <a:ext cx="0" cy="0"/>
+          <a:chOff x="0" y="0"/>
+          <a:chExt cx="0" cy="0"/>
+        </a:xfrm>
+      </p:grpSpPr>
       <p:sp>
         <p:nvSpPr>
           <p:cNvPr id="2" name="Rectangle 1"/>
@@ -9031,6 +9574,7 @@
           <a:lstStyle/>
           <a:p>
             <a:pPr algn="ctr"/>
+            <a:endParaRPr/>
           </a:p>
         </p:txBody>
       </p:sp>
@@ -9144,6 +9688,7 @@
           <a:lstStyle/>
           <a:p>
             <a:pPr algn="ctr"/>
+            <a:endParaRPr/>
           </a:p>
         </p:txBody>
       </p:sp>
@@ -9257,6 +9802,7 @@
           <a:lstStyle/>
           <a:p>
             <a:pPr algn="ctr"/>
+            <a:endParaRPr/>
           </a:p>
         </p:txBody>
       </p:sp>
@@ -9370,6 +9916,7 @@
           <a:lstStyle/>
           <a:p>
             <a:pPr algn="ctr"/>
+            <a:endParaRPr/>
           </a:p>
         </p:txBody>
       </p:sp>
@@ -9483,6 +10030,7 @@
           <a:lstStyle/>
           <a:p>
             <a:pPr algn="ctr"/>
+            <a:endParaRPr/>
           </a:p>
         </p:txBody>
       </p:sp>
@@ -9596,6 +10144,7 @@
           <a:lstStyle/>
           <a:p>
             <a:pPr algn="ctr"/>
+            <a:endParaRPr/>
           </a:p>
         </p:txBody>
       </p:sp>
@@ -9709,6 +10258,7 @@
           <a:lstStyle/>
           <a:p>
             <a:pPr algn="ctr"/>
+            <a:endParaRPr/>
           </a:p>
         </p:txBody>
       </p:sp>
@@ -9820,6 +10370,7 @@
           <a:lstStyle/>
           <a:p>
             <a:pPr algn="ctr"/>
+            <a:endParaRPr/>
           </a:p>
         </p:txBody>
       </p:sp>
@@ -9868,7 +10419,7 @@
 </file>
 
 <file path=ppt/slides/slide5.xml><?xml version="1.0" encoding="utf-8"?>
-<p:sld xmlns:a="http://schemas.openxmlformats.org/drawingml/2006/main" xmlns:p="http://schemas.openxmlformats.org/presentationml/2006/main" xmlns:r="http://schemas.openxmlformats.org/officeDocument/2006/relationships">
+<p:sld xmlns:a="http://schemas.openxmlformats.org/drawingml/2006/main" xmlns:r="http://schemas.openxmlformats.org/officeDocument/2006/relationships" xmlns:p="http://schemas.openxmlformats.org/presentationml/2006/main">
   <p:cSld>
     <p:spTree>
       <p:nvGrpSpPr>
@@ -9876,7 +10427,14 @@
         <p:cNvGrpSpPr/>
         <p:nvPr/>
       </p:nvGrpSpPr>
-      <p:grpSpPr/>
+      <p:grpSpPr>
+        <a:xfrm>
+          <a:off x="0" y="0"/>
+          <a:ext cx="0" cy="0"/>
+          <a:chOff x="0" y="0"/>
+          <a:chExt cx="0" cy="0"/>
+        </a:xfrm>
+      </p:grpSpPr>
       <p:sp>
         <p:nvSpPr>
           <p:cNvPr id="2" name="Rectangle 1"/>
@@ -9917,6 +10475,7 @@
           <a:lstStyle/>
           <a:p>
             <a:pPr algn="ctr"/>
+            <a:endParaRPr/>
           </a:p>
         </p:txBody>
       </p:sp>
@@ -10030,6 +10589,7 @@
           <a:lstStyle/>
           <a:p>
             <a:pPr algn="ctr"/>
+            <a:endParaRPr/>
           </a:p>
         </p:txBody>
       </p:sp>
@@ -10041,7 +10601,7 @@
         </p:nvSpPr>
         <p:spPr>
           <a:xfrm>
-            <a:off x="960120" y="1673352"/>
+            <a:off x="1031748" y="2501042"/>
             <a:ext cx="4480560" cy="4197096"/>
           </a:xfrm>
           <a:prstGeom prst="rect">
@@ -10064,6 +10624,7 @@
               </a:defRPr>
             </a:pPr>
             <a:r>
+              <a:rPr dirty="0"/>
               <a:t>•  Executive KPI Summary Cards</a:t>
             </a:r>
           </a:p>
@@ -10080,6 +10641,7 @@
               </a:defRPr>
             </a:pPr>
             <a:r>
+              <a:rPr dirty="0"/>
               <a:t>   Live aggregates displaying Monthly Invoiced Revenue (₹995.45), Active Billable Subscribers (5 Lines), Overdue Invoices (1 Invoice), and Total Usage (107 Mins).</a:t>
             </a:r>
           </a:p>
@@ -10093,6 +10655,7 @@
               </a:defRPr>
             </a:pPr>
             <a:r>
+              <a:rPr dirty="0"/>
               <a:t>•  Monthly Billing Trend (Bar Chart)</a:t>
             </a:r>
           </a:p>
@@ -10109,6 +10672,7 @@
               </a:defRPr>
             </a:pPr>
             <a:r>
+              <a:rPr dirty="0"/>
               <a:t>   Tracks 6-month historical billing collections from March to August 2026, visualizing revenue seasonality and growth.</a:t>
             </a:r>
           </a:p>
@@ -10122,6 +10686,7 @@
               </a:defRPr>
             </a:pPr>
             <a:r>
+              <a:rPr dirty="0"/>
               <a:t>•  Tariff Plan Distribution (Doughnut)</a:t>
             </a:r>
           </a:p>
@@ -10138,6 +10703,7 @@
               </a:defRPr>
             </a:pPr>
             <a:r>
+              <a:rPr dirty="0"/>
               <a:t>   Visual breakdown of subscribers enrolled across Prepaid Starter, Postpaid Silver, Gold Unlimited, and Enterprise tiers.</a:t>
             </a:r>
           </a:p>
@@ -10151,6 +10717,7 @@
               </a:defRPr>
             </a:pPr>
             <a:r>
+              <a:rPr dirty="0"/>
               <a:t>•  College Viva Quick Controls</a:t>
             </a:r>
           </a:p>
@@ -10167,6 +10734,7 @@
               </a:defRPr>
             </a:pPr>
             <a:r>
+              <a:rPr dirty="0"/>
               <a:t>   Instant action bar allowing single-click bill generation, call logging, and subscriber registration during presentations.</a:t>
             </a:r>
           </a:p>
@@ -10214,6 +10782,7 @@
           <a:lstStyle/>
           <a:p>
             <a:pPr algn="ctr"/>
+            <a:endParaRPr/>
           </a:p>
         </p:txBody>
       </p:sp>
@@ -10279,7 +10848,7 @@
           </a:fontRef>
         </p:style>
         <p:txBody>
-          <a:bodyPr rtlCol="0" anchor="ctr" lIns="0" tIns="0" rIns="0" bIns="0"/>
+          <a:bodyPr lIns="0" tIns="0" rIns="0" bIns="0" rtlCol="0" anchor="ctr"/>
           <a:lstStyle/>
           <a:p>
             <a:pPr algn="ctr">
@@ -10336,6 +10905,7 @@
           <a:lstStyle/>
           <a:p>
             <a:pPr algn="ctr"/>
+            <a:endParaRPr/>
           </a:p>
         </p:txBody>
       </p:sp>
@@ -10384,7 +10954,7 @@
 </file>
 
 <file path=ppt/slides/slide6.xml><?xml version="1.0" encoding="utf-8"?>
-<p:sld xmlns:a="http://schemas.openxmlformats.org/drawingml/2006/main" xmlns:p="http://schemas.openxmlformats.org/presentationml/2006/main" xmlns:r="http://schemas.openxmlformats.org/officeDocument/2006/relationships">
+<p:sld xmlns:a="http://schemas.openxmlformats.org/drawingml/2006/main" xmlns:r="http://schemas.openxmlformats.org/officeDocument/2006/relationships" xmlns:p="http://schemas.openxmlformats.org/presentationml/2006/main">
   <p:cSld>
     <p:spTree>
       <p:nvGrpSpPr>
@@ -10392,7 +10962,14 @@
         <p:cNvGrpSpPr/>
         <p:nvPr/>
       </p:nvGrpSpPr>
-      <p:grpSpPr/>
+      <p:grpSpPr>
+        <a:xfrm>
+          <a:off x="0" y="0"/>
+          <a:ext cx="0" cy="0"/>
+          <a:chOff x="0" y="0"/>
+          <a:chExt cx="0" cy="0"/>
+        </a:xfrm>
+      </p:grpSpPr>
       <p:sp>
         <p:nvSpPr>
           <p:cNvPr id="2" name="Rectangle 1"/>
@@ -10433,6 +11010,7 @@
           <a:lstStyle/>
           <a:p>
             <a:pPr algn="ctr"/>
+            <a:endParaRPr/>
           </a:p>
         </p:txBody>
       </p:sp>
@@ -10546,6 +11124,7 @@
           <a:lstStyle/>
           <a:p>
             <a:pPr algn="ctr"/>
+            <a:endParaRPr/>
           </a:p>
         </p:txBody>
       </p:sp>
@@ -10557,7 +11136,7 @@
         </p:nvSpPr>
         <p:spPr>
           <a:xfrm>
-            <a:off x="960120" y="1673352"/>
+            <a:off x="1031748" y="2653021"/>
             <a:ext cx="4480560" cy="4197096"/>
           </a:xfrm>
           <a:prstGeom prst="rect">
@@ -10730,6 +11309,7 @@
           <a:lstStyle/>
           <a:p>
             <a:pPr algn="ctr"/>
+            <a:endParaRPr/>
           </a:p>
         </p:txBody>
       </p:sp>
@@ -10795,7 +11375,7 @@
           </a:fontRef>
         </p:style>
         <p:txBody>
-          <a:bodyPr rtlCol="0" anchor="ctr" lIns="0" tIns="0" rIns="0" bIns="0"/>
+          <a:bodyPr lIns="0" tIns="0" rIns="0" bIns="0" rtlCol="0" anchor="ctr"/>
           <a:lstStyle/>
           <a:p>
             <a:pPr algn="ctr">
@@ -10852,6 +11432,7 @@
           <a:lstStyle/>
           <a:p>
             <a:pPr algn="ctr"/>
+            <a:endParaRPr/>
           </a:p>
         </p:txBody>
       </p:sp>
@@ -10863,7 +11444,7 @@
         </p:nvSpPr>
         <p:spPr>
           <a:xfrm>
-            <a:off x="731520" y="6309360"/>
+            <a:off x="731520" y="6317243"/>
             <a:ext cx="10698480" cy="320040"/>
           </a:xfrm>
           <a:prstGeom prst="rect">
@@ -10900,7 +11481,7 @@
 </file>
 
 <file path=ppt/slides/slide7.xml><?xml version="1.0" encoding="utf-8"?>
-<p:sld xmlns:a="http://schemas.openxmlformats.org/drawingml/2006/main" xmlns:p="http://schemas.openxmlformats.org/presentationml/2006/main" xmlns:r="http://schemas.openxmlformats.org/officeDocument/2006/relationships">
+<p:sld xmlns:a="http://schemas.openxmlformats.org/drawingml/2006/main" xmlns:r="http://schemas.openxmlformats.org/officeDocument/2006/relationships" xmlns:p="http://schemas.openxmlformats.org/presentationml/2006/main">
   <p:cSld>
     <p:spTree>
       <p:nvGrpSpPr>
@@ -10908,7 +11489,14 @@
         <p:cNvGrpSpPr/>
         <p:nvPr/>
       </p:nvGrpSpPr>
-      <p:grpSpPr/>
+      <p:grpSpPr>
+        <a:xfrm>
+          <a:off x="0" y="0"/>
+          <a:ext cx="0" cy="0"/>
+          <a:chOff x="0" y="0"/>
+          <a:chExt cx="0" cy="0"/>
+        </a:xfrm>
+      </p:grpSpPr>
       <p:sp>
         <p:nvSpPr>
           <p:cNvPr id="2" name="Rectangle 1"/>
@@ -10949,6 +11537,7 @@
           <a:lstStyle/>
           <a:p>
             <a:pPr algn="ctr"/>
+            <a:endParaRPr/>
           </a:p>
         </p:txBody>
       </p:sp>
@@ -11062,6 +11651,7 @@
           <a:lstStyle/>
           <a:p>
             <a:pPr algn="ctr"/>
+            <a:endParaRPr/>
           </a:p>
         </p:txBody>
       </p:sp>
@@ -11073,7 +11663,7 @@
         </p:nvSpPr>
         <p:spPr>
           <a:xfrm>
-            <a:off x="960120" y="1673352"/>
+            <a:off x="960120" y="2501041"/>
             <a:ext cx="4480560" cy="4197096"/>
           </a:xfrm>
           <a:prstGeom prst="rect">
@@ -11096,6 +11686,7 @@
               </a:defRPr>
             </a:pPr>
             <a:r>
+              <a:rPr dirty="0"/>
               <a:t>•  60-Second Pulse Ceiling</a:t>
             </a:r>
           </a:p>
@@ -11112,7 +11703,24 @@
               </a:defRPr>
             </a:pPr>
             <a:r>
-              <a:t>   Standard telecom pulse rule: Math.ceil(durationSeconds / 60.0). Even a 65-second call is billed as 2 whole minutes.</a:t>
+              <a:rPr dirty="0"/>
+              <a:t>   Standard telecom pulse rule: </a:t>
+            </a:r>
+            <a:r>
+              <a:rPr dirty="0" err="1"/>
+              <a:t>Math.ceil</a:t>
+            </a:r>
+            <a:r>
+              <a:rPr dirty="0"/>
+              <a:t>(</a:t>
+            </a:r>
+            <a:r>
+              <a:rPr dirty="0" err="1"/>
+              <a:t>durationSeconds</a:t>
+            </a:r>
+            <a:r>
+              <a:rPr dirty="0"/>
+              <a:t> / 60.0). Even a 65-second call is billed as 2 whole minutes.</a:t>
             </a:r>
           </a:p>
           <a:p>
@@ -11125,6 +11733,7 @@
               </a:defRPr>
             </a:pPr>
             <a:r>
+              <a:rPr dirty="0"/>
               <a:t>•  Free Minutes Priority Deduction</a:t>
             </a:r>
           </a:p>
@@ -11141,6 +11750,7 @@
               </a:defRPr>
             </a:pPr>
             <a:r>
+              <a:rPr dirty="0"/>
               <a:t>   Monthly free minutes quota (e.g. 150 mins) is deducted against local call minutes first; only excess usage is billed at plan rates.</a:t>
             </a:r>
           </a:p>
@@ -11154,6 +11764,7 @@
               </a:defRPr>
             </a:pPr>
             <a:r>
+              <a:rPr dirty="0"/>
               <a:t>•  Taxable Value Subtotal Calculation</a:t>
             </a:r>
           </a:p>
@@ -11170,6 +11781,7 @@
               </a:defRPr>
             </a:pPr>
             <a:r>
+              <a:rPr dirty="0"/>
               <a:t>   Subtotal = (Billable Local Mins × Rate) + (STD Mins × Rate) + (ISD Mins × Rate) + Fixed Monthly Rental.</a:t>
             </a:r>
           </a:p>
@@ -11183,6 +11795,7 @@
               </a:defRPr>
             </a:pPr>
             <a:r>
+              <a:rPr dirty="0"/>
               <a:t>•  Statutory GST &amp; Adjustments</a:t>
             </a:r>
           </a:p>
@@ -11199,6 +11812,7 @@
               </a:defRPr>
             </a:pPr>
             <a:r>
+              <a:rPr dirty="0"/>
               <a:t>   Applies 18% GST (CGST 9% + SGST 9%) on the taxable value, incorporates ₹50 late surcharge for overdue accounts, and deducts promotional discounts.</a:t>
             </a:r>
           </a:p>
@@ -11246,6 +11860,7 @@
           <a:lstStyle/>
           <a:p>
             <a:pPr algn="ctr"/>
+            <a:endParaRPr/>
           </a:p>
         </p:txBody>
       </p:sp>
@@ -11311,7 +11926,7 @@
           </a:fontRef>
         </p:style>
         <p:txBody>
-          <a:bodyPr rtlCol="0" anchor="ctr" lIns="0" tIns="0" rIns="0" bIns="0"/>
+          <a:bodyPr lIns="0" tIns="0" rIns="0" bIns="0" rtlCol="0" anchor="ctr"/>
           <a:lstStyle/>
           <a:p>
             <a:pPr algn="ctr">
@@ -11368,6 +11983,7 @@
           <a:lstStyle/>
           <a:p>
             <a:pPr algn="ctr"/>
+            <a:endParaRPr/>
           </a:p>
         </p:txBody>
       </p:sp>
@@ -11416,7 +12032,7 @@
 </file>
 
 <file path=ppt/slides/slide8.xml><?xml version="1.0" encoding="utf-8"?>
-<p:sld xmlns:a="http://schemas.openxmlformats.org/drawingml/2006/main" xmlns:p="http://schemas.openxmlformats.org/presentationml/2006/main" xmlns:r="http://schemas.openxmlformats.org/officeDocument/2006/relationships">
+<p:sld xmlns:a="http://schemas.openxmlformats.org/drawingml/2006/main" xmlns:r="http://schemas.openxmlformats.org/officeDocument/2006/relationships" xmlns:p="http://schemas.openxmlformats.org/presentationml/2006/main">
   <p:cSld>
     <p:spTree>
       <p:nvGrpSpPr>
@@ -11424,7 +12040,14 @@
         <p:cNvGrpSpPr/>
         <p:nvPr/>
       </p:nvGrpSpPr>
-      <p:grpSpPr/>
+      <p:grpSpPr>
+        <a:xfrm>
+          <a:off x="0" y="0"/>
+          <a:ext cx="0" cy="0"/>
+          <a:chOff x="0" y="0"/>
+          <a:chExt cx="0" cy="0"/>
+        </a:xfrm>
+      </p:grpSpPr>
       <p:sp>
         <p:nvSpPr>
           <p:cNvPr id="2" name="Rectangle 1"/>
@@ -11465,6 +12088,7 @@
           <a:lstStyle/>
           <a:p>
             <a:pPr algn="ctr"/>
+            <a:endParaRPr/>
           </a:p>
         </p:txBody>
       </p:sp>
@@ -11578,6 +12202,7 @@
           <a:lstStyle/>
           <a:p>
             <a:pPr algn="ctr"/>
+            <a:endParaRPr/>
           </a:p>
         </p:txBody>
       </p:sp>
@@ -11589,7 +12214,7 @@
         </p:nvSpPr>
         <p:spPr>
           <a:xfrm>
-            <a:off x="960120" y="1673352"/>
+            <a:off x="1078992" y="2582077"/>
             <a:ext cx="4480560" cy="4197096"/>
           </a:xfrm>
           <a:prstGeom prst="rect">
@@ -11612,6 +12237,7 @@
               </a:defRPr>
             </a:pPr>
             <a:r>
+              <a:rPr dirty="0"/>
               <a:t>•  Authentic Telecom Layout</a:t>
             </a:r>
           </a:p>
@@ -11628,6 +12254,7 @@
               </a:defRPr>
             </a:pPr>
             <a:r>
+              <a:rPr dirty="0"/>
               <a:t>   Features corporate Telco branding, GSTIN (27AAACA1234F1Z5), DOT license numbers, toll-free customer care details, and Net-15 payment terms.</a:t>
             </a:r>
           </a:p>
@@ -11641,6 +12268,7 @@
               </a:defRPr>
             </a:pPr>
             <a:r>
+              <a:rPr dirty="0"/>
               <a:t>•  Itemized Summary of Charges</a:t>
             </a:r>
           </a:p>
@@ -11657,6 +12285,7 @@
               </a:defRPr>
             </a:pPr>
             <a:r>
+              <a:rPr dirty="0"/>
               <a:t>   Tabular breakdown of Monthly Rental, CDR itemized pulse charges, Taxable Subtotal, CGST 9%, SGST 9%, Late Surcharge, and Total Payable.</a:t>
             </a:r>
           </a:p>
@@ -11670,6 +12299,7 @@
               </a:defRPr>
             </a:pPr>
             <a:r>
+              <a:rPr dirty="0"/>
               <a:t>•  Itemized CDR Table Inclusion</a:t>
             </a:r>
           </a:p>
@@ -11686,6 +12316,7 @@
               </a:defRPr>
             </a:pPr>
             <a:r>
+              <a:rPr dirty="0"/>
               <a:t>   Comprehensive list of every call made during the billing cycle (timestamp, dialed destination, classification, duration, and individual charge).</a:t>
             </a:r>
           </a:p>
@@ -11699,7 +12330,16 @@
               </a:defRPr>
             </a:pPr>
             <a:r>
-              <a:t>•  Dual Export (OpenPDF &amp; In-Browser)</a:t>
+              <a:rPr dirty="0"/>
+              <a:t>•  Dual Export (</a:t>
+            </a:r>
+            <a:r>
+              <a:rPr dirty="0" err="1"/>
+              <a:t>OpenPDF</a:t>
+            </a:r>
+            <a:r>
+              <a:rPr dirty="0"/>
+              <a:t> &amp; In-Browser)</a:t>
             </a:r>
           </a:p>
           <a:p>
@@ -11715,7 +12355,16 @@
               </a:defRPr>
             </a:pPr>
             <a:r>
-              <a:t>   Direct vector PDF invoice download via OpenPDF on Desktop and html2pdf on Web, plus in-browser printing with dynamic status stamps (PAID/UNPAID/OVERDUE).</a:t>
+              <a:rPr dirty="0"/>
+              <a:t>   Direct vector PDF invoice download via </a:t>
+            </a:r>
+            <a:r>
+              <a:rPr dirty="0" err="1"/>
+              <a:t>OpenPDF</a:t>
+            </a:r>
+            <a:r>
+              <a:rPr dirty="0"/>
+              <a:t> on Desktop and html2pdf on Web, plus in-browser printing with dynamic status stamps (PAID/UNPAID/OVERDUE).</a:t>
             </a:r>
           </a:p>
         </p:txBody>
@@ -11762,6 +12411,7 @@
           <a:lstStyle/>
           <a:p>
             <a:pPr algn="ctr"/>
+            <a:endParaRPr/>
           </a:p>
         </p:txBody>
       </p:sp>
@@ -11827,7 +12477,7 @@
           </a:fontRef>
         </p:style>
         <p:txBody>
-          <a:bodyPr rtlCol="0" anchor="ctr" lIns="0" tIns="0" rIns="0" bIns="0"/>
+          <a:bodyPr lIns="0" tIns="0" rIns="0" bIns="0" rtlCol="0" anchor="ctr"/>
           <a:lstStyle/>
           <a:p>
             <a:pPr algn="ctr">
@@ -11884,6 +12534,7 @@
           <a:lstStyle/>
           <a:p>
             <a:pPr algn="ctr"/>
+            <a:endParaRPr/>
           </a:p>
         </p:txBody>
       </p:sp>
@@ -11932,7 +12583,7 @@
 </file>
 
 <file path=ppt/slides/slide9.xml><?xml version="1.0" encoding="utf-8"?>
-<p:sld xmlns:a="http://schemas.openxmlformats.org/drawingml/2006/main" xmlns:p="http://schemas.openxmlformats.org/presentationml/2006/main" xmlns:r="http://schemas.openxmlformats.org/officeDocument/2006/relationships">
+<p:sld xmlns:a="http://schemas.openxmlformats.org/drawingml/2006/main" xmlns:r="http://schemas.openxmlformats.org/officeDocument/2006/relationships" xmlns:p="http://schemas.openxmlformats.org/presentationml/2006/main">
   <p:cSld>
     <p:spTree>
       <p:nvGrpSpPr>
@@ -11940,7 +12591,14 @@
         <p:cNvGrpSpPr/>
         <p:nvPr/>
       </p:nvGrpSpPr>
-      <p:grpSpPr/>
+      <p:grpSpPr>
+        <a:xfrm>
+          <a:off x="0" y="0"/>
+          <a:ext cx="0" cy="0"/>
+          <a:chOff x="0" y="0"/>
+          <a:chExt cx="0" cy="0"/>
+        </a:xfrm>
+      </p:grpSpPr>
       <p:sp>
         <p:nvSpPr>
           <p:cNvPr id="2" name="Rectangle 1"/>
@@ -11981,6 +12639,7 @@
           <a:lstStyle/>
           <a:p>
             <a:pPr algn="ctr"/>
+            <a:endParaRPr/>
           </a:p>
         </p:txBody>
       </p:sp>
@@ -12094,6 +12753,7 @@
           <a:lstStyle/>
           <a:p>
             <a:pPr algn="ctr"/>
+            <a:endParaRPr/>
           </a:p>
         </p:txBody>
       </p:sp>
@@ -12105,7 +12765,7 @@
         </p:nvSpPr>
         <p:spPr>
           <a:xfrm>
-            <a:off x="960120" y="1673352"/>
+            <a:off x="960120" y="2660904"/>
             <a:ext cx="4480560" cy="4197096"/>
           </a:xfrm>
           <a:prstGeom prst="rect">
@@ -12278,6 +12938,7 @@
           <a:lstStyle/>
           <a:p>
             <a:pPr algn="ctr"/>
+            <a:endParaRPr/>
           </a:p>
         </p:txBody>
       </p:sp>
@@ -12343,7 +13004,7 @@
           </a:fontRef>
         </p:style>
         <p:txBody>
-          <a:bodyPr rtlCol="0" anchor="ctr" lIns="0" tIns="0" rIns="0" bIns="0"/>
+          <a:bodyPr lIns="0" tIns="0" rIns="0" bIns="0" rtlCol="0" anchor="ctr"/>
           <a:lstStyle/>
           <a:p>
             <a:pPr algn="ctr">
@@ -12400,6 +13061,7 @@
           <a:lstStyle/>
           <a:p>
             <a:pPr algn="ctr"/>
+            <a:endParaRPr/>
           </a:p>
         </p:txBody>
       </p:sp>
@@ -12765,4 +13427,319 @@
   </a:objectDefaults>
   <a:extraClrSchemeLst/>
 </a:theme>
+</file>
+
+<file path=ppt/theme/theme2.xml><?xml version="1.0" encoding="utf-8"?>
+<a:theme xmlns:a="http://schemas.openxmlformats.org/drawingml/2006/main" name="Office Theme">
+  <a:themeElements>
+    <a:clrScheme name="Office">
+      <a:dk1>
+        <a:sysClr val="windowText" lastClr="000000"/>
+      </a:dk1>
+      <a:lt1>
+        <a:sysClr val="window" lastClr="FFFFFF"/>
+      </a:lt1>
+      <a:dk2>
+        <a:srgbClr val="0E2841"/>
+      </a:dk2>
+      <a:lt2>
+        <a:srgbClr val="E8E8E8"/>
+      </a:lt2>
+      <a:accent1>
+        <a:srgbClr val="156082"/>
+      </a:accent1>
+      <a:accent2>
+        <a:srgbClr val="E97132"/>
+      </a:accent2>
+      <a:accent3>
+        <a:srgbClr val="196B24"/>
+      </a:accent3>
+      <a:accent4>
+        <a:srgbClr val="0F9ED5"/>
+      </a:accent4>
+      <a:accent5>
+        <a:srgbClr val="A02B93"/>
+      </a:accent5>
+      <a:accent6>
+        <a:srgbClr val="4EA72E"/>
+      </a:accent6>
+      <a:hlink>
+        <a:srgbClr val="467886"/>
+      </a:hlink>
+      <a:folHlink>
+        <a:srgbClr val="96607D"/>
+      </a:folHlink>
+    </a:clrScheme>
+    <a:fontScheme name="Office">
+      <a:majorFont>
+        <a:latin typeface="Aptos Display" panose="02110004020202020204"/>
+        <a:ea typeface=""/>
+        <a:cs typeface=""/>
+        <a:font script="Jpan" typeface="游ゴシック Light"/>
+        <a:font script="Hang" typeface="맑은 고딕"/>
+        <a:font script="Hans" typeface="等线 Light"/>
+        <a:font script="Hant" typeface="新細明體"/>
+        <a:font script="Arab" typeface="Times New Roman"/>
+        <a:font script="Hebr" typeface="Times New Roman"/>
+        <a:font script="Thai" typeface="Angsana New"/>
+        <a:font script="Ethi" typeface="Nyala"/>
+        <a:font script="Beng" typeface="Vrinda"/>
+        <a:font script="Gujr" typeface="Shruti"/>
+        <a:font script="Khmr" typeface="MoolBoran"/>
+        <a:font script="Knda" typeface="Tunga"/>
+        <a:font script="Guru" typeface="Raavi"/>
+        <a:font script="Cans" typeface="Euphemia"/>
+        <a:font script="Cher" typeface="Plantagenet Cherokee"/>
+        <a:font script="Yiii" typeface="Microsoft Yi Baiti"/>
+        <a:font script="Tibt" typeface="Microsoft Himalaya"/>
+        <a:font script="Thaa" typeface="MV Boli"/>
+        <a:font script="Deva" typeface="Mangal"/>
+        <a:font script="Telu" typeface="Gautami"/>
+        <a:font script="Taml" typeface="Latha"/>
+        <a:font script="Syrc" typeface="Estrangelo Edessa"/>
+        <a:font script="Orya" typeface="Kalinga"/>
+        <a:font script="Mlym" typeface="Kartika"/>
+        <a:font script="Laoo" typeface="DokChampa"/>
+        <a:font script="Sinh" typeface="Iskoola Pota"/>
+        <a:font script="Mong" typeface="Mongolian Baiti"/>
+        <a:font script="Viet" typeface="Times New Roman"/>
+        <a:font script="Uigh" typeface="Microsoft Uighur"/>
+        <a:font script="Geor" typeface="Sylfaen"/>
+        <a:font script="Armn" typeface="Arial"/>
+        <a:font script="Bugi" typeface="Leelawadee UI"/>
+        <a:font script="Bopo" typeface="Microsoft JhengHei"/>
+        <a:font script="Java" typeface="Javanese Text"/>
+        <a:font script="Lisu" typeface="Segoe UI"/>
+        <a:font script="Mymr" typeface="Myanmar Text"/>
+        <a:font script="Nkoo" typeface="Ebrima"/>
+        <a:font script="Olck" typeface="Nirmala UI"/>
+        <a:font script="Osma" typeface="Ebrima"/>
+        <a:font script="Phag" typeface="Phagspa"/>
+        <a:font script="Syrn" typeface="Estrangelo Edessa"/>
+        <a:font script="Syrj" typeface="Estrangelo Edessa"/>
+        <a:font script="Syre" typeface="Estrangelo Edessa"/>
+        <a:font script="Sora" typeface="Nirmala UI"/>
+        <a:font script="Tale" typeface="Microsoft Tai Le"/>
+        <a:font script="Talu" typeface="Microsoft New Tai Lue"/>
+        <a:font script="Tfng" typeface="Ebrima"/>
+      </a:majorFont>
+      <a:minorFont>
+        <a:latin typeface="Aptos" panose="02110004020202020204"/>
+        <a:ea typeface=""/>
+        <a:cs typeface=""/>
+        <a:font script="Jpan" typeface="游ゴシック"/>
+        <a:font script="Hang" typeface="맑은 고딕"/>
+        <a:font script="Hans" typeface="等线"/>
+        <a:font script="Hant" typeface="新細明體"/>
+        <a:font script="Arab" typeface="Arial"/>
+        <a:font script="Hebr" typeface="Arial"/>
+        <a:font script="Thai" typeface="Cordia New"/>
+        <a:font script="Ethi" typeface="Nyala"/>
+        <a:font script="Beng" typeface="Vrinda"/>
+        <a:font script="Gujr" typeface="Shruti"/>
+        <a:font script="Khmr" typeface="DaunPenh"/>
+        <a:font script="Knda" typeface="Tunga"/>
+        <a:font script="Guru" typeface="Raavi"/>
+        <a:font script="Cans" typeface="Euphemia"/>
+        <a:font script="Cher" typeface="Plantagenet Cherokee"/>
+        <a:font script="Yiii" typeface="Microsoft Yi Baiti"/>
+        <a:font script="Tibt" typeface="Microsoft Himalaya"/>
+        <a:font script="Thaa" typeface="MV Boli"/>
+        <a:font script="Deva" typeface="Mangal"/>
+        <a:font script="Telu" typeface="Gautami"/>
+        <a:font script="Taml" typeface="Latha"/>
+        <a:font script="Syrc" typeface="Estrangelo Edessa"/>
+        <a:font script="Orya" typeface="Kalinga"/>
+        <a:font script="Mlym" typeface="Kartika"/>
+        <a:font script="Laoo" typeface="DokChampa"/>
+        <a:font script="Sinh" typeface="Iskoola Pota"/>
+        <a:font script="Mong" typeface="Mongolian Baiti"/>
+        <a:font script="Viet" typeface="Arial"/>
+        <a:font script="Uigh" typeface="Microsoft Uighur"/>
+        <a:font script="Geor" typeface="Sylfaen"/>
+        <a:font script="Armn" typeface="Arial"/>
+        <a:font script="Bugi" typeface="Leelawadee UI"/>
+        <a:font script="Bopo" typeface="Microsoft JhengHei"/>
+        <a:font script="Java" typeface="Javanese Text"/>
+        <a:font script="Lisu" typeface="Segoe UI"/>
+        <a:font script="Mymr" typeface="Myanmar Text"/>
+        <a:font script="Nkoo" typeface="Ebrima"/>
+        <a:font script="Olck" typeface="Nirmala UI"/>
+        <a:font script="Osma" typeface="Ebrima"/>
+        <a:font script="Phag" typeface="Phagspa"/>
+        <a:font script="Syrn" typeface="Estrangelo Edessa"/>
+        <a:font script="Syrj" typeface="Estrangelo Edessa"/>
+        <a:font script="Syre" typeface="Estrangelo Edessa"/>
+        <a:font script="Sora" typeface="Nirmala UI"/>
+        <a:font script="Tale" typeface="Microsoft Tai Le"/>
+        <a:font script="Talu" typeface="Microsoft New Tai Lue"/>
+        <a:font script="Tfng" typeface="Ebrima"/>
+      </a:minorFont>
+    </a:fontScheme>
+    <a:fmtScheme name="Office">
+      <a:fillStyleLst>
+        <a:solidFill>
+          <a:schemeClr val="phClr"/>
+        </a:solidFill>
+        <a:gradFill rotWithShape="1">
+          <a:gsLst>
+            <a:gs pos="0">
+              <a:schemeClr val="phClr">
+                <a:lumMod val="110000"/>
+                <a:satMod val="105000"/>
+                <a:tint val="67000"/>
+              </a:schemeClr>
+            </a:gs>
+            <a:gs pos="50000">
+              <a:schemeClr val="phClr">
+                <a:lumMod val="105000"/>
+                <a:satMod val="103000"/>
+                <a:tint val="73000"/>
+              </a:schemeClr>
+            </a:gs>
+            <a:gs pos="100000">
+              <a:schemeClr val="phClr">
+                <a:lumMod val="105000"/>
+                <a:satMod val="109000"/>
+                <a:tint val="81000"/>
+              </a:schemeClr>
+            </a:gs>
+          </a:gsLst>
+          <a:lin ang="5400000" scaled="0"/>
+        </a:gradFill>
+        <a:gradFill rotWithShape="1">
+          <a:gsLst>
+            <a:gs pos="0">
+              <a:schemeClr val="phClr">
+                <a:satMod val="103000"/>
+                <a:lumMod val="102000"/>
+                <a:tint val="94000"/>
+              </a:schemeClr>
+            </a:gs>
+            <a:gs pos="50000">
+              <a:schemeClr val="phClr">
+                <a:satMod val="110000"/>
+                <a:lumMod val="100000"/>
+                <a:shade val="100000"/>
+              </a:schemeClr>
+            </a:gs>
+            <a:gs pos="100000">
+              <a:schemeClr val="phClr">
+                <a:lumMod val="99000"/>
+                <a:satMod val="120000"/>
+                <a:shade val="78000"/>
+              </a:schemeClr>
+            </a:gs>
+          </a:gsLst>
+          <a:lin ang="5400000" scaled="0"/>
+        </a:gradFill>
+      </a:fillStyleLst>
+      <a:lnStyleLst>
+        <a:ln w="12700" cap="flat" cmpd="sng" algn="ctr">
+          <a:solidFill>
+            <a:schemeClr val="phClr"/>
+          </a:solidFill>
+          <a:prstDash val="solid"/>
+          <a:miter lim="800000"/>
+        </a:ln>
+        <a:ln w="19050" cap="flat" cmpd="sng" algn="ctr">
+          <a:solidFill>
+            <a:schemeClr val="phClr"/>
+          </a:solidFill>
+          <a:prstDash val="solid"/>
+          <a:miter lim="800000"/>
+        </a:ln>
+        <a:ln w="25400" cap="flat" cmpd="sng" algn="ctr">
+          <a:solidFill>
+            <a:schemeClr val="phClr"/>
+          </a:solidFill>
+          <a:prstDash val="solid"/>
+          <a:miter lim="800000"/>
+        </a:ln>
+      </a:lnStyleLst>
+      <a:effectStyleLst>
+        <a:effectStyle>
+          <a:effectLst/>
+        </a:effectStyle>
+        <a:effectStyle>
+          <a:effectLst/>
+        </a:effectStyle>
+        <a:effectStyle>
+          <a:effectLst>
+            <a:outerShdw blurRad="57150" dist="19050" dir="5400000" algn="ctr" rotWithShape="0">
+              <a:srgbClr val="000000">
+                <a:alpha val="63000"/>
+              </a:srgbClr>
+            </a:outerShdw>
+          </a:effectLst>
+        </a:effectStyle>
+      </a:effectStyleLst>
+      <a:bgFillStyleLst>
+        <a:solidFill>
+          <a:schemeClr val="phClr"/>
+        </a:solidFill>
+        <a:solidFill>
+          <a:schemeClr val="phClr">
+            <a:tint val="95000"/>
+            <a:satMod val="170000"/>
+          </a:schemeClr>
+        </a:solidFill>
+        <a:gradFill rotWithShape="1">
+          <a:gsLst>
+            <a:gs pos="0">
+              <a:schemeClr val="phClr">
+                <a:tint val="93000"/>
+                <a:satMod val="150000"/>
+                <a:shade val="98000"/>
+                <a:lumMod val="102000"/>
+              </a:schemeClr>
+            </a:gs>
+            <a:gs pos="50000">
+              <a:schemeClr val="phClr">
+                <a:tint val="98000"/>
+                <a:satMod val="130000"/>
+                <a:shade val="90000"/>
+                <a:lumMod val="103000"/>
+              </a:schemeClr>
+            </a:gs>
+            <a:gs pos="100000">
+              <a:schemeClr val="phClr">
+                <a:shade val="63000"/>
+                <a:satMod val="120000"/>
+              </a:schemeClr>
+            </a:gs>
+          </a:gsLst>
+          <a:lin ang="5400000" scaled="0"/>
+        </a:gradFill>
+      </a:bgFillStyleLst>
+    </a:fmtScheme>
+  </a:themeElements>
+  <a:objectDefaults>
+    <a:lnDef>
+      <a:spPr/>
+      <a:bodyPr/>
+      <a:lstStyle/>
+      <a:style>
+        <a:lnRef idx="2">
+          <a:schemeClr val="accent1"/>
+        </a:lnRef>
+        <a:fillRef idx="0">
+          <a:schemeClr val="accent1"/>
+        </a:fillRef>
+        <a:effectRef idx="1">
+          <a:schemeClr val="accent1"/>
+        </a:effectRef>
+        <a:fontRef idx="minor">
+          <a:schemeClr val="tx1"/>
+        </a:fontRef>
+      </a:style>
+    </a:lnDef>
+  </a:objectDefaults>
+  <a:extraClrSchemeLst/>
+  <a:extLst>
+    <a:ext uri="{05A4C25C-085E-4340-85A3-A5531E510DB2}">
+      <thm15:themeFamily xmlns:thm15="http://schemas.microsoft.com/office/thememl/2012/main" name="Office Theme" id="{2E142A2C-CD16-42D6-873A-C26D2A0506FA}" vid="{1BDDFF52-6CD6-40A5-AB3C-68EB2F1E4D0A}"/>
+    </a:ext>
+  </a:extLst>
+</a:theme>
 </file>
</xml_diff>